<commit_message>
Worked quite a bit on the presentation
</commit_message>
<xml_diff>
--- a/Prezentace.pptx
+++ b/Prezentace.pptx
@@ -5,12 +5,16 @@
     <p:sldMasterId id="2147483648" r:id="rId1"/>
   </p:sldMasterIdLst>
   <p:notesMasterIdLst>
-    <p:notesMasterId r:id="rId5"/>
+    <p:notesMasterId r:id="rId9"/>
   </p:notesMasterIdLst>
   <p:sldIdLst>
     <p:sldId id="256" r:id="rId2"/>
-    <p:sldId id="257" r:id="rId3"/>
-    <p:sldId id="258" r:id="rId4"/>
+    <p:sldId id="259" r:id="rId3"/>
+    <p:sldId id="257" r:id="rId4"/>
+    <p:sldId id="261" r:id="rId5"/>
+    <p:sldId id="263" r:id="rId6"/>
+    <p:sldId id="258" r:id="rId7"/>
+    <p:sldId id="262" r:id="rId8"/>
   </p:sldIdLst>
   <p:sldSz cx="12192000" cy="6858000"/>
   <p:notesSz cx="6858000" cy="9144000"/>
@@ -109,7 +113,76 @@
       </a:defRPr>
     </a:lvl9pPr>
   </p:defaultTextStyle>
+  <p:extLst>
+    <p:ext uri="{EFAFB233-063F-42B5-8137-9DF3F51BA10A}">
+      <p15:sldGuideLst xmlns:p15="http://schemas.microsoft.com/office/powerpoint/2012/main">
+        <p15:guide id="1" orient="horz" pos="2160" userDrawn="1">
+          <p15:clr>
+            <a:srgbClr val="A4A3A4"/>
+          </p15:clr>
+        </p15:guide>
+        <p15:guide id="2" pos="3840" userDrawn="1">
+          <p15:clr>
+            <a:srgbClr val="A4A3A4"/>
+          </p15:clr>
+        </p15:guide>
+      </p15:sldGuideLst>
+    </p:ext>
+  </p:extLst>
 </p:presentation>
+</file>
+
+<file path=ppt/authors.xml><?xml version="1.0" encoding="utf-8"?>
+<p188:authorLst xmlns:a="http://schemas.openxmlformats.org/drawingml/2006/main" xmlns:r="http://schemas.openxmlformats.org/officeDocument/2006/relationships" xmlns:p188="http://schemas.microsoft.com/office/powerpoint/2018/8/main">
+  <p188:author id="{6027075E-E1E5-2701-A4E4-E7D417A591B4}" name="Ondřej Běhal" initials="OB" userId="S::ondrej.behal@ms.krestanskegymnazium.cz::bb15c10f-1ace-45d6-9a30-85afa41deab9" providerId="AD"/>
+</p188:authorLst>
+</file>
+
+<file path=ppt/comments/modernComment_102_6449AC5C.xml><?xml version="1.0" encoding="utf-8"?>
+<p188:cmLst xmlns:a="http://schemas.openxmlformats.org/drawingml/2006/main" xmlns:r="http://schemas.openxmlformats.org/officeDocument/2006/relationships" xmlns:p188="http://schemas.microsoft.com/office/powerpoint/2018/8/main">
+  <p188:cm id="{9FF0D791-3940-4B34-8101-6CFD4C392C6D}" authorId="{6027075E-E1E5-2701-A4E4-E7D417A591B4}" created="2026-03-29T14:51:12.767">
+    <ac:txMkLst xmlns:ac="http://schemas.microsoft.com/office/drawing/2013/main/command">
+      <pc:docMk xmlns:pc="http://schemas.microsoft.com/office/powerpoint/2013/main/command"/>
+      <pc:sldMk xmlns:pc="http://schemas.microsoft.com/office/powerpoint/2013/main/command" cId="1682549852" sldId="258"/>
+      <ac:spMk id="3" creationId="{0B755DE1-F317-B53D-6CE7-0FA95ABFEC55}"/>
+      <ac:txMk cp="347" len="48">
+        <ac:context len="396" hash="2375909780"/>
+      </ac:txMk>
+    </ac:txMkLst>
+    <p188:pos x="5847608" y="3933907"/>
+    <p188:txBody>
+      <a:bodyPr/>
+      <a:lstStyle/>
+      <a:p>
+        <a:r>
+          <a:rPr lang="cs-CZ"/>
+          <a:t>Možná vynechat</a:t>
+        </a:r>
+      </a:p>
+    </p188:txBody>
+  </p188:cm>
+  <p188:cm id="{BF9AEFD2-8152-42FF-8785-86DD9765A672}" authorId="{6027075E-E1E5-2701-A4E4-E7D417A591B4}" created="2026-03-29T15:20:32.816">
+    <ac:txMkLst xmlns:ac="http://schemas.microsoft.com/office/drawing/2013/main/command">
+      <pc:docMk xmlns:pc="http://schemas.microsoft.com/office/powerpoint/2013/main/command"/>
+      <pc:sldMk xmlns:pc="http://schemas.microsoft.com/office/powerpoint/2013/main/command" cId="1682549852" sldId="258"/>
+      <ac:spMk id="3" creationId="{0B755DE1-F317-B53D-6CE7-0FA95ABFEC55}"/>
+      <ac:txMk cp="15" len="9">
+        <ac:context len="396" hash="2375909780"/>
+      </ac:txMk>
+    </ac:txMkLst>
+    <p188:pos x="4196938" y="323809"/>
+    <p188:txBody>
+      <a:bodyPr/>
+      <a:lstStyle/>
+      <a:p>
+        <a:r>
+          <a:rPr lang="cs-CZ"/>
+          <a:t>Technicky vzato víceúčelový, ale když prodáváš auto, nechlubíš se tím, že tě umí odvézt z bodu A do bodu B, ale tím, čím se odlišuje...</a:t>
+        </a:r>
+      </a:p>
+    </p188:txBody>
+  </p188:cm>
+</p188:cmLst>
 </file>
 
 <file path=ppt/notesMasters/notesMaster1.xml><?xml version="1.0" encoding="utf-8"?>
@@ -194,7 +267,7 @@
           <a:p>
             <a:fld id="{015F5405-DF1B-4076-864B-7962BED0FCA9}" type="datetimeFigureOut">
               <a:rPr lang="cs-CZ" smtClean="0"/>
-              <a:t>24.03.2026</a:t>
+              <a:t>28.03.2026</a:t>
             </a:fld>
             <a:endParaRPr lang="cs-CZ"/>
           </a:p>
@@ -567,7 +640,7 @@
       </p:grpSpPr>
       <p:sp>
         <p:nvSpPr>
-          <p:cNvPr id="2" name="Zástupný symbol pro obrázek snímku 1"/>
+          <p:cNvPr id="2" name="Slide Image Placeholder 1"/>
           <p:cNvSpPr>
             <a:spLocks noGrp="1" noRot="1" noChangeAspect="1"/>
           </p:cNvSpPr>
@@ -579,7 +652,7 @@
       </p:sp>
       <p:sp>
         <p:nvSpPr>
-          <p:cNvPr id="3" name="Zástupný symbol pro poznámky 2"/>
+          <p:cNvPr id="3" name="Notes Placeholder 2"/>
           <p:cNvSpPr>
             <a:spLocks noGrp="1"/>
           </p:cNvSpPr>
@@ -594,26 +667,14 @@
           <a:p>
             <a:r>
               <a:rPr lang="cs-CZ" dirty="0"/>
-              <a:t>Vysvětlit jednoduše RPN, jaké jsou rozdíly proti běžné infixové notaci</a:t>
-            </a:r>
-          </a:p>
-          <a:p>
-            <a:r>
-              <a:rPr lang="cs-CZ" dirty="0"/>
-              <a:t>Ukázat příklady matematických výrazů, ukázat je přímo na kalkulačce, pokud je fyzicky přítomna</a:t>
-            </a:r>
-          </a:p>
-          <a:p>
-            <a:r>
-              <a:rPr lang="cs-CZ" dirty="0"/>
-              <a:t>Lze povídat i o historickém kontextu</a:t>
-            </a:r>
-          </a:p>
-        </p:txBody>
-      </p:sp>
-      <p:sp>
-        <p:nvSpPr>
-          <p:cNvPr id="4" name="Zástupný symbol pro číslo snímku 3"/>
+              <a:t>Jak Krteček k projektu přišel</a:t>
+            </a:r>
+          </a:p>
+        </p:txBody>
+      </p:sp>
+      <p:sp>
+        <p:nvSpPr>
+          <p:cNvPr id="4" name="Slide Number Placeholder 3"/>
           <p:cNvSpPr>
             <a:spLocks noGrp="1"/>
           </p:cNvSpPr>
@@ -637,7 +698,692 @@
     </p:spTree>
     <p:extLst>
       <p:ext uri="{BB962C8B-B14F-4D97-AF65-F5344CB8AC3E}">
+        <p14:creationId xmlns:p14="http://schemas.microsoft.com/office/powerpoint/2010/main" val="4061555431"/>
+      </p:ext>
+    </p:extLst>
+  </p:cSld>
+  <p:clrMapOvr>
+    <a:masterClrMapping/>
+  </p:clrMapOvr>
+</p:notes>
+</file>
+
+<file path=ppt/notesSlides/notesSlide3.xml><?xml version="1.0" encoding="utf-8"?>
+<p:notes xmlns:a="http://schemas.openxmlformats.org/drawingml/2006/main" xmlns:r="http://schemas.openxmlformats.org/officeDocument/2006/relationships" xmlns:p="http://schemas.openxmlformats.org/presentationml/2006/main">
+  <p:cSld>
+    <p:spTree>
+      <p:nvGrpSpPr>
+        <p:cNvPr id="1" name=""/>
+        <p:cNvGrpSpPr/>
+        <p:nvPr/>
+      </p:nvGrpSpPr>
+      <p:grpSpPr>
+        <a:xfrm>
+          <a:off x="0" y="0"/>
+          <a:ext cx="0" cy="0"/>
+          <a:chOff x="0" y="0"/>
+          <a:chExt cx="0" cy="0"/>
+        </a:xfrm>
+      </p:grpSpPr>
+      <p:sp>
+        <p:nvSpPr>
+          <p:cNvPr id="2" name="Zástupný symbol pro obrázek snímku 1"/>
+          <p:cNvSpPr>
+            <a:spLocks noGrp="1" noRot="1" noChangeAspect="1"/>
+          </p:cNvSpPr>
+          <p:nvPr>
+            <p:ph type="sldImg"/>
+          </p:nvPr>
+        </p:nvSpPr>
+        <p:spPr/>
+      </p:sp>
+      <p:sp>
+        <p:nvSpPr>
+          <p:cNvPr id="3" name="Zástupný symbol pro poznámky 2"/>
+          <p:cNvSpPr>
+            <a:spLocks noGrp="1"/>
+          </p:cNvSpPr>
+          <p:nvPr>
+            <p:ph type="body" idx="1"/>
+          </p:nvPr>
+        </p:nvSpPr>
+        <p:spPr/>
+        <p:txBody>
+          <a:bodyPr/>
+          <a:lstStyle/>
+          <a:p>
+            <a:r>
+              <a:rPr lang="cs-CZ" dirty="0"/>
+              <a:t>Vysvětlit jednoduše RPN, jaké jsou rozdíly proti běžné infixové notaci</a:t>
+            </a:r>
+          </a:p>
+          <a:p>
+            <a:r>
+              <a:rPr lang="cs-CZ" dirty="0"/>
+              <a:t>Ukázat příklady matematických výrazů, ukázat je přímo na kalkulačce, pokud je fyzicky přítomna</a:t>
+            </a:r>
+          </a:p>
+          <a:p>
+            <a:r>
+              <a:rPr lang="cs-CZ" dirty="0"/>
+              <a:t>Lze povídat i o historickém kontextu</a:t>
+            </a:r>
+          </a:p>
+          <a:p>
+            <a:endParaRPr lang="cs-CZ" dirty="0"/>
+          </a:p>
+          <a:p>
+            <a:r>
+              <a:rPr lang="cs-CZ" dirty="0"/>
+              <a:t>Zdroj obrázku: https://calculator-museum.nl/?hp-12c25thanniversary ; https://calculator-museum.nl/calculators/pictures/hp-12c25thanniversary.png</a:t>
+            </a:r>
+          </a:p>
+        </p:txBody>
+      </p:sp>
+      <p:sp>
+        <p:nvSpPr>
+          <p:cNvPr id="4" name="Zástupný symbol pro číslo snímku 3"/>
+          <p:cNvSpPr>
+            <a:spLocks noGrp="1"/>
+          </p:cNvSpPr>
+          <p:nvPr>
+            <p:ph type="sldNum" sz="quarter" idx="5"/>
+          </p:nvPr>
+        </p:nvSpPr>
+        <p:spPr/>
+        <p:txBody>
+          <a:bodyPr/>
+          <a:lstStyle/>
+          <a:p>
+            <a:fld id="{27274CA6-4D7F-431B-9614-EDAF6E1099E6}" type="slidenum">
+              <a:rPr lang="cs-CZ" smtClean="0"/>
+              <a:t>3</a:t>
+            </a:fld>
+            <a:endParaRPr lang="cs-CZ"/>
+          </a:p>
+        </p:txBody>
+      </p:sp>
+    </p:spTree>
+    <p:extLst>
+      <p:ext uri="{BB962C8B-B14F-4D97-AF65-F5344CB8AC3E}">
         <p14:creationId xmlns:p14="http://schemas.microsoft.com/office/powerpoint/2010/main" val="1366362850"/>
+      </p:ext>
+    </p:extLst>
+  </p:cSld>
+  <p:clrMapOvr>
+    <a:masterClrMapping/>
+  </p:clrMapOvr>
+</p:notes>
+</file>
+
+<file path=ppt/notesSlides/notesSlide4.xml><?xml version="1.0" encoding="utf-8"?>
+<p:notes xmlns:a="http://schemas.openxmlformats.org/drawingml/2006/main" xmlns:r="http://schemas.openxmlformats.org/officeDocument/2006/relationships" xmlns:p="http://schemas.openxmlformats.org/presentationml/2006/main">
+  <p:cSld>
+    <p:spTree>
+      <p:nvGrpSpPr>
+        <p:cNvPr id="1" name=""/>
+        <p:cNvGrpSpPr/>
+        <p:nvPr/>
+      </p:nvGrpSpPr>
+      <p:grpSpPr>
+        <a:xfrm>
+          <a:off x="0" y="0"/>
+          <a:ext cx="0" cy="0"/>
+          <a:chOff x="0" y="0"/>
+          <a:chExt cx="0" cy="0"/>
+        </a:xfrm>
+      </p:grpSpPr>
+      <p:sp>
+        <p:nvSpPr>
+          <p:cNvPr id="2" name="Slide Image Placeholder 1"/>
+          <p:cNvSpPr>
+            <a:spLocks noGrp="1" noRot="1" noChangeAspect="1"/>
+          </p:cNvSpPr>
+          <p:nvPr>
+            <p:ph type="sldImg"/>
+          </p:nvPr>
+        </p:nvSpPr>
+        <p:spPr/>
+      </p:sp>
+      <p:sp>
+        <p:nvSpPr>
+          <p:cNvPr id="3" name="Notes Placeholder 2"/>
+          <p:cNvSpPr>
+            <a:spLocks noGrp="1"/>
+          </p:cNvSpPr>
+          <p:nvPr>
+            <p:ph type="body" idx="1"/>
+          </p:nvPr>
+        </p:nvSpPr>
+        <p:spPr/>
+        <p:txBody>
+          <a:bodyPr/>
+          <a:lstStyle/>
+          <a:p>
+            <a:r>
+              <a:rPr lang="cs-CZ" dirty="0"/>
+              <a:t>Rust.</a:t>
+            </a:r>
+          </a:p>
+          <a:p>
+            <a:endParaRPr lang="cs-CZ" dirty="0"/>
+          </a:p>
+          <a:p>
+            <a:r>
+              <a:rPr lang="cs-CZ" dirty="0"/>
+              <a:t>Rust je moderní (2015) systémový programovací jazyk. Sám se označuje jako „bleskurychlý“, s „neohroženou souběžností“, slibuje „dokonalou paměťovou bezpečnost a další vznešené vlastnosti.</a:t>
+            </a:r>
+          </a:p>
+          <a:p>
+            <a:r>
+              <a:rPr lang="cs-CZ" dirty="0"/>
+              <a:t>Pochopitelně to </a:t>
+            </a:r>
+          </a:p>
+          <a:p>
+            <a:r>
+              <a:rPr lang="cs-CZ" dirty="0"/>
+              <a:t>&lt;evangelizující fanoušci&gt;</a:t>
+            </a:r>
+          </a:p>
+        </p:txBody>
+      </p:sp>
+      <p:sp>
+        <p:nvSpPr>
+          <p:cNvPr id="4" name="Slide Number Placeholder 3"/>
+          <p:cNvSpPr>
+            <a:spLocks noGrp="1"/>
+          </p:cNvSpPr>
+          <p:nvPr>
+            <p:ph type="sldNum" sz="quarter" idx="5"/>
+          </p:nvPr>
+        </p:nvSpPr>
+        <p:spPr/>
+        <p:txBody>
+          <a:bodyPr/>
+          <a:lstStyle/>
+          <a:p>
+            <a:fld id="{27274CA6-4D7F-431B-9614-EDAF6E1099E6}" type="slidenum">
+              <a:rPr lang="cs-CZ" smtClean="0"/>
+              <a:t>4</a:t>
+            </a:fld>
+            <a:endParaRPr lang="cs-CZ"/>
+          </a:p>
+        </p:txBody>
+      </p:sp>
+    </p:spTree>
+    <p:extLst>
+      <p:ext uri="{BB962C8B-B14F-4D97-AF65-F5344CB8AC3E}">
+        <p14:creationId xmlns:p14="http://schemas.microsoft.com/office/powerpoint/2010/main" val="1307162140"/>
+      </p:ext>
+    </p:extLst>
+  </p:cSld>
+  <p:clrMapOvr>
+    <a:masterClrMapping/>
+  </p:clrMapOvr>
+</p:notes>
+</file>
+
+<file path=ppt/notesSlides/notesSlide5.xml><?xml version="1.0" encoding="utf-8"?>
+<p:notes xmlns:a="http://schemas.openxmlformats.org/drawingml/2006/main" xmlns:r="http://schemas.openxmlformats.org/officeDocument/2006/relationships" xmlns:p="http://schemas.openxmlformats.org/presentationml/2006/main">
+  <p:cSld>
+    <p:spTree>
+      <p:nvGrpSpPr>
+        <p:cNvPr id="1" name=""/>
+        <p:cNvGrpSpPr/>
+        <p:nvPr/>
+      </p:nvGrpSpPr>
+      <p:grpSpPr>
+        <a:xfrm>
+          <a:off x="0" y="0"/>
+          <a:ext cx="0" cy="0"/>
+          <a:chOff x="0" y="0"/>
+          <a:chExt cx="0" cy="0"/>
+        </a:xfrm>
+      </p:grpSpPr>
+      <p:sp>
+        <p:nvSpPr>
+          <p:cNvPr id="2" name="Slide Image Placeholder 1"/>
+          <p:cNvSpPr>
+            <a:spLocks noGrp="1" noRot="1" noChangeAspect="1"/>
+          </p:cNvSpPr>
+          <p:nvPr>
+            <p:ph type="sldImg"/>
+          </p:nvPr>
+        </p:nvSpPr>
+        <p:spPr/>
+      </p:sp>
+      <p:sp>
+        <p:nvSpPr>
+          <p:cNvPr id="3" name="Notes Placeholder 2"/>
+          <p:cNvSpPr>
+            <a:spLocks noGrp="1"/>
+          </p:cNvSpPr>
+          <p:nvPr>
+            <p:ph type="body" idx="1"/>
+          </p:nvPr>
+        </p:nvSpPr>
+        <p:spPr/>
+        <p:txBody>
+          <a:bodyPr/>
+          <a:lstStyle/>
+          <a:p>
+            <a:r>
+              <a:rPr lang="cs-CZ" dirty="0"/>
+              <a:t>Rust je moderní systémový programovací jazyk</a:t>
+            </a:r>
+          </a:p>
+          <a:p>
+            <a:pPr marL="171450" indent="-171450">
+              <a:buFont typeface="Arial" panose="020B0604020202020204" pitchFamily="34" charset="0"/>
+              <a:buChar char="•"/>
+            </a:pPr>
+            <a:r>
+              <a:rPr lang="cs-CZ" dirty="0"/>
+              <a:t>Relativně </a:t>
+            </a:r>
+            <a:r>
+              <a:rPr lang="cs-CZ" dirty="0" err="1"/>
+              <a:t>nízkoúrovňový</a:t>
+            </a:r>
+            <a:r>
+              <a:rPr lang="cs-CZ" dirty="0"/>
+              <a:t> – sice na absolutní škále vysokoúrovňový, ale vzhledem k jiným jazykům stále blíže k hardwaru</a:t>
+            </a:r>
+          </a:p>
+          <a:p>
+            <a:pPr marL="171450" indent="-171450">
+              <a:buFont typeface="Arial" panose="020B0604020202020204" pitchFamily="34" charset="0"/>
+              <a:buChar char="•"/>
+            </a:pPr>
+            <a:r>
+              <a:rPr lang="cs-CZ" dirty="0"/>
+              <a:t>Výkonný – politika abstrakce bez dopadu na výkon ("manuálně bys to nenapsal lépe")</a:t>
+            </a:r>
+          </a:p>
+          <a:p>
+            <a:pPr marL="171450" indent="-171450">
+              <a:buFont typeface="Arial" panose="020B0604020202020204" pitchFamily="34" charset="0"/>
+              <a:buChar char="•"/>
+            </a:pPr>
+            <a:r>
+              <a:rPr lang="cs-CZ" dirty="0"/>
+              <a:t>Díky odstupu času byl schopen vidět, co v jiných jazycích nefunguje a co udělat jinak / lépe</a:t>
+            </a:r>
+          </a:p>
+          <a:p>
+            <a:pPr marL="171450" indent="-171450">
+              <a:buFont typeface="Arial" panose="020B0604020202020204" pitchFamily="34" charset="0"/>
+              <a:buChar char="•"/>
+            </a:pPr>
+            <a:endParaRPr lang="cs-CZ" dirty="0"/>
+          </a:p>
+          <a:p>
+            <a:pPr marL="0" indent="0">
+              <a:buFont typeface="Arial" panose="020B0604020202020204" pitchFamily="34" charset="0"/>
+              <a:buNone/>
+            </a:pPr>
+            <a:r>
+              <a:rPr lang="cs-CZ" dirty="0"/>
+              <a:t>Do samého jádra jazyka je integrován statický analyzátor nazývaný „</a:t>
+            </a:r>
+            <a:r>
+              <a:rPr lang="cs-CZ" dirty="0" err="1"/>
+              <a:t>borrow</a:t>
+            </a:r>
+            <a:r>
+              <a:rPr lang="cs-CZ" dirty="0"/>
+              <a:t> checker“, který implementuje koncept vlastnictví a půjčování</a:t>
+            </a:r>
+          </a:p>
+          <a:p>
+            <a:pPr marL="171450" indent="-171450">
+              <a:buFont typeface="Arial" panose="020B0604020202020204" pitchFamily="34" charset="0"/>
+              <a:buChar char="•"/>
+            </a:pPr>
+            <a:r>
+              <a:rPr lang="cs-CZ" i="1" dirty="0"/>
+              <a:t>Již během kompilace</a:t>
+            </a:r>
+            <a:r>
+              <a:rPr lang="cs-CZ" i="0" dirty="0"/>
+              <a:t> zajišťuje platnost ukazatelů a bezpečné přístupy k paměti bez dopadů na výkon</a:t>
+            </a:r>
+          </a:p>
+          <a:p>
+            <a:pPr marL="171450" indent="-171450">
+              <a:buFont typeface="Arial" panose="020B0604020202020204" pitchFamily="34" charset="0"/>
+              <a:buChar char="•"/>
+            </a:pPr>
+            <a:r>
+              <a:rPr lang="cs-CZ" i="0" dirty="0"/>
+              <a:t>    Oproti tomu „sběr odpadu“ (</a:t>
+            </a:r>
+            <a:r>
+              <a:rPr lang="cs-CZ" i="0" dirty="0" err="1"/>
+              <a:t>GC</a:t>
+            </a:r>
+            <a:r>
+              <a:rPr lang="cs-CZ" i="0" dirty="0"/>
+              <a:t>) je nedeterministický a obecně škodí výkonu</a:t>
+            </a:r>
+          </a:p>
+          <a:p>
+            <a:pPr marL="171450" indent="-171450">
+              <a:buFont typeface="Arial" panose="020B0604020202020204" pitchFamily="34" charset="0"/>
+              <a:buChar char="•"/>
+            </a:pPr>
+            <a:r>
+              <a:rPr lang="cs-CZ" i="0" dirty="0"/>
+              <a:t>„Pokud se to zkompiluje, tak to poběží.“ / „Pokládá právě tolik (pomyslných) dopravních kuželů / bariér, aby člověku zabránil brát zkratky.“</a:t>
+            </a:r>
+          </a:p>
+          <a:p>
+            <a:pPr marL="171450" indent="-171450">
+              <a:buFont typeface="Arial" panose="020B0604020202020204" pitchFamily="34" charset="0"/>
+              <a:buChar char="•"/>
+            </a:pPr>
+            <a:endParaRPr lang="cs-CZ" i="0" dirty="0"/>
+          </a:p>
+          <a:p>
+            <a:pPr marL="0" indent="0">
+              <a:buFont typeface="Arial" panose="020B0604020202020204" pitchFamily="34" charset="0"/>
+              <a:buNone/>
+            </a:pPr>
+            <a:r>
+              <a:rPr lang="cs-CZ" dirty="0"/>
+              <a:t>Jednoduchá, jednotná a explicitní práce s chybami, kdy chyby jsou reprezentovány jednoduše jako hodnoty pomocí algebraických datových typů (</a:t>
+            </a:r>
+            <a:r>
+              <a:rPr lang="cs-CZ" dirty="0" err="1"/>
+              <a:t>enumů</a:t>
+            </a:r>
+            <a:r>
+              <a:rPr lang="cs-CZ" dirty="0"/>
+              <a:t>)</a:t>
+            </a:r>
+          </a:p>
+          <a:p>
+            <a:pPr marL="171450" indent="-171450">
+              <a:buFont typeface="Arial" panose="020B0604020202020204" pitchFamily="34" charset="0"/>
+              <a:buChar char="•"/>
+            </a:pPr>
+            <a:r>
+              <a:rPr lang="cs-CZ" dirty="0"/>
+              <a:t>Žádné zapomenuté kontroly nulového ukazatele; typový systém jasně stanovuje, zda je chyba možná</a:t>
+            </a:r>
+          </a:p>
+          <a:p>
+            <a:pPr marL="171450" indent="-171450">
+              <a:buFont typeface="Arial" panose="020B0604020202020204" pitchFamily="34" charset="0"/>
+              <a:buChar char="•"/>
+            </a:pPr>
+            <a:r>
+              <a:rPr lang="cs-CZ" dirty="0"/>
+              <a:t>Nemáme 20 různých vzájemně nekompatibilních způsobů</a:t>
+            </a:r>
+          </a:p>
+          <a:p>
+            <a:pPr marL="0" indent="0">
+              <a:buFont typeface="Arial" panose="020B0604020202020204" pitchFamily="34" charset="0"/>
+              <a:buNone/>
+            </a:pPr>
+            <a:endParaRPr lang="cs-CZ" dirty="0"/>
+          </a:p>
+          <a:p>
+            <a:pPr marL="0" indent="0">
+              <a:buFont typeface="Arial" panose="020B0604020202020204" pitchFamily="34" charset="0"/>
+              <a:buNone/>
+            </a:pPr>
+            <a:r>
+              <a:rPr lang="cs-CZ" dirty="0"/>
+              <a:t>Generické programování =&gt; jeden kód dokáže pracovat s různými datovými typy, omezuje zbytečnou duplikaci kódu</a:t>
+            </a:r>
+          </a:p>
+          <a:p>
+            <a:pPr marL="0" indent="0">
+              <a:buFont typeface="Arial" panose="020B0604020202020204" pitchFamily="34" charset="0"/>
+              <a:buNone/>
+            </a:pPr>
+            <a:endParaRPr lang="cs-CZ" dirty="0"/>
+          </a:p>
+          <a:p>
+            <a:pPr marL="0" indent="0">
+              <a:buFont typeface="Arial" panose="020B0604020202020204" pitchFamily="34" charset="0"/>
+              <a:buNone/>
+            </a:pPr>
+            <a:r>
+              <a:rPr lang="cs-CZ" dirty="0"/>
+              <a:t>Jednotný a kvalitní systém pro kompilaci </a:t>
+            </a:r>
+            <a:r>
+              <a:rPr lang="cs-CZ" dirty="0" err="1"/>
+              <a:t>Cargo</a:t>
+            </a:r>
+            <a:endParaRPr lang="cs-CZ" dirty="0"/>
+          </a:p>
+          <a:p>
+            <a:pPr marL="171450" indent="-171450">
+              <a:buFont typeface="Arial" panose="020B0604020202020204" pitchFamily="34" charset="0"/>
+              <a:buChar char="•"/>
+            </a:pPr>
+            <a:r>
+              <a:rPr lang="cs-CZ" dirty="0"/>
+              <a:t>Který zároveň figuruje jako správce balíčků (program spravující knihovny, na kterých náš projekt závisí, jejich verze, a který je dokáže automaticky stáhnout z centrálního úložiště)</a:t>
+            </a:r>
+          </a:p>
+          <a:p>
+            <a:pPr marL="171450" indent="-171450">
+              <a:buFont typeface="Arial" panose="020B0604020202020204" pitchFamily="34" charset="0"/>
+              <a:buChar char="•"/>
+            </a:pPr>
+            <a:r>
+              <a:rPr lang="cs-CZ" dirty="0"/>
+              <a:t>Velmi dobře čitelné chybové hlášky</a:t>
+            </a:r>
+          </a:p>
+          <a:p>
+            <a:pPr marL="0" indent="0">
+              <a:buFont typeface="Arial" panose="020B0604020202020204" pitchFamily="34" charset="0"/>
+              <a:buNone/>
+            </a:pPr>
+            <a:endParaRPr lang="cs-CZ" dirty="0"/>
+          </a:p>
+          <a:p>
+            <a:pPr marL="0" indent="0">
+              <a:buFont typeface="Arial" panose="020B0604020202020204" pitchFamily="34" charset="0"/>
+              <a:buNone/>
+            </a:pPr>
+            <a:r>
+              <a:rPr lang="cs-CZ" dirty="0"/>
+              <a:t>Od roku 2016 je každoročně „nejmilovanějším“ jazykem podle průzkumů společnosti </a:t>
+            </a:r>
+            <a:r>
+              <a:rPr lang="cs-CZ" dirty="0" err="1"/>
+              <a:t>Stack</a:t>
+            </a:r>
+            <a:r>
+              <a:rPr lang="cs-CZ" dirty="0"/>
+              <a:t> </a:t>
+            </a:r>
+            <a:r>
+              <a:rPr lang="cs-CZ" dirty="0" err="1"/>
+              <a:t>Overflow</a:t>
+            </a:r>
+            <a:r>
+              <a:rPr lang="cs-CZ" dirty="0"/>
+              <a:t>, tzn. největší procento respondentů, kteří ho v nedávné minulosti používali, by ho rádi používali nadále.</a:t>
+            </a:r>
+          </a:p>
+          <a:p>
+            <a:pPr marL="0" indent="0">
+              <a:buFont typeface="Arial" panose="020B0604020202020204" pitchFamily="34" charset="0"/>
+              <a:buNone/>
+            </a:pPr>
+            <a:endParaRPr lang="cs-CZ" dirty="0"/>
+          </a:p>
+          <a:p>
+            <a:pPr marL="0" indent="0">
+              <a:buFont typeface="Arial" panose="020B0604020202020204" pitchFamily="34" charset="0"/>
+              <a:buNone/>
+            </a:pPr>
+            <a:endParaRPr lang="cs-CZ" dirty="0"/>
+          </a:p>
+          <a:p>
+            <a:r>
+              <a:rPr lang="cs-CZ" dirty="0"/>
+              <a:t>Zdroj obrázku: https://rust-lang.org/static/images/rust-logo-blk.svg / https://rustfoundation.org/policy/rust-trademark-policy/#do-not-require</a:t>
+            </a:r>
+          </a:p>
+        </p:txBody>
+      </p:sp>
+      <p:sp>
+        <p:nvSpPr>
+          <p:cNvPr id="4" name="Slide Number Placeholder 3"/>
+          <p:cNvSpPr>
+            <a:spLocks noGrp="1"/>
+          </p:cNvSpPr>
+          <p:nvPr>
+            <p:ph type="sldNum" sz="quarter" idx="5"/>
+          </p:nvPr>
+        </p:nvSpPr>
+        <p:spPr/>
+        <p:txBody>
+          <a:bodyPr/>
+          <a:lstStyle/>
+          <a:p>
+            <a:fld id="{27274CA6-4D7F-431B-9614-EDAF6E1099E6}" type="slidenum">
+              <a:rPr lang="cs-CZ" smtClean="0"/>
+              <a:t>6</a:t>
+            </a:fld>
+            <a:endParaRPr lang="cs-CZ"/>
+          </a:p>
+        </p:txBody>
+      </p:sp>
+    </p:spTree>
+    <p:extLst>
+      <p:ext uri="{BB962C8B-B14F-4D97-AF65-F5344CB8AC3E}">
+        <p14:creationId xmlns:p14="http://schemas.microsoft.com/office/powerpoint/2010/main" val="2675636480"/>
+      </p:ext>
+    </p:extLst>
+  </p:cSld>
+  <p:clrMapOvr>
+    <a:masterClrMapping/>
+  </p:clrMapOvr>
+</p:notes>
+</file>
+
+<file path=ppt/notesSlides/notesSlide6.xml><?xml version="1.0" encoding="utf-8"?>
+<p:notes xmlns:a="http://schemas.openxmlformats.org/drawingml/2006/main" xmlns:r="http://schemas.openxmlformats.org/officeDocument/2006/relationships" xmlns:p="http://schemas.openxmlformats.org/presentationml/2006/main">
+  <p:cSld>
+    <p:spTree>
+      <p:nvGrpSpPr>
+        <p:cNvPr id="1" name=""/>
+        <p:cNvGrpSpPr/>
+        <p:nvPr/>
+      </p:nvGrpSpPr>
+      <p:grpSpPr>
+        <a:xfrm>
+          <a:off x="0" y="0"/>
+          <a:ext cx="0" cy="0"/>
+          <a:chOff x="0" y="0"/>
+          <a:chExt cx="0" cy="0"/>
+        </a:xfrm>
+      </p:grpSpPr>
+      <p:sp>
+        <p:nvSpPr>
+          <p:cNvPr id="2" name="Slide Image Placeholder 1"/>
+          <p:cNvSpPr>
+            <a:spLocks noGrp="1" noRot="1" noChangeAspect="1"/>
+          </p:cNvSpPr>
+          <p:nvPr>
+            <p:ph type="sldImg"/>
+          </p:nvPr>
+        </p:nvSpPr>
+        <p:spPr/>
+      </p:sp>
+      <p:sp>
+        <p:nvSpPr>
+          <p:cNvPr id="3" name="Notes Placeholder 2"/>
+          <p:cNvSpPr>
+            <a:spLocks noGrp="1"/>
+          </p:cNvSpPr>
+          <p:nvPr>
+            <p:ph type="body" idx="1"/>
+          </p:nvPr>
+        </p:nvSpPr>
+        <p:spPr/>
+        <p:txBody>
+          <a:bodyPr/>
+          <a:lstStyle/>
+          <a:p>
+            <a:pPr marL="0" marR="0" lvl="0" indent="0" algn="l" defTabSz="914400" rtl="0" eaLnBrk="1" fontAlgn="auto" latinLnBrk="0" hangingPunct="1">
+              <a:lnSpc>
+                <a:spcPct val="100000"/>
+              </a:lnSpc>
+              <a:spcBef>
+                <a:spcPts val="0"/>
+              </a:spcBef>
+              <a:spcAft>
+                <a:spcPts val="0"/>
+              </a:spcAft>
+              <a:buClrTx/>
+              <a:buSzTx/>
+              <a:buFontTx/>
+              <a:buNone/>
+              <a:tabLst/>
+              <a:defRPr/>
+            </a:pPr>
+            <a:r>
+              <a:rPr lang="cs-CZ" dirty="0" err="1"/>
+              <a:t>Traity</a:t>
+            </a:r>
+            <a:r>
+              <a:rPr lang="cs-CZ" dirty="0"/>
+              <a:t> jsou „rysy“, „vlastnosti“ nebo „příznaky“ typů definující sdílené chování a rozhraní = vlastnosti a funkce pracující s danými typy</a:t>
+            </a:r>
+          </a:p>
+          <a:p>
+            <a:endParaRPr lang="cs-CZ" dirty="0"/>
+          </a:p>
+          <a:p>
+            <a:endParaRPr lang="cs-CZ" dirty="0"/>
+          </a:p>
+          <a:p>
+            <a:r>
+              <a:rPr lang="cs-CZ" dirty="0"/>
+              <a:t>Zdroj obrázku: vlastní, pomocí https://carbon.now.sh/</a:t>
+            </a:r>
+          </a:p>
+        </p:txBody>
+      </p:sp>
+      <p:sp>
+        <p:nvSpPr>
+          <p:cNvPr id="4" name="Slide Number Placeholder 3"/>
+          <p:cNvSpPr>
+            <a:spLocks noGrp="1"/>
+          </p:cNvSpPr>
+          <p:nvPr>
+            <p:ph type="sldNum" sz="quarter" idx="5"/>
+          </p:nvPr>
+        </p:nvSpPr>
+        <p:spPr/>
+        <p:txBody>
+          <a:bodyPr/>
+          <a:lstStyle/>
+          <a:p>
+            <a:fld id="{27274CA6-4D7F-431B-9614-EDAF6E1099E6}" type="slidenum">
+              <a:rPr lang="cs-CZ" smtClean="0"/>
+              <a:t>7</a:t>
+            </a:fld>
+            <a:endParaRPr lang="cs-CZ"/>
+          </a:p>
+        </p:txBody>
+      </p:sp>
+    </p:spTree>
+    <p:extLst>
+      <p:ext uri="{BB962C8B-B14F-4D97-AF65-F5344CB8AC3E}">
+        <p14:creationId xmlns:p14="http://schemas.microsoft.com/office/powerpoint/2010/main" val="625332220"/>
       </p:ext>
     </p:extLst>
   </p:cSld>
@@ -794,7 +1540,7 @@
           <a:p>
             <a:fld id="{798D3673-CB33-4FFC-8C38-E9A4E5339B0B}" type="datetimeFigureOut">
               <a:rPr lang="cs-CZ" smtClean="0"/>
-              <a:t>24.03.2026</a:t>
+              <a:t>28.03.2026</a:t>
             </a:fld>
             <a:endParaRPr lang="cs-CZ"/>
           </a:p>
@@ -992,7 +1738,7 @@
           <a:p>
             <a:fld id="{798D3673-CB33-4FFC-8C38-E9A4E5339B0B}" type="datetimeFigureOut">
               <a:rPr lang="cs-CZ" smtClean="0"/>
-              <a:t>24.03.2026</a:t>
+              <a:t>28.03.2026</a:t>
             </a:fld>
             <a:endParaRPr lang="cs-CZ"/>
           </a:p>
@@ -1200,7 +1946,7 @@
           <a:p>
             <a:fld id="{798D3673-CB33-4FFC-8C38-E9A4E5339B0B}" type="datetimeFigureOut">
               <a:rPr lang="cs-CZ" smtClean="0"/>
-              <a:t>24.03.2026</a:t>
+              <a:t>28.03.2026</a:t>
             </a:fld>
             <a:endParaRPr lang="cs-CZ"/>
           </a:p>
@@ -1398,7 +2144,7 @@
           <a:p>
             <a:fld id="{798D3673-CB33-4FFC-8C38-E9A4E5339B0B}" type="datetimeFigureOut">
               <a:rPr lang="cs-CZ" smtClean="0"/>
-              <a:t>24.03.2026</a:t>
+              <a:t>28.03.2026</a:t>
             </a:fld>
             <a:endParaRPr lang="cs-CZ"/>
           </a:p>
@@ -1673,7 +2419,7 @@
           <a:p>
             <a:fld id="{798D3673-CB33-4FFC-8C38-E9A4E5339B0B}" type="datetimeFigureOut">
               <a:rPr lang="cs-CZ" smtClean="0"/>
-              <a:t>24.03.2026</a:t>
+              <a:t>28.03.2026</a:t>
             </a:fld>
             <a:endParaRPr lang="cs-CZ"/>
           </a:p>
@@ -1938,7 +2684,7 @@
           <a:p>
             <a:fld id="{798D3673-CB33-4FFC-8C38-E9A4E5339B0B}" type="datetimeFigureOut">
               <a:rPr lang="cs-CZ" smtClean="0"/>
-              <a:t>24.03.2026</a:t>
+              <a:t>28.03.2026</a:t>
             </a:fld>
             <a:endParaRPr lang="cs-CZ"/>
           </a:p>
@@ -2350,7 +3096,7 @@
           <a:p>
             <a:fld id="{798D3673-CB33-4FFC-8C38-E9A4E5339B0B}" type="datetimeFigureOut">
               <a:rPr lang="cs-CZ" smtClean="0"/>
-              <a:t>24.03.2026</a:t>
+              <a:t>28.03.2026</a:t>
             </a:fld>
             <a:endParaRPr lang="cs-CZ"/>
           </a:p>
@@ -2491,7 +3237,7 @@
           <a:p>
             <a:fld id="{798D3673-CB33-4FFC-8C38-E9A4E5339B0B}" type="datetimeFigureOut">
               <a:rPr lang="cs-CZ" smtClean="0"/>
-              <a:t>24.03.2026</a:t>
+              <a:t>28.03.2026</a:t>
             </a:fld>
             <a:endParaRPr lang="cs-CZ"/>
           </a:p>
@@ -2604,7 +3350,7 @@
           <a:p>
             <a:fld id="{798D3673-CB33-4FFC-8C38-E9A4E5339B0B}" type="datetimeFigureOut">
               <a:rPr lang="cs-CZ" smtClean="0"/>
-              <a:t>24.03.2026</a:t>
+              <a:t>28.03.2026</a:t>
             </a:fld>
             <a:endParaRPr lang="cs-CZ"/>
           </a:p>
@@ -2915,7 +3661,7 @@
           <a:p>
             <a:fld id="{798D3673-CB33-4FFC-8C38-E9A4E5339B0B}" type="datetimeFigureOut">
               <a:rPr lang="cs-CZ" smtClean="0"/>
-              <a:t>24.03.2026</a:t>
+              <a:t>28.03.2026</a:t>
             </a:fld>
             <a:endParaRPr lang="cs-CZ"/>
           </a:p>
@@ -3203,7 +3949,7 @@
           <a:p>
             <a:fld id="{798D3673-CB33-4FFC-8C38-E9A4E5339B0B}" type="datetimeFigureOut">
               <a:rPr lang="cs-CZ" smtClean="0"/>
-              <a:t>24.03.2026</a:t>
+              <a:t>28.03.2026</a:t>
             </a:fld>
             <a:endParaRPr lang="cs-CZ"/>
           </a:p>
@@ -3444,7 +4190,7 @@
           <a:p>
             <a:fld id="{798D3673-CB33-4FFC-8C38-E9A4E5339B0B}" type="datetimeFigureOut">
               <a:rPr lang="cs-CZ" smtClean="0"/>
-              <a:t>24.03.2026</a:t>
+              <a:t>28.03.2026</a:t>
             </a:fld>
             <a:endParaRPr lang="cs-CZ"/>
           </a:p>
@@ -3955,6 +4701,93 @@
       </p:grpSpPr>
       <p:sp>
         <p:nvSpPr>
+          <p:cNvPr id="2" name="Title 1">
+            <a:extLst>
+              <a:ext uri="{FF2B5EF4-FFF2-40B4-BE49-F238E27FC236}">
+                <a16:creationId xmlns:a16="http://schemas.microsoft.com/office/drawing/2014/main" id="{2696F417-4380-1BB1-4BF1-4CB56BDC3597}"/>
+              </a:ext>
+            </a:extLst>
+          </p:cNvPr>
+          <p:cNvSpPr>
+            <a:spLocks noGrp="1"/>
+          </p:cNvSpPr>
+          <p:nvPr>
+            <p:ph type="title"/>
+          </p:nvPr>
+        </p:nvSpPr>
+        <p:spPr/>
+        <p:txBody>
+          <a:bodyPr/>
+          <a:lstStyle/>
+          <a:p>
+            <a:r>
+              <a:rPr lang="cs-CZ" dirty="0"/>
+              <a:t>Výběr tématu</a:t>
+            </a:r>
+          </a:p>
+        </p:txBody>
+      </p:sp>
+      <p:sp>
+        <p:nvSpPr>
+          <p:cNvPr id="3" name="Content Placeholder 2">
+            <a:extLst>
+              <a:ext uri="{FF2B5EF4-FFF2-40B4-BE49-F238E27FC236}">
+                <a16:creationId xmlns:a16="http://schemas.microsoft.com/office/drawing/2014/main" id="{C03B7F35-A90D-90D9-7179-FF8F2DAB6DF1}"/>
+              </a:ext>
+            </a:extLst>
+          </p:cNvPr>
+          <p:cNvSpPr>
+            <a:spLocks noGrp="1"/>
+          </p:cNvSpPr>
+          <p:nvPr>
+            <p:ph idx="1"/>
+          </p:nvPr>
+        </p:nvSpPr>
+        <p:spPr/>
+        <p:txBody>
+          <a:bodyPr/>
+          <a:lstStyle/>
+          <a:p>
+            <a:r>
+              <a:rPr lang="cs-CZ" dirty="0" err="1"/>
+              <a:t>Aaa</a:t>
+            </a:r>
+            <a:endParaRPr lang="cs-CZ" dirty="0"/>
+          </a:p>
+        </p:txBody>
+      </p:sp>
+    </p:spTree>
+    <p:extLst>
+      <p:ext uri="{BB962C8B-B14F-4D97-AF65-F5344CB8AC3E}">
+        <p14:creationId xmlns:p14="http://schemas.microsoft.com/office/powerpoint/2010/main" val="1187054316"/>
+      </p:ext>
+    </p:extLst>
+  </p:cSld>
+  <p:clrMapOvr>
+    <a:masterClrMapping/>
+  </p:clrMapOvr>
+</p:sld>
+</file>
+
+<file path=ppt/slides/slide3.xml><?xml version="1.0" encoding="utf-8"?>
+<p:sld xmlns:a="http://schemas.openxmlformats.org/drawingml/2006/main" xmlns:r="http://schemas.openxmlformats.org/officeDocument/2006/relationships" xmlns:p="http://schemas.openxmlformats.org/presentationml/2006/main">
+  <p:cSld>
+    <p:spTree>
+      <p:nvGrpSpPr>
+        <p:cNvPr id="1" name=""/>
+        <p:cNvGrpSpPr/>
+        <p:nvPr/>
+      </p:nvGrpSpPr>
+      <p:grpSpPr>
+        <a:xfrm>
+          <a:off x="0" y="0"/>
+          <a:ext cx="0" cy="0"/>
+          <a:chOff x="0" y="0"/>
+          <a:chExt cx="0" cy="0"/>
+        </a:xfrm>
+      </p:grpSpPr>
+      <p:sp>
+        <p:nvSpPr>
           <p:cNvPr id="2" name="Nadpis 1">
             <a:extLst>
               <a:ext uri="{FF2B5EF4-FFF2-40B4-BE49-F238E27FC236}">
@@ -3975,9 +4808,10 @@
           <a:lstStyle/>
           <a:p>
             <a:r>
-              <a:rPr lang="cs-CZ" dirty="0"/>
+              <a:rPr lang="cs-CZ"/>
               <a:t>Postfixová notace</a:t>
             </a:r>
+            <a:endParaRPr lang="cs-CZ" dirty="0"/>
           </a:p>
         </p:txBody>
       </p:sp>
@@ -4040,6 +4874,9 @@
               <a:p>
                 <a:pPr marL="0" indent="0">
                   <a:buNone/>
+                  <a:tabLst>
+                    <a:tab pos="4308475" algn="l"/>
+                  </a:tabLst>
                 </a:pPr>
                 <a14:m>
                   <m:oMath xmlns:m="http://schemas.openxmlformats.org/officeDocument/2006/math">
@@ -4072,43 +4909,45 @@
                       <a:rPr lang="cs-CZ" b="0" i="1" dirty="0" smtClean="0">
                         <a:latin typeface="Cambria Math" panose="02040503050406030204" pitchFamily="18" charset="0"/>
                       </a:rPr>
-                      <m:t>3⇒</m:t>
+                      <m:t>3</m:t>
+                    </m:r>
+                  </m:oMath>
+                </a14:m>
+                <a:r>
+                  <a:rPr lang="cs-CZ" dirty="0"/>
+                  <a:t> 	</a:t>
+                </a:r>
+                <a14:m>
+                  <m:oMath xmlns:m="http://schemas.openxmlformats.org/officeDocument/2006/math">
+                    <m:r>
+                      <a:rPr lang="cs-CZ" i="1" dirty="0">
+                        <a:latin typeface="Cambria Math" panose="02040503050406030204" pitchFamily="18" charset="0"/>
+                      </a:rPr>
+                      <m:t>⇒1 2 3</m:t>
                     </m:r>
                     <m:r>
-                      <a:rPr lang="cs-CZ" i="1" dirty="0" smtClean="0">
-                        <a:latin typeface="Cambria Math" panose="02040503050406030204" pitchFamily="18" charset="0"/>
-                      </a:rPr>
-                      <m:t>1 2</m:t>
-                    </m:r>
-                    <m:r>
-                      <a:rPr lang="cs-CZ" b="0" i="1" dirty="0" smtClean="0">
-                        <a:latin typeface="Cambria Math" panose="02040503050406030204" pitchFamily="18" charset="0"/>
-                      </a:rPr>
-                      <m:t> 3</m:t>
-                    </m:r>
-                    <m:r>
-                      <a:rPr lang="cs-CZ" b="0" i="1" dirty="0" smtClean="0">
+                      <a:rPr lang="cs-CZ" i="1" dirty="0">
                         <a:latin typeface="Cambria Math" panose="02040503050406030204" pitchFamily="18" charset="0"/>
                         <a:ea typeface="Cambria Math" panose="02040503050406030204" pitchFamily="18" charset="0"/>
                       </a:rPr>
                       <m:t>×</m:t>
                     </m:r>
                     <m:r>
-                      <a:rPr lang="cs-CZ" b="0" i="1" dirty="0" smtClean="0">
+                      <a:rPr lang="cs-CZ" i="1" dirty="0">
                         <a:latin typeface="Cambria Math" panose="02040503050406030204" pitchFamily="18" charset="0"/>
                       </a:rPr>
                       <m:t>+</m:t>
                     </m:r>
                   </m:oMath>
                 </a14:m>
-                <a:r>
-                  <a:rPr lang="cs-CZ" dirty="0"/>
-                  <a:t> </a:t>
-                </a:r>
+                <a:endParaRPr lang="cs-CZ" dirty="0"/>
               </a:p>
               <a:p>
                 <a:pPr marL="0" indent="0">
                   <a:buNone/>
+                  <a:tabLst>
+                    <a:tab pos="4308475" algn="l"/>
+                  </a:tabLst>
                 </a:pPr>
                 <a14:m>
                   <m:oMath xmlns:m="http://schemas.openxmlformats.org/officeDocument/2006/math">
@@ -4134,16 +4973,24 @@
                         <a:latin typeface="Cambria Math" panose="02040503050406030204" pitchFamily="18" charset="0"/>
                         <a:ea typeface="Cambria Math" panose="02040503050406030204" pitchFamily="18" charset="0"/>
                       </a:rPr>
-                      <m:t>×</m:t>
+                      <m:t>×3</m:t>
+                    </m:r>
+                  </m:oMath>
+                </a14:m>
+                <a:r>
+                  <a:rPr lang="cs-CZ" dirty="0"/>
+                  <a:t> 	</a:t>
+                </a:r>
+                <a14:m>
+                  <m:oMath xmlns:m="http://schemas.openxmlformats.org/officeDocument/2006/math">
+                    <m:r>
+                      <a:rPr lang="cs-CZ" i="1">
+                        <a:latin typeface="Cambria Math" panose="02040503050406030204" pitchFamily="18" charset="0"/>
+                      </a:rPr>
+                      <m:t>⇒1 2+3</m:t>
                     </m:r>
                     <m:r>
-                      <a:rPr lang="cs-CZ" b="0" i="1" smtClean="0">
-                        <a:latin typeface="Cambria Math" panose="02040503050406030204" pitchFamily="18" charset="0"/>
-                      </a:rPr>
-                      <m:t>3⇒1 2+3</m:t>
-                    </m:r>
-                    <m:r>
-                      <a:rPr lang="cs-CZ" b="0" i="1" smtClean="0">
+                      <a:rPr lang="cs-CZ" i="1">
                         <a:latin typeface="Cambria Math" panose="02040503050406030204" pitchFamily="18" charset="0"/>
                         <a:ea typeface="Cambria Math" panose="02040503050406030204" pitchFamily="18" charset="0"/>
                       </a:rPr>
@@ -4159,11 +5006,101 @@
               <a:p>
                 <a:pPr marL="0" indent="0">
                   <a:buNone/>
+                  <a:tabLst>
+                    <a:tab pos="4308475" algn="l"/>
+                  </a:tabLst>
                 </a:pPr>
+                <a14:m>
+                  <m:oMath xmlns:m="http://schemas.openxmlformats.org/officeDocument/2006/math">
+                    <m:d>
+                      <m:dPr>
+                        <m:ctrlPr>
+                          <a:rPr lang="cs-CZ" b="0" i="1" smtClean="0">
+                            <a:latin typeface="Cambria Math" panose="02040503050406030204" pitchFamily="18" charset="0"/>
+                          </a:rPr>
+                        </m:ctrlPr>
+                      </m:dPr>
+                      <m:e>
+                        <m:d>
+                          <m:dPr>
+                            <m:ctrlPr>
+                              <a:rPr lang="cs-CZ" b="0" i="1" smtClean="0">
+                                <a:latin typeface="Cambria Math" panose="02040503050406030204" pitchFamily="18" charset="0"/>
+                              </a:rPr>
+                            </m:ctrlPr>
+                          </m:dPr>
+                          <m:e>
+                            <m:r>
+                              <a:rPr lang="cs-CZ" b="0" i="1" smtClean="0">
+                                <a:latin typeface="Cambria Math" panose="02040503050406030204" pitchFamily="18" charset="0"/>
+                              </a:rPr>
+                              <m:t>2+3</m:t>
+                            </m:r>
+                          </m:e>
+                        </m:d>
+                        <m:r>
+                          <a:rPr lang="cs-CZ" b="0" i="1" smtClean="0">
+                            <a:latin typeface="Cambria Math" panose="02040503050406030204" pitchFamily="18" charset="0"/>
+                          </a:rPr>
+                          <m:t>+</m:t>
+                        </m:r>
+                        <m:d>
+                          <m:dPr>
+                            <m:ctrlPr>
+                              <a:rPr lang="cs-CZ" b="0" i="1" smtClean="0">
+                                <a:latin typeface="Cambria Math" panose="02040503050406030204" pitchFamily="18" charset="0"/>
+                              </a:rPr>
+                            </m:ctrlPr>
+                          </m:dPr>
+                          <m:e>
+                            <m:r>
+                              <a:rPr lang="cs-CZ" b="0" i="1" smtClean="0">
+                                <a:latin typeface="Cambria Math" panose="02040503050406030204" pitchFamily="18" charset="0"/>
+                              </a:rPr>
+                              <m:t>5</m:t>
+                            </m:r>
+                            <m:r>
+                              <a:rPr lang="cs-CZ" b="0" i="1" smtClean="0">
+                                <a:latin typeface="Cambria Math" panose="02040503050406030204" pitchFamily="18" charset="0"/>
+                                <a:ea typeface="Cambria Math" panose="02040503050406030204" pitchFamily="18" charset="0"/>
+                              </a:rPr>
+                              <m:t>×4</m:t>
+                            </m:r>
+                          </m:e>
+                        </m:d>
+                      </m:e>
+                    </m:d>
+                    <m:r>
+                      <a:rPr lang="cs-CZ" i="1">
+                        <a:latin typeface="Cambria Math" panose="02040503050406030204" pitchFamily="18" charset="0"/>
+                        <a:ea typeface="Cambria Math" panose="02040503050406030204" pitchFamily="18" charset="0"/>
+                      </a:rPr>
+                      <m:t>÷5</m:t>
+                    </m:r>
+                  </m:oMath>
+                </a14:m>
                 <a:r>
                   <a:rPr lang="cs-CZ" dirty="0"/>
-                  <a:t>&lt;další příklady&gt;</a:t>
+                  <a:t> 	</a:t>
                 </a:r>
+                <a14:m>
+                  <m:oMath xmlns:m="http://schemas.openxmlformats.org/officeDocument/2006/math">
+                    <m:r>
+                      <a:rPr lang="cs-CZ" i="1">
+                        <a:latin typeface="Cambria Math" panose="02040503050406030204" pitchFamily="18" charset="0"/>
+                        <a:ea typeface="Cambria Math" panose="02040503050406030204" pitchFamily="18" charset="0"/>
+                      </a:rPr>
+                      <m:t>⇒2 3+5 4×+ 5÷</m:t>
+                    </m:r>
+                  </m:oMath>
+                </a14:m>
+                <a:endParaRPr lang="cs-CZ" dirty="0"/>
+              </a:p>
+              <a:p>
+                <a:pPr marL="0" indent="0">
+                  <a:buNone/>
+                </a:pPr>
+                <a:endParaRPr lang="cs-CZ" dirty="0"/>
               </a:p>
             </p:txBody>
           </p:sp>
@@ -4189,7 +5126,7 @@
               <a:blipFill>
                 <a:blip r:embed="rId3"/>
                 <a:stretch>
-                  <a:fillRect l="-1217" t="-2381"/>
+                  <a:fillRect l="-1043" t="-2381"/>
                 </a:stretch>
               </a:blipFill>
             </p:spPr>
@@ -4208,6 +5145,53 @@
           </p:sp>
         </mc:Fallback>
       </mc:AlternateContent>
+      <p:pic>
+        <p:nvPicPr>
+          <p:cNvPr id="1026" name="Picture 2" descr="HP 12C Platinum 25th Anniversary Edition">
+            <a:extLst>
+              <a:ext uri="{FF2B5EF4-FFF2-40B4-BE49-F238E27FC236}">
+                <a16:creationId xmlns:a16="http://schemas.microsoft.com/office/drawing/2014/main" id="{DB5B7F64-9BBB-9D58-C84A-23491A29CEF5}"/>
+              </a:ext>
+            </a:extLst>
+          </p:cNvPr>
+          <p:cNvPicPr>
+            <a:picLocks noChangeAspect="1" noChangeArrowheads="1"/>
+          </p:cNvPicPr>
+          <p:nvPr/>
+        </p:nvPicPr>
+        <p:blipFill>
+          <a:blip r:embed="rId4">
+            <a:extLst>
+              <a:ext uri="{28A0092B-C50C-407E-A947-70E740481C1C}">
+                <a14:useLocalDpi xmlns:a14="http://schemas.microsoft.com/office/drawing/2010/main" val="0"/>
+              </a:ext>
+            </a:extLst>
+          </a:blip>
+          <a:srcRect/>
+          <a:stretch>
+            <a:fillRect/>
+          </a:stretch>
+        </p:blipFill>
+        <p:spPr bwMode="auto">
+          <a:xfrm>
+            <a:off x="7548880" y="0"/>
+            <a:ext cx="4643120" cy="2970630"/>
+          </a:xfrm>
+          <a:prstGeom prst="rect">
+            <a:avLst/>
+          </a:prstGeom>
+          <a:noFill/>
+          <a:extLst>
+            <a:ext uri="{909E8E84-426E-40DD-AFC4-6F175D3DCCD1}">
+              <a14:hiddenFill xmlns:a14="http://schemas.microsoft.com/office/drawing/2010/main">
+                <a:solidFill>
+                  <a:srgbClr val="FFFFFF"/>
+                </a:solidFill>
+              </a14:hiddenFill>
+            </a:ext>
+          </a:extLst>
+        </p:spPr>
+      </p:pic>
     </p:spTree>
     <p:extLst>
       <p:ext uri="{BB962C8B-B14F-4D97-AF65-F5344CB8AC3E}">
@@ -4221,7 +5205,818 @@
 </p:sld>
 </file>
 
-<file path=ppt/slides/slide3.xml><?xml version="1.0" encoding="utf-8"?>
+<file path=ppt/slides/slide4.xml><?xml version="1.0" encoding="utf-8"?>
+<p:sld xmlns:a="http://schemas.openxmlformats.org/drawingml/2006/main" xmlns:r="http://schemas.openxmlformats.org/officeDocument/2006/relationships" xmlns:p="http://schemas.openxmlformats.org/presentationml/2006/main" show="0">
+  <p:cSld>
+    <p:spTree>
+      <p:nvGrpSpPr>
+        <p:cNvPr id="1" name=""/>
+        <p:cNvGrpSpPr/>
+        <p:nvPr/>
+      </p:nvGrpSpPr>
+      <p:grpSpPr>
+        <a:xfrm>
+          <a:off x="0" y="0"/>
+          <a:ext cx="0" cy="0"/>
+          <a:chOff x="0" y="0"/>
+          <a:chExt cx="0" cy="0"/>
+        </a:xfrm>
+      </p:grpSpPr>
+      <p:pic>
+        <p:nvPicPr>
+          <p:cNvPr id="7" name="Picture 6">
+            <a:extLst>
+              <a:ext uri="{FF2B5EF4-FFF2-40B4-BE49-F238E27FC236}">
+                <a16:creationId xmlns:a16="http://schemas.microsoft.com/office/drawing/2014/main" id="{A2F3CF4E-295C-DF36-8D39-9F00FE8DB55C}"/>
+              </a:ext>
+            </a:extLst>
+          </p:cNvPr>
+          <p:cNvPicPr>
+            <a:picLocks noChangeAspect="1"/>
+          </p:cNvPicPr>
+          <p:nvPr/>
+        </p:nvPicPr>
+        <p:blipFill>
+          <a:blip r:embed="rId3">
+            <a:extLst>
+              <a:ext uri="{28A0092B-C50C-407E-A947-70E740481C1C}">
+                <a14:useLocalDpi xmlns:a14="http://schemas.microsoft.com/office/drawing/2010/main" val="0"/>
+              </a:ext>
+            </a:extLst>
+          </a:blip>
+          <a:srcRect b="4768"/>
+          <a:stretch>
+            <a:fillRect/>
+          </a:stretch>
+        </p:blipFill>
+        <p:spPr>
+          <a:xfrm rot="369497">
+            <a:off x="4055744" y="2998963"/>
+            <a:ext cx="5080000" cy="3934261"/>
+          </a:xfrm>
+          <a:prstGeom prst="rect">
+            <a:avLst/>
+          </a:prstGeom>
+        </p:spPr>
+      </p:pic>
+      <p:pic>
+        <p:nvPicPr>
+          <p:cNvPr id="11" name="Picture 10">
+            <a:extLst>
+              <a:ext uri="{FF2B5EF4-FFF2-40B4-BE49-F238E27FC236}">
+                <a16:creationId xmlns:a16="http://schemas.microsoft.com/office/drawing/2014/main" id="{4660781E-0EED-EA99-93D6-14C9A393ED4C}"/>
+              </a:ext>
+            </a:extLst>
+          </p:cNvPr>
+          <p:cNvPicPr>
+            <a:picLocks noChangeAspect="1"/>
+          </p:cNvPicPr>
+          <p:nvPr/>
+        </p:nvPicPr>
+        <p:blipFill>
+          <a:blip r:embed="rId4">
+            <a:extLst>
+              <a:ext uri="{28A0092B-C50C-407E-A947-70E740481C1C}">
+                <a14:useLocalDpi xmlns:a14="http://schemas.microsoft.com/office/drawing/2010/main" val="0"/>
+              </a:ext>
+            </a:extLst>
+          </a:blip>
+          <a:srcRect b="2721"/>
+          <a:stretch>
+            <a:fillRect/>
+          </a:stretch>
+        </p:blipFill>
+        <p:spPr>
+          <a:xfrm rot="21175835">
+            <a:off x="254000" y="247649"/>
+            <a:ext cx="4187439" cy="4358640"/>
+          </a:xfrm>
+          <a:prstGeom prst="rect">
+            <a:avLst/>
+          </a:prstGeom>
+        </p:spPr>
+      </p:pic>
+      <p:pic>
+        <p:nvPicPr>
+          <p:cNvPr id="13" name="Picture 12">
+            <a:extLst>
+              <a:ext uri="{FF2B5EF4-FFF2-40B4-BE49-F238E27FC236}">
+                <a16:creationId xmlns:a16="http://schemas.microsoft.com/office/drawing/2014/main" id="{20680142-C4A9-51ED-20F5-9C554CD74951}"/>
+              </a:ext>
+            </a:extLst>
+          </p:cNvPr>
+          <p:cNvPicPr>
+            <a:picLocks noChangeAspect="1"/>
+          </p:cNvPicPr>
+          <p:nvPr/>
+        </p:nvPicPr>
+        <p:blipFill>
+          <a:blip r:embed="rId5">
+            <a:extLst>
+              <a:ext uri="{28A0092B-C50C-407E-A947-70E740481C1C}">
+                <a14:useLocalDpi xmlns:a14="http://schemas.microsoft.com/office/drawing/2010/main" val="0"/>
+              </a:ext>
+            </a:extLst>
+          </a:blip>
+          <a:stretch>
+            <a:fillRect/>
+          </a:stretch>
+        </p:blipFill>
+        <p:spPr>
+          <a:xfrm rot="21305470">
+            <a:off x="9332112" y="3573306"/>
+            <a:ext cx="2586991" cy="2586991"/>
+          </a:xfrm>
+          <a:prstGeom prst="rect">
+            <a:avLst/>
+          </a:prstGeom>
+        </p:spPr>
+      </p:pic>
+      <p:pic>
+        <p:nvPicPr>
+          <p:cNvPr id="9" name="Picture 8">
+            <a:extLst>
+              <a:ext uri="{FF2B5EF4-FFF2-40B4-BE49-F238E27FC236}">
+                <a16:creationId xmlns:a16="http://schemas.microsoft.com/office/drawing/2014/main" id="{42B71CE3-BED5-C277-A71B-B062DE160491}"/>
+              </a:ext>
+            </a:extLst>
+          </p:cNvPr>
+          <p:cNvPicPr>
+            <a:picLocks noChangeAspect="1"/>
+          </p:cNvPicPr>
+          <p:nvPr/>
+        </p:nvPicPr>
+        <p:blipFill>
+          <a:blip r:embed="rId6">
+            <a:extLst>
+              <a:ext uri="{28A0092B-C50C-407E-A947-70E740481C1C}">
+                <a14:useLocalDpi xmlns:a14="http://schemas.microsoft.com/office/drawing/2010/main" val="0"/>
+              </a:ext>
+            </a:extLst>
+          </a:blip>
+          <a:srcRect l="4592" t="1385" r="4086" b="1736"/>
+          <a:stretch>
+            <a:fillRect/>
+          </a:stretch>
+        </p:blipFill>
+        <p:spPr>
+          <a:xfrm rot="21004061">
+            <a:off x="8116716" y="273685"/>
+            <a:ext cx="3859733" cy="2834740"/>
+          </a:xfrm>
+          <a:prstGeom prst="rect">
+            <a:avLst/>
+          </a:prstGeom>
+        </p:spPr>
+      </p:pic>
+      <p:pic>
+        <p:nvPicPr>
+          <p:cNvPr id="14" name="Graphic 13">
+            <a:extLst>
+              <a:ext uri="{FF2B5EF4-FFF2-40B4-BE49-F238E27FC236}">
+                <a16:creationId xmlns:a16="http://schemas.microsoft.com/office/drawing/2014/main" id="{563EDE3D-2B12-F92D-AC18-DB824B920585}"/>
+              </a:ext>
+            </a:extLst>
+          </p:cNvPr>
+          <p:cNvPicPr>
+            <a:picLocks noChangeAspect="1"/>
+          </p:cNvPicPr>
+          <p:nvPr/>
+        </p:nvPicPr>
+        <p:blipFill>
+          <a:blip>
+            <a:extLst>
+              <a:ext uri="{96DAC541-7B7A-43D3-8B79-37D633B846F1}">
+                <asvg:svgBlip xmlns:asvg="http://schemas.microsoft.com/office/drawing/2016/SVG/main" r:embed="rId7"/>
+              </a:ext>
+            </a:extLst>
+          </a:blip>
+          <a:stretch>
+            <a:fillRect/>
+          </a:stretch>
+        </p:blipFill>
+        <p:spPr>
+          <a:xfrm>
+            <a:off x="4693735" y="-309563"/>
+            <a:ext cx="2854960" cy="2854960"/>
+          </a:xfrm>
+          <a:prstGeom prst="rect">
+            <a:avLst/>
+          </a:prstGeom>
+        </p:spPr>
+      </p:pic>
+    </p:spTree>
+    <p:extLst>
+      <p:ext uri="{BB962C8B-B14F-4D97-AF65-F5344CB8AC3E}">
+        <p14:creationId xmlns:p14="http://schemas.microsoft.com/office/powerpoint/2010/main" val="413226662"/>
+      </p:ext>
+    </p:extLst>
+  </p:cSld>
+  <p:clrMapOvr>
+    <a:masterClrMapping/>
+  </p:clrMapOvr>
+  <p:timing>
+    <p:tnLst>
+      <p:par>
+        <p:cTn id="1" dur="indefinite" restart="never" nodeType="tmRoot">
+          <p:childTnLst>
+            <p:seq concurrent="1" nextAc="seek">
+              <p:cTn id="2" dur="indefinite" nodeType="mainSeq">
+                <p:childTnLst>
+                  <p:par>
+                    <p:cTn id="3" fill="hold">
+                      <p:stCondLst>
+                        <p:cond delay="indefinite"/>
+                      </p:stCondLst>
+                      <p:childTnLst>
+                        <p:par>
+                          <p:cTn id="4" fill="hold">
+                            <p:stCondLst>
+                              <p:cond delay="0"/>
+                            </p:stCondLst>
+                            <p:childTnLst>
+                              <p:par>
+                                <p:cTn id="5" presetID="42" presetClass="entr" presetSubtype="0" fill="hold" nodeType="clickEffect">
+                                  <p:stCondLst>
+                                    <p:cond delay="0"/>
+                                  </p:stCondLst>
+                                  <p:childTnLst>
+                                    <p:set>
+                                      <p:cBhvr>
+                                        <p:cTn id="6" dur="1" fill="hold">
+                                          <p:stCondLst>
+                                            <p:cond delay="0"/>
+                                          </p:stCondLst>
+                                        </p:cTn>
+                                        <p:tgtEl>
+                                          <p:spTgt spid="11"/>
+                                        </p:tgtEl>
+                                        <p:attrNameLst>
+                                          <p:attrName>style.visibility</p:attrName>
+                                        </p:attrNameLst>
+                                      </p:cBhvr>
+                                      <p:to>
+                                        <p:strVal val="visible"/>
+                                      </p:to>
+                                    </p:set>
+                                    <p:animEffect transition="in" filter="fade">
+                                      <p:cBhvr>
+                                        <p:cTn id="7" dur="1000"/>
+                                        <p:tgtEl>
+                                          <p:spTgt spid="11"/>
+                                        </p:tgtEl>
+                                      </p:cBhvr>
+                                    </p:animEffect>
+                                    <p:anim calcmode="lin" valueType="num">
+                                      <p:cBhvr>
+                                        <p:cTn id="8" dur="1000" fill="hold"/>
+                                        <p:tgtEl>
+                                          <p:spTgt spid="11"/>
+                                        </p:tgtEl>
+                                        <p:attrNameLst>
+                                          <p:attrName>ppt_x</p:attrName>
+                                        </p:attrNameLst>
+                                      </p:cBhvr>
+                                      <p:tavLst>
+                                        <p:tav tm="0">
+                                          <p:val>
+                                            <p:strVal val="#ppt_x"/>
+                                          </p:val>
+                                        </p:tav>
+                                        <p:tav tm="100000">
+                                          <p:val>
+                                            <p:strVal val="#ppt_x"/>
+                                          </p:val>
+                                        </p:tav>
+                                      </p:tavLst>
+                                    </p:anim>
+                                    <p:anim calcmode="lin" valueType="num">
+                                      <p:cBhvr>
+                                        <p:cTn id="9" dur="1000" fill="hold"/>
+                                        <p:tgtEl>
+                                          <p:spTgt spid="11"/>
+                                        </p:tgtEl>
+                                        <p:attrNameLst>
+                                          <p:attrName>ppt_y</p:attrName>
+                                        </p:attrNameLst>
+                                      </p:cBhvr>
+                                      <p:tavLst>
+                                        <p:tav tm="0">
+                                          <p:val>
+                                            <p:strVal val="#ppt_y+.1"/>
+                                          </p:val>
+                                        </p:tav>
+                                        <p:tav tm="100000">
+                                          <p:val>
+                                            <p:strVal val="#ppt_y"/>
+                                          </p:val>
+                                        </p:tav>
+                                      </p:tavLst>
+                                    </p:anim>
+                                  </p:childTnLst>
+                                </p:cTn>
+                              </p:par>
+                            </p:childTnLst>
+                          </p:cTn>
+                        </p:par>
+                        <p:par>
+                          <p:cTn id="10" fill="hold">
+                            <p:stCondLst>
+                              <p:cond delay="1000"/>
+                            </p:stCondLst>
+                            <p:childTnLst>
+                              <p:par>
+                                <p:cTn id="11" presetID="42" presetClass="entr" presetSubtype="0" fill="hold" nodeType="afterEffect">
+                                  <p:stCondLst>
+                                    <p:cond delay="0"/>
+                                  </p:stCondLst>
+                                  <p:childTnLst>
+                                    <p:set>
+                                      <p:cBhvr>
+                                        <p:cTn id="12" dur="1" fill="hold">
+                                          <p:stCondLst>
+                                            <p:cond delay="0"/>
+                                          </p:stCondLst>
+                                        </p:cTn>
+                                        <p:tgtEl>
+                                          <p:spTgt spid="13"/>
+                                        </p:tgtEl>
+                                        <p:attrNameLst>
+                                          <p:attrName>style.visibility</p:attrName>
+                                        </p:attrNameLst>
+                                      </p:cBhvr>
+                                      <p:to>
+                                        <p:strVal val="visible"/>
+                                      </p:to>
+                                    </p:set>
+                                    <p:animEffect transition="in" filter="fade">
+                                      <p:cBhvr>
+                                        <p:cTn id="13" dur="1000"/>
+                                        <p:tgtEl>
+                                          <p:spTgt spid="13"/>
+                                        </p:tgtEl>
+                                      </p:cBhvr>
+                                    </p:animEffect>
+                                    <p:anim calcmode="lin" valueType="num">
+                                      <p:cBhvr>
+                                        <p:cTn id="14" dur="1000" fill="hold"/>
+                                        <p:tgtEl>
+                                          <p:spTgt spid="13"/>
+                                        </p:tgtEl>
+                                        <p:attrNameLst>
+                                          <p:attrName>ppt_x</p:attrName>
+                                        </p:attrNameLst>
+                                      </p:cBhvr>
+                                      <p:tavLst>
+                                        <p:tav tm="0">
+                                          <p:val>
+                                            <p:strVal val="#ppt_x"/>
+                                          </p:val>
+                                        </p:tav>
+                                        <p:tav tm="100000">
+                                          <p:val>
+                                            <p:strVal val="#ppt_x"/>
+                                          </p:val>
+                                        </p:tav>
+                                      </p:tavLst>
+                                    </p:anim>
+                                    <p:anim calcmode="lin" valueType="num">
+                                      <p:cBhvr>
+                                        <p:cTn id="15" dur="1000" fill="hold"/>
+                                        <p:tgtEl>
+                                          <p:spTgt spid="13"/>
+                                        </p:tgtEl>
+                                        <p:attrNameLst>
+                                          <p:attrName>ppt_y</p:attrName>
+                                        </p:attrNameLst>
+                                      </p:cBhvr>
+                                      <p:tavLst>
+                                        <p:tav tm="0">
+                                          <p:val>
+                                            <p:strVal val="#ppt_y+.1"/>
+                                          </p:val>
+                                        </p:tav>
+                                        <p:tav tm="100000">
+                                          <p:val>
+                                            <p:strVal val="#ppt_y"/>
+                                          </p:val>
+                                        </p:tav>
+                                      </p:tavLst>
+                                    </p:anim>
+                                  </p:childTnLst>
+                                </p:cTn>
+                              </p:par>
+                            </p:childTnLst>
+                          </p:cTn>
+                        </p:par>
+                        <p:par>
+                          <p:cTn id="16" fill="hold">
+                            <p:stCondLst>
+                              <p:cond delay="2000"/>
+                            </p:stCondLst>
+                            <p:childTnLst>
+                              <p:par>
+                                <p:cTn id="17" presetID="42" presetClass="entr" presetSubtype="0" fill="hold" nodeType="afterEffect">
+                                  <p:stCondLst>
+                                    <p:cond delay="0"/>
+                                  </p:stCondLst>
+                                  <p:childTnLst>
+                                    <p:set>
+                                      <p:cBhvr>
+                                        <p:cTn id="18" dur="1" fill="hold">
+                                          <p:stCondLst>
+                                            <p:cond delay="0"/>
+                                          </p:stCondLst>
+                                        </p:cTn>
+                                        <p:tgtEl>
+                                          <p:spTgt spid="7"/>
+                                        </p:tgtEl>
+                                        <p:attrNameLst>
+                                          <p:attrName>style.visibility</p:attrName>
+                                        </p:attrNameLst>
+                                      </p:cBhvr>
+                                      <p:to>
+                                        <p:strVal val="visible"/>
+                                      </p:to>
+                                    </p:set>
+                                    <p:animEffect transition="in" filter="fade">
+                                      <p:cBhvr>
+                                        <p:cTn id="19" dur="1000"/>
+                                        <p:tgtEl>
+                                          <p:spTgt spid="7"/>
+                                        </p:tgtEl>
+                                      </p:cBhvr>
+                                    </p:animEffect>
+                                    <p:anim calcmode="lin" valueType="num">
+                                      <p:cBhvr>
+                                        <p:cTn id="20" dur="1000" fill="hold"/>
+                                        <p:tgtEl>
+                                          <p:spTgt spid="7"/>
+                                        </p:tgtEl>
+                                        <p:attrNameLst>
+                                          <p:attrName>ppt_x</p:attrName>
+                                        </p:attrNameLst>
+                                      </p:cBhvr>
+                                      <p:tavLst>
+                                        <p:tav tm="0">
+                                          <p:val>
+                                            <p:strVal val="#ppt_x"/>
+                                          </p:val>
+                                        </p:tav>
+                                        <p:tav tm="100000">
+                                          <p:val>
+                                            <p:strVal val="#ppt_x"/>
+                                          </p:val>
+                                        </p:tav>
+                                      </p:tavLst>
+                                    </p:anim>
+                                    <p:anim calcmode="lin" valueType="num">
+                                      <p:cBhvr>
+                                        <p:cTn id="21" dur="1000" fill="hold"/>
+                                        <p:tgtEl>
+                                          <p:spTgt spid="7"/>
+                                        </p:tgtEl>
+                                        <p:attrNameLst>
+                                          <p:attrName>ppt_y</p:attrName>
+                                        </p:attrNameLst>
+                                      </p:cBhvr>
+                                      <p:tavLst>
+                                        <p:tav tm="0">
+                                          <p:val>
+                                            <p:strVal val="#ppt_y+.1"/>
+                                          </p:val>
+                                        </p:tav>
+                                        <p:tav tm="100000">
+                                          <p:val>
+                                            <p:strVal val="#ppt_y"/>
+                                          </p:val>
+                                        </p:tav>
+                                      </p:tavLst>
+                                    </p:anim>
+                                  </p:childTnLst>
+                                </p:cTn>
+                              </p:par>
+                            </p:childTnLst>
+                          </p:cTn>
+                        </p:par>
+                        <p:par>
+                          <p:cTn id="22" fill="hold">
+                            <p:stCondLst>
+                              <p:cond delay="3000"/>
+                            </p:stCondLst>
+                            <p:childTnLst>
+                              <p:par>
+                                <p:cTn id="23" presetID="42" presetClass="entr" presetSubtype="0" fill="hold" nodeType="afterEffect">
+                                  <p:stCondLst>
+                                    <p:cond delay="0"/>
+                                  </p:stCondLst>
+                                  <p:childTnLst>
+                                    <p:set>
+                                      <p:cBhvr>
+                                        <p:cTn id="24" dur="1" fill="hold">
+                                          <p:stCondLst>
+                                            <p:cond delay="0"/>
+                                          </p:stCondLst>
+                                        </p:cTn>
+                                        <p:tgtEl>
+                                          <p:spTgt spid="9"/>
+                                        </p:tgtEl>
+                                        <p:attrNameLst>
+                                          <p:attrName>style.visibility</p:attrName>
+                                        </p:attrNameLst>
+                                      </p:cBhvr>
+                                      <p:to>
+                                        <p:strVal val="visible"/>
+                                      </p:to>
+                                    </p:set>
+                                    <p:animEffect transition="in" filter="fade">
+                                      <p:cBhvr>
+                                        <p:cTn id="25" dur="1000"/>
+                                        <p:tgtEl>
+                                          <p:spTgt spid="9"/>
+                                        </p:tgtEl>
+                                      </p:cBhvr>
+                                    </p:animEffect>
+                                    <p:anim calcmode="lin" valueType="num">
+                                      <p:cBhvr>
+                                        <p:cTn id="26" dur="1000" fill="hold"/>
+                                        <p:tgtEl>
+                                          <p:spTgt spid="9"/>
+                                        </p:tgtEl>
+                                        <p:attrNameLst>
+                                          <p:attrName>ppt_x</p:attrName>
+                                        </p:attrNameLst>
+                                      </p:cBhvr>
+                                      <p:tavLst>
+                                        <p:tav tm="0">
+                                          <p:val>
+                                            <p:strVal val="#ppt_x"/>
+                                          </p:val>
+                                        </p:tav>
+                                        <p:tav tm="100000">
+                                          <p:val>
+                                            <p:strVal val="#ppt_x"/>
+                                          </p:val>
+                                        </p:tav>
+                                      </p:tavLst>
+                                    </p:anim>
+                                    <p:anim calcmode="lin" valueType="num">
+                                      <p:cBhvr>
+                                        <p:cTn id="27" dur="1000" fill="hold"/>
+                                        <p:tgtEl>
+                                          <p:spTgt spid="9"/>
+                                        </p:tgtEl>
+                                        <p:attrNameLst>
+                                          <p:attrName>ppt_y</p:attrName>
+                                        </p:attrNameLst>
+                                      </p:cBhvr>
+                                      <p:tavLst>
+                                        <p:tav tm="0">
+                                          <p:val>
+                                            <p:strVal val="#ppt_y+.1"/>
+                                          </p:val>
+                                        </p:tav>
+                                        <p:tav tm="100000">
+                                          <p:val>
+                                            <p:strVal val="#ppt_y"/>
+                                          </p:val>
+                                        </p:tav>
+                                      </p:tavLst>
+                                    </p:anim>
+                                  </p:childTnLst>
+                                </p:cTn>
+                              </p:par>
+                            </p:childTnLst>
+                          </p:cTn>
+                        </p:par>
+                      </p:childTnLst>
+                    </p:cTn>
+                  </p:par>
+                </p:childTnLst>
+              </p:cTn>
+              <p:prevCondLst>
+                <p:cond evt="onPrev" delay="0">
+                  <p:tgtEl>
+                    <p:sldTgt/>
+                  </p:tgtEl>
+                </p:cond>
+              </p:prevCondLst>
+              <p:nextCondLst>
+                <p:cond evt="onNext" delay="0">
+                  <p:tgtEl>
+                    <p:sldTgt/>
+                  </p:tgtEl>
+                </p:cond>
+              </p:nextCondLst>
+            </p:seq>
+          </p:childTnLst>
+        </p:cTn>
+      </p:par>
+    </p:tnLst>
+  </p:timing>
+</p:sld>
+</file>
+
+<file path=ppt/slides/slide5.xml><?xml version="1.0" encoding="utf-8"?>
+<p:sld xmlns:a="http://schemas.openxmlformats.org/drawingml/2006/main" xmlns:r="http://schemas.openxmlformats.org/officeDocument/2006/relationships" xmlns:p="http://schemas.openxmlformats.org/presentationml/2006/main" show="0">
+  <p:cSld>
+    <p:spTree>
+      <p:nvGrpSpPr>
+        <p:cNvPr id="1" name=""/>
+        <p:cNvGrpSpPr/>
+        <p:nvPr/>
+      </p:nvGrpSpPr>
+      <p:grpSpPr>
+        <a:xfrm>
+          <a:off x="0" y="0"/>
+          <a:ext cx="0" cy="0"/>
+          <a:chOff x="0" y="0"/>
+          <a:chExt cx="0" cy="0"/>
+        </a:xfrm>
+      </p:grpSpPr>
+      <p:sp>
+        <p:nvSpPr>
+          <p:cNvPr id="2" name="Title 1">
+            <a:extLst>
+              <a:ext uri="{FF2B5EF4-FFF2-40B4-BE49-F238E27FC236}">
+                <a16:creationId xmlns:a16="http://schemas.microsoft.com/office/drawing/2014/main" id="{1C52F4B3-035B-A1FF-2F05-763397A7F4C9}"/>
+              </a:ext>
+            </a:extLst>
+          </p:cNvPr>
+          <p:cNvSpPr>
+            <a:spLocks noGrp="1"/>
+          </p:cNvSpPr>
+          <p:nvPr>
+            <p:ph type="title"/>
+          </p:nvPr>
+        </p:nvSpPr>
+        <p:spPr/>
+        <p:txBody>
+          <a:bodyPr/>
+          <a:lstStyle/>
+          <a:p>
+            <a:endParaRPr lang="cs-CZ" dirty="0"/>
+          </a:p>
+        </p:txBody>
+      </p:sp>
+      <p:sp>
+        <p:nvSpPr>
+          <p:cNvPr id="3" name="Content Placeholder 2">
+            <a:extLst>
+              <a:ext uri="{FF2B5EF4-FFF2-40B4-BE49-F238E27FC236}">
+                <a16:creationId xmlns:a16="http://schemas.microsoft.com/office/drawing/2014/main" id="{4AC64387-3FD7-3EF0-2F93-3902CAD585A0}"/>
+              </a:ext>
+            </a:extLst>
+          </p:cNvPr>
+          <p:cNvSpPr>
+            <a:spLocks noGrp="1"/>
+          </p:cNvSpPr>
+          <p:nvPr>
+            <p:ph idx="1"/>
+          </p:nvPr>
+        </p:nvSpPr>
+        <p:spPr/>
+        <p:txBody>
+          <a:bodyPr>
+            <a:normAutofit fontScale="77500" lnSpcReduction="20000"/>
+          </a:bodyPr>
+          <a:lstStyle/>
+          <a:p>
+            <a:pPr marL="0" indent="0">
+              <a:buNone/>
+            </a:pPr>
+            <a:r>
+              <a:rPr lang="cs-CZ" dirty="0"/>
+              <a:t>Hlavní vlastnosti </a:t>
+            </a:r>
+            <a:r>
+              <a:rPr lang="cs-CZ" dirty="0" err="1"/>
+              <a:t>Rustu</a:t>
+            </a:r>
+            <a:r>
+              <a:rPr lang="cs-CZ" dirty="0"/>
+              <a:t>:</a:t>
+            </a:r>
+          </a:p>
+          <a:p>
+            <a:r>
+              <a:rPr lang="cs-CZ" dirty="0"/>
+              <a:t>hluboce integrovaný statický analyzátor (</a:t>
+            </a:r>
+            <a:r>
+              <a:rPr lang="cs-CZ" dirty="0" err="1"/>
+              <a:t>borrow</a:t>
+            </a:r>
+            <a:r>
+              <a:rPr lang="cs-CZ" dirty="0"/>
+              <a:t> checker), koncept vlastnictví</a:t>
+            </a:r>
+          </a:p>
+          <a:p>
+            <a:pPr lvl="1"/>
+            <a:r>
+              <a:rPr lang="cs-CZ" dirty="0"/>
+              <a:t>"pokud se to zkompiluje, tak to poběží"</a:t>
+            </a:r>
+          </a:p>
+          <a:p>
+            <a:r>
+              <a:rPr lang="cs-CZ" dirty="0"/>
+              <a:t>deterministická správa paměti bez náhodných pauz pro "paměťového popeláře" --&gt; efektivita</a:t>
+            </a:r>
+          </a:p>
+          <a:p>
+            <a:r>
+              <a:rPr lang="cs-CZ" dirty="0"/>
+              <a:t>generické funkce a typy, systém </a:t>
+            </a:r>
+            <a:r>
+              <a:rPr lang="cs-CZ" dirty="0" err="1"/>
+              <a:t>traitů</a:t>
+            </a:r>
+            <a:r>
+              <a:rPr lang="cs-CZ" dirty="0"/>
+              <a:t> poskytující garanci vlastností a schopností namísto OOP --&gt; vhodné pro procedurální paradigma</a:t>
+            </a:r>
+          </a:p>
+          <a:p>
+            <a:r>
+              <a:rPr lang="cs-CZ" dirty="0"/>
+              <a:t>chyby jako hodnoty – sjednocené paradigma zpracovávání chyb pomocí algebraických datových typů (</a:t>
+            </a:r>
+            <a:r>
+              <a:rPr lang="cs-CZ" dirty="0" err="1"/>
+              <a:t>enumy</a:t>
+            </a:r>
+            <a:r>
+              <a:rPr lang="cs-CZ" dirty="0"/>
+              <a:t> s daty), žádné zapomenuté </a:t>
+            </a:r>
+            <a:r>
+              <a:rPr lang="cs-CZ" dirty="0" err="1"/>
+              <a:t>if</a:t>
+            </a:r>
+            <a:r>
+              <a:rPr lang="cs-CZ" dirty="0"/>
+              <a:t> (</a:t>
+            </a:r>
+            <a:r>
+              <a:rPr lang="cs-CZ" dirty="0" err="1"/>
+              <a:t>ptr</a:t>
+            </a:r>
+            <a:r>
+              <a:rPr lang="cs-CZ" dirty="0"/>
+              <a:t> != </a:t>
+            </a:r>
+            <a:r>
+              <a:rPr lang="cs-CZ" dirty="0" err="1"/>
+              <a:t>nullptr</a:t>
+            </a:r>
+            <a:r>
+              <a:rPr lang="cs-CZ" dirty="0"/>
+              <a:t>)</a:t>
+            </a:r>
+          </a:p>
+          <a:p>
+            <a:r>
+              <a:rPr lang="cs-CZ" dirty="0"/>
+              <a:t>politika abstrakce bez dopadu na výkon ("manuálně bys to nenapsal lépe")</a:t>
+            </a:r>
+          </a:p>
+          <a:p>
+            <a:r>
+              <a:rPr lang="cs-CZ" dirty="0"/>
+              <a:t>sjednocený systém pro sestavování a správce balíčků</a:t>
+            </a:r>
+          </a:p>
+          <a:p>
+            <a:r>
+              <a:rPr lang="cs-CZ" dirty="0"/>
+              <a:t>dobře čitelné chybové hlášky</a:t>
+            </a:r>
+          </a:p>
+          <a:p>
+            <a:r>
+              <a:rPr lang="cs-CZ" dirty="0"/>
+              <a:t>(okrajově) podpora pro bezpečnější a jednoduší souběžnost</a:t>
+            </a:r>
+          </a:p>
+        </p:txBody>
+      </p:sp>
+    </p:spTree>
+    <p:extLst>
+      <p:ext uri="{BB962C8B-B14F-4D97-AF65-F5344CB8AC3E}">
+        <p14:creationId xmlns:p14="http://schemas.microsoft.com/office/powerpoint/2010/main" val="3860842770"/>
+      </p:ext>
+    </p:extLst>
+  </p:cSld>
+  <p:clrMapOvr>
+    <a:masterClrMapping/>
+  </p:clrMapOvr>
+</p:sld>
+</file>
+
+<file path=ppt/slides/slide6.xml><?xml version="1.0" encoding="utf-8"?>
 <p:sld xmlns:a="http://schemas.openxmlformats.org/drawingml/2006/main" xmlns:r="http://schemas.openxmlformats.org/officeDocument/2006/relationships" xmlns:p="http://schemas.openxmlformats.org/presentationml/2006/main">
   <p:cSld>
     <p:spTree>
@@ -4259,7 +6054,10 @@
           <a:bodyPr/>
           <a:lstStyle/>
           <a:p>
-            <a:endParaRPr lang="cs-CZ"/>
+            <a:r>
+              <a:rPr lang="cs-CZ" dirty="0"/>
+              <a:t>Rust</a:t>
+            </a:r>
           </a:p>
         </p:txBody>
       </p:sp>
@@ -4281,17 +6079,280 @@
         </p:nvSpPr>
         <p:spPr/>
         <p:txBody>
-          <a:bodyPr/>
-          <a:lstStyle/>
-          <a:p>
-            <a:endParaRPr lang="cs-CZ"/>
-          </a:p>
-        </p:txBody>
-      </p:sp>
+          <a:bodyPr>
+            <a:normAutofit/>
+          </a:bodyPr>
+          <a:lstStyle/>
+          <a:p>
+            <a:r>
+              <a:rPr lang="cs-CZ" dirty="0"/>
+              <a:t>Moderní (m.j.) systémový programovací jazyk</a:t>
+            </a:r>
+          </a:p>
+          <a:p>
+            <a:pPr lvl="1"/>
+            <a:r>
+              <a:rPr lang="cs-CZ" dirty="0"/>
+              <a:t>Relativně </a:t>
+            </a:r>
+            <a:r>
+              <a:rPr lang="cs-CZ" dirty="0" err="1"/>
+              <a:t>nízkoúrovňový</a:t>
+            </a:r>
+            <a:r>
+              <a:rPr lang="cs-CZ" dirty="0"/>
+              <a:t>, výkonný, přesto poskytuje abstrakci</a:t>
+            </a:r>
+          </a:p>
+          <a:p>
+            <a:pPr lvl="1"/>
+            <a:r>
+              <a:rPr lang="cs-CZ" dirty="0"/>
+              <a:t>Odstup času =&gt; vyhnutí se starým chybám</a:t>
+            </a:r>
+          </a:p>
+          <a:p>
+            <a:r>
+              <a:rPr lang="cs-CZ" dirty="0"/>
+              <a:t>Hluboce integrovaný statický analyzátor – </a:t>
+            </a:r>
+            <a:r>
+              <a:rPr lang="cs-CZ" dirty="0" err="1"/>
+              <a:t>borrow</a:t>
+            </a:r>
+            <a:r>
+              <a:rPr lang="cs-CZ" dirty="0"/>
+              <a:t> checker</a:t>
+            </a:r>
+          </a:p>
+          <a:p>
+            <a:pPr lvl="1"/>
+            <a:r>
+              <a:rPr lang="cs-CZ" dirty="0"/>
+              <a:t>Koncept vlastnictví a životností =&gt; paměťová bezpečnost</a:t>
+            </a:r>
+          </a:p>
+          <a:p>
+            <a:r>
+              <a:rPr lang="cs-CZ" dirty="0"/>
+              <a:t>Chyby jako hodnoty =&gt; explicitní</a:t>
+            </a:r>
+          </a:p>
+          <a:p>
+            <a:r>
+              <a:rPr lang="cs-CZ" dirty="0"/>
+              <a:t>Generické programování, systém </a:t>
+            </a:r>
+            <a:r>
+              <a:rPr lang="cs-CZ" dirty="0" err="1"/>
+              <a:t>traitů</a:t>
+            </a:r>
+            <a:endParaRPr lang="cs-CZ" dirty="0"/>
+          </a:p>
+          <a:p>
+            <a:r>
+              <a:rPr lang="cs-CZ" dirty="0"/>
+              <a:t>Kvalitní nástroje</a:t>
+            </a:r>
+          </a:p>
+          <a:p>
+            <a:r>
+              <a:rPr lang="cs-CZ" dirty="0"/>
+              <a:t>Od roku 2016 „nejmilovanější“ jazyk v průzkumech</a:t>
+            </a:r>
+          </a:p>
+        </p:txBody>
+      </p:sp>
+      <p:pic>
+        <p:nvPicPr>
+          <p:cNvPr id="11" name="Graphic 10">
+            <a:extLst>
+              <a:ext uri="{FF2B5EF4-FFF2-40B4-BE49-F238E27FC236}">
+                <a16:creationId xmlns:a16="http://schemas.microsoft.com/office/drawing/2014/main" id="{095BDB74-733A-FDE2-A739-0DE3B915B489}"/>
+              </a:ext>
+            </a:extLst>
+          </p:cNvPr>
+          <p:cNvPicPr>
+            <a:picLocks noChangeAspect="1"/>
+          </p:cNvPicPr>
+          <p:nvPr/>
+        </p:nvPicPr>
+        <p:blipFill>
+          <a:blip>
+            <a:extLst>
+              <a:ext uri="{96DAC541-7B7A-43D3-8B79-37D633B846F1}">
+                <asvg:svgBlip xmlns:asvg="http://schemas.microsoft.com/office/drawing/2016/SVG/main" r:embed="rId4"/>
+              </a:ext>
+            </a:extLst>
+          </a:blip>
+          <a:stretch>
+            <a:fillRect/>
+          </a:stretch>
+        </p:blipFill>
+        <p:spPr>
+          <a:xfrm>
+            <a:off x="9337040" y="-4763"/>
+            <a:ext cx="2854960" cy="2854960"/>
+          </a:xfrm>
+          <a:prstGeom prst="rect">
+            <a:avLst/>
+          </a:prstGeom>
+        </p:spPr>
+      </p:pic>
     </p:spTree>
     <p:extLst>
       <p:ext uri="{BB962C8B-B14F-4D97-AF65-F5344CB8AC3E}">
         <p14:creationId xmlns:p14="http://schemas.microsoft.com/office/powerpoint/2010/main" val="1682549852"/>
+      </p:ext>
+    </p:extLst>
+  </p:cSld>
+  <p:clrMapOvr>
+    <a:masterClrMapping/>
+  </p:clrMapOvr>
+  <p:extLst>
+    <p:ext uri="{6950BFC3-D8DA-4A85-94F7-54DA5524770B}">
+      <p188:commentRel xmlns:p188="http://schemas.microsoft.com/office/powerpoint/2018/8/main" r:id="rId3"/>
+    </p:ext>
+  </p:extLst>
+</p:sld>
+</file>
+
+<file path=ppt/slides/slide7.xml><?xml version="1.0" encoding="utf-8"?>
+<p:sld xmlns:a="http://schemas.openxmlformats.org/drawingml/2006/main" xmlns:r="http://schemas.openxmlformats.org/officeDocument/2006/relationships" xmlns:p="http://schemas.openxmlformats.org/presentationml/2006/main">
+  <p:cSld>
+    <p:bg>
+      <p:bgPr>
+        <a:solidFill>
+          <a:schemeClr val="bg1"/>
+        </a:solidFill>
+        <a:effectLst/>
+      </p:bgPr>
+    </p:bg>
+    <p:spTree>
+      <p:nvGrpSpPr>
+        <p:cNvPr id="1" name=""/>
+        <p:cNvGrpSpPr/>
+        <p:nvPr/>
+      </p:nvGrpSpPr>
+      <p:grpSpPr>
+        <a:xfrm>
+          <a:off x="0" y="0"/>
+          <a:ext cx="0" cy="0"/>
+          <a:chOff x="0" y="0"/>
+          <a:chExt cx="0" cy="0"/>
+        </a:xfrm>
+      </p:grpSpPr>
+      <p:sp>
+        <p:nvSpPr>
+          <p:cNvPr id="2" name="Title 1">
+            <a:extLst>
+              <a:ext uri="{FF2B5EF4-FFF2-40B4-BE49-F238E27FC236}">
+                <a16:creationId xmlns:a16="http://schemas.microsoft.com/office/drawing/2014/main" id="{B6E20D0D-91F3-3401-70D1-3692CC0CB431}"/>
+              </a:ext>
+            </a:extLst>
+          </p:cNvPr>
+          <p:cNvSpPr>
+            <a:spLocks noGrp="1"/>
+          </p:cNvSpPr>
+          <p:nvPr>
+            <p:ph type="title"/>
+          </p:nvPr>
+        </p:nvSpPr>
+        <p:spPr/>
+        <p:txBody>
+          <a:bodyPr>
+            <a:normAutofit/>
+          </a:bodyPr>
+          <a:lstStyle/>
+          <a:p>
+            <a:r>
+              <a:rPr lang="cs-CZ" dirty="0" err="1"/>
+              <a:t>Trait</a:t>
+            </a:r>
+            <a:endParaRPr lang="cs-CZ" dirty="0"/>
+          </a:p>
+        </p:txBody>
+      </p:sp>
+      <p:sp>
+        <p:nvSpPr>
+          <p:cNvPr id="13" name="Content Placeholder 12">
+            <a:extLst>
+              <a:ext uri="{FF2B5EF4-FFF2-40B4-BE49-F238E27FC236}">
+                <a16:creationId xmlns:a16="http://schemas.microsoft.com/office/drawing/2014/main" id="{56BD78AD-DE34-6F3B-2EB1-21CEF2C4D241}"/>
+              </a:ext>
+            </a:extLst>
+          </p:cNvPr>
+          <p:cNvSpPr>
+            <a:spLocks noGrp="1"/>
+          </p:cNvSpPr>
+          <p:nvPr>
+            <p:ph sz="half" idx="1"/>
+          </p:nvPr>
+        </p:nvSpPr>
+        <p:spPr/>
+        <p:txBody>
+          <a:bodyPr>
+            <a:normAutofit/>
+          </a:bodyPr>
+          <a:lstStyle/>
+          <a:p>
+            <a:r>
+              <a:rPr lang="cs-CZ" sz="2000" dirty="0"/>
+              <a:t>„rys, vlastnost, příznak“</a:t>
+            </a:r>
+          </a:p>
+          <a:p>
+            <a:r>
+              <a:rPr lang="cs-CZ" sz="2000" dirty="0" err="1"/>
+              <a:t>Aaa</a:t>
+            </a:r>
+            <a:endParaRPr lang="en-US" sz="2000" dirty="0"/>
+          </a:p>
+        </p:txBody>
+      </p:sp>
+      <p:pic>
+        <p:nvPicPr>
+          <p:cNvPr id="12" name="Content Placeholder 11">
+            <a:extLst>
+              <a:ext uri="{FF2B5EF4-FFF2-40B4-BE49-F238E27FC236}">
+                <a16:creationId xmlns:a16="http://schemas.microsoft.com/office/drawing/2014/main" id="{5A741EA8-998F-82FA-FF60-505A4104C9D2}"/>
+              </a:ext>
+            </a:extLst>
+          </p:cNvPr>
+          <p:cNvPicPr>
+            <a:picLocks noGrp="1" noChangeAspect="1"/>
+          </p:cNvPicPr>
+          <p:nvPr>
+            <p:ph sz="half" idx="2"/>
+          </p:nvPr>
+        </p:nvPicPr>
+        <p:blipFill>
+          <a:blip r:embed="rId3">
+            <a:extLst>
+              <a:ext uri="{28A0092B-C50C-407E-A947-70E740481C1C}">
+                <a14:useLocalDpi xmlns:a14="http://schemas.microsoft.com/office/drawing/2010/main" val="0"/>
+              </a:ext>
+            </a:extLst>
+          </a:blip>
+          <a:srcRect l="1913" t="2798" r="3700" b="1683"/>
+          <a:stretch>
+            <a:fillRect/>
+          </a:stretch>
+        </p:blipFill>
+        <p:spPr>
+          <a:xfrm>
+            <a:off x="6172202" y="365125"/>
+            <a:ext cx="5392420" cy="6127750"/>
+          </a:xfrm>
+          <a:prstGeom prst="rect">
+            <a:avLst/>
+          </a:prstGeom>
+        </p:spPr>
+      </p:pic>
+    </p:spTree>
+    <p:extLst>
+      <p:ext uri="{BB962C8B-B14F-4D97-AF65-F5344CB8AC3E}">
+        <p14:creationId xmlns:p14="http://schemas.microsoft.com/office/powerpoint/2010/main" val="298307023"/>
       </p:ext>
     </p:extLst>
   </p:cSld>

</xml_diff>

<commit_message>
WIP: Tweaks to docs, worked on presentation
</commit_message>
<xml_diff>
--- a/Prezentace.pptx
+++ b/Prezentace.pptx
@@ -128,6 +128,9 @@
         </p15:guide>
       </p15:sldGuideLst>
     </p:ext>
+    <p:ext uri="{2D200454-40CA-4A62-9FC3-DE9A4176ACB9}">
+      <p15:notesGuideLst xmlns:p15="http://schemas.microsoft.com/office/powerpoint/2012/main"/>
+    </p:ext>
   </p:extLst>
 </p:presentation>
 </file>
@@ -177,7 +180,7 @@
       <a:p>
         <a:r>
           <a:rPr lang="cs-CZ"/>
-          <a:t>Technicky vzato víceúčelový, ale když prodáváš auto, nechlubíš se tím, že tě umí odvézt z bodu A do bodu B, ale tím, čím se odlišuje...</a:t>
+          <a:t>Technicky vzato víceúčelový, ale když prodáváš auto, nechlubíš se tím, že tě umí odvézt z bodu A do bodu B...</a:t>
         </a:r>
       </a:p>
     </p188:txBody>
@@ -267,7 +270,7 @@
           <a:p>
             <a:fld id="{015F5405-DF1B-4076-864B-7962BED0FCA9}" type="datetimeFigureOut">
               <a:rPr lang="cs-CZ" smtClean="0"/>
-              <a:t>28.03.2026</a:t>
+              <a:t>29.03.2026</a:t>
             </a:fld>
             <a:endParaRPr lang="cs-CZ"/>
           </a:p>
@@ -1340,7 +1343,288 @@
             </a:r>
             <a:r>
               <a:rPr lang="cs-CZ" dirty="0"/>
-              <a:t> jsou „rysy“, „vlastnosti“ nebo „příznaky“ typů definující sdílené chování a rozhraní = vlastnosti a funkce pracující s danými typy</a:t>
+              <a:t>, česky „rysy“, „vlastnosti“ nebo „příznaky“, definují abstraktní chování datových typů</a:t>
+            </a:r>
+          </a:p>
+          <a:p>
+            <a:pPr marL="171450" marR="0" lvl="0" indent="-171450" algn="l" defTabSz="914400" rtl="0" eaLnBrk="1" fontAlgn="auto" latinLnBrk="0" hangingPunct="1">
+              <a:lnSpc>
+                <a:spcPct val="100000"/>
+              </a:lnSpc>
+              <a:spcBef>
+                <a:spcPts val="0"/>
+              </a:spcBef>
+              <a:spcAft>
+                <a:spcPts val="0"/>
+              </a:spcAft>
+              <a:buClrTx/>
+              <a:buSzTx/>
+              <a:buFont typeface="Arial" panose="020B0604020202020204" pitchFamily="34" charset="0"/>
+              <a:buChar char="•"/>
+              <a:tabLst/>
+              <a:defRPr/>
+            </a:pPr>
+            <a:r>
+              <a:rPr lang="cs-CZ" dirty="0"/>
+              <a:t>Implementace daného </a:t>
+            </a:r>
+            <a:r>
+              <a:rPr lang="cs-CZ" dirty="0" err="1"/>
+              <a:t>traitu</a:t>
+            </a:r>
+            <a:r>
+              <a:rPr lang="cs-CZ" dirty="0"/>
+              <a:t> garantuje, že daný typ má určité vlastnosti a implementuje určité metody</a:t>
+            </a:r>
+          </a:p>
+          <a:p>
+            <a:pPr marL="171450" marR="0" lvl="0" indent="-171450" algn="l" defTabSz="914400" rtl="0" eaLnBrk="1" fontAlgn="auto" latinLnBrk="0" hangingPunct="1">
+              <a:lnSpc>
+                <a:spcPct val="100000"/>
+              </a:lnSpc>
+              <a:spcBef>
+                <a:spcPts val="0"/>
+              </a:spcBef>
+              <a:spcAft>
+                <a:spcPts val="0"/>
+              </a:spcAft>
+              <a:buClrTx/>
+              <a:buSzTx/>
+              <a:buFont typeface="Arial" panose="020B0604020202020204" pitchFamily="34" charset="0"/>
+              <a:buChar char="•"/>
+              <a:tabLst/>
+              <a:defRPr/>
+            </a:pPr>
+            <a:r>
+              <a:rPr lang="cs-CZ" dirty="0"/>
+              <a:t>    (metody = funkce pracující s daty uvnitř daného typu, nejčastěji struktury, asociované s daným typem)</a:t>
+            </a:r>
+          </a:p>
+          <a:p>
+            <a:pPr marL="171450" marR="0" lvl="0" indent="-171450" algn="l" defTabSz="914400" rtl="0" eaLnBrk="1" fontAlgn="auto" latinLnBrk="0" hangingPunct="1">
+              <a:lnSpc>
+                <a:spcPct val="100000"/>
+              </a:lnSpc>
+              <a:spcBef>
+                <a:spcPts val="0"/>
+              </a:spcBef>
+              <a:spcAft>
+                <a:spcPts val="0"/>
+              </a:spcAft>
+              <a:buClrTx/>
+              <a:buSzTx/>
+              <a:buFont typeface="Arial" panose="020B0604020202020204" pitchFamily="34" charset="0"/>
+              <a:buChar char="•"/>
+              <a:tabLst/>
+              <a:defRPr/>
+            </a:pPr>
+            <a:r>
+              <a:rPr lang="cs-CZ" dirty="0"/>
+              <a:t>Chování je u všech typů implementujících daný </a:t>
+            </a:r>
+            <a:r>
+              <a:rPr lang="cs-CZ" dirty="0" err="1"/>
+              <a:t>trait</a:t>
+            </a:r>
+            <a:r>
+              <a:rPr lang="cs-CZ" dirty="0"/>
+              <a:t> sémanticky stejné, i když samotné implementace v kódu se mohou lišit</a:t>
+            </a:r>
+          </a:p>
+          <a:p>
+            <a:pPr marL="0" marR="0" lvl="0" indent="0" algn="l" defTabSz="914400" rtl="0" eaLnBrk="1" fontAlgn="auto" latinLnBrk="0" hangingPunct="1">
+              <a:lnSpc>
+                <a:spcPct val="100000"/>
+              </a:lnSpc>
+              <a:spcBef>
+                <a:spcPts val="0"/>
+              </a:spcBef>
+              <a:spcAft>
+                <a:spcPts val="0"/>
+              </a:spcAft>
+              <a:buClrTx/>
+              <a:buSzTx/>
+              <a:buFont typeface="Arial" panose="020B0604020202020204" pitchFamily="34" charset="0"/>
+              <a:buNone/>
+              <a:tabLst/>
+              <a:defRPr/>
+            </a:pPr>
+            <a:endParaRPr lang="cs-CZ" dirty="0"/>
+          </a:p>
+          <a:p>
+            <a:pPr marL="0" marR="0" lvl="0" indent="0" algn="l" defTabSz="914400" rtl="0" eaLnBrk="1" fontAlgn="auto" latinLnBrk="0" hangingPunct="1">
+              <a:lnSpc>
+                <a:spcPct val="100000"/>
+              </a:lnSpc>
+              <a:spcBef>
+                <a:spcPts val="0"/>
+              </a:spcBef>
+              <a:spcAft>
+                <a:spcPts val="0"/>
+              </a:spcAft>
+              <a:buClrTx/>
+              <a:buSzTx/>
+              <a:buFont typeface="Arial" panose="020B0604020202020204" pitchFamily="34" charset="0"/>
+              <a:buNone/>
+              <a:tabLst/>
+              <a:defRPr/>
+            </a:pPr>
+            <a:r>
+              <a:rPr lang="cs-CZ" dirty="0"/>
+              <a:t>Využití 1: Funkce „univerzální“ (přesněji řečeno generické) přes různé typy</a:t>
+            </a:r>
+          </a:p>
+          <a:p>
+            <a:pPr marL="171450" marR="0" lvl="0" indent="-171450" algn="l" defTabSz="914400" rtl="0" eaLnBrk="1" fontAlgn="auto" latinLnBrk="0" hangingPunct="1">
+              <a:lnSpc>
+                <a:spcPct val="100000"/>
+              </a:lnSpc>
+              <a:spcBef>
+                <a:spcPts val="0"/>
+              </a:spcBef>
+              <a:spcAft>
+                <a:spcPts val="0"/>
+              </a:spcAft>
+              <a:buClrTx/>
+              <a:buSzTx/>
+              <a:buFont typeface="Arial" panose="020B0604020202020204" pitchFamily="34" charset="0"/>
+              <a:buChar char="•"/>
+              <a:tabLst/>
+              <a:defRPr/>
+            </a:pPr>
+            <a:r>
+              <a:rPr lang="cs-CZ" dirty="0"/>
+              <a:t>Některé operace na určitých typech prostě nedávají smysl: </a:t>
+            </a:r>
+            <a:r>
+              <a:rPr lang="pt-BR" dirty="0"/>
+              <a:t>nelze se doptávat na 5. prvek v</a:t>
+            </a:r>
+            <a:r>
+              <a:rPr lang="cs-CZ" dirty="0"/>
+              <a:t> </a:t>
+            </a:r>
+            <a:r>
+              <a:rPr lang="cs-CZ" dirty="0" err="1"/>
+              <a:t>booleanu</a:t>
+            </a:r>
+            <a:endParaRPr lang="cs-CZ" dirty="0"/>
+          </a:p>
+          <a:p>
+            <a:pPr marL="171450" marR="0" lvl="0" indent="-171450" algn="l" defTabSz="914400" rtl="0" eaLnBrk="1" fontAlgn="auto" latinLnBrk="0" hangingPunct="1">
+              <a:lnSpc>
+                <a:spcPct val="100000"/>
+              </a:lnSpc>
+              <a:spcBef>
+                <a:spcPts val="0"/>
+              </a:spcBef>
+              <a:spcAft>
+                <a:spcPts val="0"/>
+              </a:spcAft>
+              <a:buClrTx/>
+              <a:buSzTx/>
+              <a:buFont typeface="Arial" panose="020B0604020202020204" pitchFamily="34" charset="0"/>
+              <a:buChar char="•"/>
+              <a:tabLst/>
+              <a:defRPr/>
+            </a:pPr>
+            <a:r>
+              <a:rPr lang="cs-CZ" dirty="0" err="1"/>
+              <a:t>Traity</a:t>
+            </a:r>
+            <a:r>
+              <a:rPr lang="cs-CZ" dirty="0"/>
+              <a:t> pomáhají omezovat </a:t>
+            </a:r>
+            <a:r>
+              <a:rPr lang="cs-CZ"/>
+              <a:t>generické parametry </a:t>
+            </a:r>
+            <a:r>
+              <a:rPr lang="cs-CZ" dirty="0"/>
+              <a:t>na pouze ty typy, které mají určité vlastnosti, které daná funkce vyžaduje</a:t>
+            </a:r>
+          </a:p>
+          <a:p>
+            <a:pPr marL="171450" marR="0" lvl="0" indent="-171450" algn="l" defTabSz="914400" rtl="0" eaLnBrk="1" fontAlgn="auto" latinLnBrk="0" hangingPunct="1">
+              <a:lnSpc>
+                <a:spcPct val="100000"/>
+              </a:lnSpc>
+              <a:spcBef>
+                <a:spcPts val="0"/>
+              </a:spcBef>
+              <a:spcAft>
+                <a:spcPts val="0"/>
+              </a:spcAft>
+              <a:buClrTx/>
+              <a:buSzTx/>
+              <a:buFont typeface="Arial" panose="020B0604020202020204" pitchFamily="34" charset="0"/>
+              <a:buChar char="•"/>
+              <a:tabLst/>
+              <a:defRPr/>
+            </a:pPr>
+            <a:r>
+              <a:rPr lang="cs-CZ" dirty="0"/>
+              <a:t>Příklad na obrázku: funkce nemůže přijmout zcela jakýkoli typ, ale pouze takový, který lze porovnávat (</a:t>
+            </a:r>
+            <a:r>
+              <a:rPr lang="cs-CZ" dirty="0" err="1"/>
+              <a:t>trait</a:t>
+            </a:r>
+            <a:r>
+              <a:rPr lang="cs-CZ" dirty="0"/>
+              <a:t> </a:t>
+            </a:r>
+            <a:r>
+              <a:rPr lang="cs-CZ" dirty="0" err="1"/>
+              <a:t>PartialOrd</a:t>
+            </a:r>
+            <a:r>
+              <a:rPr lang="cs-CZ" dirty="0"/>
+              <a:t>)</a:t>
+            </a:r>
+          </a:p>
+          <a:p>
+            <a:pPr marL="0" marR="0" lvl="0" indent="0" algn="l" defTabSz="914400" rtl="0" eaLnBrk="1" fontAlgn="auto" latinLnBrk="0" hangingPunct="1">
+              <a:lnSpc>
+                <a:spcPct val="100000"/>
+              </a:lnSpc>
+              <a:spcBef>
+                <a:spcPts val="0"/>
+              </a:spcBef>
+              <a:spcAft>
+                <a:spcPts val="0"/>
+              </a:spcAft>
+              <a:buClrTx/>
+              <a:buSzTx/>
+              <a:buFont typeface="Arial" panose="020B0604020202020204" pitchFamily="34" charset="0"/>
+              <a:buNone/>
+              <a:tabLst/>
+              <a:defRPr/>
+            </a:pPr>
+            <a:endParaRPr lang="cs-CZ" dirty="0"/>
+          </a:p>
+          <a:p>
+            <a:pPr marL="0" marR="0" lvl="0" indent="0" algn="l" defTabSz="914400" rtl="0" eaLnBrk="1" fontAlgn="auto" latinLnBrk="0" hangingPunct="1">
+              <a:lnSpc>
+                <a:spcPct val="100000"/>
+              </a:lnSpc>
+              <a:spcBef>
+                <a:spcPts val="0"/>
+              </a:spcBef>
+              <a:spcAft>
+                <a:spcPts val="0"/>
+              </a:spcAft>
+              <a:buClrTx/>
+              <a:buSzTx/>
+              <a:buFont typeface="Arial" panose="020B0604020202020204" pitchFamily="34" charset="0"/>
+              <a:buNone/>
+              <a:tabLst/>
+              <a:defRPr/>
+            </a:pPr>
+            <a:r>
+              <a:rPr lang="cs-CZ" dirty="0"/>
+              <a:t>Využití 2: univerzální rozhraní (drivery atd.)</a:t>
             </a:r>
           </a:p>
           <a:p>
@@ -1540,7 +1824,7 @@
           <a:p>
             <a:fld id="{798D3673-CB33-4FFC-8C38-E9A4E5339B0B}" type="datetimeFigureOut">
               <a:rPr lang="cs-CZ" smtClean="0"/>
-              <a:t>28.03.2026</a:t>
+              <a:t>29.03.2026</a:t>
             </a:fld>
             <a:endParaRPr lang="cs-CZ"/>
           </a:p>
@@ -1738,7 +2022,7 @@
           <a:p>
             <a:fld id="{798D3673-CB33-4FFC-8C38-E9A4E5339B0B}" type="datetimeFigureOut">
               <a:rPr lang="cs-CZ" smtClean="0"/>
-              <a:t>28.03.2026</a:t>
+              <a:t>29.03.2026</a:t>
             </a:fld>
             <a:endParaRPr lang="cs-CZ"/>
           </a:p>
@@ -1946,7 +2230,7 @@
           <a:p>
             <a:fld id="{798D3673-CB33-4FFC-8C38-E9A4E5339B0B}" type="datetimeFigureOut">
               <a:rPr lang="cs-CZ" smtClean="0"/>
-              <a:t>28.03.2026</a:t>
+              <a:t>29.03.2026</a:t>
             </a:fld>
             <a:endParaRPr lang="cs-CZ"/>
           </a:p>
@@ -2144,7 +2428,7 @@
           <a:p>
             <a:fld id="{798D3673-CB33-4FFC-8C38-E9A4E5339B0B}" type="datetimeFigureOut">
               <a:rPr lang="cs-CZ" smtClean="0"/>
-              <a:t>28.03.2026</a:t>
+              <a:t>29.03.2026</a:t>
             </a:fld>
             <a:endParaRPr lang="cs-CZ"/>
           </a:p>
@@ -2419,7 +2703,7 @@
           <a:p>
             <a:fld id="{798D3673-CB33-4FFC-8C38-E9A4E5339B0B}" type="datetimeFigureOut">
               <a:rPr lang="cs-CZ" smtClean="0"/>
-              <a:t>28.03.2026</a:t>
+              <a:t>29.03.2026</a:t>
             </a:fld>
             <a:endParaRPr lang="cs-CZ"/>
           </a:p>
@@ -2684,7 +2968,7 @@
           <a:p>
             <a:fld id="{798D3673-CB33-4FFC-8C38-E9A4E5339B0B}" type="datetimeFigureOut">
               <a:rPr lang="cs-CZ" smtClean="0"/>
-              <a:t>28.03.2026</a:t>
+              <a:t>29.03.2026</a:t>
             </a:fld>
             <a:endParaRPr lang="cs-CZ"/>
           </a:p>
@@ -3096,7 +3380,7 @@
           <a:p>
             <a:fld id="{798D3673-CB33-4FFC-8C38-E9A4E5339B0B}" type="datetimeFigureOut">
               <a:rPr lang="cs-CZ" smtClean="0"/>
-              <a:t>28.03.2026</a:t>
+              <a:t>29.03.2026</a:t>
             </a:fld>
             <a:endParaRPr lang="cs-CZ"/>
           </a:p>
@@ -3237,7 +3521,7 @@
           <a:p>
             <a:fld id="{798D3673-CB33-4FFC-8C38-E9A4E5339B0B}" type="datetimeFigureOut">
               <a:rPr lang="cs-CZ" smtClean="0"/>
-              <a:t>28.03.2026</a:t>
+              <a:t>29.03.2026</a:t>
             </a:fld>
             <a:endParaRPr lang="cs-CZ"/>
           </a:p>
@@ -3350,7 +3634,7 @@
           <a:p>
             <a:fld id="{798D3673-CB33-4FFC-8C38-E9A4E5339B0B}" type="datetimeFigureOut">
               <a:rPr lang="cs-CZ" smtClean="0"/>
-              <a:t>28.03.2026</a:t>
+              <a:t>29.03.2026</a:t>
             </a:fld>
             <a:endParaRPr lang="cs-CZ"/>
           </a:p>
@@ -3661,7 +3945,7 @@
           <a:p>
             <a:fld id="{798D3673-CB33-4FFC-8C38-E9A4E5339B0B}" type="datetimeFigureOut">
               <a:rPr lang="cs-CZ" smtClean="0"/>
-              <a:t>28.03.2026</a:t>
+              <a:t>29.03.2026</a:t>
             </a:fld>
             <a:endParaRPr lang="cs-CZ"/>
           </a:p>
@@ -3949,7 +4233,7 @@
           <a:p>
             <a:fld id="{798D3673-CB33-4FFC-8C38-E9A4E5339B0B}" type="datetimeFigureOut">
               <a:rPr lang="cs-CZ" smtClean="0"/>
-              <a:t>28.03.2026</a:t>
+              <a:t>29.03.2026</a:t>
             </a:fld>
             <a:endParaRPr lang="cs-CZ"/>
           </a:p>
@@ -4190,7 +4474,7 @@
           <a:p>
             <a:fld id="{798D3673-CB33-4FFC-8C38-E9A4E5339B0B}" type="datetimeFigureOut">
               <a:rPr lang="cs-CZ" smtClean="0"/>
-              <a:t>28.03.2026</a:t>
+              <a:t>29.03.2026</a:t>
             </a:fld>
             <a:endParaRPr lang="cs-CZ"/>
           </a:p>
@@ -4815,8 +5099,8 @@
           </a:p>
         </p:txBody>
       </p:sp>
-      <mc:AlternateContent xmlns:mc="http://schemas.openxmlformats.org/markup-compatibility/2006">
-        <mc:Choice xmlns:a14="http://schemas.microsoft.com/office/drawing/2010/main" Requires="a14">
+      <mc:AlternateContent xmlns:mc="http://schemas.openxmlformats.org/markup-compatibility/2006" xmlns:a14="http://schemas.microsoft.com/office/drawing/2010/main">
+        <mc:Choice Requires="a14">
           <p:sp>
             <p:nvSpPr>
               <p:cNvPr id="3" name="Zástupný obsah 2">
@@ -5105,7 +5389,7 @@
             </p:txBody>
           </p:sp>
         </mc:Choice>
-        <mc:Fallback>
+        <mc:Fallback xmlns="">
           <p:sp>
             <p:nvSpPr>
               <p:cNvPr id="3" name="Zástupný obsah 2">
@@ -6303,9 +6587,35 @@
           </a:p>
           <a:p>
             <a:r>
-              <a:rPr lang="cs-CZ" sz="2000" dirty="0" err="1"/>
-              <a:t>Aaa</a:t>
-            </a:r>
+              <a:rPr lang="cs-CZ" sz="2000" dirty="0"/>
+              <a:t>Definují abstraktní chování datových typů</a:t>
+            </a:r>
+          </a:p>
+          <a:p>
+            <a:pPr lvl="1"/>
+            <a:r>
+              <a:rPr lang="cs-CZ" sz="1600" dirty="0"/>
+              <a:t>Vlastnosti, metody (funkce na typy)</a:t>
+            </a:r>
+          </a:p>
+          <a:p>
+            <a:r>
+              <a:rPr lang="cs-CZ" sz="2000" dirty="0"/>
+              <a:t>Funkce „univerzální“ přes různé typy</a:t>
+            </a:r>
+          </a:p>
+          <a:p>
+            <a:pPr lvl="1"/>
+            <a:r>
+              <a:rPr lang="cs-CZ" sz="1600" dirty="0" err="1"/>
+              <a:t>Traity</a:t>
+            </a:r>
+            <a:r>
+              <a:rPr lang="cs-CZ" sz="1600" dirty="0"/>
+              <a:t> omezují generické parametry</a:t>
+            </a:r>
+          </a:p>
+          <a:p>
             <a:endParaRPr lang="en-US" sz="2000" dirty="0"/>
           </a:p>
         </p:txBody>

</xml_diff>

<commit_message>
Hopefully finished PPTX on traits now.
</commit_message>
<xml_diff>
--- a/Prezentace.pptx
+++ b/Prezentace.pptx
@@ -5,7 +5,7 @@
     <p:sldMasterId id="2147483648" r:id="rId1"/>
   </p:sldMasterIdLst>
   <p:notesMasterIdLst>
-    <p:notesMasterId r:id="rId9"/>
+    <p:notesMasterId r:id="rId15"/>
   </p:notesMasterIdLst>
   <p:sldIdLst>
     <p:sldId id="256" r:id="rId2"/>
@@ -15,6 +15,12 @@
     <p:sldId id="263" r:id="rId6"/>
     <p:sldId id="258" r:id="rId7"/>
     <p:sldId id="262" r:id="rId8"/>
+    <p:sldId id="264" r:id="rId9"/>
+    <p:sldId id="265" r:id="rId10"/>
+    <p:sldId id="266" r:id="rId11"/>
+    <p:sldId id="267" r:id="rId12"/>
+    <p:sldId id="268" r:id="rId13"/>
+    <p:sldId id="269" r:id="rId14"/>
   </p:sldIdLst>
   <p:sldSz cx="12192000" cy="6858000"/>
   <p:notesSz cx="6858000" cy="9144000"/>
@@ -270,7 +276,7 @@
           <a:p>
             <a:fld id="{015F5405-DF1B-4076-864B-7962BED0FCA9}" type="datetimeFigureOut">
               <a:rPr lang="cs-CZ" smtClean="0"/>
-              <a:t>29.03.2026</a:t>
+              <a:t>02.04.2026</a:t>
             </a:fld>
             <a:endParaRPr lang="cs-CZ"/>
           </a:p>
@@ -874,7 +880,7 @@
           <a:p>
             <a:r>
               <a:rPr lang="cs-CZ" dirty="0"/>
-              <a:t>Rust je moderní (2015) systémový programovací jazyk. Sám se označuje jako „bleskurychlý“, s „neohroženou souběžností“, slibuje „dokonalou paměťovou bezpečnost a další vznešené vlastnosti.</a:t>
+              <a:t>Rust je moderní (2015) systémový programovací jazyk. Sám se označuje jako „bleskurychlý“, s „neohroženou souběžností“, slibuje „dokonalou paměťovou bezpečnost“ a další vznešené vlastnosti.</a:t>
             </a:r>
           </a:p>
           <a:p>
@@ -1534,15 +1540,7 @@
             </a:r>
             <a:r>
               <a:rPr lang="cs-CZ" dirty="0"/>
-              <a:t> pomáhají omezovat </a:t>
-            </a:r>
-            <a:r>
-              <a:rPr lang="cs-CZ"/>
-              <a:t>generické parametry </a:t>
-            </a:r>
-            <a:r>
-              <a:rPr lang="cs-CZ" dirty="0"/>
-              <a:t>na pouze ty typy, které mají určité vlastnosti, které daná funkce vyžaduje</a:t>
+              <a:t> pomáhají omezovat generické parametry na pouze ty typy, které mají určité vlastnosti, které daná funkce vyžaduje</a:t>
             </a:r>
           </a:p>
           <a:p>
@@ -1605,6 +1603,111 @@
             <a:endParaRPr lang="cs-CZ" dirty="0"/>
           </a:p>
           <a:p>
+            <a:r>
+              <a:rPr lang="cs-CZ" dirty="0"/>
+              <a:t>Zdroj obrázku: vlastní, pomocí https://carbon.now.sh/</a:t>
+            </a:r>
+          </a:p>
+        </p:txBody>
+      </p:sp>
+      <p:sp>
+        <p:nvSpPr>
+          <p:cNvPr id="4" name="Slide Number Placeholder 3"/>
+          <p:cNvSpPr>
+            <a:spLocks noGrp="1"/>
+          </p:cNvSpPr>
+          <p:nvPr>
+            <p:ph type="sldNum" sz="quarter" idx="5"/>
+          </p:nvPr>
+        </p:nvSpPr>
+        <p:spPr/>
+        <p:txBody>
+          <a:bodyPr/>
+          <a:lstStyle/>
+          <a:p>
+            <a:fld id="{27274CA6-4D7F-431B-9614-EDAF6E1099E6}" type="slidenum">
+              <a:rPr lang="cs-CZ" smtClean="0"/>
+              <a:t>7</a:t>
+            </a:fld>
+            <a:endParaRPr lang="cs-CZ"/>
+          </a:p>
+        </p:txBody>
+      </p:sp>
+    </p:spTree>
+    <p:extLst>
+      <p:ext uri="{BB962C8B-B14F-4D97-AF65-F5344CB8AC3E}">
+        <p14:creationId xmlns:p14="http://schemas.microsoft.com/office/powerpoint/2010/main" val="625332220"/>
+      </p:ext>
+    </p:extLst>
+  </p:cSld>
+  <p:clrMapOvr>
+    <a:masterClrMapping/>
+  </p:clrMapOvr>
+</p:notes>
+</file>
+
+<file path=ppt/notesSlides/notesSlide7.xml><?xml version="1.0" encoding="utf-8"?>
+<p:notes xmlns:a="http://schemas.openxmlformats.org/drawingml/2006/main" xmlns:r="http://schemas.openxmlformats.org/officeDocument/2006/relationships" xmlns:p="http://schemas.openxmlformats.org/presentationml/2006/main">
+  <p:cSld>
+    <p:spTree>
+      <p:nvGrpSpPr>
+        <p:cNvPr id="1" name="">
+          <a:extLst>
+            <a:ext uri="{FF2B5EF4-FFF2-40B4-BE49-F238E27FC236}">
+              <a16:creationId xmlns:a16="http://schemas.microsoft.com/office/drawing/2014/main" id="{43285223-D280-3EF6-1CA1-BC09051BD568}"/>
+            </a:ext>
+          </a:extLst>
+        </p:cNvPr>
+        <p:cNvGrpSpPr/>
+        <p:nvPr/>
+      </p:nvGrpSpPr>
+      <p:grpSpPr>
+        <a:xfrm>
+          <a:off x="0" y="0"/>
+          <a:ext cx="0" cy="0"/>
+          <a:chOff x="0" y="0"/>
+          <a:chExt cx="0" cy="0"/>
+        </a:xfrm>
+      </p:grpSpPr>
+      <p:sp>
+        <p:nvSpPr>
+          <p:cNvPr id="2" name="Slide Image Placeholder 1">
+            <a:extLst>
+              <a:ext uri="{FF2B5EF4-FFF2-40B4-BE49-F238E27FC236}">
+                <a16:creationId xmlns:a16="http://schemas.microsoft.com/office/drawing/2014/main" id="{25A593B5-15A7-CBB4-FC12-BEFB26DB8D8D}"/>
+              </a:ext>
+            </a:extLst>
+          </p:cNvPr>
+          <p:cNvSpPr>
+            <a:spLocks noGrp="1" noRot="1" noChangeAspect="1"/>
+          </p:cNvSpPr>
+          <p:nvPr>
+            <p:ph type="sldImg"/>
+          </p:nvPr>
+        </p:nvSpPr>
+        <p:spPr/>
+      </p:sp>
+      <p:sp>
+        <p:nvSpPr>
+          <p:cNvPr id="3" name="Notes Placeholder 2">
+            <a:extLst>
+              <a:ext uri="{FF2B5EF4-FFF2-40B4-BE49-F238E27FC236}">
+                <a16:creationId xmlns:a16="http://schemas.microsoft.com/office/drawing/2014/main" id="{2163F266-B512-1109-6F8B-B19BC4EE2176}"/>
+              </a:ext>
+            </a:extLst>
+          </p:cNvPr>
+          <p:cNvSpPr>
+            <a:spLocks noGrp="1"/>
+          </p:cNvSpPr>
+          <p:nvPr>
+            <p:ph type="body" idx="1"/>
+          </p:nvPr>
+        </p:nvSpPr>
+        <p:spPr/>
+        <p:txBody>
+          <a:bodyPr/>
+          <a:lstStyle/>
+          <a:p>
             <a:pPr marL="0" marR="0" lvl="0" indent="0" algn="l" defTabSz="914400" rtl="0" eaLnBrk="1" fontAlgn="auto" latinLnBrk="0" hangingPunct="1">
               <a:lnSpc>
                 <a:spcPct val="100000"/>
@@ -1624,26 +1727,179 @@
             </a:pPr>
             <a:r>
               <a:rPr lang="cs-CZ" dirty="0"/>
-              <a:t>Využití 2: univerzální rozhraní (drivery atd.)</a:t>
-            </a:r>
-          </a:p>
-          <a:p>
+              <a:t>Využití 2: jednotné rozhraní pro knihovny (drivery atd.)</a:t>
+            </a:r>
+          </a:p>
+          <a:p>
+            <a:pPr marL="171450" indent="-171450">
+              <a:buFont typeface="Arial" panose="020B0604020202020204" pitchFamily="34" charset="0"/>
+              <a:buChar char="•"/>
+            </a:pPr>
+            <a:r>
+              <a:rPr lang="cs-CZ" dirty="0"/>
+              <a:t>Některé knihovny (typicky ovladače v </a:t>
+            </a:r>
+            <a:r>
+              <a:rPr lang="cs-CZ" dirty="0" err="1"/>
+              <a:t>embedded</a:t>
+            </a:r>
+            <a:r>
+              <a:rPr lang="cs-CZ" dirty="0"/>
+              <a:t> sféře) potřebují být přenositelné přes mnoho různých </a:t>
+            </a:r>
+            <a:r>
+              <a:rPr lang="cs-CZ" dirty="0" err="1"/>
+              <a:t>backendů</a:t>
+            </a:r>
             <a:endParaRPr lang="cs-CZ" dirty="0"/>
           </a:p>
           <a:p>
+            <a:pPr marL="171450" indent="-171450">
+              <a:buFont typeface="Arial" panose="020B0604020202020204" pitchFamily="34" charset="0"/>
+              <a:buChar char="•"/>
+            </a:pPr>
+            <a:r>
+              <a:rPr lang="cs-CZ" dirty="0" err="1"/>
+              <a:t>Traity</a:t>
+            </a:r>
+            <a:r>
+              <a:rPr lang="cs-CZ" dirty="0"/>
+              <a:t> mohou být tímto „styčným bodem“, umožňujícím </a:t>
+            </a:r>
+            <a:r>
+              <a:rPr lang="cs-CZ" dirty="0" err="1"/>
+              <a:t>backendům</a:t>
+            </a:r>
+            <a:r>
+              <a:rPr lang="cs-CZ" dirty="0"/>
+              <a:t> abstrahovat své fungování do jednotných rozhraní</a:t>
+            </a:r>
+          </a:p>
+          <a:p>
+            <a:pPr marL="171450" indent="-171450">
+              <a:buFont typeface="Arial" panose="020B0604020202020204" pitchFamily="34" charset="0"/>
+              <a:buChar char="•"/>
+            </a:pPr>
+            <a:r>
+              <a:rPr lang="cs-CZ" dirty="0"/>
+              <a:t>Knihovny pak mohou cílit na toto jednotné rozhraní a tak podporovat jakýkoli </a:t>
+            </a:r>
+            <a:r>
+              <a:rPr lang="cs-CZ" dirty="0" err="1"/>
+              <a:t>backend</a:t>
+            </a:r>
+            <a:r>
+              <a:rPr lang="cs-CZ" dirty="0"/>
+              <a:t>, který toto rozhraní implementuje</a:t>
+            </a:r>
+          </a:p>
+          <a:p>
+            <a:pPr marL="0" indent="0">
+              <a:buFont typeface="Arial" panose="020B0604020202020204" pitchFamily="34" charset="0"/>
+              <a:buNone/>
+            </a:pPr>
             <a:endParaRPr lang="cs-CZ" dirty="0"/>
           </a:p>
           <a:p>
-            <a:r>
-              <a:rPr lang="cs-CZ" dirty="0"/>
-              <a:t>Zdroj obrázku: vlastní, pomocí https://carbon.now.sh/</a:t>
-            </a:r>
-          </a:p>
-        </p:txBody>
-      </p:sp>
-      <p:sp>
-        <p:nvSpPr>
-          <p:cNvPr id="4" name="Slide Number Placeholder 3"/>
+            <a:pPr marL="0" indent="0">
+              <a:buFont typeface="Arial" panose="020B0604020202020204" pitchFamily="34" charset="0"/>
+              <a:buNone/>
+            </a:pPr>
+            <a:r>
+              <a:rPr lang="cs-CZ" dirty="0"/>
+              <a:t>Například v našem projektu jsme použili knihovnu </a:t>
+            </a:r>
+            <a:r>
+              <a:rPr lang="cs-CZ" dirty="0" err="1"/>
+              <a:t>embedded</a:t>
+            </a:r>
+            <a:r>
+              <a:rPr lang="cs-CZ" dirty="0"/>
+              <a:t>-hal, která sama o sobě pouze poskytuje </a:t>
+            </a:r>
+            <a:r>
+              <a:rPr lang="cs-CZ" dirty="0" err="1"/>
+              <a:t>traity</a:t>
+            </a:r>
+            <a:r>
+              <a:rPr lang="cs-CZ" dirty="0"/>
+              <a:t>.</a:t>
+            </a:r>
+          </a:p>
+          <a:p>
+            <a:pPr marL="0" indent="0">
+              <a:buFont typeface="Arial" panose="020B0604020202020204" pitchFamily="34" charset="0"/>
+              <a:buNone/>
+            </a:pPr>
+            <a:r>
+              <a:rPr lang="cs-CZ" dirty="0"/>
+              <a:t>Konkrétní HAL (vrstvy pro abstrakci hardwaru) pak implementují tyto </a:t>
+            </a:r>
+            <a:r>
+              <a:rPr lang="cs-CZ" dirty="0" err="1"/>
+              <a:t>traity</a:t>
+            </a:r>
+            <a:r>
+              <a:rPr lang="cs-CZ" dirty="0"/>
+              <a:t> na svých strukturách poskytujících přístup k hardwaru,</a:t>
+            </a:r>
+          </a:p>
+          <a:p>
+            <a:pPr marL="0" indent="0">
+              <a:buFont typeface="Arial" panose="020B0604020202020204" pitchFamily="34" charset="0"/>
+              <a:buNone/>
+            </a:pPr>
+            <a:r>
+              <a:rPr lang="cs-CZ" dirty="0"/>
+              <a:t>a ovladače pro periferie mohou psát své funkce generické přes tyto stejné </a:t>
+            </a:r>
+            <a:r>
+              <a:rPr lang="cs-CZ" dirty="0" err="1"/>
+              <a:t>traity</a:t>
+            </a:r>
+            <a:r>
+              <a:rPr lang="cs-CZ" dirty="0"/>
+              <a:t>.</a:t>
+            </a:r>
+          </a:p>
+          <a:p>
+            <a:pPr marL="0" indent="0">
+              <a:buFont typeface="Arial" panose="020B0604020202020204" pitchFamily="34" charset="0"/>
+              <a:buNone/>
+            </a:pPr>
+            <a:r>
+              <a:rPr lang="cs-CZ" dirty="0"/>
+              <a:t>Každý ovladač je pak schopen běžet na každé HAL bez potíží.</a:t>
+            </a:r>
+          </a:p>
+          <a:p>
+            <a:endParaRPr lang="cs-CZ" dirty="0"/>
+          </a:p>
+          <a:p>
+            <a:r>
+              <a:rPr lang="cs-CZ" dirty="0"/>
+              <a:t>Zdroj obrázku: </a:t>
+            </a:r>
+            <a:r>
+              <a:rPr lang="cs-CZ" dirty="0" err="1"/>
+              <a:t>Gemini</a:t>
+            </a:r>
+            <a:r>
+              <a:rPr lang="cs-CZ" dirty="0"/>
+              <a:t> 3.1 Pro (2.4.2026)</a:t>
+            </a:r>
+          </a:p>
+        </p:txBody>
+      </p:sp>
+      <p:sp>
+        <p:nvSpPr>
+          <p:cNvPr id="4" name="Slide Number Placeholder 3">
+            <a:extLst>
+              <a:ext uri="{FF2B5EF4-FFF2-40B4-BE49-F238E27FC236}">
+                <a16:creationId xmlns:a16="http://schemas.microsoft.com/office/drawing/2014/main" id="{FAF16A58-DEF8-805F-E932-8A08E9957065}"/>
+              </a:ext>
+            </a:extLst>
+          </p:cNvPr>
           <p:cNvSpPr>
             <a:spLocks noGrp="1"/>
           </p:cNvSpPr>
@@ -1658,7 +1914,7 @@
           <a:p>
             <a:fld id="{27274CA6-4D7F-431B-9614-EDAF6E1099E6}" type="slidenum">
               <a:rPr lang="cs-CZ" smtClean="0"/>
-              <a:t>7</a:t>
+              <a:t>8</a:t>
             </a:fld>
             <a:endParaRPr lang="cs-CZ"/>
           </a:p>
@@ -1667,7 +1923,7 @@
     </p:spTree>
     <p:extLst>
       <p:ext uri="{BB962C8B-B14F-4D97-AF65-F5344CB8AC3E}">
-        <p14:creationId xmlns:p14="http://schemas.microsoft.com/office/powerpoint/2010/main" val="625332220"/>
+        <p14:creationId xmlns:p14="http://schemas.microsoft.com/office/powerpoint/2010/main" val="3904475521"/>
       </p:ext>
     </p:extLst>
   </p:cSld>
@@ -1824,7 +2080,7 @@
           <a:p>
             <a:fld id="{798D3673-CB33-4FFC-8C38-E9A4E5339B0B}" type="datetimeFigureOut">
               <a:rPr lang="cs-CZ" smtClean="0"/>
-              <a:t>29.03.2026</a:t>
+              <a:t>02.04.2026</a:t>
             </a:fld>
             <a:endParaRPr lang="cs-CZ"/>
           </a:p>
@@ -2022,7 +2278,7 @@
           <a:p>
             <a:fld id="{798D3673-CB33-4FFC-8C38-E9A4E5339B0B}" type="datetimeFigureOut">
               <a:rPr lang="cs-CZ" smtClean="0"/>
-              <a:t>29.03.2026</a:t>
+              <a:t>02.04.2026</a:t>
             </a:fld>
             <a:endParaRPr lang="cs-CZ"/>
           </a:p>
@@ -2230,7 +2486,7 @@
           <a:p>
             <a:fld id="{798D3673-CB33-4FFC-8C38-E9A4E5339B0B}" type="datetimeFigureOut">
               <a:rPr lang="cs-CZ" smtClean="0"/>
-              <a:t>29.03.2026</a:t>
+              <a:t>02.04.2026</a:t>
             </a:fld>
             <a:endParaRPr lang="cs-CZ"/>
           </a:p>
@@ -2428,7 +2684,7 @@
           <a:p>
             <a:fld id="{798D3673-CB33-4FFC-8C38-E9A4E5339B0B}" type="datetimeFigureOut">
               <a:rPr lang="cs-CZ" smtClean="0"/>
-              <a:t>29.03.2026</a:t>
+              <a:t>02.04.2026</a:t>
             </a:fld>
             <a:endParaRPr lang="cs-CZ"/>
           </a:p>
@@ -2703,7 +2959,7 @@
           <a:p>
             <a:fld id="{798D3673-CB33-4FFC-8C38-E9A4E5339B0B}" type="datetimeFigureOut">
               <a:rPr lang="cs-CZ" smtClean="0"/>
-              <a:t>29.03.2026</a:t>
+              <a:t>02.04.2026</a:t>
             </a:fld>
             <a:endParaRPr lang="cs-CZ"/>
           </a:p>
@@ -2968,7 +3224,7 @@
           <a:p>
             <a:fld id="{798D3673-CB33-4FFC-8C38-E9A4E5339B0B}" type="datetimeFigureOut">
               <a:rPr lang="cs-CZ" smtClean="0"/>
-              <a:t>29.03.2026</a:t>
+              <a:t>02.04.2026</a:t>
             </a:fld>
             <a:endParaRPr lang="cs-CZ"/>
           </a:p>
@@ -3380,7 +3636,7 @@
           <a:p>
             <a:fld id="{798D3673-CB33-4FFC-8C38-E9A4E5339B0B}" type="datetimeFigureOut">
               <a:rPr lang="cs-CZ" smtClean="0"/>
-              <a:t>29.03.2026</a:t>
+              <a:t>02.04.2026</a:t>
             </a:fld>
             <a:endParaRPr lang="cs-CZ"/>
           </a:p>
@@ -3521,7 +3777,7 @@
           <a:p>
             <a:fld id="{798D3673-CB33-4FFC-8C38-E9A4E5339B0B}" type="datetimeFigureOut">
               <a:rPr lang="cs-CZ" smtClean="0"/>
-              <a:t>29.03.2026</a:t>
+              <a:t>02.04.2026</a:t>
             </a:fld>
             <a:endParaRPr lang="cs-CZ"/>
           </a:p>
@@ -3634,7 +3890,7 @@
           <a:p>
             <a:fld id="{798D3673-CB33-4FFC-8C38-E9A4E5339B0B}" type="datetimeFigureOut">
               <a:rPr lang="cs-CZ" smtClean="0"/>
-              <a:t>29.03.2026</a:t>
+              <a:t>02.04.2026</a:t>
             </a:fld>
             <a:endParaRPr lang="cs-CZ"/>
           </a:p>
@@ -3945,7 +4201,7 @@
           <a:p>
             <a:fld id="{798D3673-CB33-4FFC-8C38-E9A4E5339B0B}" type="datetimeFigureOut">
               <a:rPr lang="cs-CZ" smtClean="0"/>
-              <a:t>29.03.2026</a:t>
+              <a:t>02.04.2026</a:t>
             </a:fld>
             <a:endParaRPr lang="cs-CZ"/>
           </a:p>
@@ -4233,7 +4489,7 @@
           <a:p>
             <a:fld id="{798D3673-CB33-4FFC-8C38-E9A4E5339B0B}" type="datetimeFigureOut">
               <a:rPr lang="cs-CZ" smtClean="0"/>
-              <a:t>29.03.2026</a:t>
+              <a:t>02.04.2026</a:t>
             </a:fld>
             <a:endParaRPr lang="cs-CZ"/>
           </a:p>
@@ -4474,7 +4730,7 @@
           <a:p>
             <a:fld id="{798D3673-CB33-4FFC-8C38-E9A4E5339B0B}" type="datetimeFigureOut">
               <a:rPr lang="cs-CZ" smtClean="0"/>
-              <a:t>29.03.2026</a:t>
+              <a:t>02.04.2026</a:t>
             </a:fld>
             <a:endParaRPr lang="cs-CZ"/>
           </a:p>
@@ -4966,6 +5222,338 @@
 </p:sld>
 </file>
 
+<file path=ppt/slides/slide10.xml><?xml version="1.0" encoding="utf-8"?>
+<p:sld xmlns:a="http://schemas.openxmlformats.org/drawingml/2006/main" xmlns:r="http://schemas.openxmlformats.org/officeDocument/2006/relationships" xmlns:p="http://schemas.openxmlformats.org/presentationml/2006/main">
+  <p:cSld>
+    <p:spTree>
+      <p:nvGrpSpPr>
+        <p:cNvPr id="1" name=""/>
+        <p:cNvGrpSpPr/>
+        <p:nvPr/>
+      </p:nvGrpSpPr>
+      <p:grpSpPr>
+        <a:xfrm>
+          <a:off x="0" y="0"/>
+          <a:ext cx="0" cy="0"/>
+          <a:chOff x="0" y="0"/>
+          <a:chExt cx="0" cy="0"/>
+        </a:xfrm>
+      </p:grpSpPr>
+      <p:sp>
+        <p:nvSpPr>
+          <p:cNvPr id="2" name="Title 1">
+            <a:extLst>
+              <a:ext uri="{FF2B5EF4-FFF2-40B4-BE49-F238E27FC236}">
+                <a16:creationId xmlns:a16="http://schemas.microsoft.com/office/drawing/2014/main" id="{D7393CDE-8F32-A485-10B4-FA031EFC1144}"/>
+              </a:ext>
+            </a:extLst>
+          </p:cNvPr>
+          <p:cNvSpPr>
+            <a:spLocks noGrp="1"/>
+          </p:cNvSpPr>
+          <p:nvPr>
+            <p:ph type="title"/>
+          </p:nvPr>
+        </p:nvSpPr>
+        <p:spPr/>
+        <p:txBody>
+          <a:bodyPr/>
+          <a:lstStyle/>
+          <a:p>
+            <a:r>
+              <a:rPr lang="cs-CZ" dirty="0"/>
+              <a:t>Desetinná čísla</a:t>
+            </a:r>
+          </a:p>
+        </p:txBody>
+      </p:sp>
+      <p:sp>
+        <p:nvSpPr>
+          <p:cNvPr id="3" name="Content Placeholder 2">
+            <a:extLst>
+              <a:ext uri="{FF2B5EF4-FFF2-40B4-BE49-F238E27FC236}">
+                <a16:creationId xmlns:a16="http://schemas.microsoft.com/office/drawing/2014/main" id="{2615C0BB-C97C-4C65-9E4F-8751068C46AC}"/>
+              </a:ext>
+            </a:extLst>
+          </p:cNvPr>
+          <p:cNvSpPr>
+            <a:spLocks noGrp="1"/>
+          </p:cNvSpPr>
+          <p:nvPr>
+            <p:ph idx="1"/>
+          </p:nvPr>
+        </p:nvSpPr>
+        <p:spPr/>
+        <p:txBody>
+          <a:bodyPr/>
+          <a:lstStyle/>
+          <a:p>
+            <a:endParaRPr lang="cs-CZ"/>
+          </a:p>
+        </p:txBody>
+      </p:sp>
+    </p:spTree>
+    <p:extLst>
+      <p:ext uri="{BB962C8B-B14F-4D97-AF65-F5344CB8AC3E}">
+        <p14:creationId xmlns:p14="http://schemas.microsoft.com/office/powerpoint/2010/main" val="2721032930"/>
+      </p:ext>
+    </p:extLst>
+  </p:cSld>
+  <p:clrMapOvr>
+    <a:masterClrMapping/>
+  </p:clrMapOvr>
+</p:sld>
+</file>
+
+<file path=ppt/slides/slide11.xml><?xml version="1.0" encoding="utf-8"?>
+<p:sld xmlns:a="http://schemas.openxmlformats.org/drawingml/2006/main" xmlns:r="http://schemas.openxmlformats.org/officeDocument/2006/relationships" xmlns:p="http://schemas.openxmlformats.org/presentationml/2006/main">
+  <p:cSld>
+    <p:spTree>
+      <p:nvGrpSpPr>
+        <p:cNvPr id="1" name=""/>
+        <p:cNvGrpSpPr/>
+        <p:nvPr/>
+      </p:nvGrpSpPr>
+      <p:grpSpPr>
+        <a:xfrm>
+          <a:off x="0" y="0"/>
+          <a:ext cx="0" cy="0"/>
+          <a:chOff x="0" y="0"/>
+          <a:chExt cx="0" cy="0"/>
+        </a:xfrm>
+      </p:grpSpPr>
+      <p:sp>
+        <p:nvSpPr>
+          <p:cNvPr id="2" name="Title 1">
+            <a:extLst>
+              <a:ext uri="{FF2B5EF4-FFF2-40B4-BE49-F238E27FC236}">
+                <a16:creationId xmlns:a16="http://schemas.microsoft.com/office/drawing/2014/main" id="{8075CEB5-567A-56FC-A79D-8EBBE314CA35}"/>
+              </a:ext>
+            </a:extLst>
+          </p:cNvPr>
+          <p:cNvSpPr>
+            <a:spLocks noGrp="1"/>
+          </p:cNvSpPr>
+          <p:nvPr>
+            <p:ph type="title"/>
+          </p:nvPr>
+        </p:nvSpPr>
+        <p:spPr/>
+        <p:txBody>
+          <a:bodyPr/>
+          <a:lstStyle/>
+          <a:p>
+            <a:r>
+              <a:rPr lang="cs-CZ" dirty="0"/>
+              <a:t>Ovládání</a:t>
+            </a:r>
+          </a:p>
+        </p:txBody>
+      </p:sp>
+      <p:sp>
+        <p:nvSpPr>
+          <p:cNvPr id="3" name="Content Placeholder 2">
+            <a:extLst>
+              <a:ext uri="{FF2B5EF4-FFF2-40B4-BE49-F238E27FC236}">
+                <a16:creationId xmlns:a16="http://schemas.microsoft.com/office/drawing/2014/main" id="{B72313B4-1167-5BFE-4914-AF8C4B665E04}"/>
+              </a:ext>
+            </a:extLst>
+          </p:cNvPr>
+          <p:cNvSpPr>
+            <a:spLocks noGrp="1"/>
+          </p:cNvSpPr>
+          <p:nvPr>
+            <p:ph idx="1"/>
+          </p:nvPr>
+        </p:nvSpPr>
+        <p:spPr/>
+        <p:txBody>
+          <a:bodyPr/>
+          <a:lstStyle/>
+          <a:p>
+            <a:endParaRPr lang="cs-CZ"/>
+          </a:p>
+        </p:txBody>
+      </p:sp>
+    </p:spTree>
+    <p:extLst>
+      <p:ext uri="{BB962C8B-B14F-4D97-AF65-F5344CB8AC3E}">
+        <p14:creationId xmlns:p14="http://schemas.microsoft.com/office/powerpoint/2010/main" val="3593242919"/>
+      </p:ext>
+    </p:extLst>
+  </p:cSld>
+  <p:clrMapOvr>
+    <a:masterClrMapping/>
+  </p:clrMapOvr>
+</p:sld>
+</file>
+
+<file path=ppt/slides/slide12.xml><?xml version="1.0" encoding="utf-8"?>
+<p:sld xmlns:a="http://schemas.openxmlformats.org/drawingml/2006/main" xmlns:r="http://schemas.openxmlformats.org/officeDocument/2006/relationships" xmlns:p="http://schemas.openxmlformats.org/presentationml/2006/main">
+  <p:cSld>
+    <p:spTree>
+      <p:nvGrpSpPr>
+        <p:cNvPr id="1" name=""/>
+        <p:cNvGrpSpPr/>
+        <p:nvPr/>
+      </p:nvGrpSpPr>
+      <p:grpSpPr>
+        <a:xfrm>
+          <a:off x="0" y="0"/>
+          <a:ext cx="0" cy="0"/>
+          <a:chOff x="0" y="0"/>
+          <a:chExt cx="0" cy="0"/>
+        </a:xfrm>
+      </p:grpSpPr>
+      <p:sp>
+        <p:nvSpPr>
+          <p:cNvPr id="2" name="Title 1">
+            <a:extLst>
+              <a:ext uri="{FF2B5EF4-FFF2-40B4-BE49-F238E27FC236}">
+                <a16:creationId xmlns:a16="http://schemas.microsoft.com/office/drawing/2014/main" id="{07195F07-92E8-AF88-403B-50025CB8E99C}"/>
+              </a:ext>
+            </a:extLst>
+          </p:cNvPr>
+          <p:cNvSpPr>
+            <a:spLocks noGrp="1"/>
+          </p:cNvSpPr>
+          <p:nvPr>
+            <p:ph type="title"/>
+          </p:nvPr>
+        </p:nvSpPr>
+        <p:spPr/>
+        <p:txBody>
+          <a:bodyPr/>
+          <a:lstStyle/>
+          <a:p>
+            <a:r>
+              <a:rPr lang="cs-CZ" dirty="0"/>
+              <a:t>Výsledek v akci</a:t>
+            </a:r>
+          </a:p>
+        </p:txBody>
+      </p:sp>
+      <p:sp>
+        <p:nvSpPr>
+          <p:cNvPr id="3" name="Content Placeholder 2">
+            <a:extLst>
+              <a:ext uri="{FF2B5EF4-FFF2-40B4-BE49-F238E27FC236}">
+                <a16:creationId xmlns:a16="http://schemas.microsoft.com/office/drawing/2014/main" id="{59779220-6287-5881-E828-1F00E207B336}"/>
+              </a:ext>
+            </a:extLst>
+          </p:cNvPr>
+          <p:cNvSpPr>
+            <a:spLocks noGrp="1"/>
+          </p:cNvSpPr>
+          <p:nvPr>
+            <p:ph idx="1"/>
+          </p:nvPr>
+        </p:nvSpPr>
+        <p:spPr/>
+        <p:txBody>
+          <a:bodyPr/>
+          <a:lstStyle/>
+          <a:p>
+            <a:endParaRPr lang="cs-CZ"/>
+          </a:p>
+        </p:txBody>
+      </p:sp>
+    </p:spTree>
+    <p:extLst>
+      <p:ext uri="{BB962C8B-B14F-4D97-AF65-F5344CB8AC3E}">
+        <p14:creationId xmlns:p14="http://schemas.microsoft.com/office/powerpoint/2010/main" val="48455641"/>
+      </p:ext>
+    </p:extLst>
+  </p:cSld>
+  <p:clrMapOvr>
+    <a:masterClrMapping/>
+  </p:clrMapOvr>
+</p:sld>
+</file>
+
+<file path=ppt/slides/slide13.xml><?xml version="1.0" encoding="utf-8"?>
+<p:sld xmlns:a="http://schemas.openxmlformats.org/drawingml/2006/main" xmlns:r="http://schemas.openxmlformats.org/officeDocument/2006/relationships" xmlns:p="http://schemas.openxmlformats.org/presentationml/2006/main">
+  <p:cSld>
+    <p:spTree>
+      <p:nvGrpSpPr>
+        <p:cNvPr id="1" name=""/>
+        <p:cNvGrpSpPr/>
+        <p:nvPr/>
+      </p:nvGrpSpPr>
+      <p:grpSpPr>
+        <a:xfrm>
+          <a:off x="0" y="0"/>
+          <a:ext cx="0" cy="0"/>
+          <a:chOff x="0" y="0"/>
+          <a:chExt cx="0" cy="0"/>
+        </a:xfrm>
+      </p:grpSpPr>
+      <p:sp>
+        <p:nvSpPr>
+          <p:cNvPr id="2" name="Title 1">
+            <a:extLst>
+              <a:ext uri="{FF2B5EF4-FFF2-40B4-BE49-F238E27FC236}">
+                <a16:creationId xmlns:a16="http://schemas.microsoft.com/office/drawing/2014/main" id="{E0CE017E-CF88-884F-B871-85FFD3A79129}"/>
+              </a:ext>
+            </a:extLst>
+          </p:cNvPr>
+          <p:cNvSpPr>
+            <a:spLocks noGrp="1"/>
+          </p:cNvSpPr>
+          <p:nvPr>
+            <p:ph type="title"/>
+          </p:nvPr>
+        </p:nvSpPr>
+        <p:spPr/>
+        <p:txBody>
+          <a:bodyPr/>
+          <a:lstStyle/>
+          <a:p>
+            <a:r>
+              <a:rPr lang="cs-CZ" dirty="0"/>
+              <a:t>Osobní shrnutí</a:t>
+            </a:r>
+          </a:p>
+        </p:txBody>
+      </p:sp>
+      <p:sp>
+        <p:nvSpPr>
+          <p:cNvPr id="3" name="Content Placeholder 2">
+            <a:extLst>
+              <a:ext uri="{FF2B5EF4-FFF2-40B4-BE49-F238E27FC236}">
+                <a16:creationId xmlns:a16="http://schemas.microsoft.com/office/drawing/2014/main" id="{F8F97471-F608-2CF7-AC14-186A540FD6FA}"/>
+              </a:ext>
+            </a:extLst>
+          </p:cNvPr>
+          <p:cNvSpPr>
+            <a:spLocks noGrp="1"/>
+          </p:cNvSpPr>
+          <p:nvPr>
+            <p:ph idx="1"/>
+          </p:nvPr>
+        </p:nvSpPr>
+        <p:spPr/>
+        <p:txBody>
+          <a:bodyPr/>
+          <a:lstStyle/>
+          <a:p>
+            <a:endParaRPr lang="cs-CZ"/>
+          </a:p>
+        </p:txBody>
+      </p:sp>
+    </p:spTree>
+    <p:extLst>
+      <p:ext uri="{BB962C8B-B14F-4D97-AF65-F5344CB8AC3E}">
+        <p14:creationId xmlns:p14="http://schemas.microsoft.com/office/powerpoint/2010/main" val="2980597053"/>
+      </p:ext>
+    </p:extLst>
+  </p:cSld>
+  <p:clrMapOvr>
+    <a:masterClrMapping/>
+  </p:clrMapOvr>
+</p:sld>
+</file>
+
 <file path=ppt/slides/slide2.xml><?xml version="1.0" encoding="utf-8"?>
 <p:sld xmlns:a="http://schemas.openxmlformats.org/drawingml/2006/main" xmlns:r="http://schemas.openxmlformats.org/officeDocument/2006/relationships" xmlns:p="http://schemas.openxmlformats.org/presentationml/2006/main">
   <p:cSld>
@@ -5092,15 +5680,14 @@
           <a:lstStyle/>
           <a:p>
             <a:r>
-              <a:rPr lang="cs-CZ"/>
+              <a:rPr lang="cs-CZ" dirty="0"/>
               <a:t>Postfixová notace</a:t>
             </a:r>
-            <a:endParaRPr lang="cs-CZ" dirty="0"/>
-          </a:p>
-        </p:txBody>
-      </p:sp>
-      <mc:AlternateContent xmlns:mc="http://schemas.openxmlformats.org/markup-compatibility/2006" xmlns:a14="http://schemas.microsoft.com/office/drawing/2010/main">
-        <mc:Choice Requires="a14">
+          </a:p>
+        </p:txBody>
+      </p:sp>
+      <mc:AlternateContent xmlns:mc="http://schemas.openxmlformats.org/markup-compatibility/2006">
+        <mc:Choice xmlns:a14="http://schemas.microsoft.com/office/drawing/2010/main" Requires="a14">
           <p:sp>
             <p:nvSpPr>
               <p:cNvPr id="3" name="Zástupný obsah 2">
@@ -5124,7 +5711,15 @@
               <a:p>
                 <a:r>
                   <a:rPr lang="cs-CZ" dirty="0"/>
-                  <a:t>= zpětná polská notace (RPN)</a:t>
+                  <a:t>= zpětná polská notace (</a:t>
+                </a:r>
+                <a:r>
+                  <a:rPr lang="cs-CZ" dirty="0" err="1"/>
+                  <a:t>RPN</a:t>
+                </a:r>
+                <a:r>
+                  <a:rPr lang="cs-CZ" dirty="0"/>
+                  <a:t>)</a:t>
                 </a:r>
               </a:p>
               <a:p>
@@ -5165,32 +5760,32 @@
                 <a14:m>
                   <m:oMath xmlns:m="http://schemas.openxmlformats.org/officeDocument/2006/math">
                     <m:r>
-                      <a:rPr lang="cs-CZ" i="1" dirty="0" smtClean="0">
+                      <a:rPr lang="cs-CZ" i="1" smtClean="0">
                         <a:latin typeface="Cambria Math" panose="02040503050406030204" pitchFamily="18" charset="0"/>
                       </a:rPr>
                       <m:t>1</m:t>
                     </m:r>
                     <m:r>
-                      <a:rPr lang="cs-CZ" b="0" i="1" dirty="0" smtClean="0">
+                      <a:rPr lang="cs-CZ" b="0" i="1" smtClean="0">
                         <a:latin typeface="Cambria Math" panose="02040503050406030204" pitchFamily="18" charset="0"/>
                       </a:rPr>
                       <m:t>+</m:t>
                     </m:r>
                     <m:r>
-                      <a:rPr lang="cs-CZ" i="1" dirty="0" smtClean="0">
+                      <a:rPr lang="cs-CZ" i="1" smtClean="0">
                         <a:latin typeface="Cambria Math" panose="02040503050406030204" pitchFamily="18" charset="0"/>
                       </a:rPr>
                       <m:t>2</m:t>
                     </m:r>
                     <m:r>
-                      <a:rPr lang="cs-CZ" b="0" i="1" dirty="0" smtClean="0">
+                      <a:rPr lang="cs-CZ" b="0" i="1" smtClean="0">
                         <a:latin typeface="Cambria Math" panose="02040503050406030204" pitchFamily="18" charset="0"/>
                         <a:ea typeface="Cambria Math" panose="02040503050406030204" pitchFamily="18" charset="0"/>
                       </a:rPr>
                       <m:t>×</m:t>
                     </m:r>
                     <m:r>
-                      <a:rPr lang="cs-CZ" b="0" i="1" dirty="0" smtClean="0">
+                      <a:rPr lang="cs-CZ" b="0" i="1" smtClean="0">
                         <a:latin typeface="Cambria Math" panose="02040503050406030204" pitchFamily="18" charset="0"/>
                       </a:rPr>
                       <m:t>3</m:t>
@@ -5204,20 +5799,20 @@
                 <a14:m>
                   <m:oMath xmlns:m="http://schemas.openxmlformats.org/officeDocument/2006/math">
                     <m:r>
-                      <a:rPr lang="cs-CZ" i="1" dirty="0">
+                      <a:rPr lang="cs-CZ" i="1">
                         <a:latin typeface="Cambria Math" panose="02040503050406030204" pitchFamily="18" charset="0"/>
                       </a:rPr>
                       <m:t>⇒1 2 3</m:t>
                     </m:r>
                     <m:r>
-                      <a:rPr lang="cs-CZ" i="1" dirty="0">
+                      <a:rPr lang="cs-CZ" i="1">
                         <a:latin typeface="Cambria Math" panose="02040503050406030204" pitchFamily="18" charset="0"/>
                         <a:ea typeface="Cambria Math" panose="02040503050406030204" pitchFamily="18" charset="0"/>
                       </a:rPr>
                       <m:t>×</m:t>
                     </m:r>
                     <m:r>
-                      <a:rPr lang="cs-CZ" i="1" dirty="0">
+                      <a:rPr lang="cs-CZ" i="1">
                         <a:latin typeface="Cambria Math" panose="02040503050406030204" pitchFamily="18" charset="0"/>
                       </a:rPr>
                       <m:t>+</m:t>
@@ -5389,7 +5984,7 @@
             </p:txBody>
           </p:sp>
         </mc:Choice>
-        <mc:Fallback xmlns="">
+        <mc:Fallback>
           <p:sp>
             <p:nvSpPr>
               <p:cNvPr id="3" name="Zástupný obsah 2">
@@ -6526,6 +7121,66 @@
           <a:chExt cx="0" cy="0"/>
         </a:xfrm>
       </p:grpSpPr>
+      <p:sp useBgFill="1">
+        <p:nvSpPr>
+          <p:cNvPr id="18" name="Rectangle 17">
+            <a:extLst>
+              <a:ext uri="{FF2B5EF4-FFF2-40B4-BE49-F238E27FC236}">
+                <a16:creationId xmlns:a16="http://schemas.microsoft.com/office/drawing/2014/main" id="{2B97F24A-32CE-4C1C-A50D-3016B394DCFB}"/>
+              </a:ext>
+              <a:ext uri="{C183D7F6-B498-43B3-948B-1728B52AA6E4}">
+                <adec:decorative xmlns:adec="http://schemas.microsoft.com/office/drawing/2017/decorative" val="1"/>
+              </a:ext>
+            </a:extLst>
+          </p:cNvPr>
+          <p:cNvSpPr>
+            <a:spLocks noGrp="1" noRot="1" noChangeAspect="1" noMove="1" noResize="1" noEditPoints="1" noAdjustHandles="1" noChangeArrowheads="1" noChangeShapeType="1" noTextEdit="1"/>
+          </p:cNvSpPr>
+          <p:nvPr>
+            <p:extLst>
+              <p:ext uri="{386F3935-93C4-4BCD-93E2-E3B085C9AB24}">
+                <p16:designElem xmlns:p16="http://schemas.microsoft.com/office/powerpoint/2015/main" val="1"/>
+              </p:ext>
+            </p:extLst>
+          </p:nvPr>
+        </p:nvSpPr>
+        <p:spPr>
+          <a:xfrm>
+            <a:off x="0" y="0"/>
+            <a:ext cx="12192000" cy="6858000"/>
+          </a:xfrm>
+          <a:prstGeom prst="rect">
+            <a:avLst/>
+          </a:prstGeom>
+          <a:ln>
+            <a:noFill/>
+          </a:ln>
+        </p:spPr>
+        <p:style>
+          <a:lnRef idx="2">
+            <a:schemeClr val="accent1">
+              <a:shade val="50000"/>
+            </a:schemeClr>
+          </a:lnRef>
+          <a:fillRef idx="1">
+            <a:schemeClr val="accent1"/>
+          </a:fillRef>
+          <a:effectRef idx="0">
+            <a:schemeClr val="accent1"/>
+          </a:effectRef>
+          <a:fontRef idx="minor">
+            <a:schemeClr val="lt1"/>
+          </a:fontRef>
+        </p:style>
+        <p:txBody>
+          <a:bodyPr rtlCol="0" anchor="ctr"/>
+          <a:lstStyle/>
+          <a:p>
+            <a:pPr algn="ctr"/>
+            <a:endParaRPr lang="cs-CZ" dirty="0"/>
+          </a:p>
+        </p:txBody>
+      </p:sp>
       <p:sp>
         <p:nvSpPr>
           <p:cNvPr id="2" name="Title 1">
@@ -6542,17 +7197,309 @@
             <p:ph type="title"/>
           </p:nvPr>
         </p:nvSpPr>
-        <p:spPr/>
-        <p:txBody>
-          <a:bodyPr>
+        <p:spPr>
+          <a:xfrm>
+            <a:off x="630936" y="639520"/>
+            <a:ext cx="3429000" cy="1719072"/>
+          </a:xfrm>
+        </p:spPr>
+        <p:txBody>
+          <a:bodyPr vert="horz" lIns="91440" tIns="45720" rIns="91440" bIns="45720" rtlCol="0" anchor="b">
             <a:normAutofit/>
           </a:bodyPr>
           <a:lstStyle/>
           <a:p>
             <a:r>
-              <a:rPr lang="cs-CZ" dirty="0" err="1"/>
-              <a:t>Trait</a:t>
-            </a:r>
+              <a:rPr lang="cs-CZ" sz="5400" kern="1200" dirty="0" err="1">
+                <a:solidFill>
+                  <a:schemeClr val="tx1"/>
+                </a:solidFill>
+                <a:latin typeface="+mj-lt"/>
+                <a:ea typeface="+mj-ea"/>
+                <a:cs typeface="+mj-cs"/>
+              </a:rPr>
+              <a:t>Traity</a:t>
+            </a:r>
+            <a:endParaRPr lang="cs-CZ" sz="5400" kern="1200" dirty="0">
+              <a:solidFill>
+                <a:schemeClr val="tx1"/>
+              </a:solidFill>
+              <a:latin typeface="+mj-lt"/>
+              <a:ea typeface="+mj-ea"/>
+              <a:cs typeface="+mj-cs"/>
+            </a:endParaRPr>
+          </a:p>
+        </p:txBody>
+      </p:sp>
+      <p:sp>
+        <p:nvSpPr>
+          <p:cNvPr id="20" name="sketch line">
+            <a:extLst>
+              <a:ext uri="{FF2B5EF4-FFF2-40B4-BE49-F238E27FC236}">
+                <a16:creationId xmlns:a16="http://schemas.microsoft.com/office/drawing/2014/main" id="{6357EC4F-235E-4222-A36F-C7878ACE37F2}"/>
+              </a:ext>
+              <a:ext uri="{C183D7F6-B498-43B3-948B-1728B52AA6E4}">
+                <adec:decorative xmlns:adec="http://schemas.microsoft.com/office/drawing/2017/decorative" val="1"/>
+              </a:ext>
+            </a:extLst>
+          </p:cNvPr>
+          <p:cNvSpPr>
+            <a:spLocks noGrp="1" noRot="1" noChangeAspect="1" noMove="1" noResize="1" noEditPoints="1" noAdjustHandles="1" noChangeArrowheads="1" noChangeShapeType="1" noTextEdit="1"/>
+          </p:cNvSpPr>
+          <p:nvPr>
+            <p:extLst>
+              <p:ext uri="{386F3935-93C4-4BCD-93E2-E3B085C9AB24}">
+                <p16:designElem xmlns:p16="http://schemas.microsoft.com/office/powerpoint/2015/main" val="1"/>
+              </p:ext>
+            </p:extLst>
+          </p:nvPr>
+        </p:nvSpPr>
+        <p:spPr>
+          <a:xfrm>
+            <a:off x="643278" y="2573756"/>
+            <a:ext cx="3255095" cy="18288"/>
+          </a:xfrm>
+          <a:custGeom>
+            <a:avLst/>
+            <a:gdLst>
+              <a:gd name="csX0" fmla="*/ 0 w 3255095"/>
+              <a:gd name="csY0" fmla="*/ 0 h 18288"/>
+              <a:gd name="csX1" fmla="*/ 618468 w 3255095"/>
+              <a:gd name="csY1" fmla="*/ 0 h 18288"/>
+              <a:gd name="csX2" fmla="*/ 1269487 w 3255095"/>
+              <a:gd name="csY2" fmla="*/ 0 h 18288"/>
+              <a:gd name="csX3" fmla="*/ 1953057 w 3255095"/>
+              <a:gd name="csY3" fmla="*/ 0 h 18288"/>
+              <a:gd name="csX4" fmla="*/ 2636627 w 3255095"/>
+              <a:gd name="csY4" fmla="*/ 0 h 18288"/>
+              <a:gd name="csX5" fmla="*/ 3255095 w 3255095"/>
+              <a:gd name="csY5" fmla="*/ 0 h 18288"/>
+              <a:gd name="csX6" fmla="*/ 3255095 w 3255095"/>
+              <a:gd name="csY6" fmla="*/ 18288 h 18288"/>
+              <a:gd name="csX7" fmla="*/ 2538974 w 3255095"/>
+              <a:gd name="csY7" fmla="*/ 18288 h 18288"/>
+              <a:gd name="csX8" fmla="*/ 1822853 w 3255095"/>
+              <a:gd name="csY8" fmla="*/ 18288 h 18288"/>
+              <a:gd name="csX9" fmla="*/ 1171834 w 3255095"/>
+              <a:gd name="csY9" fmla="*/ 18288 h 18288"/>
+              <a:gd name="csX10" fmla="*/ 0 w 3255095"/>
+              <a:gd name="csY10" fmla="*/ 18288 h 18288"/>
+              <a:gd name="csX11" fmla="*/ 0 w 3255095"/>
+              <a:gd name="csY11" fmla="*/ 0 h 18288"/>
+            </a:gdLst>
+            <a:ahLst/>
+            <a:cxnLst>
+              <a:cxn ang="0">
+                <a:pos x="csX0" y="csY0"/>
+              </a:cxn>
+              <a:cxn ang="0">
+                <a:pos x="csX1" y="csY1"/>
+              </a:cxn>
+              <a:cxn ang="0">
+                <a:pos x="csX2" y="csY2"/>
+              </a:cxn>
+              <a:cxn ang="0">
+                <a:pos x="csX3" y="csY3"/>
+              </a:cxn>
+              <a:cxn ang="0">
+                <a:pos x="csX4" y="csY4"/>
+              </a:cxn>
+              <a:cxn ang="0">
+                <a:pos x="csX5" y="csY5"/>
+              </a:cxn>
+              <a:cxn ang="0">
+                <a:pos x="csX6" y="csY6"/>
+              </a:cxn>
+              <a:cxn ang="0">
+                <a:pos x="csX7" y="csY7"/>
+              </a:cxn>
+              <a:cxn ang="0">
+                <a:pos x="csX8" y="csY8"/>
+              </a:cxn>
+              <a:cxn ang="0">
+                <a:pos x="csX9" y="csY9"/>
+              </a:cxn>
+              <a:cxn ang="0">
+                <a:pos x="csX10" y="csY10"/>
+              </a:cxn>
+              <a:cxn ang="0">
+                <a:pos x="csX11" y="csY11"/>
+              </a:cxn>
+            </a:cxnLst>
+            <a:rect l="l" t="t" r="r" b="b"/>
+            <a:pathLst>
+              <a:path w="3255095" h="18288" fill="none" extrusionOk="0">
+                <a:moveTo>
+                  <a:pt x="0" y="0"/>
+                </a:moveTo>
+                <a:cubicBezTo>
+                  <a:pt x="240201" y="-22123"/>
+                  <a:pt x="462021" y="-19623"/>
+                  <a:pt x="618468" y="0"/>
+                </a:cubicBezTo>
+                <a:cubicBezTo>
+                  <a:pt x="774915" y="19623"/>
+                  <a:pt x="974734" y="2035"/>
+                  <a:pt x="1269487" y="0"/>
+                </a:cubicBezTo>
+                <a:cubicBezTo>
+                  <a:pt x="1564240" y="-2035"/>
+                  <a:pt x="1733579" y="10639"/>
+                  <a:pt x="1953057" y="0"/>
+                </a:cubicBezTo>
+                <a:cubicBezTo>
+                  <a:pt x="2172535" y="-10639"/>
+                  <a:pt x="2453962" y="14018"/>
+                  <a:pt x="2636627" y="0"/>
+                </a:cubicBezTo>
+                <a:cubicBezTo>
+                  <a:pt x="2819292" y="-14018"/>
+                  <a:pt x="3121375" y="5399"/>
+                  <a:pt x="3255095" y="0"/>
+                </a:cubicBezTo>
+                <a:cubicBezTo>
+                  <a:pt x="3254386" y="8157"/>
+                  <a:pt x="3254682" y="12125"/>
+                  <a:pt x="3255095" y="18288"/>
+                </a:cubicBezTo>
+                <a:cubicBezTo>
+                  <a:pt x="3088545" y="23203"/>
+                  <a:pt x="2687475" y="7419"/>
+                  <a:pt x="2538974" y="18288"/>
+                </a:cubicBezTo>
+                <a:cubicBezTo>
+                  <a:pt x="2390473" y="29157"/>
+                  <a:pt x="2137381" y="-8959"/>
+                  <a:pt x="1822853" y="18288"/>
+                </a:cubicBezTo>
+                <a:cubicBezTo>
+                  <a:pt x="1508325" y="45535"/>
+                  <a:pt x="1466437" y="20385"/>
+                  <a:pt x="1171834" y="18288"/>
+                </a:cubicBezTo>
+                <a:cubicBezTo>
+                  <a:pt x="877231" y="16191"/>
+                  <a:pt x="561097" y="37643"/>
+                  <a:pt x="0" y="18288"/>
+                </a:cubicBezTo>
+                <a:cubicBezTo>
+                  <a:pt x="-46" y="12483"/>
+                  <a:pt x="-203" y="6491"/>
+                  <a:pt x="0" y="0"/>
+                </a:cubicBezTo>
+                <a:close/>
+              </a:path>
+              <a:path w="3255095" h="18288" stroke="0" extrusionOk="0">
+                <a:moveTo>
+                  <a:pt x="0" y="0"/>
+                </a:moveTo>
+                <a:cubicBezTo>
+                  <a:pt x="291965" y="19429"/>
+                  <a:pt x="363155" y="8568"/>
+                  <a:pt x="618468" y="0"/>
+                </a:cubicBezTo>
+                <a:cubicBezTo>
+                  <a:pt x="873781" y="-8568"/>
+                  <a:pt x="904459" y="-19505"/>
+                  <a:pt x="1171834" y="0"/>
+                </a:cubicBezTo>
+                <a:cubicBezTo>
+                  <a:pt x="1439209" y="19505"/>
+                  <a:pt x="1744369" y="9790"/>
+                  <a:pt x="1887955" y="0"/>
+                </a:cubicBezTo>
+                <a:cubicBezTo>
+                  <a:pt x="2031541" y="-9790"/>
+                  <a:pt x="2346378" y="21240"/>
+                  <a:pt x="2506423" y="0"/>
+                </a:cubicBezTo>
+                <a:cubicBezTo>
+                  <a:pt x="2666468" y="-21240"/>
+                  <a:pt x="2990257" y="30414"/>
+                  <a:pt x="3255095" y="0"/>
+                </a:cubicBezTo>
+                <a:cubicBezTo>
+                  <a:pt x="3254831" y="4493"/>
+                  <a:pt x="3255479" y="9472"/>
+                  <a:pt x="3255095" y="18288"/>
+                </a:cubicBezTo>
+                <a:cubicBezTo>
+                  <a:pt x="3120743" y="16690"/>
+                  <a:pt x="2759628" y="42462"/>
+                  <a:pt x="2604076" y="18288"/>
+                </a:cubicBezTo>
+                <a:cubicBezTo>
+                  <a:pt x="2448524" y="-5886"/>
+                  <a:pt x="2184336" y="19599"/>
+                  <a:pt x="1887955" y="18288"/>
+                </a:cubicBezTo>
+                <a:cubicBezTo>
+                  <a:pt x="1591574" y="16977"/>
+                  <a:pt x="1548845" y="6870"/>
+                  <a:pt x="1334589" y="18288"/>
+                </a:cubicBezTo>
+                <a:cubicBezTo>
+                  <a:pt x="1120333" y="29706"/>
+                  <a:pt x="996014" y="9662"/>
+                  <a:pt x="683570" y="18288"/>
+                </a:cubicBezTo>
+                <a:cubicBezTo>
+                  <a:pt x="371126" y="26914"/>
+                  <a:pt x="198687" y="16167"/>
+                  <a:pt x="0" y="18288"/>
+                </a:cubicBezTo>
+                <a:cubicBezTo>
+                  <a:pt x="843" y="9577"/>
+                  <a:pt x="371" y="6900"/>
+                  <a:pt x="0" y="0"/>
+                </a:cubicBezTo>
+                <a:close/>
+              </a:path>
+            </a:pathLst>
+          </a:custGeom>
+          <a:solidFill>
+            <a:schemeClr val="accent2"/>
+          </a:solidFill>
+          <a:ln w="38100" cap="rnd">
+            <a:solidFill>
+              <a:schemeClr val="accent2"/>
+            </a:solidFill>
+            <a:round/>
+            <a:extLst>
+              <a:ext uri="{C807C97D-BFC1-408E-A445-0C87EB9F89A2}">
+                <ask:lineSketchStyleProps xmlns:ask="http://schemas.microsoft.com/office/drawing/2018/sketchyshapes" sd="1219033472">
+                  <a:prstGeom prst="rect">
+                    <a:avLst/>
+                  </a:prstGeom>
+                  <ask:type>
+                    <ask:lineSketchFreehand/>
+                  </ask:type>
+                </ask:lineSketchStyleProps>
+              </a:ext>
+            </a:extLst>
+          </a:ln>
+        </p:spPr>
+        <p:style>
+          <a:lnRef idx="2">
+            <a:schemeClr val="accent1">
+              <a:shade val="50000"/>
+            </a:schemeClr>
+          </a:lnRef>
+          <a:fillRef idx="1">
+            <a:schemeClr val="accent1"/>
+          </a:fillRef>
+          <a:effectRef idx="0">
+            <a:schemeClr val="accent1"/>
+          </a:effectRef>
+          <a:fontRef idx="minor">
+            <a:schemeClr val="lt1"/>
+          </a:fontRef>
+        </p:style>
+        <p:txBody>
+          <a:bodyPr rtlCol="0" anchor="ctr"/>
+          <a:lstStyle/>
+          <a:p>
+            <a:pPr algn="ctr"/>
             <a:endParaRPr lang="cs-CZ" dirty="0"/>
           </a:p>
         </p:txBody>
@@ -6573,50 +7520,52 @@
             <p:ph sz="half" idx="1"/>
           </p:nvPr>
         </p:nvSpPr>
-        <p:spPr/>
-        <p:txBody>
-          <a:bodyPr>
+        <p:spPr>
+          <a:xfrm>
+            <a:off x="630935" y="2807208"/>
+            <a:ext cx="5465065" cy="3410712"/>
+          </a:xfrm>
+        </p:spPr>
+        <p:txBody>
+          <a:bodyPr vert="horz" lIns="91440" tIns="45720" rIns="91440" bIns="45720" rtlCol="0" anchor="t">
             <a:normAutofit/>
           </a:bodyPr>
           <a:lstStyle/>
           <a:p>
             <a:r>
+              <a:rPr lang="cs-CZ" sz="2200" dirty="0"/>
+              <a:t>„rys, vlastnost, příznak“</a:t>
+            </a:r>
+          </a:p>
+          <a:p>
+            <a:r>
+              <a:rPr lang="cs-CZ" sz="2200" dirty="0"/>
+              <a:t>Definují abstraktní chování datových typů</a:t>
+            </a:r>
+          </a:p>
+          <a:p>
+            <a:pPr lvl="1"/>
+            <a:r>
               <a:rPr lang="cs-CZ" sz="2000" dirty="0"/>
-              <a:t>„rys, vlastnost, příznak“</a:t>
-            </a:r>
-          </a:p>
-          <a:p>
+              <a:t>Vlastnosti, metody (funkce na typy)</a:t>
+            </a:r>
+          </a:p>
+          <a:p>
+            <a:r>
+              <a:rPr lang="cs-CZ" sz="2200" dirty="0"/>
+              <a:t>Funkce „univerzální“ přes různé typy</a:t>
+            </a:r>
+          </a:p>
+          <a:p>
+            <a:pPr lvl="1"/>
+            <a:r>
+              <a:rPr lang="cs-CZ" sz="2000" dirty="0" err="1"/>
+              <a:t>Traity</a:t>
+            </a:r>
             <a:r>
               <a:rPr lang="cs-CZ" sz="2000" dirty="0"/>
-              <a:t>Definují abstraktní chování datových typů</a:t>
-            </a:r>
-          </a:p>
-          <a:p>
-            <a:pPr lvl="1"/>
-            <a:r>
-              <a:rPr lang="cs-CZ" sz="1600" dirty="0"/>
-              <a:t>Vlastnosti, metody (funkce na typy)</a:t>
-            </a:r>
-          </a:p>
-          <a:p>
-            <a:r>
-              <a:rPr lang="cs-CZ" sz="2000" dirty="0"/>
-              <a:t>Funkce „univerzální“ přes různé typy</a:t>
-            </a:r>
-          </a:p>
-          <a:p>
-            <a:pPr lvl="1"/>
-            <a:r>
-              <a:rPr lang="cs-CZ" sz="1600" dirty="0" err="1"/>
-              <a:t>Traity</a:t>
-            </a:r>
-            <a:r>
-              <a:rPr lang="cs-CZ" sz="1600" dirty="0"/>
               <a:t> omezují generické parametry</a:t>
             </a:r>
-          </a:p>
-          <a:p>
-            <a:endParaRPr lang="en-US" sz="2000" dirty="0"/>
           </a:p>
         </p:txBody>
       </p:sp>
@@ -6651,8 +7600,8 @@
         </p:blipFill>
         <p:spPr>
           <a:xfrm>
-            <a:off x="6172202" y="365125"/>
-            <a:ext cx="5392420" cy="6127750"/>
+            <a:off x="6655622" y="640080"/>
+            <a:ext cx="4905446" cy="5577840"/>
           </a:xfrm>
           <a:prstGeom prst="rect">
             <a:avLst/>
@@ -6663,6 +7612,651 @@
     <p:extLst>
       <p:ext uri="{BB962C8B-B14F-4D97-AF65-F5344CB8AC3E}">
         <p14:creationId xmlns:p14="http://schemas.microsoft.com/office/powerpoint/2010/main" val="298307023"/>
+      </p:ext>
+    </p:extLst>
+  </p:cSld>
+  <p:clrMapOvr>
+    <a:masterClrMapping/>
+  </p:clrMapOvr>
+</p:sld>
+</file>
+
+<file path=ppt/slides/slide8.xml><?xml version="1.0" encoding="utf-8"?>
+<p:sld xmlns:a="http://schemas.openxmlformats.org/drawingml/2006/main" xmlns:r="http://schemas.openxmlformats.org/officeDocument/2006/relationships" xmlns:p="http://schemas.openxmlformats.org/presentationml/2006/main">
+  <p:cSld>
+    <p:bg>
+      <p:bgPr>
+        <a:solidFill>
+          <a:schemeClr val="bg1"/>
+        </a:solidFill>
+        <a:effectLst/>
+      </p:bgPr>
+    </p:bg>
+    <p:spTree>
+      <p:nvGrpSpPr>
+        <p:cNvPr id="1" name="">
+          <a:extLst>
+            <a:ext uri="{FF2B5EF4-FFF2-40B4-BE49-F238E27FC236}">
+              <a16:creationId xmlns:a16="http://schemas.microsoft.com/office/drawing/2014/main" id="{9EC53ACE-5A18-0223-F078-F212AF8D0543}"/>
+            </a:ext>
+          </a:extLst>
+        </p:cNvPr>
+        <p:cNvGrpSpPr/>
+        <p:nvPr/>
+      </p:nvGrpSpPr>
+      <p:grpSpPr>
+        <a:xfrm>
+          <a:off x="0" y="0"/>
+          <a:ext cx="0" cy="0"/>
+          <a:chOff x="0" y="0"/>
+          <a:chExt cx="0" cy="0"/>
+        </a:xfrm>
+      </p:grpSpPr>
+      <p:sp useBgFill="1">
+        <p:nvSpPr>
+          <p:cNvPr id="28" name="Rectangle 27">
+            <a:extLst>
+              <a:ext uri="{FF2B5EF4-FFF2-40B4-BE49-F238E27FC236}">
+                <a16:creationId xmlns:a16="http://schemas.microsoft.com/office/drawing/2014/main" id="{2B97F24A-32CE-4C1C-A50D-3016B394DCFB}"/>
+              </a:ext>
+              <a:ext uri="{C183D7F6-B498-43B3-948B-1728B52AA6E4}">
+                <adec:decorative xmlns:adec="http://schemas.microsoft.com/office/drawing/2017/decorative" val="1"/>
+              </a:ext>
+            </a:extLst>
+          </p:cNvPr>
+          <p:cNvSpPr>
+            <a:spLocks noGrp="1" noRot="1" noChangeAspect="1" noMove="1" noResize="1" noEditPoints="1" noAdjustHandles="1" noChangeArrowheads="1" noChangeShapeType="1" noTextEdit="1"/>
+          </p:cNvSpPr>
+          <p:nvPr>
+            <p:extLst>
+              <p:ext uri="{386F3935-93C4-4BCD-93E2-E3B085C9AB24}">
+                <p16:designElem xmlns:p16="http://schemas.microsoft.com/office/powerpoint/2015/main" val="1"/>
+              </p:ext>
+            </p:extLst>
+          </p:nvPr>
+        </p:nvSpPr>
+        <p:spPr>
+          <a:xfrm>
+            <a:off x="0" y="0"/>
+            <a:ext cx="12192000" cy="6858000"/>
+          </a:xfrm>
+          <a:prstGeom prst="rect">
+            <a:avLst/>
+          </a:prstGeom>
+          <a:ln>
+            <a:noFill/>
+          </a:ln>
+        </p:spPr>
+        <p:style>
+          <a:lnRef idx="2">
+            <a:schemeClr val="accent1">
+              <a:shade val="50000"/>
+            </a:schemeClr>
+          </a:lnRef>
+          <a:fillRef idx="1">
+            <a:schemeClr val="accent1"/>
+          </a:fillRef>
+          <a:effectRef idx="0">
+            <a:schemeClr val="accent1"/>
+          </a:effectRef>
+          <a:fontRef idx="minor">
+            <a:schemeClr val="lt1"/>
+          </a:fontRef>
+        </p:style>
+        <p:txBody>
+          <a:bodyPr rtlCol="0" anchor="ctr"/>
+          <a:lstStyle/>
+          <a:p>
+            <a:pPr algn="ctr"/>
+            <a:endParaRPr lang="cs-CZ" noProof="0" dirty="0"/>
+          </a:p>
+        </p:txBody>
+      </p:sp>
+      <p:sp>
+        <p:nvSpPr>
+          <p:cNvPr id="2" name="Title 1">
+            <a:extLst>
+              <a:ext uri="{FF2B5EF4-FFF2-40B4-BE49-F238E27FC236}">
+                <a16:creationId xmlns:a16="http://schemas.microsoft.com/office/drawing/2014/main" id="{D9AF63F9-96E4-CAE6-8E27-BAD90F2D31C2}"/>
+              </a:ext>
+            </a:extLst>
+          </p:cNvPr>
+          <p:cNvSpPr>
+            <a:spLocks noGrp="1"/>
+          </p:cNvSpPr>
+          <p:nvPr>
+            <p:ph type="title"/>
+          </p:nvPr>
+        </p:nvSpPr>
+        <p:spPr>
+          <a:xfrm>
+            <a:off x="630936" y="639520"/>
+            <a:ext cx="3429000" cy="1719072"/>
+          </a:xfrm>
+        </p:spPr>
+        <p:txBody>
+          <a:bodyPr vert="horz" lIns="91440" tIns="45720" rIns="91440" bIns="45720" rtlCol="0" anchor="b">
+            <a:normAutofit/>
+          </a:bodyPr>
+          <a:lstStyle/>
+          <a:p>
+            <a:r>
+              <a:rPr lang="cs-CZ" sz="5400" kern="1200">
+                <a:solidFill>
+                  <a:schemeClr val="tx1"/>
+                </a:solidFill>
+                <a:latin typeface="+mj-lt"/>
+                <a:ea typeface="+mj-ea"/>
+                <a:cs typeface="+mj-cs"/>
+              </a:rPr>
+              <a:t>Traity 2</a:t>
+            </a:r>
+            <a:endParaRPr lang="cs-CZ" sz="5400" kern="1200" dirty="0">
+              <a:solidFill>
+                <a:schemeClr val="tx1"/>
+              </a:solidFill>
+              <a:latin typeface="+mj-lt"/>
+              <a:ea typeface="+mj-ea"/>
+              <a:cs typeface="+mj-cs"/>
+            </a:endParaRPr>
+          </a:p>
+        </p:txBody>
+      </p:sp>
+      <p:sp>
+        <p:nvSpPr>
+          <p:cNvPr id="30" name="sketch line">
+            <a:extLst>
+              <a:ext uri="{FF2B5EF4-FFF2-40B4-BE49-F238E27FC236}">
+                <a16:creationId xmlns:a16="http://schemas.microsoft.com/office/drawing/2014/main" id="{6357EC4F-235E-4222-A36F-C7878ACE37F2}"/>
+              </a:ext>
+              <a:ext uri="{C183D7F6-B498-43B3-948B-1728B52AA6E4}">
+                <adec:decorative xmlns:adec="http://schemas.microsoft.com/office/drawing/2017/decorative" val="1"/>
+              </a:ext>
+            </a:extLst>
+          </p:cNvPr>
+          <p:cNvSpPr>
+            <a:spLocks noGrp="1" noRot="1" noChangeAspect="1" noMove="1" noResize="1" noEditPoints="1" noAdjustHandles="1" noChangeArrowheads="1" noChangeShapeType="1" noTextEdit="1"/>
+          </p:cNvSpPr>
+          <p:nvPr>
+            <p:extLst>
+              <p:ext uri="{386F3935-93C4-4BCD-93E2-E3B085C9AB24}">
+                <p16:designElem xmlns:p16="http://schemas.microsoft.com/office/powerpoint/2015/main" val="1"/>
+              </p:ext>
+            </p:extLst>
+          </p:nvPr>
+        </p:nvSpPr>
+        <p:spPr>
+          <a:xfrm>
+            <a:off x="643278" y="2573756"/>
+            <a:ext cx="3255095" cy="18288"/>
+          </a:xfrm>
+          <a:custGeom>
+            <a:avLst/>
+            <a:gdLst>
+              <a:gd name="csX0" fmla="*/ 0 w 3255095"/>
+              <a:gd name="csY0" fmla="*/ 0 h 18288"/>
+              <a:gd name="csX1" fmla="*/ 618468 w 3255095"/>
+              <a:gd name="csY1" fmla="*/ 0 h 18288"/>
+              <a:gd name="csX2" fmla="*/ 1269487 w 3255095"/>
+              <a:gd name="csY2" fmla="*/ 0 h 18288"/>
+              <a:gd name="csX3" fmla="*/ 1953057 w 3255095"/>
+              <a:gd name="csY3" fmla="*/ 0 h 18288"/>
+              <a:gd name="csX4" fmla="*/ 2636627 w 3255095"/>
+              <a:gd name="csY4" fmla="*/ 0 h 18288"/>
+              <a:gd name="csX5" fmla="*/ 3255095 w 3255095"/>
+              <a:gd name="csY5" fmla="*/ 0 h 18288"/>
+              <a:gd name="csX6" fmla="*/ 3255095 w 3255095"/>
+              <a:gd name="csY6" fmla="*/ 18288 h 18288"/>
+              <a:gd name="csX7" fmla="*/ 2538974 w 3255095"/>
+              <a:gd name="csY7" fmla="*/ 18288 h 18288"/>
+              <a:gd name="csX8" fmla="*/ 1822853 w 3255095"/>
+              <a:gd name="csY8" fmla="*/ 18288 h 18288"/>
+              <a:gd name="csX9" fmla="*/ 1171834 w 3255095"/>
+              <a:gd name="csY9" fmla="*/ 18288 h 18288"/>
+              <a:gd name="csX10" fmla="*/ 0 w 3255095"/>
+              <a:gd name="csY10" fmla="*/ 18288 h 18288"/>
+              <a:gd name="csX11" fmla="*/ 0 w 3255095"/>
+              <a:gd name="csY11" fmla="*/ 0 h 18288"/>
+            </a:gdLst>
+            <a:ahLst/>
+            <a:cxnLst>
+              <a:cxn ang="0">
+                <a:pos x="csX0" y="csY0"/>
+              </a:cxn>
+              <a:cxn ang="0">
+                <a:pos x="csX1" y="csY1"/>
+              </a:cxn>
+              <a:cxn ang="0">
+                <a:pos x="csX2" y="csY2"/>
+              </a:cxn>
+              <a:cxn ang="0">
+                <a:pos x="csX3" y="csY3"/>
+              </a:cxn>
+              <a:cxn ang="0">
+                <a:pos x="csX4" y="csY4"/>
+              </a:cxn>
+              <a:cxn ang="0">
+                <a:pos x="csX5" y="csY5"/>
+              </a:cxn>
+              <a:cxn ang="0">
+                <a:pos x="csX6" y="csY6"/>
+              </a:cxn>
+              <a:cxn ang="0">
+                <a:pos x="csX7" y="csY7"/>
+              </a:cxn>
+              <a:cxn ang="0">
+                <a:pos x="csX8" y="csY8"/>
+              </a:cxn>
+              <a:cxn ang="0">
+                <a:pos x="csX9" y="csY9"/>
+              </a:cxn>
+              <a:cxn ang="0">
+                <a:pos x="csX10" y="csY10"/>
+              </a:cxn>
+              <a:cxn ang="0">
+                <a:pos x="csX11" y="csY11"/>
+              </a:cxn>
+            </a:cxnLst>
+            <a:rect l="l" t="t" r="r" b="b"/>
+            <a:pathLst>
+              <a:path w="3255095" h="18288" fill="none" extrusionOk="0">
+                <a:moveTo>
+                  <a:pt x="0" y="0"/>
+                </a:moveTo>
+                <a:cubicBezTo>
+                  <a:pt x="240201" y="-22123"/>
+                  <a:pt x="462021" y="-19623"/>
+                  <a:pt x="618468" y="0"/>
+                </a:cubicBezTo>
+                <a:cubicBezTo>
+                  <a:pt x="774915" y="19623"/>
+                  <a:pt x="974734" y="2035"/>
+                  <a:pt x="1269487" y="0"/>
+                </a:cubicBezTo>
+                <a:cubicBezTo>
+                  <a:pt x="1564240" y="-2035"/>
+                  <a:pt x="1733579" y="10639"/>
+                  <a:pt x="1953057" y="0"/>
+                </a:cubicBezTo>
+                <a:cubicBezTo>
+                  <a:pt x="2172535" y="-10639"/>
+                  <a:pt x="2453962" y="14018"/>
+                  <a:pt x="2636627" y="0"/>
+                </a:cubicBezTo>
+                <a:cubicBezTo>
+                  <a:pt x="2819292" y="-14018"/>
+                  <a:pt x="3121375" y="5399"/>
+                  <a:pt x="3255095" y="0"/>
+                </a:cubicBezTo>
+                <a:cubicBezTo>
+                  <a:pt x="3254386" y="8157"/>
+                  <a:pt x="3254682" y="12125"/>
+                  <a:pt x="3255095" y="18288"/>
+                </a:cubicBezTo>
+                <a:cubicBezTo>
+                  <a:pt x="3088545" y="23203"/>
+                  <a:pt x="2687475" y="7419"/>
+                  <a:pt x="2538974" y="18288"/>
+                </a:cubicBezTo>
+                <a:cubicBezTo>
+                  <a:pt x="2390473" y="29157"/>
+                  <a:pt x="2137381" y="-8959"/>
+                  <a:pt x="1822853" y="18288"/>
+                </a:cubicBezTo>
+                <a:cubicBezTo>
+                  <a:pt x="1508325" y="45535"/>
+                  <a:pt x="1466437" y="20385"/>
+                  <a:pt x="1171834" y="18288"/>
+                </a:cubicBezTo>
+                <a:cubicBezTo>
+                  <a:pt x="877231" y="16191"/>
+                  <a:pt x="561097" y="37643"/>
+                  <a:pt x="0" y="18288"/>
+                </a:cubicBezTo>
+                <a:cubicBezTo>
+                  <a:pt x="-46" y="12483"/>
+                  <a:pt x="-203" y="6491"/>
+                  <a:pt x="0" y="0"/>
+                </a:cubicBezTo>
+                <a:close/>
+              </a:path>
+              <a:path w="3255095" h="18288" stroke="0" extrusionOk="0">
+                <a:moveTo>
+                  <a:pt x="0" y="0"/>
+                </a:moveTo>
+                <a:cubicBezTo>
+                  <a:pt x="291965" y="19429"/>
+                  <a:pt x="363155" y="8568"/>
+                  <a:pt x="618468" y="0"/>
+                </a:cubicBezTo>
+                <a:cubicBezTo>
+                  <a:pt x="873781" y="-8568"/>
+                  <a:pt x="904459" y="-19505"/>
+                  <a:pt x="1171834" y="0"/>
+                </a:cubicBezTo>
+                <a:cubicBezTo>
+                  <a:pt x="1439209" y="19505"/>
+                  <a:pt x="1744369" y="9790"/>
+                  <a:pt x="1887955" y="0"/>
+                </a:cubicBezTo>
+                <a:cubicBezTo>
+                  <a:pt x="2031541" y="-9790"/>
+                  <a:pt x="2346378" y="21240"/>
+                  <a:pt x="2506423" y="0"/>
+                </a:cubicBezTo>
+                <a:cubicBezTo>
+                  <a:pt x="2666468" y="-21240"/>
+                  <a:pt x="2990257" y="30414"/>
+                  <a:pt x="3255095" y="0"/>
+                </a:cubicBezTo>
+                <a:cubicBezTo>
+                  <a:pt x="3254831" y="4493"/>
+                  <a:pt x="3255479" y="9472"/>
+                  <a:pt x="3255095" y="18288"/>
+                </a:cubicBezTo>
+                <a:cubicBezTo>
+                  <a:pt x="3120743" y="16690"/>
+                  <a:pt x="2759628" y="42462"/>
+                  <a:pt x="2604076" y="18288"/>
+                </a:cubicBezTo>
+                <a:cubicBezTo>
+                  <a:pt x="2448524" y="-5886"/>
+                  <a:pt x="2184336" y="19599"/>
+                  <a:pt x="1887955" y="18288"/>
+                </a:cubicBezTo>
+                <a:cubicBezTo>
+                  <a:pt x="1591574" y="16977"/>
+                  <a:pt x="1548845" y="6870"/>
+                  <a:pt x="1334589" y="18288"/>
+                </a:cubicBezTo>
+                <a:cubicBezTo>
+                  <a:pt x="1120333" y="29706"/>
+                  <a:pt x="996014" y="9662"/>
+                  <a:pt x="683570" y="18288"/>
+                </a:cubicBezTo>
+                <a:cubicBezTo>
+                  <a:pt x="371126" y="26914"/>
+                  <a:pt x="198687" y="16167"/>
+                  <a:pt x="0" y="18288"/>
+                </a:cubicBezTo>
+                <a:cubicBezTo>
+                  <a:pt x="843" y="9577"/>
+                  <a:pt x="371" y="6900"/>
+                  <a:pt x="0" y="0"/>
+                </a:cubicBezTo>
+                <a:close/>
+              </a:path>
+            </a:pathLst>
+          </a:custGeom>
+          <a:solidFill>
+            <a:schemeClr val="accent2"/>
+          </a:solidFill>
+          <a:ln w="38100" cap="rnd">
+            <a:solidFill>
+              <a:schemeClr val="accent2"/>
+            </a:solidFill>
+            <a:round/>
+            <a:extLst>
+              <a:ext uri="{C807C97D-BFC1-408E-A445-0C87EB9F89A2}">
+                <ask:lineSketchStyleProps xmlns:ask="http://schemas.microsoft.com/office/drawing/2018/sketchyshapes" sd="1219033472">
+                  <a:prstGeom prst="rect">
+                    <a:avLst/>
+                  </a:prstGeom>
+                  <ask:type>
+                    <ask:lineSketchFreehand/>
+                  </ask:type>
+                </ask:lineSketchStyleProps>
+              </a:ext>
+            </a:extLst>
+          </a:ln>
+        </p:spPr>
+        <p:style>
+          <a:lnRef idx="2">
+            <a:schemeClr val="accent1">
+              <a:shade val="50000"/>
+            </a:schemeClr>
+          </a:lnRef>
+          <a:fillRef idx="1">
+            <a:schemeClr val="accent1"/>
+          </a:fillRef>
+          <a:effectRef idx="0">
+            <a:schemeClr val="accent1"/>
+          </a:effectRef>
+          <a:fontRef idx="minor">
+            <a:schemeClr val="lt1"/>
+          </a:fontRef>
+        </p:style>
+        <p:txBody>
+          <a:bodyPr rtlCol="0" anchor="ctr"/>
+          <a:lstStyle/>
+          <a:p>
+            <a:pPr algn="ctr"/>
+            <a:endParaRPr lang="cs-CZ" noProof="0" dirty="0"/>
+          </a:p>
+        </p:txBody>
+      </p:sp>
+      <p:pic>
+        <p:nvPicPr>
+          <p:cNvPr id="16" name="Graphic 15">
+            <a:extLst>
+              <a:ext uri="{FF2B5EF4-FFF2-40B4-BE49-F238E27FC236}">
+                <a16:creationId xmlns:a16="http://schemas.microsoft.com/office/drawing/2014/main" id="{D05A3046-89B3-C287-04D7-C746C3920836}"/>
+              </a:ext>
+            </a:extLst>
+          </p:cNvPr>
+          <p:cNvPicPr>
+            <a:picLocks noChangeAspect="1"/>
+          </p:cNvPicPr>
+          <p:nvPr/>
+        </p:nvPicPr>
+        <p:blipFill>
+          <a:blip>
+            <a:extLst>
+              <a:ext uri="{96DAC541-7B7A-43D3-8B79-37D633B846F1}">
+                <asvg:svgBlip xmlns:asvg="http://schemas.microsoft.com/office/drawing/2016/SVG/main" r:embed="rId3"/>
+              </a:ext>
+            </a:extLst>
+          </a:blip>
+          <a:srcRect/>
+          <a:stretch/>
+        </p:blipFill>
+        <p:spPr>
+          <a:xfrm>
+            <a:off x="5201392" y="1043156"/>
+            <a:ext cx="6362250" cy="4771688"/>
+          </a:xfrm>
+          <a:prstGeom prst="rect">
+            <a:avLst/>
+          </a:prstGeom>
+        </p:spPr>
+      </p:pic>
+      <p:sp>
+        <p:nvSpPr>
+          <p:cNvPr id="13" name="Content Placeholder 12">
+            <a:extLst>
+              <a:ext uri="{FF2B5EF4-FFF2-40B4-BE49-F238E27FC236}">
+                <a16:creationId xmlns:a16="http://schemas.microsoft.com/office/drawing/2014/main" id="{7A44BED2-120E-0B7F-D74E-A629CFE6635F}"/>
+              </a:ext>
+            </a:extLst>
+          </p:cNvPr>
+          <p:cNvSpPr>
+            <a:spLocks noGrp="1"/>
+          </p:cNvSpPr>
+          <p:nvPr>
+            <p:ph sz="half" idx="1"/>
+          </p:nvPr>
+        </p:nvSpPr>
+        <p:spPr>
+          <a:xfrm>
+            <a:off x="630936" y="2807208"/>
+            <a:ext cx="4570456" cy="3410712"/>
+          </a:xfrm>
+        </p:spPr>
+        <p:txBody>
+          <a:bodyPr vert="horz" lIns="91440" tIns="45720" rIns="91440" bIns="45720" rtlCol="0" anchor="t">
+            <a:normAutofit/>
+          </a:bodyPr>
+          <a:lstStyle/>
+          <a:p>
+            <a:r>
+              <a:rPr lang="cs-CZ" sz="2200" dirty="0"/>
+              <a:t>Přenositelné knihovny</a:t>
+            </a:r>
+          </a:p>
+          <a:p>
+            <a:pPr lvl="1"/>
+            <a:r>
+              <a:rPr lang="cs-CZ" sz="2000" dirty="0" err="1"/>
+              <a:t>Traity</a:t>
+            </a:r>
+            <a:r>
+              <a:rPr lang="cs-CZ" sz="2000" dirty="0"/>
+              <a:t> poskytují jednotné rozhraní pro různé </a:t>
+            </a:r>
+            <a:r>
+              <a:rPr lang="cs-CZ" sz="2000" dirty="0" err="1"/>
+              <a:t>backendy</a:t>
+            </a:r>
+            <a:endParaRPr lang="cs-CZ" sz="2000" dirty="0"/>
+          </a:p>
+          <a:p>
+            <a:pPr lvl="1"/>
+            <a:r>
+              <a:rPr lang="cs-CZ" sz="2000" dirty="0"/>
+              <a:t>Knihovny pak mohou být psány oproti těmto rozhraním namísto konkrétních implementací</a:t>
+            </a:r>
+            <a:endParaRPr lang="cs-CZ" sz="2200" dirty="0"/>
+          </a:p>
+          <a:p>
+            <a:r>
+              <a:rPr lang="cs-CZ" sz="2200" dirty="0"/>
+              <a:t>Příklad: </a:t>
+            </a:r>
+            <a:r>
+              <a:rPr lang="cs-CZ" sz="2200" dirty="0" err="1">
+                <a:highlight>
+                  <a:srgbClr val="C0C0C0"/>
+                </a:highlight>
+              </a:rPr>
+              <a:t>embedded</a:t>
+            </a:r>
+            <a:r>
+              <a:rPr lang="cs-CZ" sz="2200" dirty="0">
+                <a:highlight>
+                  <a:srgbClr val="C0C0C0"/>
+                </a:highlight>
+              </a:rPr>
+              <a:t>-hal</a:t>
+            </a:r>
+            <a:r>
+              <a:rPr lang="cs-CZ" sz="2200" dirty="0"/>
+              <a:t> (různé mikrořadiče, jedno rozhraní)</a:t>
+            </a:r>
+          </a:p>
+        </p:txBody>
+      </p:sp>
+    </p:spTree>
+    <p:extLst>
+      <p:ext uri="{BB962C8B-B14F-4D97-AF65-F5344CB8AC3E}">
+        <p14:creationId xmlns:p14="http://schemas.microsoft.com/office/powerpoint/2010/main" val="3835894341"/>
+      </p:ext>
+    </p:extLst>
+  </p:cSld>
+  <p:clrMapOvr>
+    <a:masterClrMapping/>
+  </p:clrMapOvr>
+</p:sld>
+</file>
+
+<file path=ppt/slides/slide9.xml><?xml version="1.0" encoding="utf-8"?>
+<p:sld xmlns:a="http://schemas.openxmlformats.org/drawingml/2006/main" xmlns:r="http://schemas.openxmlformats.org/officeDocument/2006/relationships" xmlns:p="http://schemas.openxmlformats.org/presentationml/2006/main">
+  <p:cSld>
+    <p:spTree>
+      <p:nvGrpSpPr>
+        <p:cNvPr id="1" name=""/>
+        <p:cNvGrpSpPr/>
+        <p:nvPr/>
+      </p:nvGrpSpPr>
+      <p:grpSpPr>
+        <a:xfrm>
+          <a:off x="0" y="0"/>
+          <a:ext cx="0" cy="0"/>
+          <a:chOff x="0" y="0"/>
+          <a:chExt cx="0" cy="0"/>
+        </a:xfrm>
+      </p:grpSpPr>
+      <p:sp>
+        <p:nvSpPr>
+          <p:cNvPr id="5" name="Title 4">
+            <a:extLst>
+              <a:ext uri="{FF2B5EF4-FFF2-40B4-BE49-F238E27FC236}">
+                <a16:creationId xmlns:a16="http://schemas.microsoft.com/office/drawing/2014/main" id="{1F9CC341-C25B-F877-D447-AF84B4A23EEB}"/>
+              </a:ext>
+            </a:extLst>
+          </p:cNvPr>
+          <p:cNvSpPr>
+            <a:spLocks noGrp="1"/>
+          </p:cNvSpPr>
+          <p:nvPr>
+            <p:ph type="title"/>
+          </p:nvPr>
+        </p:nvSpPr>
+        <p:spPr/>
+        <p:txBody>
+          <a:bodyPr/>
+          <a:lstStyle/>
+          <a:p>
+            <a:r>
+              <a:rPr lang="cs-CZ" dirty="0"/>
+              <a:t>Architektura programu</a:t>
+            </a:r>
+          </a:p>
+        </p:txBody>
+      </p:sp>
+      <p:sp>
+        <p:nvSpPr>
+          <p:cNvPr id="6" name="Content Placeholder 5">
+            <a:extLst>
+              <a:ext uri="{FF2B5EF4-FFF2-40B4-BE49-F238E27FC236}">
+                <a16:creationId xmlns:a16="http://schemas.microsoft.com/office/drawing/2014/main" id="{9D2AB956-920E-CF3C-3578-10FABD0ACECA}"/>
+              </a:ext>
+            </a:extLst>
+          </p:cNvPr>
+          <p:cNvSpPr>
+            <a:spLocks noGrp="1"/>
+          </p:cNvSpPr>
+          <p:nvPr>
+            <p:ph idx="1"/>
+          </p:nvPr>
+        </p:nvSpPr>
+        <p:spPr/>
+        <p:txBody>
+          <a:bodyPr/>
+          <a:lstStyle/>
+          <a:p>
+            <a:r>
+              <a:rPr lang="cs-CZ" dirty="0"/>
+              <a:t>Setup, event </a:t>
+            </a:r>
+            <a:r>
+              <a:rPr lang="cs-CZ" dirty="0" err="1"/>
+              <a:t>loop</a:t>
+            </a:r>
+            <a:endParaRPr lang="cs-CZ" dirty="0"/>
+          </a:p>
+          <a:p>
+            <a:r>
+              <a:rPr lang="cs-CZ" dirty="0" err="1"/>
+              <a:t>modules</a:t>
+            </a:r>
+            <a:endParaRPr lang="cs-CZ" dirty="0"/>
+          </a:p>
+        </p:txBody>
+      </p:sp>
+    </p:spTree>
+    <p:extLst>
+      <p:ext uri="{BB962C8B-B14F-4D97-AF65-F5344CB8AC3E}">
+        <p14:creationId xmlns:p14="http://schemas.microsoft.com/office/powerpoint/2010/main" val="2334217468"/>
       </p:ext>
     </p:extLst>
   </p:cSld>

</xml_diff>

<commit_message>
WIP: Ownership and borrowing
</commit_message>
<xml_diff>
--- a/Prezentace.pptx
+++ b/Prezentace.pptx
@@ -5,7 +5,7 @@
     <p:sldMasterId id="2147483648" r:id="rId1"/>
   </p:sldMasterIdLst>
   <p:notesMasterIdLst>
-    <p:notesMasterId r:id="rId15"/>
+    <p:notesMasterId r:id="rId17"/>
   </p:notesMasterIdLst>
   <p:sldIdLst>
     <p:sldId id="256" r:id="rId2"/>
@@ -14,13 +14,15 @@
     <p:sldId id="261" r:id="rId5"/>
     <p:sldId id="263" r:id="rId6"/>
     <p:sldId id="258" r:id="rId7"/>
-    <p:sldId id="262" r:id="rId8"/>
-    <p:sldId id="264" r:id="rId9"/>
-    <p:sldId id="265" r:id="rId10"/>
-    <p:sldId id="266" r:id="rId11"/>
-    <p:sldId id="267" r:id="rId12"/>
-    <p:sldId id="268" r:id="rId13"/>
-    <p:sldId id="269" r:id="rId14"/>
+    <p:sldId id="271" r:id="rId8"/>
+    <p:sldId id="270" r:id="rId9"/>
+    <p:sldId id="262" r:id="rId10"/>
+    <p:sldId id="264" r:id="rId11"/>
+    <p:sldId id="265" r:id="rId12"/>
+    <p:sldId id="266" r:id="rId13"/>
+    <p:sldId id="267" r:id="rId14"/>
+    <p:sldId id="268" r:id="rId15"/>
+    <p:sldId id="269" r:id="rId16"/>
   </p:sldIdLst>
   <p:sldSz cx="12192000" cy="6858000"/>
   <p:notesSz cx="6858000" cy="9144000"/>
@@ -1051,6 +1053,16 @@
               <a:buChar char="•"/>
             </a:pPr>
             <a:r>
+              <a:rPr lang="cs-CZ" i="0" dirty="0"/>
+              <a:t>Vlastnictví a půjčování popsán dále</a:t>
+            </a:r>
+          </a:p>
+          <a:p>
+            <a:pPr marL="171450" indent="-171450">
+              <a:buFont typeface="Arial" panose="020B0604020202020204" pitchFamily="34" charset="0"/>
+              <a:buChar char="•"/>
+            </a:pPr>
+            <a:r>
               <a:rPr lang="cs-CZ" i="1" dirty="0"/>
               <a:t>Již během kompilace</a:t>
             </a:r>
@@ -1118,6 +1130,20 @@
               <a:buChar char="•"/>
             </a:pPr>
             <a:r>
+              <a:rPr lang="cs-CZ" dirty="0" err="1"/>
+              <a:t>Enum</a:t>
+            </a:r>
+            <a:r>
+              <a:rPr lang="cs-CZ" dirty="0"/>
+              <a:t> je disjunktní sjednocení – popsáno dále</a:t>
+            </a:r>
+          </a:p>
+          <a:p>
+            <a:pPr marL="171450" indent="-171450">
+              <a:buFont typeface="Arial" panose="020B0604020202020204" pitchFamily="34" charset="0"/>
+              <a:buChar char="•"/>
+            </a:pPr>
+            <a:r>
               <a:rPr lang="cs-CZ" dirty="0"/>
               <a:t>Žádné zapomenuté kontroly nulového ukazatele; typový systém jasně stanovuje, zda je chyba možná</a:t>
             </a:r>
@@ -1147,6 +1173,24 @@
             <a:r>
               <a:rPr lang="cs-CZ" dirty="0"/>
               <a:t>Generické programování =&gt; jeden kód dokáže pracovat s různými datovými typy, omezuje zbytečnou duplikaci kódu</a:t>
+            </a:r>
+          </a:p>
+          <a:p>
+            <a:pPr marL="171450" indent="-171450">
+              <a:buFont typeface="Arial" panose="020B0604020202020204" pitchFamily="34" charset="0"/>
+              <a:buChar char="•"/>
+            </a:pPr>
+            <a:r>
+              <a:rPr lang="cs-CZ" dirty="0"/>
+              <a:t>Systém </a:t>
+            </a:r>
+            <a:r>
+              <a:rPr lang="cs-CZ" dirty="0" err="1"/>
+              <a:t>traitů</a:t>
+            </a:r>
+            <a:r>
+              <a:rPr lang="cs-CZ" dirty="0"/>
+              <a:t> popsán dále</a:t>
             </a:r>
           </a:p>
           <a:p>
@@ -1326,6 +1370,386 @@
           <a:bodyPr/>
           <a:lstStyle/>
           <a:p>
+            <a:r>
+              <a:rPr lang="cs-CZ" dirty="0" err="1"/>
+              <a:t>Enum</a:t>
+            </a:r>
+            <a:r>
+              <a:rPr lang="cs-CZ" dirty="0"/>
+              <a:t>, česky také „výčtový typ“, je datový typ, ve kterém programátor specifikuje konečnou množinu hodnot, kterých smí nabývat.</a:t>
+            </a:r>
+          </a:p>
+          <a:p>
+            <a:r>
+              <a:rPr lang="cs-CZ" dirty="0"/>
+              <a:t>Každé hodnotě je běžně přiřazen textový identifikátor (a interní číselná reprezentace), který lze dále používat v kódu.</a:t>
+            </a:r>
+          </a:p>
+          <a:p>
+            <a:r>
+              <a:rPr lang="cs-CZ" dirty="0"/>
+              <a:t>Na vrchním obrázku je příklad definice takovéhoto výčtu v jazyce C.</a:t>
+            </a:r>
+          </a:p>
+          <a:p>
+            <a:endParaRPr lang="cs-CZ" dirty="0"/>
+          </a:p>
+          <a:p>
+            <a:r>
+              <a:rPr lang="cs-CZ" dirty="0"/>
+              <a:t>V jazyce Rust ale dokáží </a:t>
+            </a:r>
+            <a:r>
+              <a:rPr lang="cs-CZ" dirty="0" err="1"/>
+              <a:t>enumy</a:t>
+            </a:r>
+            <a:r>
+              <a:rPr lang="cs-CZ" dirty="0"/>
+              <a:t> mnohem více: jedná se o disjunktní sjednocení. To znamená, že je tvořen několika množinami hodnot,</a:t>
+            </a:r>
+          </a:p>
+          <a:p>
+            <a:r>
+              <a:rPr lang="cs-CZ" dirty="0"/>
+              <a:t>a dokáže nabývat jakékoli z nich, ale rozlišuje stejné hodnoty z jiných množin.</a:t>
+            </a:r>
+          </a:p>
+          <a:p>
+            <a:pPr marL="171450" indent="-171450">
+              <a:buFont typeface="Arial" panose="020B0604020202020204" pitchFamily="34" charset="0"/>
+              <a:buChar char="•"/>
+            </a:pPr>
+            <a:r>
+              <a:rPr lang="cs-CZ" dirty="0"/>
+              <a:t>Na příkladu zde je vidět, že když tyto dvě množiny hodnot obsahují hodnotu 2, tak běžné sjednocení by ji nerozlišovalo,</a:t>
+            </a:r>
+            <a:br>
+              <a:rPr lang="cs-CZ" dirty="0"/>
+            </a:br>
+            <a:r>
+              <a:rPr lang="cs-CZ" dirty="0"/>
+              <a:t>ale disjunktní sjednocení rozlišuje mezi 2 z množiny A </a:t>
+            </a:r>
+            <a:r>
+              <a:rPr lang="cs-CZ" dirty="0" err="1"/>
+              <a:t>a</a:t>
+            </a:r>
+            <a:r>
+              <a:rPr lang="cs-CZ" dirty="0"/>
+              <a:t> 2 z množiny B.</a:t>
+            </a:r>
+          </a:p>
+          <a:p>
+            <a:pPr marL="171450" indent="-171450">
+              <a:buFont typeface="Arial" panose="020B0604020202020204" pitchFamily="34" charset="0"/>
+              <a:buChar char="•"/>
+            </a:pPr>
+            <a:r>
+              <a:rPr lang="cs-CZ" dirty="0"/>
+              <a:t>V praxi je to využíváno tak, že každá varianta </a:t>
+            </a:r>
+            <a:r>
+              <a:rPr lang="cs-CZ" dirty="0" err="1"/>
+              <a:t>enumu</a:t>
+            </a:r>
+            <a:r>
+              <a:rPr lang="cs-CZ" dirty="0"/>
+              <a:t> se skládá nejen z identifikátoru,</a:t>
+            </a:r>
+            <a:br>
+              <a:rPr lang="cs-CZ" dirty="0"/>
+            </a:br>
+            <a:r>
+              <a:rPr lang="cs-CZ" dirty="0"/>
+              <a:t>ale volitelně i z jednoho nebo více datového typů, které pak daná varianta bude obsahovat.</a:t>
+            </a:r>
+          </a:p>
+          <a:p>
+            <a:pPr marL="171450" indent="-171450">
+              <a:buFont typeface="Arial" panose="020B0604020202020204" pitchFamily="34" charset="0"/>
+              <a:buChar char="•"/>
+            </a:pPr>
+            <a:r>
+              <a:rPr lang="cs-CZ" dirty="0"/>
+              <a:t>Na spodním obrázku je příklad definice takového </a:t>
+            </a:r>
+            <a:r>
+              <a:rPr lang="cs-CZ" dirty="0" err="1"/>
+              <a:t>enumu</a:t>
+            </a:r>
+            <a:r>
+              <a:rPr lang="cs-CZ" dirty="0"/>
+              <a:t>.</a:t>
+            </a:r>
+          </a:p>
+          <a:p>
+            <a:pPr marL="0" indent="0">
+              <a:buFont typeface="Arial" panose="020B0604020202020204" pitchFamily="34" charset="0"/>
+              <a:buNone/>
+            </a:pPr>
+            <a:endParaRPr lang="cs-CZ" dirty="0"/>
+          </a:p>
+          <a:p>
+            <a:pPr marL="0" indent="0">
+              <a:buFont typeface="Arial" panose="020B0604020202020204" pitchFamily="34" charset="0"/>
+              <a:buNone/>
+            </a:pPr>
+            <a:r>
+              <a:rPr lang="cs-CZ" dirty="0"/>
+              <a:t>Rust hojně využívá </a:t>
+            </a:r>
+            <a:r>
+              <a:rPr lang="cs-CZ" dirty="0" err="1"/>
+              <a:t>enumy</a:t>
+            </a:r>
+            <a:r>
+              <a:rPr lang="cs-CZ" dirty="0"/>
+              <a:t> pro práci s chybami</a:t>
+            </a:r>
+          </a:p>
+          <a:p>
+            <a:pPr marL="171450" indent="-171450">
+              <a:buFont typeface="Arial" panose="020B0604020202020204" pitchFamily="34" charset="0"/>
+              <a:buChar char="•"/>
+            </a:pPr>
+            <a:r>
+              <a:rPr lang="cs-CZ" dirty="0"/>
+              <a:t>Data, která jsou navrácena při úspěchu, jsou obsažena ve variantě Ok</a:t>
+            </a:r>
+          </a:p>
+          <a:p>
+            <a:pPr marL="171450" indent="-171450">
+              <a:buFont typeface="Arial" panose="020B0604020202020204" pitchFamily="34" charset="0"/>
+              <a:buChar char="•"/>
+            </a:pPr>
+            <a:r>
+              <a:rPr lang="cs-CZ" dirty="0"/>
+              <a:t>Data navrácena při chybě (označující nejčastěji druh chyby, ke které došlo) jsou obsažena ve variantě </a:t>
+            </a:r>
+            <a:r>
+              <a:rPr lang="cs-CZ" dirty="0" err="1"/>
+              <a:t>Err</a:t>
+            </a:r>
+            <a:endParaRPr lang="cs-CZ" dirty="0"/>
+          </a:p>
+          <a:p>
+            <a:pPr marL="0" indent="0">
+              <a:buFont typeface="Arial" panose="020B0604020202020204" pitchFamily="34" charset="0"/>
+              <a:buNone/>
+            </a:pPr>
+            <a:endParaRPr lang="cs-CZ" dirty="0"/>
+          </a:p>
+          <a:p>
+            <a:pPr marL="0" indent="0">
+              <a:buFont typeface="Arial" panose="020B0604020202020204" pitchFamily="34" charset="0"/>
+              <a:buNone/>
+            </a:pPr>
+            <a:r>
+              <a:rPr lang="cs-CZ" dirty="0"/>
+              <a:t>Zdroje obrázků: vlastní tvorba</a:t>
+            </a:r>
+          </a:p>
+        </p:txBody>
+      </p:sp>
+      <p:sp>
+        <p:nvSpPr>
+          <p:cNvPr id="4" name="Slide Number Placeholder 3"/>
+          <p:cNvSpPr>
+            <a:spLocks noGrp="1"/>
+          </p:cNvSpPr>
+          <p:nvPr>
+            <p:ph type="sldNum" sz="quarter" idx="5"/>
+          </p:nvPr>
+        </p:nvSpPr>
+        <p:spPr/>
+        <p:txBody>
+          <a:bodyPr/>
+          <a:lstStyle/>
+          <a:p>
+            <a:fld id="{27274CA6-4D7F-431B-9614-EDAF6E1099E6}" type="slidenum">
+              <a:rPr lang="cs-CZ" smtClean="0"/>
+              <a:t>7</a:t>
+            </a:fld>
+            <a:endParaRPr lang="cs-CZ"/>
+          </a:p>
+        </p:txBody>
+      </p:sp>
+    </p:spTree>
+    <p:extLst>
+      <p:ext uri="{BB962C8B-B14F-4D97-AF65-F5344CB8AC3E}">
+        <p14:creationId xmlns:p14="http://schemas.microsoft.com/office/powerpoint/2010/main" val="3849682786"/>
+      </p:ext>
+    </p:extLst>
+  </p:cSld>
+  <p:clrMapOvr>
+    <a:masterClrMapping/>
+  </p:clrMapOvr>
+</p:notes>
+</file>
+
+<file path=ppt/notesSlides/notesSlide7.xml><?xml version="1.0" encoding="utf-8"?>
+<p:notes xmlns:a="http://schemas.openxmlformats.org/drawingml/2006/main" xmlns:r="http://schemas.openxmlformats.org/officeDocument/2006/relationships" xmlns:p="http://schemas.openxmlformats.org/presentationml/2006/main">
+  <p:cSld>
+    <p:spTree>
+      <p:nvGrpSpPr>
+        <p:cNvPr id="1" name=""/>
+        <p:cNvGrpSpPr/>
+        <p:nvPr/>
+      </p:nvGrpSpPr>
+      <p:grpSpPr>
+        <a:xfrm>
+          <a:off x="0" y="0"/>
+          <a:ext cx="0" cy="0"/>
+          <a:chOff x="0" y="0"/>
+          <a:chExt cx="0" cy="0"/>
+        </a:xfrm>
+      </p:grpSpPr>
+      <p:sp>
+        <p:nvSpPr>
+          <p:cNvPr id="2" name="Slide Image Placeholder 1"/>
+          <p:cNvSpPr>
+            <a:spLocks noGrp="1" noRot="1" noChangeAspect="1"/>
+          </p:cNvSpPr>
+          <p:nvPr>
+            <p:ph type="sldImg"/>
+          </p:nvPr>
+        </p:nvSpPr>
+        <p:spPr/>
+      </p:sp>
+      <p:sp>
+        <p:nvSpPr>
+          <p:cNvPr id="3" name="Notes Placeholder 2"/>
+          <p:cNvSpPr>
+            <a:spLocks noGrp="1"/>
+          </p:cNvSpPr>
+          <p:nvPr>
+            <p:ph type="body" idx="1"/>
+          </p:nvPr>
+        </p:nvSpPr>
+        <p:spPr/>
+        <p:txBody>
+          <a:bodyPr/>
+          <a:lstStyle/>
+          <a:p>
+            <a:r>
+              <a:rPr lang="cs-CZ" dirty="0"/>
+              <a:t>Základní „teze“ </a:t>
+            </a:r>
+            <a:r>
+              <a:rPr lang="cs-CZ" dirty="0" err="1"/>
+              <a:t>borrow</a:t>
+            </a:r>
+            <a:r>
+              <a:rPr lang="cs-CZ" dirty="0"/>
+              <a:t> </a:t>
+            </a:r>
+            <a:r>
+              <a:rPr lang="cs-CZ" dirty="0" err="1"/>
+              <a:t>checkeru</a:t>
+            </a:r>
+            <a:r>
+              <a:rPr lang="cs-CZ" dirty="0"/>
+              <a:t> jsou následující:</a:t>
+            </a:r>
+          </a:p>
+          <a:p>
+            <a:endParaRPr lang="cs-CZ" dirty="0"/>
+          </a:p>
+          <a:p>
+            <a:r>
+              <a:rPr lang="cs-CZ" dirty="0"/>
+              <a:t>Každá hodnota má svého jediného vlastníka</a:t>
+            </a:r>
+          </a:p>
+          <a:p>
+            <a:pPr marL="171450" indent="-171450">
+              <a:buFont typeface="Arial" panose="020B0604020202020204" pitchFamily="34" charset="0"/>
+              <a:buChar char="•"/>
+            </a:pPr>
+            <a:endParaRPr lang="cs-CZ" dirty="0"/>
+          </a:p>
+        </p:txBody>
+      </p:sp>
+      <p:sp>
+        <p:nvSpPr>
+          <p:cNvPr id="4" name="Slide Number Placeholder 3"/>
+          <p:cNvSpPr>
+            <a:spLocks noGrp="1"/>
+          </p:cNvSpPr>
+          <p:nvPr>
+            <p:ph type="sldNum" sz="quarter" idx="5"/>
+          </p:nvPr>
+        </p:nvSpPr>
+        <p:spPr/>
+        <p:txBody>
+          <a:bodyPr/>
+          <a:lstStyle/>
+          <a:p>
+            <a:fld id="{27274CA6-4D7F-431B-9614-EDAF6E1099E6}" type="slidenum">
+              <a:rPr lang="cs-CZ" smtClean="0"/>
+              <a:t>8</a:t>
+            </a:fld>
+            <a:endParaRPr lang="cs-CZ"/>
+          </a:p>
+        </p:txBody>
+      </p:sp>
+    </p:spTree>
+    <p:extLst>
+      <p:ext uri="{BB962C8B-B14F-4D97-AF65-F5344CB8AC3E}">
+        <p14:creationId xmlns:p14="http://schemas.microsoft.com/office/powerpoint/2010/main" val="3561771506"/>
+      </p:ext>
+    </p:extLst>
+  </p:cSld>
+  <p:clrMapOvr>
+    <a:masterClrMapping/>
+  </p:clrMapOvr>
+</p:notes>
+</file>
+
+<file path=ppt/notesSlides/notesSlide8.xml><?xml version="1.0" encoding="utf-8"?>
+<p:notes xmlns:a="http://schemas.openxmlformats.org/drawingml/2006/main" xmlns:r="http://schemas.openxmlformats.org/officeDocument/2006/relationships" xmlns:p="http://schemas.openxmlformats.org/presentationml/2006/main">
+  <p:cSld>
+    <p:spTree>
+      <p:nvGrpSpPr>
+        <p:cNvPr id="1" name=""/>
+        <p:cNvGrpSpPr/>
+        <p:nvPr/>
+      </p:nvGrpSpPr>
+      <p:grpSpPr>
+        <a:xfrm>
+          <a:off x="0" y="0"/>
+          <a:ext cx="0" cy="0"/>
+          <a:chOff x="0" y="0"/>
+          <a:chExt cx="0" cy="0"/>
+        </a:xfrm>
+      </p:grpSpPr>
+      <p:sp>
+        <p:nvSpPr>
+          <p:cNvPr id="2" name="Slide Image Placeholder 1"/>
+          <p:cNvSpPr>
+            <a:spLocks noGrp="1" noRot="1" noChangeAspect="1"/>
+          </p:cNvSpPr>
+          <p:nvPr>
+            <p:ph type="sldImg"/>
+          </p:nvPr>
+        </p:nvSpPr>
+        <p:spPr/>
+      </p:sp>
+      <p:sp>
+        <p:nvSpPr>
+          <p:cNvPr id="3" name="Notes Placeholder 2"/>
+          <p:cNvSpPr>
+            <a:spLocks noGrp="1"/>
+          </p:cNvSpPr>
+          <p:nvPr>
+            <p:ph type="body" idx="1"/>
+          </p:nvPr>
+        </p:nvSpPr>
+        <p:spPr/>
+        <p:txBody>
+          <a:bodyPr/>
+          <a:lstStyle/>
+          <a:p>
             <a:pPr marL="0" marR="0" lvl="0" indent="0" algn="l" defTabSz="914400" rtl="0" eaLnBrk="1" fontAlgn="auto" latinLnBrk="0" hangingPunct="1">
               <a:lnSpc>
                 <a:spcPct val="100000"/>
@@ -1627,7 +2051,7 @@
           <a:p>
             <a:fld id="{27274CA6-4D7F-431B-9614-EDAF6E1099E6}" type="slidenum">
               <a:rPr lang="cs-CZ" smtClean="0"/>
-              <a:t>7</a:t>
+              <a:t>9</a:t>
             </a:fld>
             <a:endParaRPr lang="cs-CZ"/>
           </a:p>
@@ -1646,7 +2070,7 @@
 </p:notes>
 </file>
 
-<file path=ppt/notesSlides/notesSlide7.xml><?xml version="1.0" encoding="utf-8"?>
+<file path=ppt/notesSlides/notesSlide9.xml><?xml version="1.0" encoding="utf-8"?>
 <p:notes xmlns:a="http://schemas.openxmlformats.org/drawingml/2006/main" xmlns:r="http://schemas.openxmlformats.org/officeDocument/2006/relationships" xmlns:p="http://schemas.openxmlformats.org/presentationml/2006/main">
   <p:cSld>
     <p:spTree>
@@ -1914,7 +2338,7 @@
           <a:p>
             <a:fld id="{27274CA6-4D7F-431B-9614-EDAF6E1099E6}" type="slidenum">
               <a:rPr lang="cs-CZ" smtClean="0"/>
-              <a:t>8</a:t>
+              <a:t>10</a:t>
             </a:fld>
             <a:endParaRPr lang="cs-CZ"/>
           </a:p>
@@ -5225,9 +5649,23 @@
 <file path=ppt/slides/slide10.xml><?xml version="1.0" encoding="utf-8"?>
 <p:sld xmlns:a="http://schemas.openxmlformats.org/drawingml/2006/main" xmlns:r="http://schemas.openxmlformats.org/officeDocument/2006/relationships" xmlns:p="http://schemas.openxmlformats.org/presentationml/2006/main">
   <p:cSld>
+    <p:bg>
+      <p:bgPr>
+        <a:solidFill>
+          <a:schemeClr val="bg1"/>
+        </a:solidFill>
+        <a:effectLst/>
+      </p:bgPr>
+    </p:bg>
     <p:spTree>
       <p:nvGrpSpPr>
-        <p:cNvPr id="1" name=""/>
+        <p:cNvPr id="1" name="">
+          <a:extLst>
+            <a:ext uri="{FF2B5EF4-FFF2-40B4-BE49-F238E27FC236}">
+              <a16:creationId xmlns:a16="http://schemas.microsoft.com/office/drawing/2014/main" id="{9EC53ACE-5A18-0223-F078-F212AF8D0543}"/>
+            </a:ext>
+          </a:extLst>
+        </p:cNvPr>
         <p:cNvGrpSpPr/>
         <p:nvPr/>
       </p:nvGrpSpPr>
@@ -5239,12 +5677,72 @@
           <a:chExt cx="0" cy="0"/>
         </a:xfrm>
       </p:grpSpPr>
+      <p:sp useBgFill="1">
+        <p:nvSpPr>
+          <p:cNvPr id="28" name="Rectangle 27">
+            <a:extLst>
+              <a:ext uri="{FF2B5EF4-FFF2-40B4-BE49-F238E27FC236}">
+                <a16:creationId xmlns:a16="http://schemas.microsoft.com/office/drawing/2014/main" id="{2B97F24A-32CE-4C1C-A50D-3016B394DCFB}"/>
+              </a:ext>
+              <a:ext uri="{C183D7F6-B498-43B3-948B-1728B52AA6E4}">
+                <adec:decorative xmlns:adec="http://schemas.microsoft.com/office/drawing/2017/decorative" val="1"/>
+              </a:ext>
+            </a:extLst>
+          </p:cNvPr>
+          <p:cNvSpPr>
+            <a:spLocks noGrp="1" noRot="1" noChangeAspect="1" noMove="1" noResize="1" noEditPoints="1" noAdjustHandles="1" noChangeArrowheads="1" noChangeShapeType="1" noTextEdit="1"/>
+          </p:cNvSpPr>
+          <p:nvPr>
+            <p:extLst>
+              <p:ext uri="{386F3935-93C4-4BCD-93E2-E3B085C9AB24}">
+                <p16:designElem xmlns:p16="http://schemas.microsoft.com/office/powerpoint/2015/main" val="1"/>
+              </p:ext>
+            </p:extLst>
+          </p:nvPr>
+        </p:nvSpPr>
+        <p:spPr>
+          <a:xfrm>
+            <a:off x="0" y="0"/>
+            <a:ext cx="12192000" cy="6858000"/>
+          </a:xfrm>
+          <a:prstGeom prst="rect">
+            <a:avLst/>
+          </a:prstGeom>
+          <a:ln>
+            <a:noFill/>
+          </a:ln>
+        </p:spPr>
+        <p:style>
+          <a:lnRef idx="2">
+            <a:schemeClr val="accent1">
+              <a:shade val="50000"/>
+            </a:schemeClr>
+          </a:lnRef>
+          <a:fillRef idx="1">
+            <a:schemeClr val="accent1"/>
+          </a:fillRef>
+          <a:effectRef idx="0">
+            <a:schemeClr val="accent1"/>
+          </a:effectRef>
+          <a:fontRef idx="minor">
+            <a:schemeClr val="lt1"/>
+          </a:fontRef>
+        </p:style>
+        <p:txBody>
+          <a:bodyPr rtlCol="0" anchor="ctr"/>
+          <a:lstStyle/>
+          <a:p>
+            <a:pPr algn="ctr"/>
+            <a:endParaRPr lang="cs-CZ" noProof="0" dirty="0"/>
+          </a:p>
+        </p:txBody>
+      </p:sp>
       <p:sp>
         <p:nvSpPr>
           <p:cNvPr id="2" name="Title 1">
             <a:extLst>
               <a:ext uri="{FF2B5EF4-FFF2-40B4-BE49-F238E27FC236}">
-                <a16:creationId xmlns:a16="http://schemas.microsoft.com/office/drawing/2014/main" id="{D7393CDE-8F32-A485-10B4-FA031EFC1144}"/>
+                <a16:creationId xmlns:a16="http://schemas.microsoft.com/office/drawing/2014/main" id="{D9AF63F9-96E4-CAE6-8E27-BAD90F2D31C2}"/>
               </a:ext>
             </a:extLst>
           </p:cNvPr>
@@ -5255,47 +5753,437 @@
             <p:ph type="title"/>
           </p:nvPr>
         </p:nvSpPr>
-        <p:spPr/>
-        <p:txBody>
-          <a:bodyPr/>
+        <p:spPr>
+          <a:xfrm>
+            <a:off x="630936" y="639520"/>
+            <a:ext cx="3429000" cy="1719072"/>
+          </a:xfrm>
+        </p:spPr>
+        <p:txBody>
+          <a:bodyPr vert="horz" lIns="91440" tIns="45720" rIns="91440" bIns="45720" rtlCol="0" anchor="b">
+            <a:normAutofit/>
+          </a:bodyPr>
           <a:lstStyle/>
           <a:p>
             <a:r>
-              <a:rPr lang="cs-CZ" dirty="0"/>
-              <a:t>Desetinná čísla</a:t>
-            </a:r>
-          </a:p>
-        </p:txBody>
-      </p:sp>
-      <p:sp>
-        <p:nvSpPr>
-          <p:cNvPr id="3" name="Content Placeholder 2">
-            <a:extLst>
-              <a:ext uri="{FF2B5EF4-FFF2-40B4-BE49-F238E27FC236}">
-                <a16:creationId xmlns:a16="http://schemas.microsoft.com/office/drawing/2014/main" id="{2615C0BB-C97C-4C65-9E4F-8751068C46AC}"/>
-              </a:ext>
-            </a:extLst>
-          </p:cNvPr>
-          <p:cNvSpPr>
-            <a:spLocks noGrp="1"/>
-          </p:cNvSpPr>
-          <p:nvPr>
-            <p:ph idx="1"/>
-          </p:nvPr>
-        </p:nvSpPr>
-        <p:spPr/>
-        <p:txBody>
-          <a:bodyPr/>
+              <a:rPr lang="cs-CZ" sz="5400" kern="1200">
+                <a:solidFill>
+                  <a:schemeClr val="tx1"/>
+                </a:solidFill>
+                <a:latin typeface="+mj-lt"/>
+                <a:ea typeface="+mj-ea"/>
+                <a:cs typeface="+mj-cs"/>
+              </a:rPr>
+              <a:t>Traity 2</a:t>
+            </a:r>
+            <a:endParaRPr lang="cs-CZ" sz="5400" kern="1200" dirty="0">
+              <a:solidFill>
+                <a:schemeClr val="tx1"/>
+              </a:solidFill>
+              <a:latin typeface="+mj-lt"/>
+              <a:ea typeface="+mj-ea"/>
+              <a:cs typeface="+mj-cs"/>
+            </a:endParaRPr>
+          </a:p>
+        </p:txBody>
+      </p:sp>
+      <p:sp>
+        <p:nvSpPr>
+          <p:cNvPr id="30" name="sketch line">
+            <a:extLst>
+              <a:ext uri="{FF2B5EF4-FFF2-40B4-BE49-F238E27FC236}">
+                <a16:creationId xmlns:a16="http://schemas.microsoft.com/office/drawing/2014/main" id="{6357EC4F-235E-4222-A36F-C7878ACE37F2}"/>
+              </a:ext>
+              <a:ext uri="{C183D7F6-B498-43B3-948B-1728B52AA6E4}">
+                <adec:decorative xmlns:adec="http://schemas.microsoft.com/office/drawing/2017/decorative" val="1"/>
+              </a:ext>
+            </a:extLst>
+          </p:cNvPr>
+          <p:cNvSpPr>
+            <a:spLocks noGrp="1" noRot="1" noChangeAspect="1" noMove="1" noResize="1" noEditPoints="1" noAdjustHandles="1" noChangeArrowheads="1" noChangeShapeType="1" noTextEdit="1"/>
+          </p:cNvSpPr>
+          <p:nvPr>
+            <p:extLst>
+              <p:ext uri="{386F3935-93C4-4BCD-93E2-E3B085C9AB24}">
+                <p16:designElem xmlns:p16="http://schemas.microsoft.com/office/powerpoint/2015/main" val="1"/>
+              </p:ext>
+            </p:extLst>
+          </p:nvPr>
+        </p:nvSpPr>
+        <p:spPr>
+          <a:xfrm>
+            <a:off x="643278" y="2573756"/>
+            <a:ext cx="3255095" cy="18288"/>
+          </a:xfrm>
+          <a:custGeom>
+            <a:avLst/>
+            <a:gdLst>
+              <a:gd name="csX0" fmla="*/ 0 w 3255095"/>
+              <a:gd name="csY0" fmla="*/ 0 h 18288"/>
+              <a:gd name="csX1" fmla="*/ 618468 w 3255095"/>
+              <a:gd name="csY1" fmla="*/ 0 h 18288"/>
+              <a:gd name="csX2" fmla="*/ 1269487 w 3255095"/>
+              <a:gd name="csY2" fmla="*/ 0 h 18288"/>
+              <a:gd name="csX3" fmla="*/ 1953057 w 3255095"/>
+              <a:gd name="csY3" fmla="*/ 0 h 18288"/>
+              <a:gd name="csX4" fmla="*/ 2636627 w 3255095"/>
+              <a:gd name="csY4" fmla="*/ 0 h 18288"/>
+              <a:gd name="csX5" fmla="*/ 3255095 w 3255095"/>
+              <a:gd name="csY5" fmla="*/ 0 h 18288"/>
+              <a:gd name="csX6" fmla="*/ 3255095 w 3255095"/>
+              <a:gd name="csY6" fmla="*/ 18288 h 18288"/>
+              <a:gd name="csX7" fmla="*/ 2538974 w 3255095"/>
+              <a:gd name="csY7" fmla="*/ 18288 h 18288"/>
+              <a:gd name="csX8" fmla="*/ 1822853 w 3255095"/>
+              <a:gd name="csY8" fmla="*/ 18288 h 18288"/>
+              <a:gd name="csX9" fmla="*/ 1171834 w 3255095"/>
+              <a:gd name="csY9" fmla="*/ 18288 h 18288"/>
+              <a:gd name="csX10" fmla="*/ 0 w 3255095"/>
+              <a:gd name="csY10" fmla="*/ 18288 h 18288"/>
+              <a:gd name="csX11" fmla="*/ 0 w 3255095"/>
+              <a:gd name="csY11" fmla="*/ 0 h 18288"/>
+            </a:gdLst>
+            <a:ahLst/>
+            <a:cxnLst>
+              <a:cxn ang="0">
+                <a:pos x="csX0" y="csY0"/>
+              </a:cxn>
+              <a:cxn ang="0">
+                <a:pos x="csX1" y="csY1"/>
+              </a:cxn>
+              <a:cxn ang="0">
+                <a:pos x="csX2" y="csY2"/>
+              </a:cxn>
+              <a:cxn ang="0">
+                <a:pos x="csX3" y="csY3"/>
+              </a:cxn>
+              <a:cxn ang="0">
+                <a:pos x="csX4" y="csY4"/>
+              </a:cxn>
+              <a:cxn ang="0">
+                <a:pos x="csX5" y="csY5"/>
+              </a:cxn>
+              <a:cxn ang="0">
+                <a:pos x="csX6" y="csY6"/>
+              </a:cxn>
+              <a:cxn ang="0">
+                <a:pos x="csX7" y="csY7"/>
+              </a:cxn>
+              <a:cxn ang="0">
+                <a:pos x="csX8" y="csY8"/>
+              </a:cxn>
+              <a:cxn ang="0">
+                <a:pos x="csX9" y="csY9"/>
+              </a:cxn>
+              <a:cxn ang="0">
+                <a:pos x="csX10" y="csY10"/>
+              </a:cxn>
+              <a:cxn ang="0">
+                <a:pos x="csX11" y="csY11"/>
+              </a:cxn>
+            </a:cxnLst>
+            <a:rect l="l" t="t" r="r" b="b"/>
+            <a:pathLst>
+              <a:path w="3255095" h="18288" fill="none" extrusionOk="0">
+                <a:moveTo>
+                  <a:pt x="0" y="0"/>
+                </a:moveTo>
+                <a:cubicBezTo>
+                  <a:pt x="240201" y="-22123"/>
+                  <a:pt x="462021" y="-19623"/>
+                  <a:pt x="618468" y="0"/>
+                </a:cubicBezTo>
+                <a:cubicBezTo>
+                  <a:pt x="774915" y="19623"/>
+                  <a:pt x="974734" y="2035"/>
+                  <a:pt x="1269487" y="0"/>
+                </a:cubicBezTo>
+                <a:cubicBezTo>
+                  <a:pt x="1564240" y="-2035"/>
+                  <a:pt x="1733579" y="10639"/>
+                  <a:pt x="1953057" y="0"/>
+                </a:cubicBezTo>
+                <a:cubicBezTo>
+                  <a:pt x="2172535" y="-10639"/>
+                  <a:pt x="2453962" y="14018"/>
+                  <a:pt x="2636627" y="0"/>
+                </a:cubicBezTo>
+                <a:cubicBezTo>
+                  <a:pt x="2819292" y="-14018"/>
+                  <a:pt x="3121375" y="5399"/>
+                  <a:pt x="3255095" y="0"/>
+                </a:cubicBezTo>
+                <a:cubicBezTo>
+                  <a:pt x="3254386" y="8157"/>
+                  <a:pt x="3254682" y="12125"/>
+                  <a:pt x="3255095" y="18288"/>
+                </a:cubicBezTo>
+                <a:cubicBezTo>
+                  <a:pt x="3088545" y="23203"/>
+                  <a:pt x="2687475" y="7419"/>
+                  <a:pt x="2538974" y="18288"/>
+                </a:cubicBezTo>
+                <a:cubicBezTo>
+                  <a:pt x="2390473" y="29157"/>
+                  <a:pt x="2137381" y="-8959"/>
+                  <a:pt x="1822853" y="18288"/>
+                </a:cubicBezTo>
+                <a:cubicBezTo>
+                  <a:pt x="1508325" y="45535"/>
+                  <a:pt x="1466437" y="20385"/>
+                  <a:pt x="1171834" y="18288"/>
+                </a:cubicBezTo>
+                <a:cubicBezTo>
+                  <a:pt x="877231" y="16191"/>
+                  <a:pt x="561097" y="37643"/>
+                  <a:pt x="0" y="18288"/>
+                </a:cubicBezTo>
+                <a:cubicBezTo>
+                  <a:pt x="-46" y="12483"/>
+                  <a:pt x="-203" y="6491"/>
+                  <a:pt x="0" y="0"/>
+                </a:cubicBezTo>
+                <a:close/>
+              </a:path>
+              <a:path w="3255095" h="18288" stroke="0" extrusionOk="0">
+                <a:moveTo>
+                  <a:pt x="0" y="0"/>
+                </a:moveTo>
+                <a:cubicBezTo>
+                  <a:pt x="291965" y="19429"/>
+                  <a:pt x="363155" y="8568"/>
+                  <a:pt x="618468" y="0"/>
+                </a:cubicBezTo>
+                <a:cubicBezTo>
+                  <a:pt x="873781" y="-8568"/>
+                  <a:pt x="904459" y="-19505"/>
+                  <a:pt x="1171834" y="0"/>
+                </a:cubicBezTo>
+                <a:cubicBezTo>
+                  <a:pt x="1439209" y="19505"/>
+                  <a:pt x="1744369" y="9790"/>
+                  <a:pt x="1887955" y="0"/>
+                </a:cubicBezTo>
+                <a:cubicBezTo>
+                  <a:pt x="2031541" y="-9790"/>
+                  <a:pt x="2346378" y="21240"/>
+                  <a:pt x="2506423" y="0"/>
+                </a:cubicBezTo>
+                <a:cubicBezTo>
+                  <a:pt x="2666468" y="-21240"/>
+                  <a:pt x="2990257" y="30414"/>
+                  <a:pt x="3255095" y="0"/>
+                </a:cubicBezTo>
+                <a:cubicBezTo>
+                  <a:pt x="3254831" y="4493"/>
+                  <a:pt x="3255479" y="9472"/>
+                  <a:pt x="3255095" y="18288"/>
+                </a:cubicBezTo>
+                <a:cubicBezTo>
+                  <a:pt x="3120743" y="16690"/>
+                  <a:pt x="2759628" y="42462"/>
+                  <a:pt x="2604076" y="18288"/>
+                </a:cubicBezTo>
+                <a:cubicBezTo>
+                  <a:pt x="2448524" y="-5886"/>
+                  <a:pt x="2184336" y="19599"/>
+                  <a:pt x="1887955" y="18288"/>
+                </a:cubicBezTo>
+                <a:cubicBezTo>
+                  <a:pt x="1591574" y="16977"/>
+                  <a:pt x="1548845" y="6870"/>
+                  <a:pt x="1334589" y="18288"/>
+                </a:cubicBezTo>
+                <a:cubicBezTo>
+                  <a:pt x="1120333" y="29706"/>
+                  <a:pt x="996014" y="9662"/>
+                  <a:pt x="683570" y="18288"/>
+                </a:cubicBezTo>
+                <a:cubicBezTo>
+                  <a:pt x="371126" y="26914"/>
+                  <a:pt x="198687" y="16167"/>
+                  <a:pt x="0" y="18288"/>
+                </a:cubicBezTo>
+                <a:cubicBezTo>
+                  <a:pt x="843" y="9577"/>
+                  <a:pt x="371" y="6900"/>
+                  <a:pt x="0" y="0"/>
+                </a:cubicBezTo>
+                <a:close/>
+              </a:path>
+            </a:pathLst>
+          </a:custGeom>
+          <a:solidFill>
+            <a:schemeClr val="accent2"/>
+          </a:solidFill>
+          <a:ln w="38100" cap="rnd">
+            <a:solidFill>
+              <a:schemeClr val="accent2"/>
+            </a:solidFill>
+            <a:round/>
+            <a:extLst>
+              <a:ext uri="{C807C97D-BFC1-408E-A445-0C87EB9F89A2}">
+                <ask:lineSketchStyleProps xmlns:ask="http://schemas.microsoft.com/office/drawing/2018/sketchyshapes" sd="1219033472">
+                  <a:prstGeom prst="rect">
+                    <a:avLst/>
+                  </a:prstGeom>
+                  <ask:type>
+                    <ask:lineSketchFreehand/>
+                  </ask:type>
+                </ask:lineSketchStyleProps>
+              </a:ext>
+            </a:extLst>
+          </a:ln>
+        </p:spPr>
+        <p:style>
+          <a:lnRef idx="2">
+            <a:schemeClr val="accent1">
+              <a:shade val="50000"/>
+            </a:schemeClr>
+          </a:lnRef>
+          <a:fillRef idx="1">
+            <a:schemeClr val="accent1"/>
+          </a:fillRef>
+          <a:effectRef idx="0">
+            <a:schemeClr val="accent1"/>
+          </a:effectRef>
+          <a:fontRef idx="minor">
+            <a:schemeClr val="lt1"/>
+          </a:fontRef>
+        </p:style>
+        <p:txBody>
+          <a:bodyPr rtlCol="0" anchor="ctr"/>
           <a:lstStyle/>
           <a:p>
-            <a:endParaRPr lang="cs-CZ"/>
+            <a:pPr algn="ctr"/>
+            <a:endParaRPr lang="cs-CZ" noProof="0" dirty="0"/>
+          </a:p>
+        </p:txBody>
+      </p:sp>
+      <p:pic>
+        <p:nvPicPr>
+          <p:cNvPr id="16" name="Graphic 15">
+            <a:extLst>
+              <a:ext uri="{FF2B5EF4-FFF2-40B4-BE49-F238E27FC236}">
+                <a16:creationId xmlns:a16="http://schemas.microsoft.com/office/drawing/2014/main" id="{D05A3046-89B3-C287-04D7-C746C3920836}"/>
+              </a:ext>
+            </a:extLst>
+          </p:cNvPr>
+          <p:cNvPicPr>
+            <a:picLocks noChangeAspect="1"/>
+          </p:cNvPicPr>
+          <p:nvPr/>
+        </p:nvPicPr>
+        <p:blipFill>
+          <a:blip>
+            <a:extLst>
+              <a:ext uri="{96DAC541-7B7A-43D3-8B79-37D633B846F1}">
+                <asvg:svgBlip xmlns:asvg="http://schemas.microsoft.com/office/drawing/2016/SVG/main" r:embed="rId3"/>
+              </a:ext>
+            </a:extLst>
+          </a:blip>
+          <a:srcRect/>
+          <a:stretch/>
+        </p:blipFill>
+        <p:spPr>
+          <a:xfrm>
+            <a:off x="5201392" y="1043156"/>
+            <a:ext cx="6362250" cy="4771688"/>
+          </a:xfrm>
+          <a:prstGeom prst="rect">
+            <a:avLst/>
+          </a:prstGeom>
+        </p:spPr>
+      </p:pic>
+      <p:sp>
+        <p:nvSpPr>
+          <p:cNvPr id="13" name="Content Placeholder 12">
+            <a:extLst>
+              <a:ext uri="{FF2B5EF4-FFF2-40B4-BE49-F238E27FC236}">
+                <a16:creationId xmlns:a16="http://schemas.microsoft.com/office/drawing/2014/main" id="{7A44BED2-120E-0B7F-D74E-A629CFE6635F}"/>
+              </a:ext>
+            </a:extLst>
+          </p:cNvPr>
+          <p:cNvSpPr>
+            <a:spLocks noGrp="1"/>
+          </p:cNvSpPr>
+          <p:nvPr>
+            <p:ph sz="half" idx="1"/>
+          </p:nvPr>
+        </p:nvSpPr>
+        <p:spPr>
+          <a:xfrm>
+            <a:off x="630936" y="2807208"/>
+            <a:ext cx="4570456" cy="3410712"/>
+          </a:xfrm>
+        </p:spPr>
+        <p:txBody>
+          <a:bodyPr vert="horz" lIns="91440" tIns="45720" rIns="91440" bIns="45720" rtlCol="0" anchor="t">
+            <a:normAutofit/>
+          </a:bodyPr>
+          <a:lstStyle/>
+          <a:p>
+            <a:r>
+              <a:rPr lang="cs-CZ" sz="2200" dirty="0"/>
+              <a:t>Přenositelné knihovny</a:t>
+            </a:r>
+          </a:p>
+          <a:p>
+            <a:pPr lvl="1"/>
+            <a:r>
+              <a:rPr lang="cs-CZ" sz="2000" dirty="0" err="1"/>
+              <a:t>Traity</a:t>
+            </a:r>
+            <a:r>
+              <a:rPr lang="cs-CZ" sz="2000" dirty="0"/>
+              <a:t> poskytují jednotné rozhraní pro různé </a:t>
+            </a:r>
+            <a:r>
+              <a:rPr lang="cs-CZ" sz="2000" dirty="0" err="1"/>
+              <a:t>backendy</a:t>
+            </a:r>
+            <a:endParaRPr lang="cs-CZ" sz="2000" dirty="0"/>
+          </a:p>
+          <a:p>
+            <a:pPr lvl="1"/>
+            <a:r>
+              <a:rPr lang="cs-CZ" sz="2000" dirty="0"/>
+              <a:t>Knihovny pak mohou být psány oproti těmto rozhraním namísto konkrétních implementací</a:t>
+            </a:r>
+            <a:endParaRPr lang="cs-CZ" sz="2200" dirty="0"/>
+          </a:p>
+          <a:p>
+            <a:r>
+              <a:rPr lang="cs-CZ" sz="2200" dirty="0"/>
+              <a:t>Příklad: </a:t>
+            </a:r>
+            <a:r>
+              <a:rPr lang="cs-CZ" sz="2200" dirty="0" err="1">
+                <a:highlight>
+                  <a:srgbClr val="C0C0C0"/>
+                </a:highlight>
+              </a:rPr>
+              <a:t>embedded</a:t>
+            </a:r>
+            <a:r>
+              <a:rPr lang="cs-CZ" sz="2200" dirty="0">
+                <a:highlight>
+                  <a:srgbClr val="C0C0C0"/>
+                </a:highlight>
+              </a:rPr>
+              <a:t>-hal</a:t>
+            </a:r>
+            <a:r>
+              <a:rPr lang="cs-CZ" sz="2200" dirty="0"/>
+              <a:t> (různé mikrořadiče, jedno rozhraní)</a:t>
+            </a:r>
           </a:p>
         </p:txBody>
       </p:sp>
     </p:spTree>
     <p:extLst>
       <p:ext uri="{BB962C8B-B14F-4D97-AF65-F5344CB8AC3E}">
-        <p14:creationId xmlns:p14="http://schemas.microsoft.com/office/powerpoint/2010/main" val="2721032930"/>
+        <p14:creationId xmlns:p14="http://schemas.microsoft.com/office/powerpoint/2010/main" val="3835894341"/>
       </p:ext>
     </p:extLst>
   </p:cSld>
@@ -5324,10 +6212,10 @@
       </p:grpSpPr>
       <p:sp>
         <p:nvSpPr>
-          <p:cNvPr id="2" name="Title 1">
-            <a:extLst>
-              <a:ext uri="{FF2B5EF4-FFF2-40B4-BE49-F238E27FC236}">
-                <a16:creationId xmlns:a16="http://schemas.microsoft.com/office/drawing/2014/main" id="{8075CEB5-567A-56FC-A79D-8EBBE314CA35}"/>
+          <p:cNvPr id="5" name="Title 4">
+            <a:extLst>
+              <a:ext uri="{FF2B5EF4-FFF2-40B4-BE49-F238E27FC236}">
+                <a16:creationId xmlns:a16="http://schemas.microsoft.com/office/drawing/2014/main" id="{1F9CC341-C25B-F877-D447-AF84B4A23EEB}"/>
               </a:ext>
             </a:extLst>
           </p:cNvPr>
@@ -5345,17 +6233,17 @@
           <a:p>
             <a:r>
               <a:rPr lang="cs-CZ" dirty="0"/>
-              <a:t>Ovládání</a:t>
-            </a:r>
-          </a:p>
-        </p:txBody>
-      </p:sp>
-      <p:sp>
-        <p:nvSpPr>
-          <p:cNvPr id="3" name="Content Placeholder 2">
-            <a:extLst>
-              <a:ext uri="{FF2B5EF4-FFF2-40B4-BE49-F238E27FC236}">
-                <a16:creationId xmlns:a16="http://schemas.microsoft.com/office/drawing/2014/main" id="{B72313B4-1167-5BFE-4914-AF8C4B665E04}"/>
+              <a:t>Architektura programu</a:t>
+            </a:r>
+          </a:p>
+        </p:txBody>
+      </p:sp>
+      <p:sp>
+        <p:nvSpPr>
+          <p:cNvPr id="6" name="Content Placeholder 5">
+            <a:extLst>
+              <a:ext uri="{FF2B5EF4-FFF2-40B4-BE49-F238E27FC236}">
+                <a16:creationId xmlns:a16="http://schemas.microsoft.com/office/drawing/2014/main" id="{9D2AB956-920E-CF3C-3578-10FABD0ACECA}"/>
               </a:ext>
             </a:extLst>
           </p:cNvPr>
@@ -5371,14 +6259,29 @@
           <a:bodyPr/>
           <a:lstStyle/>
           <a:p>
-            <a:endParaRPr lang="cs-CZ"/>
+            <a:r>
+              <a:rPr lang="cs-CZ" dirty="0"/>
+              <a:t>Setup, event </a:t>
+            </a:r>
+            <a:r>
+              <a:rPr lang="cs-CZ" dirty="0" err="1"/>
+              <a:t>loop</a:t>
+            </a:r>
+            <a:endParaRPr lang="cs-CZ" dirty="0"/>
+          </a:p>
+          <a:p>
+            <a:r>
+              <a:rPr lang="cs-CZ" dirty="0" err="1"/>
+              <a:t>modules</a:t>
+            </a:r>
+            <a:endParaRPr lang="cs-CZ" dirty="0"/>
           </a:p>
         </p:txBody>
       </p:sp>
     </p:spTree>
     <p:extLst>
       <p:ext uri="{BB962C8B-B14F-4D97-AF65-F5344CB8AC3E}">
-        <p14:creationId xmlns:p14="http://schemas.microsoft.com/office/powerpoint/2010/main" val="3593242919"/>
+        <p14:creationId xmlns:p14="http://schemas.microsoft.com/office/powerpoint/2010/main" val="2334217468"/>
       </p:ext>
     </p:extLst>
   </p:cSld>
@@ -5410,6 +6313,172 @@
           <p:cNvPr id="2" name="Title 1">
             <a:extLst>
               <a:ext uri="{FF2B5EF4-FFF2-40B4-BE49-F238E27FC236}">
+                <a16:creationId xmlns:a16="http://schemas.microsoft.com/office/drawing/2014/main" id="{D7393CDE-8F32-A485-10B4-FA031EFC1144}"/>
+              </a:ext>
+            </a:extLst>
+          </p:cNvPr>
+          <p:cNvSpPr>
+            <a:spLocks noGrp="1"/>
+          </p:cNvSpPr>
+          <p:nvPr>
+            <p:ph type="title"/>
+          </p:nvPr>
+        </p:nvSpPr>
+        <p:spPr/>
+        <p:txBody>
+          <a:bodyPr/>
+          <a:lstStyle/>
+          <a:p>
+            <a:r>
+              <a:rPr lang="cs-CZ" dirty="0"/>
+              <a:t>Desetinná čísla</a:t>
+            </a:r>
+          </a:p>
+        </p:txBody>
+      </p:sp>
+      <p:sp>
+        <p:nvSpPr>
+          <p:cNvPr id="3" name="Content Placeholder 2">
+            <a:extLst>
+              <a:ext uri="{FF2B5EF4-FFF2-40B4-BE49-F238E27FC236}">
+                <a16:creationId xmlns:a16="http://schemas.microsoft.com/office/drawing/2014/main" id="{2615C0BB-C97C-4C65-9E4F-8751068C46AC}"/>
+              </a:ext>
+            </a:extLst>
+          </p:cNvPr>
+          <p:cNvSpPr>
+            <a:spLocks noGrp="1"/>
+          </p:cNvSpPr>
+          <p:nvPr>
+            <p:ph idx="1"/>
+          </p:nvPr>
+        </p:nvSpPr>
+        <p:spPr/>
+        <p:txBody>
+          <a:bodyPr/>
+          <a:lstStyle/>
+          <a:p>
+            <a:endParaRPr lang="cs-CZ"/>
+          </a:p>
+        </p:txBody>
+      </p:sp>
+    </p:spTree>
+    <p:extLst>
+      <p:ext uri="{BB962C8B-B14F-4D97-AF65-F5344CB8AC3E}">
+        <p14:creationId xmlns:p14="http://schemas.microsoft.com/office/powerpoint/2010/main" val="2721032930"/>
+      </p:ext>
+    </p:extLst>
+  </p:cSld>
+  <p:clrMapOvr>
+    <a:masterClrMapping/>
+  </p:clrMapOvr>
+</p:sld>
+</file>
+
+<file path=ppt/slides/slide13.xml><?xml version="1.0" encoding="utf-8"?>
+<p:sld xmlns:a="http://schemas.openxmlformats.org/drawingml/2006/main" xmlns:r="http://schemas.openxmlformats.org/officeDocument/2006/relationships" xmlns:p="http://schemas.openxmlformats.org/presentationml/2006/main">
+  <p:cSld>
+    <p:spTree>
+      <p:nvGrpSpPr>
+        <p:cNvPr id="1" name=""/>
+        <p:cNvGrpSpPr/>
+        <p:nvPr/>
+      </p:nvGrpSpPr>
+      <p:grpSpPr>
+        <a:xfrm>
+          <a:off x="0" y="0"/>
+          <a:ext cx="0" cy="0"/>
+          <a:chOff x="0" y="0"/>
+          <a:chExt cx="0" cy="0"/>
+        </a:xfrm>
+      </p:grpSpPr>
+      <p:sp>
+        <p:nvSpPr>
+          <p:cNvPr id="2" name="Title 1">
+            <a:extLst>
+              <a:ext uri="{FF2B5EF4-FFF2-40B4-BE49-F238E27FC236}">
+                <a16:creationId xmlns:a16="http://schemas.microsoft.com/office/drawing/2014/main" id="{8075CEB5-567A-56FC-A79D-8EBBE314CA35}"/>
+              </a:ext>
+            </a:extLst>
+          </p:cNvPr>
+          <p:cNvSpPr>
+            <a:spLocks noGrp="1"/>
+          </p:cNvSpPr>
+          <p:nvPr>
+            <p:ph type="title"/>
+          </p:nvPr>
+        </p:nvSpPr>
+        <p:spPr/>
+        <p:txBody>
+          <a:bodyPr/>
+          <a:lstStyle/>
+          <a:p>
+            <a:r>
+              <a:rPr lang="cs-CZ" dirty="0"/>
+              <a:t>Ovládání</a:t>
+            </a:r>
+          </a:p>
+        </p:txBody>
+      </p:sp>
+      <p:sp>
+        <p:nvSpPr>
+          <p:cNvPr id="3" name="Content Placeholder 2">
+            <a:extLst>
+              <a:ext uri="{FF2B5EF4-FFF2-40B4-BE49-F238E27FC236}">
+                <a16:creationId xmlns:a16="http://schemas.microsoft.com/office/drawing/2014/main" id="{B72313B4-1167-5BFE-4914-AF8C4B665E04}"/>
+              </a:ext>
+            </a:extLst>
+          </p:cNvPr>
+          <p:cNvSpPr>
+            <a:spLocks noGrp="1"/>
+          </p:cNvSpPr>
+          <p:nvPr>
+            <p:ph idx="1"/>
+          </p:nvPr>
+        </p:nvSpPr>
+        <p:spPr/>
+        <p:txBody>
+          <a:bodyPr/>
+          <a:lstStyle/>
+          <a:p>
+            <a:endParaRPr lang="cs-CZ"/>
+          </a:p>
+        </p:txBody>
+      </p:sp>
+    </p:spTree>
+    <p:extLst>
+      <p:ext uri="{BB962C8B-B14F-4D97-AF65-F5344CB8AC3E}">
+        <p14:creationId xmlns:p14="http://schemas.microsoft.com/office/powerpoint/2010/main" val="3593242919"/>
+      </p:ext>
+    </p:extLst>
+  </p:cSld>
+  <p:clrMapOvr>
+    <a:masterClrMapping/>
+  </p:clrMapOvr>
+</p:sld>
+</file>
+
+<file path=ppt/slides/slide14.xml><?xml version="1.0" encoding="utf-8"?>
+<p:sld xmlns:a="http://schemas.openxmlformats.org/drawingml/2006/main" xmlns:r="http://schemas.openxmlformats.org/officeDocument/2006/relationships" xmlns:p="http://schemas.openxmlformats.org/presentationml/2006/main">
+  <p:cSld>
+    <p:spTree>
+      <p:nvGrpSpPr>
+        <p:cNvPr id="1" name=""/>
+        <p:cNvGrpSpPr/>
+        <p:nvPr/>
+      </p:nvGrpSpPr>
+      <p:grpSpPr>
+        <a:xfrm>
+          <a:off x="0" y="0"/>
+          <a:ext cx="0" cy="0"/>
+          <a:chOff x="0" y="0"/>
+          <a:chExt cx="0" cy="0"/>
+        </a:xfrm>
+      </p:grpSpPr>
+      <p:sp>
+        <p:nvSpPr>
+          <p:cNvPr id="2" name="Title 1">
+            <a:extLst>
+              <a:ext uri="{FF2B5EF4-FFF2-40B4-BE49-F238E27FC236}">
                 <a16:creationId xmlns:a16="http://schemas.microsoft.com/office/drawing/2014/main" id="{07195F07-92E8-AF88-403B-50025CB8E99C}"/>
               </a:ext>
             </a:extLst>
@@ -5471,7 +6540,7 @@
 </p:sld>
 </file>
 
-<file path=ppt/slides/slide13.xml><?xml version="1.0" encoding="utf-8"?>
+<file path=ppt/slides/slide15.xml><?xml version="1.0" encoding="utf-8"?>
 <p:sld xmlns:a="http://schemas.openxmlformats.org/drawingml/2006/main" xmlns:r="http://schemas.openxmlformats.org/officeDocument/2006/relationships" xmlns:p="http://schemas.openxmlformats.org/presentationml/2006/main">
   <p:cSld>
     <p:spTree>
@@ -5686,8 +6755,8 @@
           </a:p>
         </p:txBody>
       </p:sp>
-      <mc:AlternateContent xmlns:mc="http://schemas.openxmlformats.org/markup-compatibility/2006">
-        <mc:Choice xmlns:a14="http://schemas.microsoft.com/office/drawing/2010/main" Requires="a14">
+      <mc:AlternateContent xmlns:mc="http://schemas.openxmlformats.org/markup-compatibility/2006" xmlns:a14="http://schemas.microsoft.com/office/drawing/2010/main">
+        <mc:Choice Requires="a14">
           <p:sp>
             <p:nvSpPr>
               <p:cNvPr id="3" name="Zástupný obsah 2">
@@ -5984,7 +7053,7 @@
             </p:txBody>
           </p:sp>
         </mc:Choice>
-        <mc:Fallback>
+        <mc:Fallback xmlns="">
           <p:sp>
             <p:nvSpPr>
               <p:cNvPr id="3" name="Zástupný obsah 2">
@@ -6053,8 +7122,8 @@
         </p:blipFill>
         <p:spPr bwMode="auto">
           <a:xfrm>
-            <a:off x="7548880" y="0"/>
-            <a:ext cx="4643120" cy="2970630"/>
+            <a:off x="7980218" y="0"/>
+            <a:ext cx="4211782" cy="2694663"/>
           </a:xfrm>
           <a:prstGeom prst="rect">
             <a:avLst/>
@@ -7123,6 +8192,1135 @@
       </p:grpSpPr>
       <p:sp useBgFill="1">
         <p:nvSpPr>
+          <p:cNvPr id="16" name="Rectangle 15">
+            <a:extLst>
+              <a:ext uri="{FF2B5EF4-FFF2-40B4-BE49-F238E27FC236}">
+                <a16:creationId xmlns:a16="http://schemas.microsoft.com/office/drawing/2014/main" id="{352BEC0E-22F8-46D0-9632-375DB541B06C}"/>
+              </a:ext>
+              <a:ext uri="{C183D7F6-B498-43B3-948B-1728B52AA6E4}">
+                <adec:decorative xmlns:adec="http://schemas.microsoft.com/office/drawing/2017/decorative" val="1"/>
+              </a:ext>
+            </a:extLst>
+          </p:cNvPr>
+          <p:cNvSpPr>
+            <a:spLocks noGrp="1" noRot="1" noChangeAspect="1" noMove="1" noResize="1" noEditPoints="1" noAdjustHandles="1" noChangeArrowheads="1" noChangeShapeType="1" noTextEdit="1"/>
+          </p:cNvSpPr>
+          <p:nvPr>
+            <p:extLst>
+              <p:ext uri="{386F3935-93C4-4BCD-93E2-E3B085C9AB24}">
+                <p16:designElem xmlns:p16="http://schemas.microsoft.com/office/powerpoint/2015/main" val="1"/>
+              </p:ext>
+            </p:extLst>
+          </p:nvPr>
+        </p:nvSpPr>
+        <p:spPr>
+          <a:xfrm>
+            <a:off x="0" y="0"/>
+            <a:ext cx="12188952" cy="6858000"/>
+          </a:xfrm>
+          <a:prstGeom prst="rect">
+            <a:avLst/>
+          </a:prstGeom>
+          <a:ln>
+            <a:noFill/>
+          </a:ln>
+        </p:spPr>
+        <p:style>
+          <a:lnRef idx="2">
+            <a:schemeClr val="accent1">
+              <a:shade val="50000"/>
+            </a:schemeClr>
+          </a:lnRef>
+          <a:fillRef idx="1">
+            <a:schemeClr val="accent1"/>
+          </a:fillRef>
+          <a:effectRef idx="0">
+            <a:schemeClr val="accent1"/>
+          </a:effectRef>
+          <a:fontRef idx="minor">
+            <a:schemeClr val="lt1"/>
+          </a:fontRef>
+        </p:style>
+        <p:txBody>
+          <a:bodyPr rtlCol="0" anchor="ctr"/>
+          <a:lstStyle/>
+          <a:p>
+            <a:pPr algn="ctr"/>
+            <a:endParaRPr lang="en-US"/>
+          </a:p>
+        </p:txBody>
+      </p:sp>
+      <p:sp>
+        <p:nvSpPr>
+          <p:cNvPr id="2" name="Title 1">
+            <a:extLst>
+              <a:ext uri="{FF2B5EF4-FFF2-40B4-BE49-F238E27FC236}">
+                <a16:creationId xmlns:a16="http://schemas.microsoft.com/office/drawing/2014/main" id="{607940D3-E158-1255-6253-DDC86DF077C7}"/>
+              </a:ext>
+            </a:extLst>
+          </p:cNvPr>
+          <p:cNvSpPr>
+            <a:spLocks noGrp="1"/>
+          </p:cNvSpPr>
+          <p:nvPr>
+            <p:ph type="title"/>
+          </p:nvPr>
+        </p:nvSpPr>
+        <p:spPr>
+          <a:xfrm>
+            <a:off x="640080" y="329184"/>
+            <a:ext cx="6894576" cy="1783080"/>
+          </a:xfrm>
+        </p:spPr>
+        <p:txBody>
+          <a:bodyPr anchor="b">
+            <a:normAutofit/>
+          </a:bodyPr>
+          <a:lstStyle/>
+          <a:p>
+            <a:r>
+              <a:rPr lang="cs-CZ" sz="5400"/>
+              <a:t>Enum</a:t>
+            </a:r>
+          </a:p>
+        </p:txBody>
+      </p:sp>
+      <p:sp>
+        <p:nvSpPr>
+          <p:cNvPr id="18" name="sketch line">
+            <a:extLst>
+              <a:ext uri="{FF2B5EF4-FFF2-40B4-BE49-F238E27FC236}">
+                <a16:creationId xmlns:a16="http://schemas.microsoft.com/office/drawing/2014/main" id="{3FCFB1DE-0B7E-48CC-BA90-B2AB0889F9D6}"/>
+              </a:ext>
+              <a:ext uri="{C183D7F6-B498-43B3-948B-1728B52AA6E4}">
+                <adec:decorative xmlns:adec="http://schemas.microsoft.com/office/drawing/2017/decorative" val="1"/>
+              </a:ext>
+            </a:extLst>
+          </p:cNvPr>
+          <p:cNvSpPr>
+            <a:spLocks noGrp="1" noRot="1" noChangeAspect="1" noMove="1" noResize="1" noEditPoints="1" noAdjustHandles="1" noChangeArrowheads="1" noChangeShapeType="1" noTextEdit="1"/>
+          </p:cNvSpPr>
+          <p:nvPr>
+            <p:extLst>
+              <p:ext uri="{386F3935-93C4-4BCD-93E2-E3B085C9AB24}">
+                <p16:designElem xmlns:p16="http://schemas.microsoft.com/office/powerpoint/2015/main" val="1"/>
+              </p:ext>
+            </p:extLst>
+          </p:nvPr>
+        </p:nvSpPr>
+        <p:spPr>
+          <a:xfrm>
+            <a:off x="758952" y="2395728"/>
+            <a:ext cx="4243589" cy="18288"/>
+          </a:xfrm>
+          <a:custGeom>
+            <a:avLst/>
+            <a:gdLst>
+              <a:gd name="csX0" fmla="*/ 0 w 4243589"/>
+              <a:gd name="csY0" fmla="*/ 0 h 18288"/>
+              <a:gd name="csX1" fmla="*/ 478919 w 4243589"/>
+              <a:gd name="csY1" fmla="*/ 0 h 18288"/>
+              <a:gd name="csX2" fmla="*/ 957839 w 4243589"/>
+              <a:gd name="csY2" fmla="*/ 0 h 18288"/>
+              <a:gd name="csX3" fmla="*/ 1521630 w 4243589"/>
+              <a:gd name="csY3" fmla="*/ 0 h 18288"/>
+              <a:gd name="csX4" fmla="*/ 2212729 w 4243589"/>
+              <a:gd name="csY4" fmla="*/ 0 h 18288"/>
+              <a:gd name="csX5" fmla="*/ 2734084 w 4243589"/>
+              <a:gd name="csY5" fmla="*/ 0 h 18288"/>
+              <a:gd name="csX6" fmla="*/ 3255439 w 4243589"/>
+              <a:gd name="csY6" fmla="*/ 0 h 18288"/>
+              <a:gd name="csX7" fmla="*/ 4243589 w 4243589"/>
+              <a:gd name="csY7" fmla="*/ 0 h 18288"/>
+              <a:gd name="csX8" fmla="*/ 4243589 w 4243589"/>
+              <a:gd name="csY8" fmla="*/ 18288 h 18288"/>
+              <a:gd name="csX9" fmla="*/ 3594926 w 4243589"/>
+              <a:gd name="csY9" fmla="*/ 18288 h 18288"/>
+              <a:gd name="csX10" fmla="*/ 3073571 w 4243589"/>
+              <a:gd name="csY10" fmla="*/ 18288 h 18288"/>
+              <a:gd name="csX11" fmla="*/ 2552216 w 4243589"/>
+              <a:gd name="csY11" fmla="*/ 18288 h 18288"/>
+              <a:gd name="csX12" fmla="*/ 1903553 w 4243589"/>
+              <a:gd name="csY12" fmla="*/ 18288 h 18288"/>
+              <a:gd name="csX13" fmla="*/ 1212454 w 4243589"/>
+              <a:gd name="csY13" fmla="*/ 18288 h 18288"/>
+              <a:gd name="csX14" fmla="*/ 733535 w 4243589"/>
+              <a:gd name="csY14" fmla="*/ 18288 h 18288"/>
+              <a:gd name="csX15" fmla="*/ 0 w 4243589"/>
+              <a:gd name="csY15" fmla="*/ 18288 h 18288"/>
+              <a:gd name="csX16" fmla="*/ 0 w 4243589"/>
+              <a:gd name="csY16" fmla="*/ 0 h 18288"/>
+            </a:gdLst>
+            <a:ahLst/>
+            <a:cxnLst>
+              <a:cxn ang="0">
+                <a:pos x="csX0" y="csY0"/>
+              </a:cxn>
+              <a:cxn ang="0">
+                <a:pos x="csX1" y="csY1"/>
+              </a:cxn>
+              <a:cxn ang="0">
+                <a:pos x="csX2" y="csY2"/>
+              </a:cxn>
+              <a:cxn ang="0">
+                <a:pos x="csX3" y="csY3"/>
+              </a:cxn>
+              <a:cxn ang="0">
+                <a:pos x="csX4" y="csY4"/>
+              </a:cxn>
+              <a:cxn ang="0">
+                <a:pos x="csX5" y="csY5"/>
+              </a:cxn>
+              <a:cxn ang="0">
+                <a:pos x="csX6" y="csY6"/>
+              </a:cxn>
+              <a:cxn ang="0">
+                <a:pos x="csX7" y="csY7"/>
+              </a:cxn>
+              <a:cxn ang="0">
+                <a:pos x="csX8" y="csY8"/>
+              </a:cxn>
+              <a:cxn ang="0">
+                <a:pos x="csX9" y="csY9"/>
+              </a:cxn>
+              <a:cxn ang="0">
+                <a:pos x="csX10" y="csY10"/>
+              </a:cxn>
+              <a:cxn ang="0">
+                <a:pos x="csX11" y="csY11"/>
+              </a:cxn>
+              <a:cxn ang="0">
+                <a:pos x="csX12" y="csY12"/>
+              </a:cxn>
+              <a:cxn ang="0">
+                <a:pos x="csX13" y="csY13"/>
+              </a:cxn>
+              <a:cxn ang="0">
+                <a:pos x="csX14" y="csY14"/>
+              </a:cxn>
+              <a:cxn ang="0">
+                <a:pos x="csX15" y="csY15"/>
+              </a:cxn>
+              <a:cxn ang="0">
+                <a:pos x="csX16" y="csY16"/>
+              </a:cxn>
+            </a:cxnLst>
+            <a:rect l="l" t="t" r="r" b="b"/>
+            <a:pathLst>
+              <a:path w="4243589" h="18288" fill="none" extrusionOk="0">
+                <a:moveTo>
+                  <a:pt x="0" y="0"/>
+                </a:moveTo>
+                <a:cubicBezTo>
+                  <a:pt x="213395" y="-21006"/>
+                  <a:pt x="307421" y="-18116"/>
+                  <a:pt x="478919" y="0"/>
+                </a:cubicBezTo>
+                <a:cubicBezTo>
+                  <a:pt x="650417" y="18116"/>
+                  <a:pt x="831092" y="-21237"/>
+                  <a:pt x="957839" y="0"/>
+                </a:cubicBezTo>
+                <a:cubicBezTo>
+                  <a:pt x="1084586" y="21237"/>
+                  <a:pt x="1301682" y="25124"/>
+                  <a:pt x="1521630" y="0"/>
+                </a:cubicBezTo>
+                <a:cubicBezTo>
+                  <a:pt x="1741578" y="-25124"/>
+                  <a:pt x="1970269" y="-29139"/>
+                  <a:pt x="2212729" y="0"/>
+                </a:cubicBezTo>
+                <a:cubicBezTo>
+                  <a:pt x="2455189" y="29139"/>
+                  <a:pt x="2558847" y="-4796"/>
+                  <a:pt x="2734084" y="0"/>
+                </a:cubicBezTo>
+                <a:cubicBezTo>
+                  <a:pt x="2909321" y="4796"/>
+                  <a:pt x="3097217" y="-13409"/>
+                  <a:pt x="3255439" y="0"/>
+                </a:cubicBezTo>
+                <a:cubicBezTo>
+                  <a:pt x="3413662" y="13409"/>
+                  <a:pt x="3979999" y="-10121"/>
+                  <a:pt x="4243589" y="0"/>
+                </a:cubicBezTo>
+                <a:cubicBezTo>
+                  <a:pt x="4244484" y="8974"/>
+                  <a:pt x="4243043" y="9359"/>
+                  <a:pt x="4243589" y="18288"/>
+                </a:cubicBezTo>
+                <a:cubicBezTo>
+                  <a:pt x="4058777" y="31246"/>
+                  <a:pt x="3910348" y="3158"/>
+                  <a:pt x="3594926" y="18288"/>
+                </a:cubicBezTo>
+                <a:cubicBezTo>
+                  <a:pt x="3279504" y="33418"/>
+                  <a:pt x="3319955" y="-3977"/>
+                  <a:pt x="3073571" y="18288"/>
+                </a:cubicBezTo>
+                <a:cubicBezTo>
+                  <a:pt x="2827187" y="40553"/>
+                  <a:pt x="2767387" y="1863"/>
+                  <a:pt x="2552216" y="18288"/>
+                </a:cubicBezTo>
+                <a:cubicBezTo>
+                  <a:pt x="2337046" y="34713"/>
+                  <a:pt x="2181871" y="19527"/>
+                  <a:pt x="1903553" y="18288"/>
+                </a:cubicBezTo>
+                <a:cubicBezTo>
+                  <a:pt x="1625235" y="17049"/>
+                  <a:pt x="1557672" y="24174"/>
+                  <a:pt x="1212454" y="18288"/>
+                </a:cubicBezTo>
+                <a:cubicBezTo>
+                  <a:pt x="867236" y="12402"/>
+                  <a:pt x="874382" y="15627"/>
+                  <a:pt x="733535" y="18288"/>
+                </a:cubicBezTo>
+                <a:cubicBezTo>
+                  <a:pt x="592688" y="20949"/>
+                  <a:pt x="183477" y="14753"/>
+                  <a:pt x="0" y="18288"/>
+                </a:cubicBezTo>
+                <a:cubicBezTo>
+                  <a:pt x="-229" y="14222"/>
+                  <a:pt x="509" y="5816"/>
+                  <a:pt x="0" y="0"/>
+                </a:cubicBezTo>
+                <a:close/>
+              </a:path>
+              <a:path w="4243589" h="18288" stroke="0" extrusionOk="0">
+                <a:moveTo>
+                  <a:pt x="0" y="0"/>
+                </a:moveTo>
+                <a:cubicBezTo>
+                  <a:pt x="143690" y="16630"/>
+                  <a:pt x="266667" y="14847"/>
+                  <a:pt x="521355" y="0"/>
+                </a:cubicBezTo>
+                <a:cubicBezTo>
+                  <a:pt x="776043" y="-14847"/>
+                  <a:pt x="814491" y="-17363"/>
+                  <a:pt x="1000275" y="0"/>
+                </a:cubicBezTo>
+                <a:cubicBezTo>
+                  <a:pt x="1186059" y="17363"/>
+                  <a:pt x="1352504" y="-23507"/>
+                  <a:pt x="1521630" y="0"/>
+                </a:cubicBezTo>
+                <a:cubicBezTo>
+                  <a:pt x="1690756" y="23507"/>
+                  <a:pt x="1889525" y="5871"/>
+                  <a:pt x="2127857" y="0"/>
+                </a:cubicBezTo>
+                <a:cubicBezTo>
+                  <a:pt x="2366189" y="-5871"/>
+                  <a:pt x="2620628" y="-27997"/>
+                  <a:pt x="2776520" y="0"/>
+                </a:cubicBezTo>
+                <a:cubicBezTo>
+                  <a:pt x="2932412" y="27997"/>
+                  <a:pt x="3131683" y="-25073"/>
+                  <a:pt x="3467618" y="0"/>
+                </a:cubicBezTo>
+                <a:cubicBezTo>
+                  <a:pt x="3803553" y="25073"/>
+                  <a:pt x="4017371" y="3071"/>
+                  <a:pt x="4243589" y="0"/>
+                </a:cubicBezTo>
+                <a:cubicBezTo>
+                  <a:pt x="4243134" y="6162"/>
+                  <a:pt x="4243492" y="11775"/>
+                  <a:pt x="4243589" y="18288"/>
+                </a:cubicBezTo>
+                <a:cubicBezTo>
+                  <a:pt x="4017834" y="-5779"/>
+                  <a:pt x="3834586" y="13376"/>
+                  <a:pt x="3594926" y="18288"/>
+                </a:cubicBezTo>
+                <a:cubicBezTo>
+                  <a:pt x="3355266" y="23200"/>
+                  <a:pt x="3204179" y="2869"/>
+                  <a:pt x="2903827" y="18288"/>
+                </a:cubicBezTo>
+                <a:cubicBezTo>
+                  <a:pt x="2603475" y="33707"/>
+                  <a:pt x="2526187" y="46187"/>
+                  <a:pt x="2212729" y="18288"/>
+                </a:cubicBezTo>
+                <a:cubicBezTo>
+                  <a:pt x="1899271" y="-9611"/>
+                  <a:pt x="1966289" y="29692"/>
+                  <a:pt x="1733809" y="18288"/>
+                </a:cubicBezTo>
+                <a:cubicBezTo>
+                  <a:pt x="1501329" y="6884"/>
+                  <a:pt x="1343612" y="12492"/>
+                  <a:pt x="1085146" y="18288"/>
+                </a:cubicBezTo>
+                <a:cubicBezTo>
+                  <a:pt x="826680" y="24084"/>
+                  <a:pt x="778184" y="35607"/>
+                  <a:pt x="521355" y="18288"/>
+                </a:cubicBezTo>
+                <a:cubicBezTo>
+                  <a:pt x="264526" y="969"/>
+                  <a:pt x="120277" y="4268"/>
+                  <a:pt x="0" y="18288"/>
+                </a:cubicBezTo>
+                <a:cubicBezTo>
+                  <a:pt x="766" y="10800"/>
+                  <a:pt x="-457" y="8180"/>
+                  <a:pt x="0" y="0"/>
+                </a:cubicBezTo>
+                <a:close/>
+              </a:path>
+            </a:pathLst>
+          </a:custGeom>
+          <a:solidFill>
+            <a:schemeClr val="accent2"/>
+          </a:solidFill>
+          <a:ln w="41275" cap="rnd">
+            <a:solidFill>
+              <a:schemeClr val="accent2"/>
+            </a:solidFill>
+            <a:round/>
+            <a:extLst>
+              <a:ext uri="{C807C97D-BFC1-408E-A445-0C87EB9F89A2}">
+                <ask:lineSketchStyleProps xmlns:ask="http://schemas.microsoft.com/office/drawing/2018/sketchyshapes" sd="2727557108">
+                  <a:prstGeom prst="rect">
+                    <a:avLst/>
+                  </a:prstGeom>
+                  <ask:type>
+                    <ask:lineSketchFreehand/>
+                  </ask:type>
+                </ask:lineSketchStyleProps>
+              </a:ext>
+            </a:extLst>
+          </a:ln>
+        </p:spPr>
+        <p:style>
+          <a:lnRef idx="2">
+            <a:schemeClr val="accent1">
+              <a:shade val="50000"/>
+            </a:schemeClr>
+          </a:lnRef>
+          <a:fillRef idx="1">
+            <a:schemeClr val="accent1"/>
+          </a:fillRef>
+          <a:effectRef idx="0">
+            <a:schemeClr val="accent1"/>
+          </a:effectRef>
+          <a:fontRef idx="minor">
+            <a:schemeClr val="lt1"/>
+          </a:fontRef>
+        </p:style>
+        <p:txBody>
+          <a:bodyPr rtlCol="0" anchor="ctr"/>
+          <a:lstStyle/>
+          <a:p>
+            <a:pPr algn="ctr"/>
+            <a:endParaRPr lang="en-US"/>
+          </a:p>
+        </p:txBody>
+      </p:sp>
+      <mc:AlternateContent xmlns:mc="http://schemas.openxmlformats.org/markup-compatibility/2006">
+        <mc:Choice xmlns:a14="http://schemas.microsoft.com/office/drawing/2010/main" Requires="a14">
+          <p:sp>
+            <p:nvSpPr>
+              <p:cNvPr id="3" name="Content Placeholder 2">
+                <a:extLst>
+                  <a:ext uri="{FF2B5EF4-FFF2-40B4-BE49-F238E27FC236}">
+                    <a16:creationId xmlns:a16="http://schemas.microsoft.com/office/drawing/2014/main" id="{3F778074-DBD7-5D46-2FE2-5F5EBCCDE4D4}"/>
+                  </a:ext>
+                </a:extLst>
+              </p:cNvPr>
+              <p:cNvSpPr>
+                <a:spLocks noGrp="1"/>
+              </p:cNvSpPr>
+              <p:nvPr>
+                <p:ph idx="1"/>
+              </p:nvPr>
+            </p:nvSpPr>
+            <p:spPr>
+              <a:xfrm>
+                <a:off x="640079" y="2706624"/>
+                <a:ext cx="7328263" cy="3483864"/>
+              </a:xfrm>
+            </p:spPr>
+            <p:txBody>
+              <a:bodyPr>
+                <a:normAutofit/>
+              </a:bodyPr>
+              <a:lstStyle/>
+              <a:p>
+                <a:r>
+                  <a:rPr lang="cs-CZ" sz="2200" dirty="0"/>
+                  <a:t>C: výčtový typ (fixní sada hodnot s identifikátory)</a:t>
+                </a:r>
+              </a:p>
+              <a:p>
+                <a:r>
+                  <a:rPr lang="cs-CZ" sz="2200" dirty="0"/>
+                  <a:t>Rust: disjunktní sjednocení množin hodnot</a:t>
+                </a:r>
+              </a:p>
+              <a:p>
+                <a:pPr lvl="1"/>
+                <a:r>
+                  <a:rPr lang="cs-CZ" sz="2000" dirty="0"/>
+                  <a:t>Běžné sjednocení: </a:t>
+                </a:r>
+                <a14:m>
+                  <m:oMath xmlns:m="http://schemas.openxmlformats.org/officeDocument/2006/math">
+                    <m:d>
+                      <m:dPr>
+                        <m:begChr m:val="{"/>
+                        <m:endChr m:val="}"/>
+                        <m:ctrlPr>
+                          <a:rPr lang="cs-CZ" sz="2000" b="0" i="1">
+                            <a:latin typeface="Cambria Math" panose="02040503050406030204" pitchFamily="18" charset="0"/>
+                          </a:rPr>
+                        </m:ctrlPr>
+                      </m:dPr>
+                      <m:e>
+                        <m:r>
+                          <a:rPr lang="cs-CZ" sz="2000" b="0" i="1">
+                            <a:latin typeface="Cambria Math" panose="02040503050406030204" pitchFamily="18" charset="0"/>
+                          </a:rPr>
+                          <m:t>1, 2, 5</m:t>
+                        </m:r>
+                      </m:e>
+                    </m:d>
+                    <m:r>
+                      <a:rPr lang="cs-CZ" sz="2000" b="0" i="1">
+                        <a:latin typeface="Cambria Math" panose="02040503050406030204" pitchFamily="18" charset="0"/>
+                        <a:ea typeface="Cambria Math" panose="02040503050406030204" pitchFamily="18" charset="0"/>
+                      </a:rPr>
+                      <m:t>∪</m:t>
+                    </m:r>
+                    <m:d>
+                      <m:dPr>
+                        <m:begChr m:val="{"/>
+                        <m:endChr m:val="}"/>
+                        <m:ctrlPr>
+                          <a:rPr lang="cs-CZ" sz="2000" b="0" i="1">
+                            <a:latin typeface="Cambria Math" panose="02040503050406030204" pitchFamily="18" charset="0"/>
+                            <a:ea typeface="Cambria Math" panose="02040503050406030204" pitchFamily="18" charset="0"/>
+                          </a:rPr>
+                        </m:ctrlPr>
+                      </m:dPr>
+                      <m:e>
+                        <m:r>
+                          <a:rPr lang="cs-CZ" sz="2000" b="0" i="1">
+                            <a:latin typeface="Cambria Math" panose="02040503050406030204" pitchFamily="18" charset="0"/>
+                            <a:ea typeface="Cambria Math" panose="02040503050406030204" pitchFamily="18" charset="0"/>
+                          </a:rPr>
+                          <m:t>2, 10</m:t>
+                        </m:r>
+                      </m:e>
+                    </m:d>
+                    <m:r>
+                      <a:rPr lang="cs-CZ" sz="2000" b="0" i="1">
+                        <a:latin typeface="Cambria Math" panose="02040503050406030204" pitchFamily="18" charset="0"/>
+                        <a:ea typeface="Cambria Math" panose="02040503050406030204" pitchFamily="18" charset="0"/>
+                      </a:rPr>
+                      <m:t>={1, 2, 5, 10}</m:t>
+                    </m:r>
+                  </m:oMath>
+                </a14:m>
+                <a:endParaRPr lang="cs-CZ" sz="2000" dirty="0"/>
+              </a:p>
+              <a:p>
+                <a:pPr lvl="1"/>
+                <a:r>
+                  <a:rPr lang="cs-CZ" sz="2000" dirty="0"/>
+                  <a:t>Disjunktní sjednocení: </a:t>
+                </a:r>
+                <a14:m>
+                  <m:oMath xmlns:m="http://schemas.openxmlformats.org/officeDocument/2006/math">
+                    <m:d>
+                      <m:dPr>
+                        <m:begChr m:val="{"/>
+                        <m:endChr m:val="}"/>
+                        <m:ctrlPr>
+                          <a:rPr lang="cs-CZ" sz="2000" b="0" i="1">
+                            <a:latin typeface="Cambria Math" panose="02040503050406030204" pitchFamily="18" charset="0"/>
+                          </a:rPr>
+                        </m:ctrlPr>
+                      </m:dPr>
+                      <m:e>
+                        <m:r>
+                          <a:rPr lang="cs-CZ" sz="2000" b="0" i="1">
+                            <a:latin typeface="Cambria Math" panose="02040503050406030204" pitchFamily="18" charset="0"/>
+                          </a:rPr>
+                          <m:t>1, 2, 5</m:t>
+                        </m:r>
+                      </m:e>
+                    </m:d>
+                    <m:r>
+                      <a:rPr lang="cs-CZ" sz="2000" i="1">
+                        <a:latin typeface="Cambria Math" panose="02040503050406030204" pitchFamily="18" charset="0"/>
+                        <a:ea typeface="Cambria Math" panose="02040503050406030204" pitchFamily="18" charset="0"/>
+                      </a:rPr>
+                      <m:t>⊔</m:t>
+                    </m:r>
+                    <m:d>
+                      <m:dPr>
+                        <m:begChr m:val="{"/>
+                        <m:endChr m:val="}"/>
+                        <m:ctrlPr>
+                          <a:rPr lang="cs-CZ" sz="2000" b="0" i="1">
+                            <a:latin typeface="Cambria Math" panose="02040503050406030204" pitchFamily="18" charset="0"/>
+                            <a:ea typeface="Cambria Math" panose="02040503050406030204" pitchFamily="18" charset="0"/>
+                          </a:rPr>
+                        </m:ctrlPr>
+                      </m:dPr>
+                      <m:e>
+                        <m:r>
+                          <a:rPr lang="cs-CZ" sz="2000" b="0" i="1">
+                            <a:latin typeface="Cambria Math" panose="02040503050406030204" pitchFamily="18" charset="0"/>
+                            <a:ea typeface="Cambria Math" panose="02040503050406030204" pitchFamily="18" charset="0"/>
+                          </a:rPr>
+                          <m:t>2, 10</m:t>
+                        </m:r>
+                      </m:e>
+                    </m:d>
+                    <m:r>
+                      <a:rPr lang="cs-CZ" sz="2000" b="0" i="1">
+                        <a:latin typeface="Cambria Math" panose="02040503050406030204" pitchFamily="18" charset="0"/>
+                        <a:ea typeface="Cambria Math" panose="02040503050406030204" pitchFamily="18" charset="0"/>
+                      </a:rPr>
+                      <m:t>={</m:t>
+                    </m:r>
+                    <m:sSub>
+                      <m:sSubPr>
+                        <m:ctrlPr>
+                          <a:rPr lang="cs-CZ" sz="2000" b="0" i="1">
+                            <a:latin typeface="Cambria Math" panose="02040503050406030204" pitchFamily="18" charset="0"/>
+                            <a:ea typeface="Cambria Math" panose="02040503050406030204" pitchFamily="18" charset="0"/>
+                          </a:rPr>
+                        </m:ctrlPr>
+                      </m:sSubPr>
+                      <m:e>
+                        <m:r>
+                          <a:rPr lang="cs-CZ" sz="2000" b="0" i="1">
+                            <a:latin typeface="Cambria Math" panose="02040503050406030204" pitchFamily="18" charset="0"/>
+                            <a:ea typeface="Cambria Math" panose="02040503050406030204" pitchFamily="18" charset="0"/>
+                          </a:rPr>
+                          <m:t>1</m:t>
+                        </m:r>
+                      </m:e>
+                      <m:sub>
+                        <m:r>
+                          <a:rPr lang="cs-CZ" sz="2000" b="0" i="1">
+                            <a:latin typeface="Cambria Math" panose="02040503050406030204" pitchFamily="18" charset="0"/>
+                            <a:ea typeface="Cambria Math" panose="02040503050406030204" pitchFamily="18" charset="0"/>
+                          </a:rPr>
+                          <m:t>𝐴</m:t>
+                        </m:r>
+                      </m:sub>
+                    </m:sSub>
+                    <m:r>
+                      <a:rPr lang="cs-CZ" sz="2000" b="0" i="1">
+                        <a:latin typeface="Cambria Math" panose="02040503050406030204" pitchFamily="18" charset="0"/>
+                        <a:ea typeface="Cambria Math" panose="02040503050406030204" pitchFamily="18" charset="0"/>
+                      </a:rPr>
+                      <m:t>, </m:t>
+                    </m:r>
+                    <m:sSub>
+                      <m:sSubPr>
+                        <m:ctrlPr>
+                          <a:rPr lang="cs-CZ" sz="2000" b="0" i="1">
+                            <a:latin typeface="Cambria Math" panose="02040503050406030204" pitchFamily="18" charset="0"/>
+                            <a:ea typeface="Cambria Math" panose="02040503050406030204" pitchFamily="18" charset="0"/>
+                          </a:rPr>
+                        </m:ctrlPr>
+                      </m:sSubPr>
+                      <m:e>
+                        <m:r>
+                          <a:rPr lang="cs-CZ" sz="2000" b="0" i="1">
+                            <a:latin typeface="Cambria Math" panose="02040503050406030204" pitchFamily="18" charset="0"/>
+                            <a:ea typeface="Cambria Math" panose="02040503050406030204" pitchFamily="18" charset="0"/>
+                          </a:rPr>
+                          <m:t>2</m:t>
+                        </m:r>
+                      </m:e>
+                      <m:sub>
+                        <m:r>
+                          <a:rPr lang="cs-CZ" sz="2000" b="0" i="1">
+                            <a:latin typeface="Cambria Math" panose="02040503050406030204" pitchFamily="18" charset="0"/>
+                            <a:ea typeface="Cambria Math" panose="02040503050406030204" pitchFamily="18" charset="0"/>
+                          </a:rPr>
+                          <m:t>𝐴</m:t>
+                        </m:r>
+                      </m:sub>
+                    </m:sSub>
+                    <m:r>
+                      <a:rPr lang="cs-CZ" sz="2000" b="0" i="1">
+                        <a:latin typeface="Cambria Math" panose="02040503050406030204" pitchFamily="18" charset="0"/>
+                        <a:ea typeface="Cambria Math" panose="02040503050406030204" pitchFamily="18" charset="0"/>
+                      </a:rPr>
+                      <m:t>, </m:t>
+                    </m:r>
+                    <m:sSub>
+                      <m:sSubPr>
+                        <m:ctrlPr>
+                          <a:rPr lang="cs-CZ" sz="2000" b="0" i="1">
+                            <a:latin typeface="Cambria Math" panose="02040503050406030204" pitchFamily="18" charset="0"/>
+                            <a:ea typeface="Cambria Math" panose="02040503050406030204" pitchFamily="18" charset="0"/>
+                          </a:rPr>
+                        </m:ctrlPr>
+                      </m:sSubPr>
+                      <m:e>
+                        <m:r>
+                          <a:rPr lang="cs-CZ" sz="2000" b="0" i="1">
+                            <a:latin typeface="Cambria Math" panose="02040503050406030204" pitchFamily="18" charset="0"/>
+                            <a:ea typeface="Cambria Math" panose="02040503050406030204" pitchFamily="18" charset="0"/>
+                          </a:rPr>
+                          <m:t>5</m:t>
+                        </m:r>
+                      </m:e>
+                      <m:sub>
+                        <m:r>
+                          <a:rPr lang="cs-CZ" sz="2000" b="0" i="1">
+                            <a:latin typeface="Cambria Math" panose="02040503050406030204" pitchFamily="18" charset="0"/>
+                            <a:ea typeface="Cambria Math" panose="02040503050406030204" pitchFamily="18" charset="0"/>
+                          </a:rPr>
+                          <m:t>𝐴</m:t>
+                        </m:r>
+                      </m:sub>
+                    </m:sSub>
+                    <m:r>
+                      <a:rPr lang="cs-CZ" sz="2000" b="0" i="1">
+                        <a:latin typeface="Cambria Math" panose="02040503050406030204" pitchFamily="18" charset="0"/>
+                        <a:ea typeface="Cambria Math" panose="02040503050406030204" pitchFamily="18" charset="0"/>
+                      </a:rPr>
+                      <m:t>, </m:t>
+                    </m:r>
+                    <m:sSub>
+                      <m:sSubPr>
+                        <m:ctrlPr>
+                          <a:rPr lang="cs-CZ" sz="2000" b="0" i="1">
+                            <a:latin typeface="Cambria Math" panose="02040503050406030204" pitchFamily="18" charset="0"/>
+                            <a:ea typeface="Cambria Math" panose="02040503050406030204" pitchFamily="18" charset="0"/>
+                          </a:rPr>
+                        </m:ctrlPr>
+                      </m:sSubPr>
+                      <m:e>
+                        <m:r>
+                          <a:rPr lang="cs-CZ" sz="2000" b="0" i="1">
+                            <a:latin typeface="Cambria Math" panose="02040503050406030204" pitchFamily="18" charset="0"/>
+                            <a:ea typeface="Cambria Math" panose="02040503050406030204" pitchFamily="18" charset="0"/>
+                          </a:rPr>
+                          <m:t>2</m:t>
+                        </m:r>
+                      </m:e>
+                      <m:sub>
+                        <m:r>
+                          <a:rPr lang="cs-CZ" sz="2000" b="0" i="1">
+                            <a:latin typeface="Cambria Math" panose="02040503050406030204" pitchFamily="18" charset="0"/>
+                            <a:ea typeface="Cambria Math" panose="02040503050406030204" pitchFamily="18" charset="0"/>
+                          </a:rPr>
+                          <m:t>𝐵</m:t>
+                        </m:r>
+                      </m:sub>
+                    </m:sSub>
+                    <m:r>
+                      <a:rPr lang="cs-CZ" sz="2000" b="0" i="1">
+                        <a:latin typeface="Cambria Math" panose="02040503050406030204" pitchFamily="18" charset="0"/>
+                        <a:ea typeface="Cambria Math" panose="02040503050406030204" pitchFamily="18" charset="0"/>
+                      </a:rPr>
+                      <m:t>, </m:t>
+                    </m:r>
+                    <m:sSub>
+                      <m:sSubPr>
+                        <m:ctrlPr>
+                          <a:rPr lang="cs-CZ" sz="2000" b="0" i="1">
+                            <a:latin typeface="Cambria Math" panose="02040503050406030204" pitchFamily="18" charset="0"/>
+                            <a:ea typeface="Cambria Math" panose="02040503050406030204" pitchFamily="18" charset="0"/>
+                          </a:rPr>
+                        </m:ctrlPr>
+                      </m:sSubPr>
+                      <m:e>
+                        <m:r>
+                          <a:rPr lang="cs-CZ" sz="2000" b="0" i="1">
+                            <a:latin typeface="Cambria Math" panose="02040503050406030204" pitchFamily="18" charset="0"/>
+                            <a:ea typeface="Cambria Math" panose="02040503050406030204" pitchFamily="18" charset="0"/>
+                          </a:rPr>
+                          <m:t>10</m:t>
+                        </m:r>
+                      </m:e>
+                      <m:sub>
+                        <m:r>
+                          <a:rPr lang="cs-CZ" sz="2000" b="0" i="1">
+                            <a:latin typeface="Cambria Math" panose="02040503050406030204" pitchFamily="18" charset="0"/>
+                            <a:ea typeface="Cambria Math" panose="02040503050406030204" pitchFamily="18" charset="0"/>
+                          </a:rPr>
+                          <m:t>𝐵</m:t>
+                        </m:r>
+                      </m:sub>
+                    </m:sSub>
+                    <m:r>
+                      <a:rPr lang="cs-CZ" sz="2000" b="0" i="1">
+                        <a:latin typeface="Cambria Math" panose="02040503050406030204" pitchFamily="18" charset="0"/>
+                        <a:ea typeface="Cambria Math" panose="02040503050406030204" pitchFamily="18" charset="0"/>
+                      </a:rPr>
+                      <m:t>}</m:t>
+                    </m:r>
+                  </m:oMath>
+                </a14:m>
+                <a:r>
+                  <a:rPr lang="cs-CZ" sz="2000" dirty="0"/>
+                  <a:t> </a:t>
+                </a:r>
+              </a:p>
+              <a:p>
+                <a:r>
+                  <a:rPr lang="cs-CZ" sz="2200" dirty="0"/>
+                  <a:t>Každá varianta </a:t>
+                </a:r>
+                <a:r>
+                  <a:rPr lang="cs-CZ" sz="2200" dirty="0" err="1"/>
+                  <a:t>enumu</a:t>
+                </a:r>
+                <a:r>
+                  <a:rPr lang="cs-CZ" sz="2200" dirty="0"/>
+                  <a:t> dokáže obsahovat další data</a:t>
+                </a:r>
+              </a:p>
+              <a:p>
+                <a:r>
+                  <a:rPr lang="cs-CZ" sz="2200" dirty="0"/>
+                  <a:t>Rozsáhlé využití při zacházení s chybami</a:t>
+                </a:r>
+              </a:p>
+            </p:txBody>
+          </p:sp>
+        </mc:Choice>
+        <mc:Fallback>
+          <p:sp>
+            <p:nvSpPr>
+              <p:cNvPr id="3" name="Content Placeholder 2">
+                <a:extLst>
+                  <a:ext uri="{FF2B5EF4-FFF2-40B4-BE49-F238E27FC236}">
+                    <a16:creationId xmlns:a16="http://schemas.microsoft.com/office/drawing/2014/main" id="{3F778074-DBD7-5D46-2FE2-5F5EBCCDE4D4}"/>
+                  </a:ext>
+                </a:extLst>
+              </p:cNvPr>
+              <p:cNvSpPr>
+                <a:spLocks noGrp="1" noRot="1" noChangeAspect="1" noMove="1" noResize="1" noEditPoints="1" noAdjustHandles="1" noChangeArrowheads="1" noChangeShapeType="1" noTextEdit="1"/>
+              </p:cNvSpPr>
+              <p:nvPr>
+                <p:ph idx="1"/>
+              </p:nvPr>
+            </p:nvSpPr>
+            <p:spPr>
+              <a:xfrm>
+                <a:off x="640079" y="2706624"/>
+                <a:ext cx="7328263" cy="3483864"/>
+              </a:xfrm>
+              <a:blipFill>
+                <a:blip r:embed="rId3"/>
+                <a:stretch>
+                  <a:fillRect l="-915" t="-2098"/>
+                </a:stretch>
+              </a:blipFill>
+            </p:spPr>
+            <p:txBody>
+              <a:bodyPr/>
+              <a:lstStyle/>
+              <a:p>
+                <a:r>
+                  <a:rPr lang="cs-CZ">
+                    <a:noFill/>
+                  </a:rPr>
+                  <a:t> </a:t>
+                </a:r>
+              </a:p>
+            </p:txBody>
+          </p:sp>
+        </mc:Fallback>
+      </mc:AlternateContent>
+      <p:pic>
+        <p:nvPicPr>
+          <p:cNvPr id="9" name="Picture 8">
+            <a:extLst>
+              <a:ext uri="{FF2B5EF4-FFF2-40B4-BE49-F238E27FC236}">
+                <a16:creationId xmlns:a16="http://schemas.microsoft.com/office/drawing/2014/main" id="{BE57D732-8A3D-41DB-F70E-E13CE98B0710}"/>
+              </a:ext>
+            </a:extLst>
+          </p:cNvPr>
+          <p:cNvPicPr>
+            <a:picLocks noChangeAspect="1"/>
+          </p:cNvPicPr>
+          <p:nvPr/>
+        </p:nvPicPr>
+        <p:blipFill>
+          <a:blip r:embed="rId4">
+            <a:extLst>
+              <a:ext uri="{28A0092B-C50C-407E-A947-70E740481C1C}">
+                <a14:useLocalDpi xmlns:a14="http://schemas.microsoft.com/office/drawing/2010/main" val="0"/>
+              </a:ext>
+            </a:extLst>
+          </a:blip>
+          <a:srcRect l="2674" t="9905" r="56040" b="2300"/>
+          <a:stretch>
+            <a:fillRect/>
+          </a:stretch>
+        </p:blipFill>
+        <p:spPr>
+          <a:xfrm>
+            <a:off x="8633679" y="329183"/>
+            <a:ext cx="2474537" cy="3429969"/>
+          </a:xfrm>
+          <a:prstGeom prst="rect">
+            <a:avLst/>
+          </a:prstGeom>
+        </p:spPr>
+      </p:pic>
+      <p:pic>
+        <p:nvPicPr>
+          <p:cNvPr id="11" name="Picture 10">
+            <a:extLst>
+              <a:ext uri="{FF2B5EF4-FFF2-40B4-BE49-F238E27FC236}">
+                <a16:creationId xmlns:a16="http://schemas.microsoft.com/office/drawing/2014/main" id="{7B761382-BF14-2CEB-D414-A505672C3AAA}"/>
+              </a:ext>
+            </a:extLst>
+          </p:cNvPr>
+          <p:cNvPicPr>
+            <a:picLocks noChangeAspect="1"/>
+          </p:cNvPicPr>
+          <p:nvPr/>
+        </p:nvPicPr>
+        <p:blipFill>
+          <a:blip r:embed="rId5">
+            <a:extLst>
+              <a:ext uri="{28A0092B-C50C-407E-A947-70E740481C1C}">
+                <a14:useLocalDpi xmlns:a14="http://schemas.microsoft.com/office/drawing/2010/main" val="0"/>
+              </a:ext>
+            </a:extLst>
+          </a:blip>
+          <a:srcRect l="2320" t="12605" r="34817" b="2986"/>
+          <a:stretch>
+            <a:fillRect/>
+          </a:stretch>
+        </p:blipFill>
+        <p:spPr>
+          <a:xfrm>
+            <a:off x="8368600" y="4353511"/>
+            <a:ext cx="3420093" cy="1836977"/>
+          </a:xfrm>
+          <a:prstGeom prst="rect">
+            <a:avLst/>
+          </a:prstGeom>
+        </p:spPr>
+      </p:pic>
+    </p:spTree>
+    <p:extLst>
+      <p:ext uri="{BB962C8B-B14F-4D97-AF65-F5344CB8AC3E}">
+        <p14:creationId xmlns:p14="http://schemas.microsoft.com/office/powerpoint/2010/main" val="490412682"/>
+      </p:ext>
+    </p:extLst>
+  </p:cSld>
+  <p:clrMapOvr>
+    <a:masterClrMapping/>
+  </p:clrMapOvr>
+</p:sld>
+</file>
+
+<file path=ppt/slides/slide8.xml><?xml version="1.0" encoding="utf-8"?>
+<p:sld xmlns:a="http://schemas.openxmlformats.org/drawingml/2006/main" xmlns:r="http://schemas.openxmlformats.org/officeDocument/2006/relationships" xmlns:p="http://schemas.openxmlformats.org/presentationml/2006/main">
+  <p:cSld>
+    <p:spTree>
+      <p:nvGrpSpPr>
+        <p:cNvPr id="1" name=""/>
+        <p:cNvGrpSpPr/>
+        <p:nvPr/>
+      </p:nvGrpSpPr>
+      <p:grpSpPr>
+        <a:xfrm>
+          <a:off x="0" y="0"/>
+          <a:ext cx="0" cy="0"/>
+          <a:chOff x="0" y="0"/>
+          <a:chExt cx="0" cy="0"/>
+        </a:xfrm>
+      </p:grpSpPr>
+      <p:sp>
+        <p:nvSpPr>
+          <p:cNvPr id="2" name="Title 1">
+            <a:extLst>
+              <a:ext uri="{FF2B5EF4-FFF2-40B4-BE49-F238E27FC236}">
+                <a16:creationId xmlns:a16="http://schemas.microsoft.com/office/drawing/2014/main" id="{EC154250-EC80-B686-0879-9FC018462F3E}"/>
+              </a:ext>
+            </a:extLst>
+          </p:cNvPr>
+          <p:cNvSpPr>
+            <a:spLocks noGrp="1"/>
+          </p:cNvSpPr>
+          <p:nvPr>
+            <p:ph type="title"/>
+          </p:nvPr>
+        </p:nvSpPr>
+        <p:spPr/>
+        <p:txBody>
+          <a:bodyPr/>
+          <a:lstStyle/>
+          <a:p>
+            <a:r>
+              <a:rPr lang="cs-CZ" dirty="0"/>
+              <a:t>Vlastnictví a půjčování</a:t>
+            </a:r>
+          </a:p>
+        </p:txBody>
+      </p:sp>
+      <p:sp>
+        <p:nvSpPr>
+          <p:cNvPr id="3" name="Content Placeholder 2">
+            <a:extLst>
+              <a:ext uri="{FF2B5EF4-FFF2-40B4-BE49-F238E27FC236}">
+                <a16:creationId xmlns:a16="http://schemas.microsoft.com/office/drawing/2014/main" id="{C33F5ACF-B009-EEA3-F009-17084C1AB282}"/>
+              </a:ext>
+            </a:extLst>
+          </p:cNvPr>
+          <p:cNvSpPr>
+            <a:spLocks noGrp="1"/>
+          </p:cNvSpPr>
+          <p:nvPr>
+            <p:ph idx="1"/>
+          </p:nvPr>
+        </p:nvSpPr>
+        <p:spPr>
+          <a:xfrm>
+            <a:off x="838200" y="1825624"/>
+            <a:ext cx="10515600" cy="5032375"/>
+          </a:xfrm>
+        </p:spPr>
+        <p:txBody>
+          <a:bodyPr>
+            <a:normAutofit/>
+          </a:bodyPr>
+          <a:lstStyle/>
+          <a:p>
+            <a:r>
+              <a:rPr lang="cs-CZ" dirty="0"/>
+              <a:t>Každá hodnota má jediného vlastníka</a:t>
+            </a:r>
+          </a:p>
+          <a:p>
+            <a:pPr lvl="1"/>
+            <a:r>
+              <a:rPr lang="cs-CZ" dirty="0"/>
+              <a:t>Vlastník: blok kódu proměnné / objekt (struktura či </a:t>
+            </a:r>
+            <a:r>
+              <a:rPr lang="cs-CZ" dirty="0" err="1"/>
+              <a:t>enum</a:t>
+            </a:r>
+            <a:r>
+              <a:rPr lang="cs-CZ" dirty="0"/>
+              <a:t>)</a:t>
+            </a:r>
+          </a:p>
+          <a:p>
+            <a:pPr lvl="1"/>
+            <a:r>
+              <a:rPr lang="cs-CZ" dirty="0"/>
+              <a:t>Proměnná je přístupná pouze pro jejího vlastníka</a:t>
+            </a:r>
+          </a:p>
+          <a:p>
+            <a:pPr lvl="1"/>
+            <a:r>
+              <a:rPr lang="cs-CZ" dirty="0"/>
+              <a:t>(předávání vlastnictví)</a:t>
+            </a:r>
+          </a:p>
+          <a:p>
+            <a:r>
+              <a:rPr lang="cs-CZ" dirty="0"/>
+              <a:t>Proměnné jsou ve výchozím stavu neměnné</a:t>
+            </a:r>
+          </a:p>
+          <a:p>
+            <a:r>
+              <a:rPr lang="cs-CZ" dirty="0"/>
+              <a:t>Reference = ukazatele</a:t>
+            </a:r>
+          </a:p>
+          <a:p>
+            <a:pPr lvl="1"/>
+            <a:r>
+              <a:rPr lang="cs-CZ" dirty="0"/>
+              <a:t>„Propůjčují“ danou hodnotu někomu jinému (nejčastěji funkci)</a:t>
+            </a:r>
+          </a:p>
+          <a:p>
+            <a:pPr lvl="1"/>
+            <a:r>
+              <a:rPr lang="cs-CZ" dirty="0"/>
+              <a:t>Nikdy nesmí mít delší životnost než původní hodnota</a:t>
+            </a:r>
+          </a:p>
+          <a:p>
+            <a:pPr lvl="1"/>
+            <a:r>
+              <a:rPr lang="cs-CZ" dirty="0"/>
+              <a:t>1 měnitelná reference, nebo ∞ neměnných referencí, ne oboje naráz</a:t>
+            </a:r>
+          </a:p>
+          <a:p>
+            <a:r>
+              <a:rPr lang="cs-CZ" dirty="0"/>
+              <a:t>Při skončení životnosti automaticky zavolán Drop</a:t>
+            </a:r>
+          </a:p>
+        </p:txBody>
+      </p:sp>
+    </p:spTree>
+    <p:extLst>
+      <p:ext uri="{BB962C8B-B14F-4D97-AF65-F5344CB8AC3E}">
+        <p14:creationId xmlns:p14="http://schemas.microsoft.com/office/powerpoint/2010/main" val="3028556012"/>
+      </p:ext>
+    </p:extLst>
+  </p:cSld>
+  <p:clrMapOvr>
+    <a:masterClrMapping/>
+  </p:clrMapOvr>
+</p:sld>
+</file>
+
+<file path=ppt/slides/slide9.xml><?xml version="1.0" encoding="utf-8"?>
+<p:sld xmlns:a="http://schemas.openxmlformats.org/drawingml/2006/main" xmlns:r="http://schemas.openxmlformats.org/officeDocument/2006/relationships" xmlns:p="http://schemas.openxmlformats.org/presentationml/2006/main">
+  <p:cSld>
+    <p:bg>
+      <p:bgPr>
+        <a:solidFill>
+          <a:schemeClr val="bg1"/>
+        </a:solidFill>
+        <a:effectLst/>
+      </p:bgPr>
+    </p:bg>
+    <p:spTree>
+      <p:nvGrpSpPr>
+        <p:cNvPr id="1" name=""/>
+        <p:cNvGrpSpPr/>
+        <p:nvPr/>
+      </p:nvGrpSpPr>
+      <p:grpSpPr>
+        <a:xfrm>
+          <a:off x="0" y="0"/>
+          <a:ext cx="0" cy="0"/>
+          <a:chOff x="0" y="0"/>
+          <a:chExt cx="0" cy="0"/>
+        </a:xfrm>
+      </p:grpSpPr>
+      <p:sp useBgFill="1">
+        <p:nvSpPr>
           <p:cNvPr id="18" name="Rectangle 17">
             <a:extLst>
               <a:ext uri="{FF2B5EF4-FFF2-40B4-BE49-F238E27FC236}">
@@ -7612,651 +9810,6 @@
     <p:extLst>
       <p:ext uri="{BB962C8B-B14F-4D97-AF65-F5344CB8AC3E}">
         <p14:creationId xmlns:p14="http://schemas.microsoft.com/office/powerpoint/2010/main" val="298307023"/>
-      </p:ext>
-    </p:extLst>
-  </p:cSld>
-  <p:clrMapOvr>
-    <a:masterClrMapping/>
-  </p:clrMapOvr>
-</p:sld>
-</file>
-
-<file path=ppt/slides/slide8.xml><?xml version="1.0" encoding="utf-8"?>
-<p:sld xmlns:a="http://schemas.openxmlformats.org/drawingml/2006/main" xmlns:r="http://schemas.openxmlformats.org/officeDocument/2006/relationships" xmlns:p="http://schemas.openxmlformats.org/presentationml/2006/main">
-  <p:cSld>
-    <p:bg>
-      <p:bgPr>
-        <a:solidFill>
-          <a:schemeClr val="bg1"/>
-        </a:solidFill>
-        <a:effectLst/>
-      </p:bgPr>
-    </p:bg>
-    <p:spTree>
-      <p:nvGrpSpPr>
-        <p:cNvPr id="1" name="">
-          <a:extLst>
-            <a:ext uri="{FF2B5EF4-FFF2-40B4-BE49-F238E27FC236}">
-              <a16:creationId xmlns:a16="http://schemas.microsoft.com/office/drawing/2014/main" id="{9EC53ACE-5A18-0223-F078-F212AF8D0543}"/>
-            </a:ext>
-          </a:extLst>
-        </p:cNvPr>
-        <p:cNvGrpSpPr/>
-        <p:nvPr/>
-      </p:nvGrpSpPr>
-      <p:grpSpPr>
-        <a:xfrm>
-          <a:off x="0" y="0"/>
-          <a:ext cx="0" cy="0"/>
-          <a:chOff x="0" y="0"/>
-          <a:chExt cx="0" cy="0"/>
-        </a:xfrm>
-      </p:grpSpPr>
-      <p:sp useBgFill="1">
-        <p:nvSpPr>
-          <p:cNvPr id="28" name="Rectangle 27">
-            <a:extLst>
-              <a:ext uri="{FF2B5EF4-FFF2-40B4-BE49-F238E27FC236}">
-                <a16:creationId xmlns:a16="http://schemas.microsoft.com/office/drawing/2014/main" id="{2B97F24A-32CE-4C1C-A50D-3016B394DCFB}"/>
-              </a:ext>
-              <a:ext uri="{C183D7F6-B498-43B3-948B-1728B52AA6E4}">
-                <adec:decorative xmlns:adec="http://schemas.microsoft.com/office/drawing/2017/decorative" val="1"/>
-              </a:ext>
-            </a:extLst>
-          </p:cNvPr>
-          <p:cNvSpPr>
-            <a:spLocks noGrp="1" noRot="1" noChangeAspect="1" noMove="1" noResize="1" noEditPoints="1" noAdjustHandles="1" noChangeArrowheads="1" noChangeShapeType="1" noTextEdit="1"/>
-          </p:cNvSpPr>
-          <p:nvPr>
-            <p:extLst>
-              <p:ext uri="{386F3935-93C4-4BCD-93E2-E3B085C9AB24}">
-                <p16:designElem xmlns:p16="http://schemas.microsoft.com/office/powerpoint/2015/main" val="1"/>
-              </p:ext>
-            </p:extLst>
-          </p:nvPr>
-        </p:nvSpPr>
-        <p:spPr>
-          <a:xfrm>
-            <a:off x="0" y="0"/>
-            <a:ext cx="12192000" cy="6858000"/>
-          </a:xfrm>
-          <a:prstGeom prst="rect">
-            <a:avLst/>
-          </a:prstGeom>
-          <a:ln>
-            <a:noFill/>
-          </a:ln>
-        </p:spPr>
-        <p:style>
-          <a:lnRef idx="2">
-            <a:schemeClr val="accent1">
-              <a:shade val="50000"/>
-            </a:schemeClr>
-          </a:lnRef>
-          <a:fillRef idx="1">
-            <a:schemeClr val="accent1"/>
-          </a:fillRef>
-          <a:effectRef idx="0">
-            <a:schemeClr val="accent1"/>
-          </a:effectRef>
-          <a:fontRef idx="minor">
-            <a:schemeClr val="lt1"/>
-          </a:fontRef>
-        </p:style>
-        <p:txBody>
-          <a:bodyPr rtlCol="0" anchor="ctr"/>
-          <a:lstStyle/>
-          <a:p>
-            <a:pPr algn="ctr"/>
-            <a:endParaRPr lang="cs-CZ" noProof="0" dirty="0"/>
-          </a:p>
-        </p:txBody>
-      </p:sp>
-      <p:sp>
-        <p:nvSpPr>
-          <p:cNvPr id="2" name="Title 1">
-            <a:extLst>
-              <a:ext uri="{FF2B5EF4-FFF2-40B4-BE49-F238E27FC236}">
-                <a16:creationId xmlns:a16="http://schemas.microsoft.com/office/drawing/2014/main" id="{D9AF63F9-96E4-CAE6-8E27-BAD90F2D31C2}"/>
-              </a:ext>
-            </a:extLst>
-          </p:cNvPr>
-          <p:cNvSpPr>
-            <a:spLocks noGrp="1"/>
-          </p:cNvSpPr>
-          <p:nvPr>
-            <p:ph type="title"/>
-          </p:nvPr>
-        </p:nvSpPr>
-        <p:spPr>
-          <a:xfrm>
-            <a:off x="630936" y="639520"/>
-            <a:ext cx="3429000" cy="1719072"/>
-          </a:xfrm>
-        </p:spPr>
-        <p:txBody>
-          <a:bodyPr vert="horz" lIns="91440" tIns="45720" rIns="91440" bIns="45720" rtlCol="0" anchor="b">
-            <a:normAutofit/>
-          </a:bodyPr>
-          <a:lstStyle/>
-          <a:p>
-            <a:r>
-              <a:rPr lang="cs-CZ" sz="5400" kern="1200">
-                <a:solidFill>
-                  <a:schemeClr val="tx1"/>
-                </a:solidFill>
-                <a:latin typeface="+mj-lt"/>
-                <a:ea typeface="+mj-ea"/>
-                <a:cs typeface="+mj-cs"/>
-              </a:rPr>
-              <a:t>Traity 2</a:t>
-            </a:r>
-            <a:endParaRPr lang="cs-CZ" sz="5400" kern="1200" dirty="0">
-              <a:solidFill>
-                <a:schemeClr val="tx1"/>
-              </a:solidFill>
-              <a:latin typeface="+mj-lt"/>
-              <a:ea typeface="+mj-ea"/>
-              <a:cs typeface="+mj-cs"/>
-            </a:endParaRPr>
-          </a:p>
-        </p:txBody>
-      </p:sp>
-      <p:sp>
-        <p:nvSpPr>
-          <p:cNvPr id="30" name="sketch line">
-            <a:extLst>
-              <a:ext uri="{FF2B5EF4-FFF2-40B4-BE49-F238E27FC236}">
-                <a16:creationId xmlns:a16="http://schemas.microsoft.com/office/drawing/2014/main" id="{6357EC4F-235E-4222-A36F-C7878ACE37F2}"/>
-              </a:ext>
-              <a:ext uri="{C183D7F6-B498-43B3-948B-1728B52AA6E4}">
-                <adec:decorative xmlns:adec="http://schemas.microsoft.com/office/drawing/2017/decorative" val="1"/>
-              </a:ext>
-            </a:extLst>
-          </p:cNvPr>
-          <p:cNvSpPr>
-            <a:spLocks noGrp="1" noRot="1" noChangeAspect="1" noMove="1" noResize="1" noEditPoints="1" noAdjustHandles="1" noChangeArrowheads="1" noChangeShapeType="1" noTextEdit="1"/>
-          </p:cNvSpPr>
-          <p:nvPr>
-            <p:extLst>
-              <p:ext uri="{386F3935-93C4-4BCD-93E2-E3B085C9AB24}">
-                <p16:designElem xmlns:p16="http://schemas.microsoft.com/office/powerpoint/2015/main" val="1"/>
-              </p:ext>
-            </p:extLst>
-          </p:nvPr>
-        </p:nvSpPr>
-        <p:spPr>
-          <a:xfrm>
-            <a:off x="643278" y="2573756"/>
-            <a:ext cx="3255095" cy="18288"/>
-          </a:xfrm>
-          <a:custGeom>
-            <a:avLst/>
-            <a:gdLst>
-              <a:gd name="csX0" fmla="*/ 0 w 3255095"/>
-              <a:gd name="csY0" fmla="*/ 0 h 18288"/>
-              <a:gd name="csX1" fmla="*/ 618468 w 3255095"/>
-              <a:gd name="csY1" fmla="*/ 0 h 18288"/>
-              <a:gd name="csX2" fmla="*/ 1269487 w 3255095"/>
-              <a:gd name="csY2" fmla="*/ 0 h 18288"/>
-              <a:gd name="csX3" fmla="*/ 1953057 w 3255095"/>
-              <a:gd name="csY3" fmla="*/ 0 h 18288"/>
-              <a:gd name="csX4" fmla="*/ 2636627 w 3255095"/>
-              <a:gd name="csY4" fmla="*/ 0 h 18288"/>
-              <a:gd name="csX5" fmla="*/ 3255095 w 3255095"/>
-              <a:gd name="csY5" fmla="*/ 0 h 18288"/>
-              <a:gd name="csX6" fmla="*/ 3255095 w 3255095"/>
-              <a:gd name="csY6" fmla="*/ 18288 h 18288"/>
-              <a:gd name="csX7" fmla="*/ 2538974 w 3255095"/>
-              <a:gd name="csY7" fmla="*/ 18288 h 18288"/>
-              <a:gd name="csX8" fmla="*/ 1822853 w 3255095"/>
-              <a:gd name="csY8" fmla="*/ 18288 h 18288"/>
-              <a:gd name="csX9" fmla="*/ 1171834 w 3255095"/>
-              <a:gd name="csY9" fmla="*/ 18288 h 18288"/>
-              <a:gd name="csX10" fmla="*/ 0 w 3255095"/>
-              <a:gd name="csY10" fmla="*/ 18288 h 18288"/>
-              <a:gd name="csX11" fmla="*/ 0 w 3255095"/>
-              <a:gd name="csY11" fmla="*/ 0 h 18288"/>
-            </a:gdLst>
-            <a:ahLst/>
-            <a:cxnLst>
-              <a:cxn ang="0">
-                <a:pos x="csX0" y="csY0"/>
-              </a:cxn>
-              <a:cxn ang="0">
-                <a:pos x="csX1" y="csY1"/>
-              </a:cxn>
-              <a:cxn ang="0">
-                <a:pos x="csX2" y="csY2"/>
-              </a:cxn>
-              <a:cxn ang="0">
-                <a:pos x="csX3" y="csY3"/>
-              </a:cxn>
-              <a:cxn ang="0">
-                <a:pos x="csX4" y="csY4"/>
-              </a:cxn>
-              <a:cxn ang="0">
-                <a:pos x="csX5" y="csY5"/>
-              </a:cxn>
-              <a:cxn ang="0">
-                <a:pos x="csX6" y="csY6"/>
-              </a:cxn>
-              <a:cxn ang="0">
-                <a:pos x="csX7" y="csY7"/>
-              </a:cxn>
-              <a:cxn ang="0">
-                <a:pos x="csX8" y="csY8"/>
-              </a:cxn>
-              <a:cxn ang="0">
-                <a:pos x="csX9" y="csY9"/>
-              </a:cxn>
-              <a:cxn ang="0">
-                <a:pos x="csX10" y="csY10"/>
-              </a:cxn>
-              <a:cxn ang="0">
-                <a:pos x="csX11" y="csY11"/>
-              </a:cxn>
-            </a:cxnLst>
-            <a:rect l="l" t="t" r="r" b="b"/>
-            <a:pathLst>
-              <a:path w="3255095" h="18288" fill="none" extrusionOk="0">
-                <a:moveTo>
-                  <a:pt x="0" y="0"/>
-                </a:moveTo>
-                <a:cubicBezTo>
-                  <a:pt x="240201" y="-22123"/>
-                  <a:pt x="462021" y="-19623"/>
-                  <a:pt x="618468" y="0"/>
-                </a:cubicBezTo>
-                <a:cubicBezTo>
-                  <a:pt x="774915" y="19623"/>
-                  <a:pt x="974734" y="2035"/>
-                  <a:pt x="1269487" y="0"/>
-                </a:cubicBezTo>
-                <a:cubicBezTo>
-                  <a:pt x="1564240" y="-2035"/>
-                  <a:pt x="1733579" y="10639"/>
-                  <a:pt x="1953057" y="0"/>
-                </a:cubicBezTo>
-                <a:cubicBezTo>
-                  <a:pt x="2172535" y="-10639"/>
-                  <a:pt x="2453962" y="14018"/>
-                  <a:pt x="2636627" y="0"/>
-                </a:cubicBezTo>
-                <a:cubicBezTo>
-                  <a:pt x="2819292" y="-14018"/>
-                  <a:pt x="3121375" y="5399"/>
-                  <a:pt x="3255095" y="0"/>
-                </a:cubicBezTo>
-                <a:cubicBezTo>
-                  <a:pt x="3254386" y="8157"/>
-                  <a:pt x="3254682" y="12125"/>
-                  <a:pt x="3255095" y="18288"/>
-                </a:cubicBezTo>
-                <a:cubicBezTo>
-                  <a:pt x="3088545" y="23203"/>
-                  <a:pt x="2687475" y="7419"/>
-                  <a:pt x="2538974" y="18288"/>
-                </a:cubicBezTo>
-                <a:cubicBezTo>
-                  <a:pt x="2390473" y="29157"/>
-                  <a:pt x="2137381" y="-8959"/>
-                  <a:pt x="1822853" y="18288"/>
-                </a:cubicBezTo>
-                <a:cubicBezTo>
-                  <a:pt x="1508325" y="45535"/>
-                  <a:pt x="1466437" y="20385"/>
-                  <a:pt x="1171834" y="18288"/>
-                </a:cubicBezTo>
-                <a:cubicBezTo>
-                  <a:pt x="877231" y="16191"/>
-                  <a:pt x="561097" y="37643"/>
-                  <a:pt x="0" y="18288"/>
-                </a:cubicBezTo>
-                <a:cubicBezTo>
-                  <a:pt x="-46" y="12483"/>
-                  <a:pt x="-203" y="6491"/>
-                  <a:pt x="0" y="0"/>
-                </a:cubicBezTo>
-                <a:close/>
-              </a:path>
-              <a:path w="3255095" h="18288" stroke="0" extrusionOk="0">
-                <a:moveTo>
-                  <a:pt x="0" y="0"/>
-                </a:moveTo>
-                <a:cubicBezTo>
-                  <a:pt x="291965" y="19429"/>
-                  <a:pt x="363155" y="8568"/>
-                  <a:pt x="618468" y="0"/>
-                </a:cubicBezTo>
-                <a:cubicBezTo>
-                  <a:pt x="873781" y="-8568"/>
-                  <a:pt x="904459" y="-19505"/>
-                  <a:pt x="1171834" y="0"/>
-                </a:cubicBezTo>
-                <a:cubicBezTo>
-                  <a:pt x="1439209" y="19505"/>
-                  <a:pt x="1744369" y="9790"/>
-                  <a:pt x="1887955" y="0"/>
-                </a:cubicBezTo>
-                <a:cubicBezTo>
-                  <a:pt x="2031541" y="-9790"/>
-                  <a:pt x="2346378" y="21240"/>
-                  <a:pt x="2506423" y="0"/>
-                </a:cubicBezTo>
-                <a:cubicBezTo>
-                  <a:pt x="2666468" y="-21240"/>
-                  <a:pt x="2990257" y="30414"/>
-                  <a:pt x="3255095" y="0"/>
-                </a:cubicBezTo>
-                <a:cubicBezTo>
-                  <a:pt x="3254831" y="4493"/>
-                  <a:pt x="3255479" y="9472"/>
-                  <a:pt x="3255095" y="18288"/>
-                </a:cubicBezTo>
-                <a:cubicBezTo>
-                  <a:pt x="3120743" y="16690"/>
-                  <a:pt x="2759628" y="42462"/>
-                  <a:pt x="2604076" y="18288"/>
-                </a:cubicBezTo>
-                <a:cubicBezTo>
-                  <a:pt x="2448524" y="-5886"/>
-                  <a:pt x="2184336" y="19599"/>
-                  <a:pt x="1887955" y="18288"/>
-                </a:cubicBezTo>
-                <a:cubicBezTo>
-                  <a:pt x="1591574" y="16977"/>
-                  <a:pt x="1548845" y="6870"/>
-                  <a:pt x="1334589" y="18288"/>
-                </a:cubicBezTo>
-                <a:cubicBezTo>
-                  <a:pt x="1120333" y="29706"/>
-                  <a:pt x="996014" y="9662"/>
-                  <a:pt x="683570" y="18288"/>
-                </a:cubicBezTo>
-                <a:cubicBezTo>
-                  <a:pt x="371126" y="26914"/>
-                  <a:pt x="198687" y="16167"/>
-                  <a:pt x="0" y="18288"/>
-                </a:cubicBezTo>
-                <a:cubicBezTo>
-                  <a:pt x="843" y="9577"/>
-                  <a:pt x="371" y="6900"/>
-                  <a:pt x="0" y="0"/>
-                </a:cubicBezTo>
-                <a:close/>
-              </a:path>
-            </a:pathLst>
-          </a:custGeom>
-          <a:solidFill>
-            <a:schemeClr val="accent2"/>
-          </a:solidFill>
-          <a:ln w="38100" cap="rnd">
-            <a:solidFill>
-              <a:schemeClr val="accent2"/>
-            </a:solidFill>
-            <a:round/>
-            <a:extLst>
-              <a:ext uri="{C807C97D-BFC1-408E-A445-0C87EB9F89A2}">
-                <ask:lineSketchStyleProps xmlns:ask="http://schemas.microsoft.com/office/drawing/2018/sketchyshapes" sd="1219033472">
-                  <a:prstGeom prst="rect">
-                    <a:avLst/>
-                  </a:prstGeom>
-                  <ask:type>
-                    <ask:lineSketchFreehand/>
-                  </ask:type>
-                </ask:lineSketchStyleProps>
-              </a:ext>
-            </a:extLst>
-          </a:ln>
-        </p:spPr>
-        <p:style>
-          <a:lnRef idx="2">
-            <a:schemeClr val="accent1">
-              <a:shade val="50000"/>
-            </a:schemeClr>
-          </a:lnRef>
-          <a:fillRef idx="1">
-            <a:schemeClr val="accent1"/>
-          </a:fillRef>
-          <a:effectRef idx="0">
-            <a:schemeClr val="accent1"/>
-          </a:effectRef>
-          <a:fontRef idx="minor">
-            <a:schemeClr val="lt1"/>
-          </a:fontRef>
-        </p:style>
-        <p:txBody>
-          <a:bodyPr rtlCol="0" anchor="ctr"/>
-          <a:lstStyle/>
-          <a:p>
-            <a:pPr algn="ctr"/>
-            <a:endParaRPr lang="cs-CZ" noProof="0" dirty="0"/>
-          </a:p>
-        </p:txBody>
-      </p:sp>
-      <p:pic>
-        <p:nvPicPr>
-          <p:cNvPr id="16" name="Graphic 15">
-            <a:extLst>
-              <a:ext uri="{FF2B5EF4-FFF2-40B4-BE49-F238E27FC236}">
-                <a16:creationId xmlns:a16="http://schemas.microsoft.com/office/drawing/2014/main" id="{D05A3046-89B3-C287-04D7-C746C3920836}"/>
-              </a:ext>
-            </a:extLst>
-          </p:cNvPr>
-          <p:cNvPicPr>
-            <a:picLocks noChangeAspect="1"/>
-          </p:cNvPicPr>
-          <p:nvPr/>
-        </p:nvPicPr>
-        <p:blipFill>
-          <a:blip>
-            <a:extLst>
-              <a:ext uri="{96DAC541-7B7A-43D3-8B79-37D633B846F1}">
-                <asvg:svgBlip xmlns:asvg="http://schemas.microsoft.com/office/drawing/2016/SVG/main" r:embed="rId3"/>
-              </a:ext>
-            </a:extLst>
-          </a:blip>
-          <a:srcRect/>
-          <a:stretch/>
-        </p:blipFill>
-        <p:spPr>
-          <a:xfrm>
-            <a:off x="5201392" y="1043156"/>
-            <a:ext cx="6362250" cy="4771688"/>
-          </a:xfrm>
-          <a:prstGeom prst="rect">
-            <a:avLst/>
-          </a:prstGeom>
-        </p:spPr>
-      </p:pic>
-      <p:sp>
-        <p:nvSpPr>
-          <p:cNvPr id="13" name="Content Placeholder 12">
-            <a:extLst>
-              <a:ext uri="{FF2B5EF4-FFF2-40B4-BE49-F238E27FC236}">
-                <a16:creationId xmlns:a16="http://schemas.microsoft.com/office/drawing/2014/main" id="{7A44BED2-120E-0B7F-D74E-A629CFE6635F}"/>
-              </a:ext>
-            </a:extLst>
-          </p:cNvPr>
-          <p:cNvSpPr>
-            <a:spLocks noGrp="1"/>
-          </p:cNvSpPr>
-          <p:nvPr>
-            <p:ph sz="half" idx="1"/>
-          </p:nvPr>
-        </p:nvSpPr>
-        <p:spPr>
-          <a:xfrm>
-            <a:off x="630936" y="2807208"/>
-            <a:ext cx="4570456" cy="3410712"/>
-          </a:xfrm>
-        </p:spPr>
-        <p:txBody>
-          <a:bodyPr vert="horz" lIns="91440" tIns="45720" rIns="91440" bIns="45720" rtlCol="0" anchor="t">
-            <a:normAutofit/>
-          </a:bodyPr>
-          <a:lstStyle/>
-          <a:p>
-            <a:r>
-              <a:rPr lang="cs-CZ" sz="2200" dirty="0"/>
-              <a:t>Přenositelné knihovny</a:t>
-            </a:r>
-          </a:p>
-          <a:p>
-            <a:pPr lvl="1"/>
-            <a:r>
-              <a:rPr lang="cs-CZ" sz="2000" dirty="0" err="1"/>
-              <a:t>Traity</a:t>
-            </a:r>
-            <a:r>
-              <a:rPr lang="cs-CZ" sz="2000" dirty="0"/>
-              <a:t> poskytují jednotné rozhraní pro různé </a:t>
-            </a:r>
-            <a:r>
-              <a:rPr lang="cs-CZ" sz="2000" dirty="0" err="1"/>
-              <a:t>backendy</a:t>
-            </a:r>
-            <a:endParaRPr lang="cs-CZ" sz="2000" dirty="0"/>
-          </a:p>
-          <a:p>
-            <a:pPr lvl="1"/>
-            <a:r>
-              <a:rPr lang="cs-CZ" sz="2000" dirty="0"/>
-              <a:t>Knihovny pak mohou být psány oproti těmto rozhraním namísto konkrétních implementací</a:t>
-            </a:r>
-            <a:endParaRPr lang="cs-CZ" sz="2200" dirty="0"/>
-          </a:p>
-          <a:p>
-            <a:r>
-              <a:rPr lang="cs-CZ" sz="2200" dirty="0"/>
-              <a:t>Příklad: </a:t>
-            </a:r>
-            <a:r>
-              <a:rPr lang="cs-CZ" sz="2200" dirty="0" err="1">
-                <a:highlight>
-                  <a:srgbClr val="C0C0C0"/>
-                </a:highlight>
-              </a:rPr>
-              <a:t>embedded</a:t>
-            </a:r>
-            <a:r>
-              <a:rPr lang="cs-CZ" sz="2200" dirty="0">
-                <a:highlight>
-                  <a:srgbClr val="C0C0C0"/>
-                </a:highlight>
-              </a:rPr>
-              <a:t>-hal</a:t>
-            </a:r>
-            <a:r>
-              <a:rPr lang="cs-CZ" sz="2200" dirty="0"/>
-              <a:t> (různé mikrořadiče, jedno rozhraní)</a:t>
-            </a:r>
-          </a:p>
-        </p:txBody>
-      </p:sp>
-    </p:spTree>
-    <p:extLst>
-      <p:ext uri="{BB962C8B-B14F-4D97-AF65-F5344CB8AC3E}">
-        <p14:creationId xmlns:p14="http://schemas.microsoft.com/office/powerpoint/2010/main" val="3835894341"/>
-      </p:ext>
-    </p:extLst>
-  </p:cSld>
-  <p:clrMapOvr>
-    <a:masterClrMapping/>
-  </p:clrMapOvr>
-</p:sld>
-</file>
-
-<file path=ppt/slides/slide9.xml><?xml version="1.0" encoding="utf-8"?>
-<p:sld xmlns:a="http://schemas.openxmlformats.org/drawingml/2006/main" xmlns:r="http://schemas.openxmlformats.org/officeDocument/2006/relationships" xmlns:p="http://schemas.openxmlformats.org/presentationml/2006/main">
-  <p:cSld>
-    <p:spTree>
-      <p:nvGrpSpPr>
-        <p:cNvPr id="1" name=""/>
-        <p:cNvGrpSpPr/>
-        <p:nvPr/>
-      </p:nvGrpSpPr>
-      <p:grpSpPr>
-        <a:xfrm>
-          <a:off x="0" y="0"/>
-          <a:ext cx="0" cy="0"/>
-          <a:chOff x="0" y="0"/>
-          <a:chExt cx="0" cy="0"/>
-        </a:xfrm>
-      </p:grpSpPr>
-      <p:sp>
-        <p:nvSpPr>
-          <p:cNvPr id="5" name="Title 4">
-            <a:extLst>
-              <a:ext uri="{FF2B5EF4-FFF2-40B4-BE49-F238E27FC236}">
-                <a16:creationId xmlns:a16="http://schemas.microsoft.com/office/drawing/2014/main" id="{1F9CC341-C25B-F877-D447-AF84B4A23EEB}"/>
-              </a:ext>
-            </a:extLst>
-          </p:cNvPr>
-          <p:cNvSpPr>
-            <a:spLocks noGrp="1"/>
-          </p:cNvSpPr>
-          <p:nvPr>
-            <p:ph type="title"/>
-          </p:nvPr>
-        </p:nvSpPr>
-        <p:spPr/>
-        <p:txBody>
-          <a:bodyPr/>
-          <a:lstStyle/>
-          <a:p>
-            <a:r>
-              <a:rPr lang="cs-CZ" dirty="0"/>
-              <a:t>Architektura programu</a:t>
-            </a:r>
-          </a:p>
-        </p:txBody>
-      </p:sp>
-      <p:sp>
-        <p:nvSpPr>
-          <p:cNvPr id="6" name="Content Placeholder 5">
-            <a:extLst>
-              <a:ext uri="{FF2B5EF4-FFF2-40B4-BE49-F238E27FC236}">
-                <a16:creationId xmlns:a16="http://schemas.microsoft.com/office/drawing/2014/main" id="{9D2AB956-920E-CF3C-3578-10FABD0ACECA}"/>
-              </a:ext>
-            </a:extLst>
-          </p:cNvPr>
-          <p:cNvSpPr>
-            <a:spLocks noGrp="1"/>
-          </p:cNvSpPr>
-          <p:nvPr>
-            <p:ph idx="1"/>
-          </p:nvPr>
-        </p:nvSpPr>
-        <p:spPr/>
-        <p:txBody>
-          <a:bodyPr/>
-          <a:lstStyle/>
-          <a:p>
-            <a:r>
-              <a:rPr lang="cs-CZ" dirty="0"/>
-              <a:t>Setup, event </a:t>
-            </a:r>
-            <a:r>
-              <a:rPr lang="cs-CZ" dirty="0" err="1"/>
-              <a:t>loop</a:t>
-            </a:r>
-            <a:endParaRPr lang="cs-CZ" dirty="0"/>
-          </a:p>
-          <a:p>
-            <a:r>
-              <a:rPr lang="cs-CZ" dirty="0" err="1"/>
-              <a:t>modules</a:t>
-            </a:r>
-            <a:endParaRPr lang="cs-CZ" dirty="0"/>
-          </a:p>
-        </p:txBody>
-      </p:sp>
-    </p:spTree>
-    <p:extLst>
-      <p:ext uri="{BB962C8B-B14F-4D97-AF65-F5344CB8AC3E}">
-        <p14:creationId xmlns:p14="http://schemas.microsoft.com/office/powerpoint/2010/main" val="2334217468"/>
       </p:ext>
     </p:extLst>
   </p:cSld>

</xml_diff>

<commit_message>
Fixed uninitialised variable section in Word; did notes for a PPTX section on ownership
</commit_message>
<xml_diff>
--- a/Prezentace.pptx
+++ b/Prezentace.pptx
@@ -5,7 +5,7 @@
     <p:sldMasterId id="2147483648" r:id="rId1"/>
   </p:sldMasterIdLst>
   <p:notesMasterIdLst>
-    <p:notesMasterId r:id="rId17"/>
+    <p:notesMasterId r:id="rId18"/>
   </p:notesMasterIdLst>
   <p:sldIdLst>
     <p:sldId id="256" r:id="rId2"/>
@@ -18,11 +18,12 @@
     <p:sldId id="270" r:id="rId9"/>
     <p:sldId id="262" r:id="rId10"/>
     <p:sldId id="264" r:id="rId11"/>
-    <p:sldId id="265" r:id="rId12"/>
-    <p:sldId id="266" r:id="rId13"/>
-    <p:sldId id="267" r:id="rId14"/>
-    <p:sldId id="268" r:id="rId15"/>
-    <p:sldId id="269" r:id="rId16"/>
+    <p:sldId id="272" r:id="rId12"/>
+    <p:sldId id="265" r:id="rId13"/>
+    <p:sldId id="266" r:id="rId14"/>
+    <p:sldId id="267" r:id="rId15"/>
+    <p:sldId id="268" r:id="rId16"/>
+    <p:sldId id="269" r:id="rId17"/>
   </p:sldIdLst>
   <p:sldSz cx="12192000" cy="6858000"/>
   <p:notesSz cx="6858000" cy="9144000"/>
@@ -1666,7 +1667,337 @@
               <a:buFont typeface="Arial" panose="020B0604020202020204" pitchFamily="34" charset="0"/>
               <a:buChar char="•"/>
             </a:pPr>
+            <a:r>
+              <a:rPr lang="cs-CZ" dirty="0"/>
+              <a:t>Vlastníkem může být proměnná deklarovaná v určitém bloku kódu, nebo nějaký objekt (struktura nebo </a:t>
+            </a:r>
+            <a:r>
+              <a:rPr lang="cs-CZ" dirty="0" err="1"/>
+              <a:t>enum</a:t>
+            </a:r>
+            <a:r>
+              <a:rPr lang="cs-CZ" dirty="0"/>
+              <a:t>)</a:t>
+            </a:r>
+          </a:p>
+          <a:p>
+            <a:pPr marL="171450" indent="-171450">
+              <a:buFont typeface="Arial" panose="020B0604020202020204" pitchFamily="34" charset="0"/>
+              <a:buChar char="•"/>
+            </a:pPr>
+            <a:r>
+              <a:rPr lang="cs-CZ" dirty="0"/>
+              <a:t>K proměnné dokáže přistupovat pouze její vlastník (nebo blok kódu uvnitř vlastníka)</a:t>
+            </a:r>
+          </a:p>
+          <a:p>
+            <a:pPr marL="171450" indent="-171450">
+              <a:buFont typeface="Arial" panose="020B0604020202020204" pitchFamily="34" charset="0"/>
+              <a:buChar char="•"/>
+            </a:pPr>
+            <a:r>
+              <a:rPr lang="cs-CZ" dirty="0"/>
+              <a:t>Ve výchozím stavu, pokud přiřadíme proměnnou do jiné proměnné, nebo ji předáme jako parametr nějaké funkci,</a:t>
+            </a:r>
+            <a:br>
+              <a:rPr lang="cs-CZ" dirty="0"/>
+            </a:br>
+            <a:r>
+              <a:rPr lang="cs-CZ" dirty="0"/>
+              <a:t>předáme vlastnictví této nové proměnné nebo bloku kódu tvořící kód funkce, tzv. ji přesuneme</a:t>
+            </a:r>
+          </a:p>
+          <a:p>
+            <a:pPr marL="171450" indent="-171450">
+              <a:buFont typeface="Arial" panose="020B0604020202020204" pitchFamily="34" charset="0"/>
+              <a:buChar char="•"/>
+            </a:pPr>
+            <a:r>
+              <a:rPr lang="cs-CZ" dirty="0"/>
+              <a:t>    Až na později popsanou výjimku, </a:t>
+            </a:r>
+            <a:r>
+              <a:rPr lang="cs-CZ" dirty="0" err="1"/>
+              <a:t>trait</a:t>
+            </a:r>
+            <a:r>
+              <a:rPr lang="cs-CZ" dirty="0"/>
+              <a:t> Copy</a:t>
+            </a:r>
+          </a:p>
+          <a:p>
+            <a:pPr marL="0" indent="0">
+              <a:buFont typeface="Arial" panose="020B0604020202020204" pitchFamily="34" charset="0"/>
+              <a:buNone/>
+            </a:pPr>
             <a:endParaRPr lang="cs-CZ" dirty="0"/>
+          </a:p>
+          <a:p>
+            <a:pPr marL="0" indent="0">
+              <a:buFont typeface="Arial" panose="020B0604020202020204" pitchFamily="34" charset="0"/>
+              <a:buNone/>
+            </a:pPr>
+            <a:r>
+              <a:rPr lang="cs-CZ" dirty="0"/>
+              <a:t>Ve výchozím stavu jsou všechny proměnné a reference neměnné, je třeba je explicitně označit jako měnitelné klíčovým slovem </a:t>
+            </a:r>
+            <a:r>
+              <a:rPr lang="cs-CZ" dirty="0" err="1"/>
+              <a:t>mut</a:t>
+            </a:r>
+            <a:endParaRPr lang="cs-CZ" dirty="0"/>
+          </a:p>
+          <a:p>
+            <a:pPr marL="171450" indent="-171450">
+              <a:buFont typeface="Arial" panose="020B0604020202020204" pitchFamily="34" charset="0"/>
+              <a:buChar char="•"/>
+            </a:pPr>
+            <a:r>
+              <a:rPr lang="cs-CZ" dirty="0"/>
+              <a:t>V jiných jazycích jako C a C++ naopak jsou všechny proměnné měnitelné, pokud nejsou označeny jinak, což m.j. ztěžuje optimalizace kompilátoru</a:t>
+            </a:r>
+          </a:p>
+          <a:p>
+            <a:pPr marL="0" indent="0">
+              <a:buFont typeface="Arial" panose="020B0604020202020204" pitchFamily="34" charset="0"/>
+              <a:buNone/>
+            </a:pPr>
+            <a:endParaRPr lang="cs-CZ" dirty="0"/>
+          </a:p>
+          <a:p>
+            <a:pPr marL="0" indent="0">
+              <a:buFont typeface="Arial" panose="020B0604020202020204" pitchFamily="34" charset="0"/>
+              <a:buNone/>
+            </a:pPr>
+            <a:r>
+              <a:rPr lang="cs-CZ" dirty="0"/>
+              <a:t>Reference jsou ukazatele na proměnné – hodnoty ukládající adresu v paměti, kde se ukazovaná proměnná nachází</a:t>
+            </a:r>
+          </a:p>
+          <a:p>
+            <a:pPr marL="171450" indent="-171450">
+              <a:buFont typeface="Arial" panose="020B0604020202020204" pitchFamily="34" charset="0"/>
+              <a:buChar char="•"/>
+            </a:pPr>
+            <a:r>
+              <a:rPr lang="cs-CZ" dirty="0"/>
+              <a:t>V paradigmatu vlastnictví reference „propůjčují“ vlastnictví, povolují vlastníkovi proměnné dočasně přistupovat k proměnné,</a:t>
+            </a:r>
+            <a:br>
+              <a:rPr lang="cs-CZ" dirty="0"/>
+            </a:br>
+            <a:r>
+              <a:rPr lang="cs-CZ" dirty="0"/>
+              <a:t>ale vlastnictví zůstává stejné</a:t>
+            </a:r>
+          </a:p>
+          <a:p>
+            <a:pPr marL="171450" indent="-171450">
+              <a:buFont typeface="Arial" panose="020B0604020202020204" pitchFamily="34" charset="0"/>
+              <a:buChar char="•"/>
+            </a:pPr>
+            <a:r>
+              <a:rPr lang="cs-CZ" dirty="0"/>
+              <a:t>    </a:t>
+            </a:r>
+            <a:r>
+              <a:rPr lang="cs-CZ" dirty="0" err="1"/>
+              <a:t>Nejčatěji</a:t>
+            </a:r>
+            <a:r>
+              <a:rPr lang="cs-CZ" dirty="0"/>
+              <a:t> jsou propůjčovány funkcím, protože když předáme hodnotu funkci, která ji nám nevrátí, proměnná zanikne,</a:t>
+            </a:r>
+            <a:br>
+              <a:rPr lang="cs-CZ" dirty="0"/>
+            </a:br>
+            <a:r>
+              <a:rPr lang="cs-CZ" dirty="0"/>
+              <a:t>    takže pokud předáme funkci jen referenci, tak s hodnotou může funkce pracovat, aniž by proměnná zanikla</a:t>
+            </a:r>
+          </a:p>
+          <a:p>
+            <a:pPr marL="171450" indent="-171450">
+              <a:buFont typeface="Arial" panose="020B0604020202020204" pitchFamily="34" charset="0"/>
+              <a:buChar char="•"/>
+            </a:pPr>
+            <a:r>
+              <a:rPr lang="cs-CZ" dirty="0"/>
+              <a:t>Rovněž se dělí na měnitelné, které mohou měnit hodnotu ukazované proměnné, a neměnné, které mohou pouze číst hodnotu</a:t>
+            </a:r>
+          </a:p>
+          <a:p>
+            <a:pPr marL="0" indent="0">
+              <a:buFont typeface="Arial" panose="020B0604020202020204" pitchFamily="34" charset="0"/>
+              <a:buNone/>
+            </a:pPr>
+            <a:r>
+              <a:rPr lang="cs-CZ" dirty="0" err="1"/>
+              <a:t>Borrow</a:t>
+            </a:r>
+            <a:r>
+              <a:rPr lang="cs-CZ" dirty="0"/>
+              <a:t> checker zajišťuje, že reference vždy ukazují na platné místo v paměti, zejm. že:</a:t>
+            </a:r>
+          </a:p>
+          <a:p>
+            <a:pPr marL="171450" indent="-171450">
+              <a:buFont typeface="Arial" panose="020B0604020202020204" pitchFamily="34" charset="0"/>
+              <a:buChar char="•"/>
+            </a:pPr>
+            <a:r>
+              <a:rPr lang="cs-CZ" dirty="0"/>
+              <a:t>Reference není tzv. nulovým ukazatelem, tedy že neukazuje doslova nikam, na žádnou hodnotu (reprezentováno adresou nula – 0)</a:t>
+            </a:r>
+          </a:p>
+          <a:p>
+            <a:pPr marL="171450" indent="-171450">
+              <a:buFont typeface="Arial" panose="020B0604020202020204" pitchFamily="34" charset="0"/>
+              <a:buChar char="•"/>
+            </a:pPr>
+            <a:r>
+              <a:rPr lang="cs-CZ" dirty="0"/>
+              <a:t>Ukazovaná proměnná nezanikne po celou životnost reference, což </a:t>
+            </a:r>
+            <a:r>
+              <a:rPr lang="cs-CZ" dirty="0" err="1"/>
+              <a:t>borrow</a:t>
+            </a:r>
+            <a:r>
+              <a:rPr lang="cs-CZ" dirty="0"/>
+              <a:t> checker vynucuje pomocí sledování životností proměnných</a:t>
+            </a:r>
+          </a:p>
+          <a:p>
+            <a:pPr marL="0" indent="0">
+              <a:buFont typeface="Arial" panose="020B0604020202020204" pitchFamily="34" charset="0"/>
+              <a:buNone/>
+            </a:pPr>
+            <a:r>
+              <a:rPr lang="cs-CZ" dirty="0"/>
+              <a:t>V zájmu zabránění souběhu (konfliktnímu přístupu k proměnné) smí existovat naráz (z pohledu životností) buď nejvýše jedna měnitelná reference, nebo nekonečno neměnných</a:t>
+            </a:r>
+          </a:p>
+          <a:p>
+            <a:pPr marL="0" indent="0">
+              <a:buFont typeface="Arial" panose="020B0604020202020204" pitchFamily="34" charset="0"/>
+              <a:buNone/>
+            </a:pPr>
+            <a:endParaRPr lang="cs-CZ" dirty="0"/>
+          </a:p>
+          <a:p>
+            <a:pPr marL="0" indent="0">
+              <a:buFont typeface="Arial" panose="020B0604020202020204" pitchFamily="34" charset="0"/>
+              <a:buNone/>
+            </a:pPr>
+            <a:r>
+              <a:rPr lang="cs-CZ" dirty="0"/>
+              <a:t>Po skončení životnosti proměnné zavolá kompilátor automaticky její implementaci </a:t>
+            </a:r>
+            <a:r>
+              <a:rPr lang="cs-CZ" dirty="0" err="1"/>
+              <a:t>traitu</a:t>
+            </a:r>
+            <a:r>
+              <a:rPr lang="cs-CZ" dirty="0"/>
+              <a:t> Drop, pokud existuje,</a:t>
+            </a:r>
+            <a:br>
+              <a:rPr lang="cs-CZ" dirty="0"/>
+            </a:br>
+            <a:r>
+              <a:rPr lang="cs-CZ" dirty="0"/>
+              <a:t>která „po sobě uklidí“, například uvolní alokovanou paměť.</a:t>
+            </a:r>
+          </a:p>
+          <a:p>
+            <a:pPr marL="171450" indent="-171450">
+              <a:buFont typeface="Arial" panose="020B0604020202020204" pitchFamily="34" charset="0"/>
+              <a:buChar char="•"/>
+            </a:pPr>
+            <a:r>
+              <a:rPr lang="cs-CZ" dirty="0"/>
+              <a:t>Struktury a </a:t>
+            </a:r>
+            <a:r>
+              <a:rPr lang="cs-CZ" dirty="0" err="1"/>
+              <a:t>enumy</a:t>
+            </a:r>
+            <a:r>
+              <a:rPr lang="cs-CZ" dirty="0"/>
+              <a:t> nejdříve zavolají Drop samy na sobě, a pak na hodnotách v </a:t>
+            </a:r>
+            <a:r>
+              <a:rPr lang="cs-CZ"/>
+              <a:t>nich uložených</a:t>
+            </a:r>
+          </a:p>
+          <a:p>
+            <a:pPr marL="0" indent="0">
+              <a:buFont typeface="Arial" panose="020B0604020202020204" pitchFamily="34" charset="0"/>
+              <a:buNone/>
+            </a:pPr>
+            <a:endParaRPr lang="cs-CZ" dirty="0"/>
+          </a:p>
+          <a:p>
+            <a:pPr marL="0" indent="0">
+              <a:buFont typeface="Arial" panose="020B0604020202020204" pitchFamily="34" charset="0"/>
+              <a:buNone/>
+            </a:pPr>
+            <a:r>
+              <a:rPr lang="cs-CZ" dirty="0"/>
+              <a:t>Pokud </a:t>
+            </a:r>
+            <a:r>
+              <a:rPr lang="cs-CZ" dirty="0" err="1"/>
+              <a:t>borrow</a:t>
+            </a:r>
+            <a:r>
+              <a:rPr lang="cs-CZ" dirty="0"/>
+              <a:t> checker není schopen zajistit, že jeho pravidla budou naplněna, je možné použít ještě tzv. surové ukazatele,</a:t>
+            </a:r>
+          </a:p>
+          <a:p>
+            <a:pPr marL="0" indent="0">
+              <a:buFont typeface="Arial" panose="020B0604020202020204" pitchFamily="34" charset="0"/>
+              <a:buNone/>
+            </a:pPr>
+            <a:r>
+              <a:rPr lang="cs-CZ" dirty="0"/>
+              <a:t>které samy o sobě neposkytují žádné garance a u kterých je za dodržování pravidel zodpovědný programátor.</a:t>
+            </a:r>
+          </a:p>
+          <a:p>
+            <a:pPr marL="171450" indent="-171450">
+              <a:buFont typeface="Arial" panose="020B0604020202020204" pitchFamily="34" charset="0"/>
+              <a:buChar char="•"/>
+            </a:pPr>
+            <a:r>
+              <a:rPr lang="cs-CZ" dirty="0"/>
+              <a:t>Ztráta těchto garancí je však nebezpečná, protože nelze 100% prokázat, tudíž je možné přistupovat k hodnotám na adresách,</a:t>
+            </a:r>
+            <a:br>
+              <a:rPr lang="cs-CZ" dirty="0"/>
+            </a:br>
+            <a:r>
+              <a:rPr lang="cs-CZ" dirty="0"/>
+              <a:t>na které surové ukazatele ukazují, pouze v speciálně označených blocích </a:t>
+            </a:r>
+            <a:r>
+              <a:rPr lang="cs-CZ" dirty="0" err="1"/>
+              <a:t>unsafe</a:t>
+            </a:r>
+            <a:r>
+              <a:rPr lang="cs-CZ" dirty="0"/>
+              <a:t>, které tak omezují možný rozsah,</a:t>
+            </a:r>
+            <a:br>
+              <a:rPr lang="cs-CZ" dirty="0"/>
+            </a:br>
+            <a:r>
+              <a:rPr lang="cs-CZ" dirty="0"/>
+              <a:t>kde by se mohly dít nebezpečné operace, na nutné minimum.</a:t>
+            </a:r>
           </a:p>
         </p:txBody>
       </p:sp>
@@ -6215,7 +6546,7 @@
           <p:cNvPr id="5" name="Title 4">
             <a:extLst>
               <a:ext uri="{FF2B5EF4-FFF2-40B4-BE49-F238E27FC236}">
-                <a16:creationId xmlns:a16="http://schemas.microsoft.com/office/drawing/2014/main" id="{1F9CC341-C25B-F877-D447-AF84B4A23EEB}"/>
+                <a16:creationId xmlns:a16="http://schemas.microsoft.com/office/drawing/2014/main" id="{907E7AA4-EFEC-4617-E1DF-3E0BA4706DF9}"/>
               </a:ext>
             </a:extLst>
           </p:cNvPr>
@@ -6232,8 +6563,12 @@
           <a:lstStyle/>
           <a:p>
             <a:r>
-              <a:rPr lang="cs-CZ" dirty="0"/>
-              <a:t>Architektura programu</a:t>
+              <a:rPr lang="cs-CZ" dirty="0" err="1"/>
+              <a:t>Traity</a:t>
+            </a:r>
+            <a:r>
+              <a:rPr lang="cs-CZ" dirty="0"/>
+              <a:t> 3</a:t>
             </a:r>
           </a:p>
         </p:txBody>
@@ -6243,7 +6578,7 @@
           <p:cNvPr id="6" name="Content Placeholder 5">
             <a:extLst>
               <a:ext uri="{FF2B5EF4-FFF2-40B4-BE49-F238E27FC236}">
-                <a16:creationId xmlns:a16="http://schemas.microsoft.com/office/drawing/2014/main" id="{9D2AB956-920E-CF3C-3578-10FABD0ACECA}"/>
+                <a16:creationId xmlns:a16="http://schemas.microsoft.com/office/drawing/2014/main" id="{25717209-8749-396C-9CE4-92D63F73388D}"/>
               </a:ext>
             </a:extLst>
           </p:cNvPr>
@@ -6259,29 +6594,14 @@
           <a:bodyPr/>
           <a:lstStyle/>
           <a:p>
-            <a:r>
-              <a:rPr lang="cs-CZ" dirty="0"/>
-              <a:t>Setup, event </a:t>
-            </a:r>
-            <a:r>
-              <a:rPr lang="cs-CZ" dirty="0" err="1"/>
-              <a:t>loop</a:t>
-            </a:r>
-            <a:endParaRPr lang="cs-CZ" dirty="0"/>
-          </a:p>
-          <a:p>
-            <a:r>
-              <a:rPr lang="cs-CZ" dirty="0" err="1"/>
-              <a:t>modules</a:t>
-            </a:r>
-            <a:endParaRPr lang="cs-CZ" dirty="0"/>
+            <a:endParaRPr lang="cs-CZ"/>
           </a:p>
         </p:txBody>
       </p:sp>
     </p:spTree>
     <p:extLst>
       <p:ext uri="{BB962C8B-B14F-4D97-AF65-F5344CB8AC3E}">
-        <p14:creationId xmlns:p14="http://schemas.microsoft.com/office/powerpoint/2010/main" val="2334217468"/>
+        <p14:creationId xmlns:p14="http://schemas.microsoft.com/office/powerpoint/2010/main" val="594048469"/>
       </p:ext>
     </p:extLst>
   </p:cSld>
@@ -6310,10 +6630,10 @@
       </p:grpSpPr>
       <p:sp>
         <p:nvSpPr>
-          <p:cNvPr id="2" name="Title 1">
-            <a:extLst>
-              <a:ext uri="{FF2B5EF4-FFF2-40B4-BE49-F238E27FC236}">
-                <a16:creationId xmlns:a16="http://schemas.microsoft.com/office/drawing/2014/main" id="{D7393CDE-8F32-A485-10B4-FA031EFC1144}"/>
+          <p:cNvPr id="5" name="Title 4">
+            <a:extLst>
+              <a:ext uri="{FF2B5EF4-FFF2-40B4-BE49-F238E27FC236}">
+                <a16:creationId xmlns:a16="http://schemas.microsoft.com/office/drawing/2014/main" id="{1F9CC341-C25B-F877-D447-AF84B4A23EEB}"/>
               </a:ext>
             </a:extLst>
           </p:cNvPr>
@@ -6331,17 +6651,17 @@
           <a:p>
             <a:r>
               <a:rPr lang="cs-CZ" dirty="0"/>
-              <a:t>Desetinná čísla</a:t>
-            </a:r>
-          </a:p>
-        </p:txBody>
-      </p:sp>
-      <p:sp>
-        <p:nvSpPr>
-          <p:cNvPr id="3" name="Content Placeholder 2">
-            <a:extLst>
-              <a:ext uri="{FF2B5EF4-FFF2-40B4-BE49-F238E27FC236}">
-                <a16:creationId xmlns:a16="http://schemas.microsoft.com/office/drawing/2014/main" id="{2615C0BB-C97C-4C65-9E4F-8751068C46AC}"/>
+              <a:t>Architektura programu</a:t>
+            </a:r>
+          </a:p>
+        </p:txBody>
+      </p:sp>
+      <p:sp>
+        <p:nvSpPr>
+          <p:cNvPr id="6" name="Content Placeholder 5">
+            <a:extLst>
+              <a:ext uri="{FF2B5EF4-FFF2-40B4-BE49-F238E27FC236}">
+                <a16:creationId xmlns:a16="http://schemas.microsoft.com/office/drawing/2014/main" id="{9D2AB956-920E-CF3C-3578-10FABD0ACECA}"/>
               </a:ext>
             </a:extLst>
           </p:cNvPr>
@@ -6357,14 +6677,29 @@
           <a:bodyPr/>
           <a:lstStyle/>
           <a:p>
-            <a:endParaRPr lang="cs-CZ"/>
+            <a:r>
+              <a:rPr lang="cs-CZ" dirty="0"/>
+              <a:t>Setup, event </a:t>
+            </a:r>
+            <a:r>
+              <a:rPr lang="cs-CZ" dirty="0" err="1"/>
+              <a:t>loop</a:t>
+            </a:r>
+            <a:endParaRPr lang="cs-CZ" dirty="0"/>
+          </a:p>
+          <a:p>
+            <a:r>
+              <a:rPr lang="cs-CZ" dirty="0" err="1"/>
+              <a:t>modules</a:t>
+            </a:r>
+            <a:endParaRPr lang="cs-CZ" dirty="0"/>
           </a:p>
         </p:txBody>
       </p:sp>
     </p:spTree>
     <p:extLst>
       <p:ext uri="{BB962C8B-B14F-4D97-AF65-F5344CB8AC3E}">
-        <p14:creationId xmlns:p14="http://schemas.microsoft.com/office/powerpoint/2010/main" val="2721032930"/>
+        <p14:creationId xmlns:p14="http://schemas.microsoft.com/office/powerpoint/2010/main" val="2334217468"/>
       </p:ext>
     </p:extLst>
   </p:cSld>
@@ -6396,7 +6731,7 @@
           <p:cNvPr id="2" name="Title 1">
             <a:extLst>
               <a:ext uri="{FF2B5EF4-FFF2-40B4-BE49-F238E27FC236}">
-                <a16:creationId xmlns:a16="http://schemas.microsoft.com/office/drawing/2014/main" id="{8075CEB5-567A-56FC-A79D-8EBBE314CA35}"/>
+                <a16:creationId xmlns:a16="http://schemas.microsoft.com/office/drawing/2014/main" id="{D7393CDE-8F32-A485-10B4-FA031EFC1144}"/>
               </a:ext>
             </a:extLst>
           </p:cNvPr>
@@ -6414,7 +6749,7 @@
           <a:p>
             <a:r>
               <a:rPr lang="cs-CZ" dirty="0"/>
-              <a:t>Ovládání</a:t>
+              <a:t>Desetinná čísla</a:t>
             </a:r>
           </a:p>
         </p:txBody>
@@ -6424,7 +6759,7 @@
           <p:cNvPr id="3" name="Content Placeholder 2">
             <a:extLst>
               <a:ext uri="{FF2B5EF4-FFF2-40B4-BE49-F238E27FC236}">
-                <a16:creationId xmlns:a16="http://schemas.microsoft.com/office/drawing/2014/main" id="{B72313B4-1167-5BFE-4914-AF8C4B665E04}"/>
+                <a16:creationId xmlns:a16="http://schemas.microsoft.com/office/drawing/2014/main" id="{2615C0BB-C97C-4C65-9E4F-8751068C46AC}"/>
               </a:ext>
             </a:extLst>
           </p:cNvPr>
@@ -6447,7 +6782,7 @@
     </p:spTree>
     <p:extLst>
       <p:ext uri="{BB962C8B-B14F-4D97-AF65-F5344CB8AC3E}">
-        <p14:creationId xmlns:p14="http://schemas.microsoft.com/office/powerpoint/2010/main" val="3593242919"/>
+        <p14:creationId xmlns:p14="http://schemas.microsoft.com/office/powerpoint/2010/main" val="2721032930"/>
       </p:ext>
     </p:extLst>
   </p:cSld>
@@ -6479,6 +6814,89 @@
           <p:cNvPr id="2" name="Title 1">
             <a:extLst>
               <a:ext uri="{FF2B5EF4-FFF2-40B4-BE49-F238E27FC236}">
+                <a16:creationId xmlns:a16="http://schemas.microsoft.com/office/drawing/2014/main" id="{8075CEB5-567A-56FC-A79D-8EBBE314CA35}"/>
+              </a:ext>
+            </a:extLst>
+          </p:cNvPr>
+          <p:cNvSpPr>
+            <a:spLocks noGrp="1"/>
+          </p:cNvSpPr>
+          <p:nvPr>
+            <p:ph type="title"/>
+          </p:nvPr>
+        </p:nvSpPr>
+        <p:spPr/>
+        <p:txBody>
+          <a:bodyPr/>
+          <a:lstStyle/>
+          <a:p>
+            <a:r>
+              <a:rPr lang="cs-CZ" dirty="0"/>
+              <a:t>Ovládání</a:t>
+            </a:r>
+          </a:p>
+        </p:txBody>
+      </p:sp>
+      <p:sp>
+        <p:nvSpPr>
+          <p:cNvPr id="3" name="Content Placeholder 2">
+            <a:extLst>
+              <a:ext uri="{FF2B5EF4-FFF2-40B4-BE49-F238E27FC236}">
+                <a16:creationId xmlns:a16="http://schemas.microsoft.com/office/drawing/2014/main" id="{B72313B4-1167-5BFE-4914-AF8C4B665E04}"/>
+              </a:ext>
+            </a:extLst>
+          </p:cNvPr>
+          <p:cNvSpPr>
+            <a:spLocks noGrp="1"/>
+          </p:cNvSpPr>
+          <p:nvPr>
+            <p:ph idx="1"/>
+          </p:nvPr>
+        </p:nvSpPr>
+        <p:spPr/>
+        <p:txBody>
+          <a:bodyPr/>
+          <a:lstStyle/>
+          <a:p>
+            <a:endParaRPr lang="cs-CZ"/>
+          </a:p>
+        </p:txBody>
+      </p:sp>
+    </p:spTree>
+    <p:extLst>
+      <p:ext uri="{BB962C8B-B14F-4D97-AF65-F5344CB8AC3E}">
+        <p14:creationId xmlns:p14="http://schemas.microsoft.com/office/powerpoint/2010/main" val="3593242919"/>
+      </p:ext>
+    </p:extLst>
+  </p:cSld>
+  <p:clrMapOvr>
+    <a:masterClrMapping/>
+  </p:clrMapOvr>
+</p:sld>
+</file>
+
+<file path=ppt/slides/slide15.xml><?xml version="1.0" encoding="utf-8"?>
+<p:sld xmlns:a="http://schemas.openxmlformats.org/drawingml/2006/main" xmlns:r="http://schemas.openxmlformats.org/officeDocument/2006/relationships" xmlns:p="http://schemas.openxmlformats.org/presentationml/2006/main">
+  <p:cSld>
+    <p:spTree>
+      <p:nvGrpSpPr>
+        <p:cNvPr id="1" name=""/>
+        <p:cNvGrpSpPr/>
+        <p:nvPr/>
+      </p:nvGrpSpPr>
+      <p:grpSpPr>
+        <a:xfrm>
+          <a:off x="0" y="0"/>
+          <a:ext cx="0" cy="0"/>
+          <a:chOff x="0" y="0"/>
+          <a:chExt cx="0" cy="0"/>
+        </a:xfrm>
+      </p:grpSpPr>
+      <p:sp>
+        <p:nvSpPr>
+          <p:cNvPr id="2" name="Title 1">
+            <a:extLst>
+              <a:ext uri="{FF2B5EF4-FFF2-40B4-BE49-F238E27FC236}">
                 <a16:creationId xmlns:a16="http://schemas.microsoft.com/office/drawing/2014/main" id="{07195F07-92E8-AF88-403B-50025CB8E99C}"/>
               </a:ext>
             </a:extLst>
@@ -6540,7 +6958,7 @@
 </p:sld>
 </file>
 
-<file path=ppt/slides/slide15.xml><?xml version="1.0" encoding="utf-8"?>
+<file path=ppt/slides/slide16.xml><?xml version="1.0" encoding="utf-8"?>
 <p:sld xmlns:a="http://schemas.openxmlformats.org/drawingml/2006/main" xmlns:r="http://schemas.openxmlformats.org/officeDocument/2006/relationships" xmlns:p="http://schemas.openxmlformats.org/presentationml/2006/main">
   <p:cSld>
     <p:spTree>
@@ -8278,9 +8696,26 @@
           </a:bodyPr>
           <a:lstStyle/>
           <a:p>
-            <a:r>
-              <a:rPr lang="cs-CZ" sz="5400"/>
+            <a:pPr>
+              <a:tabLst>
+                <a:tab pos="1971675" algn="l"/>
+              </a:tabLst>
+            </a:pPr>
+            <a:r>
+              <a:rPr lang="cs-CZ" sz="5400" dirty="0" err="1"/>
               <a:t>Enum</a:t>
+            </a:r>
+            <a:r>
+              <a:rPr lang="cs-CZ" sz="5400" dirty="0"/>
+              <a:t> [</a:t>
+            </a:r>
+            <a:r>
+              <a:rPr lang="cs-CZ" sz="5400" dirty="0" err="1"/>
+              <a:t>ínam</a:t>
+            </a:r>
+            <a:r>
+              <a:rPr lang="cs-CZ" sz="5400" dirty="0"/>
+              <a:t>]</a:t>
             </a:r>
           </a:p>
         </p:txBody>
@@ -8628,8 +9063,8 @@
           </a:p>
         </p:txBody>
       </p:sp>
-      <mc:AlternateContent xmlns:mc="http://schemas.openxmlformats.org/markup-compatibility/2006">
-        <mc:Choice xmlns:a14="http://schemas.microsoft.com/office/drawing/2010/main" Requires="a14">
+      <mc:AlternateContent xmlns:mc="http://schemas.openxmlformats.org/markup-compatibility/2006" xmlns:a14="http://schemas.microsoft.com/office/drawing/2010/main">
+        <mc:Choice Requires="a14">
           <p:sp>
             <p:nvSpPr>
               <p:cNvPr id="3" name="Content Placeholder 2">
@@ -9002,7 +9437,7 @@
             </p:txBody>
           </p:sp>
         </mc:Choice>
-        <mc:Fallback>
+        <mc:Fallback xmlns="">
           <p:sp>
             <p:nvSpPr>
               <p:cNvPr id="3" name="Content Placeholder 2">
@@ -9215,7 +9650,7 @@
             <a:pPr lvl="1"/>
             <a:r>
               <a:rPr lang="cs-CZ" dirty="0"/>
-              <a:t>Vlastník: blok kódu proměnné / objekt (struktura či </a:t>
+              <a:t>Vlastník: proměnná v bloku kódu / objekt (struktura či </a:t>
             </a:r>
             <a:r>
               <a:rPr lang="cs-CZ" dirty="0" err="1"/>
@@ -9237,13 +9672,26 @@
             <a:pPr lvl="1"/>
             <a:r>
               <a:rPr lang="cs-CZ" dirty="0"/>
-              <a:t>(předávání vlastnictví)</a:t>
-            </a:r>
-          </a:p>
-          <a:p>
-            <a:r>
-              <a:rPr lang="cs-CZ" dirty="0"/>
-              <a:t>Proměnné jsou ve výchozím stavu neměnné</a:t>
+              <a:t>Přiřazení do jiné proměnné nebo parametru funkce předá vlastnictví</a:t>
+            </a:r>
+          </a:p>
+          <a:p>
+            <a:r>
+              <a:rPr lang="cs-CZ" dirty="0"/>
+              <a:t>Proměnné jsou ve výchozím stavu neměnné – klíčové slovo </a:t>
+            </a:r>
+            <a:r>
+              <a:rPr lang="cs-CZ" dirty="0" err="1">
+                <a:highlight>
+                  <a:srgbClr val="C0C0C0"/>
+                </a:highlight>
+                <a:latin typeface="Consolas" panose="020B0609020204030204" pitchFamily="49" charset="0"/>
+              </a:rPr>
+              <a:t>mut</a:t>
+            </a:r>
+            <a:r>
+              <a:rPr lang="cs-CZ" dirty="0"/>
+              <a:t> </a:t>
             </a:r>
           </a:p>
           <a:p>
@@ -9270,7 +9718,7 @@
             <a:pPr lvl="1"/>
             <a:r>
               <a:rPr lang="cs-CZ" dirty="0"/>
-              <a:t>1 měnitelná reference, nebo ∞ neměnných referencí, ne oboje naráz</a:t>
+              <a:t>1 měnitelná reference, nebo nekonečno neměnných referencí</a:t>
             </a:r>
           </a:p>
           <a:p>

</xml_diff>

<commit_message>
WIP: Small edit on PartialEq, working on event loop in PPTX
</commit_message>
<xml_diff>
--- a/Prezentace.pptx
+++ b/Prezentace.pptx
@@ -197,6 +197,53 @@
 </p188:cmLst>
 </file>
 
+<file path=ppt/comments/modernComment_109_8B2154FC.xml><?xml version="1.0" encoding="utf-8"?>
+<p188:cmLst xmlns:a="http://schemas.openxmlformats.org/drawingml/2006/main" xmlns:r="http://schemas.openxmlformats.org/officeDocument/2006/relationships" xmlns:p188="http://schemas.microsoft.com/office/powerpoint/2018/8/main">
+  <p188:cm id="{4114CA40-1E1C-4583-9708-DB630D347108}" authorId="{6027075E-E1E5-2701-A4E4-E7D417A591B4}" created="2026-04-03T10:23:43.275">
+    <pc:sldMkLst xmlns:pc="http://schemas.microsoft.com/office/powerpoint/2013/main/command">
+      <pc:docMk/>
+      <pc:sldMk cId="2334217468" sldId="265"/>
+    </pc:sldMkLst>
+    <p188:txBody>
+      <a:bodyPr/>
+      <a:lstStyle/>
+      <a:p>
+        <a:r>
+          <a:rPr lang="cs-CZ"/>
+          <a:t>Teoreticky není potřeba ho převádět na Unicode, ale… Pššt!</a:t>
+        </a:r>
+      </a:p>
+    </p188:txBody>
+  </p188:cm>
+</p188:cmLst>
+</file>
+
+<file path=ppt/comments/modernComment_10F_1D3B1A8A.xml><?xml version="1.0" encoding="utf-8"?>
+<p188:cmLst xmlns:a="http://schemas.openxmlformats.org/drawingml/2006/main" xmlns:r="http://schemas.openxmlformats.org/officeDocument/2006/relationships" xmlns:p188="http://schemas.microsoft.com/office/powerpoint/2018/8/main">
+  <p188:cm id="{53E681B9-C046-4031-A410-095919527E16}" authorId="{6027075E-E1E5-2701-A4E4-E7D417A591B4}" created="2026-04-03T09:12:43.940">
+    <ac:txMkLst xmlns:ac="http://schemas.microsoft.com/office/drawing/2013/main/command">
+      <pc:docMk xmlns:pc="http://schemas.microsoft.com/office/powerpoint/2013/main/command"/>
+      <pc:sldMk xmlns:pc="http://schemas.microsoft.com/office/powerpoint/2013/main/command" cId="490412682" sldId="271"/>
+      <ac:spMk id="2" creationId="{607940D3-E158-1255-6253-DDC86DF077C7}"/>
+      <ac:txMk cp="5" len="7">
+        <ac:context len="13" hash="2811815585"/>
+      </ac:txMk>
+    </ac:txMkLst>
+    <p188:pos x="4181302" y="1273985"/>
+    <p188:txBody>
+      <a:bodyPr/>
+      <a:lstStyle/>
+      <a:p>
+        <a:r>
+          <a:rPr lang="cs-CZ"/>
+          <a:t>Mezinárodní fonetická abeceda, abychom potěšili předsedu češtináře...</a:t>
+        </a:r>
+      </a:p>
+    </p188:txBody>
+  </p188:cm>
+</p188:cmLst>
+</file>
+
 <file path=ppt/notesMasters/notesMaster1.xml><?xml version="1.0" encoding="utf-8"?>
 <p:notesMaster xmlns:a="http://schemas.openxmlformats.org/drawingml/2006/main" xmlns:r="http://schemas.openxmlformats.org/officeDocument/2006/relationships" xmlns:p="http://schemas.openxmlformats.org/presentationml/2006/main">
   <p:cSld>
@@ -279,7 +326,7 @@
           <a:p>
             <a:fld id="{015F5405-DF1B-4076-864B-7962BED0FCA9}" type="datetimeFigureOut">
               <a:rPr lang="cs-CZ" smtClean="0"/>
-              <a:t>02.04.2026</a:t>
+              <a:t>03.04.2026</a:t>
             </a:fld>
             <a:endParaRPr lang="cs-CZ"/>
           </a:p>
@@ -616,7 +663,7 @@
               <a:rPr lang="cs-CZ" smtClean="0"/>
               <a:t>1</a:t>
             </a:fld>
-            <a:endParaRPr lang="cs-CZ"/>
+            <a:endParaRPr lang="cs-CZ" dirty="0"/>
           </a:p>
         </p:txBody>
       </p:sp>
@@ -624,6 +671,795 @@
     <p:extLst>
       <p:ext uri="{BB962C8B-B14F-4D97-AF65-F5344CB8AC3E}">
         <p14:creationId xmlns:p14="http://schemas.microsoft.com/office/powerpoint/2010/main" val="254276558"/>
+      </p:ext>
+    </p:extLst>
+  </p:cSld>
+  <p:clrMapOvr>
+    <a:masterClrMapping/>
+  </p:clrMapOvr>
+</p:notes>
+</file>
+
+<file path=ppt/notesSlides/notesSlide10.xml><?xml version="1.0" encoding="utf-8"?>
+<p:notes xmlns:a="http://schemas.openxmlformats.org/drawingml/2006/main" xmlns:r="http://schemas.openxmlformats.org/officeDocument/2006/relationships" xmlns:p="http://schemas.openxmlformats.org/presentationml/2006/main">
+  <p:cSld>
+    <p:spTree>
+      <p:nvGrpSpPr>
+        <p:cNvPr id="1" name=""/>
+        <p:cNvGrpSpPr/>
+        <p:nvPr/>
+      </p:nvGrpSpPr>
+      <p:grpSpPr>
+        <a:xfrm>
+          <a:off x="0" y="0"/>
+          <a:ext cx="0" cy="0"/>
+          <a:chOff x="0" y="0"/>
+          <a:chExt cx="0" cy="0"/>
+        </a:xfrm>
+      </p:grpSpPr>
+      <p:sp>
+        <p:nvSpPr>
+          <p:cNvPr id="2" name="Slide Image Placeholder 1"/>
+          <p:cNvSpPr>
+            <a:spLocks noGrp="1" noRot="1" noChangeAspect="1"/>
+          </p:cNvSpPr>
+          <p:nvPr>
+            <p:ph type="sldImg"/>
+          </p:nvPr>
+        </p:nvSpPr>
+        <p:spPr/>
+      </p:sp>
+      <p:sp>
+        <p:nvSpPr>
+          <p:cNvPr id="3" name="Notes Placeholder 2"/>
+          <p:cNvSpPr>
+            <a:spLocks noGrp="1"/>
+          </p:cNvSpPr>
+          <p:nvPr>
+            <p:ph type="body" idx="1"/>
+          </p:nvPr>
+        </p:nvSpPr>
+        <p:spPr/>
+        <p:txBody>
+          <a:bodyPr/>
+          <a:lstStyle/>
+          <a:p>
+            <a:r>
+              <a:rPr lang="cs-CZ" dirty="0"/>
+              <a:t>Využití 3: samotný jazyk využívá interně různé speciální </a:t>
+            </a:r>
+            <a:r>
+              <a:rPr lang="cs-CZ" dirty="0" err="1"/>
+              <a:t>traity</a:t>
+            </a:r>
+            <a:r>
+              <a:rPr lang="cs-CZ" dirty="0"/>
+              <a:t> pro některé své funkce</a:t>
+            </a:r>
+          </a:p>
+          <a:p>
+            <a:endParaRPr lang="cs-CZ" dirty="0"/>
+          </a:p>
+          <a:p>
+            <a:r>
+              <a:rPr lang="cs-CZ" dirty="0" err="1"/>
+              <a:t>Traity</a:t>
+            </a:r>
+            <a:r>
+              <a:rPr lang="cs-CZ" dirty="0"/>
+              <a:t> </a:t>
+            </a:r>
+            <a:r>
+              <a:rPr lang="cs-CZ" dirty="0" err="1"/>
+              <a:t>Clone</a:t>
+            </a:r>
+            <a:r>
+              <a:rPr lang="cs-CZ" dirty="0"/>
+              <a:t> a Copy poskytují způsoby, jak zkopírovat hodnotu</a:t>
+            </a:r>
+          </a:p>
+          <a:p>
+            <a:pPr marL="171450" indent="-171450">
+              <a:buFont typeface="Arial" panose="020B0604020202020204" pitchFamily="34" charset="0"/>
+              <a:buChar char="•"/>
+            </a:pPr>
+            <a:r>
+              <a:rPr lang="cs-CZ" dirty="0" err="1"/>
+              <a:t>Clone</a:t>
+            </a:r>
+            <a:r>
+              <a:rPr lang="cs-CZ" dirty="0"/>
+              <a:t> poskytuje nějakou metodu, která vytvoří sémantickou kopii, může alokovat novou paměť atd.</a:t>
+            </a:r>
+          </a:p>
+          <a:p>
+            <a:pPr marL="171450" indent="-171450">
+              <a:buFont typeface="Arial" panose="020B0604020202020204" pitchFamily="34" charset="0"/>
+              <a:buChar char="•"/>
+            </a:pPr>
+            <a:r>
+              <a:rPr lang="cs-CZ" dirty="0"/>
+              <a:t>Copy pouze označuje, že lze hodnotu zkopírovat slepou kopií bitů</a:t>
+            </a:r>
+          </a:p>
+          <a:p>
+            <a:pPr marL="171450" indent="-171450">
+              <a:buFont typeface="Arial" panose="020B0604020202020204" pitchFamily="34" charset="0"/>
+              <a:buChar char="•"/>
+            </a:pPr>
+            <a:r>
+              <a:rPr lang="cs-CZ" dirty="0"/>
+              <a:t>    Pokud typ implementuje Copy, je automaticky kopírován, kdykoli by byl přesunut</a:t>
+            </a:r>
+          </a:p>
+          <a:p>
+            <a:pPr marL="171450" indent="-171450">
+              <a:buFont typeface="Arial" panose="020B0604020202020204" pitchFamily="34" charset="0"/>
+              <a:buChar char="•"/>
+            </a:pPr>
+            <a:r>
+              <a:rPr lang="cs-CZ" dirty="0"/>
+              <a:t>    Copy vyžaduje i implementaci </a:t>
+            </a:r>
+            <a:r>
+              <a:rPr lang="cs-CZ" dirty="0" err="1"/>
+              <a:t>Clone</a:t>
+            </a:r>
+            <a:r>
+              <a:rPr lang="cs-CZ" dirty="0"/>
+              <a:t>, který je pak implementovaný prostou kopií</a:t>
+            </a:r>
+          </a:p>
+          <a:p>
+            <a:pPr marL="0" indent="0">
+              <a:buFont typeface="Arial" panose="020B0604020202020204" pitchFamily="34" charset="0"/>
+              <a:buNone/>
+            </a:pPr>
+            <a:endParaRPr lang="cs-CZ" dirty="0"/>
+          </a:p>
+          <a:p>
+            <a:pPr marL="0" indent="0">
+              <a:buFont typeface="Arial" panose="020B0604020202020204" pitchFamily="34" charset="0"/>
+              <a:buNone/>
+            </a:pPr>
+            <a:r>
+              <a:rPr lang="cs-CZ" dirty="0" err="1"/>
+              <a:t>Trait</a:t>
+            </a:r>
+            <a:r>
+              <a:rPr lang="cs-CZ" dirty="0"/>
+              <a:t> Drop, jak již bylo popsáno, umožňuje spustit vlastní kód, kdykoli je hodnota zničena (tzv. destruktor)</a:t>
+            </a:r>
+          </a:p>
+          <a:p>
+            <a:pPr marL="171450" indent="-171450">
+              <a:buFont typeface="Arial" panose="020B0604020202020204" pitchFamily="34" charset="0"/>
+              <a:buChar char="•"/>
+            </a:pPr>
+            <a:r>
+              <a:rPr lang="cs-CZ" dirty="0"/>
+              <a:t>Např. uvolnění zdrojů, uzavření </a:t>
+            </a:r>
+            <a:r>
+              <a:rPr lang="cs-CZ" dirty="0" err="1"/>
+              <a:t>socketu</a:t>
+            </a:r>
+            <a:r>
+              <a:rPr lang="cs-CZ" dirty="0"/>
+              <a:t> apod.</a:t>
+            </a:r>
+          </a:p>
+          <a:p>
+            <a:pPr marL="171450" indent="-171450">
+              <a:buFont typeface="Arial" panose="020B0604020202020204" pitchFamily="34" charset="0"/>
+              <a:buChar char="•"/>
+            </a:pPr>
+            <a:r>
+              <a:rPr lang="cs-CZ" dirty="0"/>
+              <a:t>Vzájemně se vylučuje s Copy, protože by bylo velmi náročné předvídat, kdy a jak často by byly destruktory volány</a:t>
+            </a:r>
+          </a:p>
+          <a:p>
+            <a:pPr marL="0" indent="0">
+              <a:buFont typeface="Arial" panose="020B0604020202020204" pitchFamily="34" charset="0"/>
+              <a:buNone/>
+            </a:pPr>
+            <a:endParaRPr lang="cs-CZ" dirty="0"/>
+          </a:p>
+          <a:p>
+            <a:pPr marL="0" indent="0">
+              <a:buFont typeface="Arial" panose="020B0604020202020204" pitchFamily="34" charset="0"/>
+              <a:buNone/>
+            </a:pPr>
+            <a:r>
+              <a:rPr lang="cs-CZ" dirty="0" err="1"/>
+              <a:t>Trait</a:t>
+            </a:r>
+            <a:r>
+              <a:rPr lang="cs-CZ" dirty="0"/>
+              <a:t> Default vyžaduje metodu, která by fungovala jako výchozí konstruktor, navracejíc výchozí hodnotu typu</a:t>
+            </a:r>
+          </a:p>
+          <a:p>
+            <a:pPr marL="171450" indent="-171450">
+              <a:buFont typeface="Arial" panose="020B0604020202020204" pitchFamily="34" charset="0"/>
+              <a:buChar char="•"/>
+            </a:pPr>
+            <a:r>
+              <a:rPr lang="cs-CZ" dirty="0"/>
+              <a:t>Např. u čísel je to nula (0), u </a:t>
+            </a:r>
+            <a:r>
+              <a:rPr lang="cs-CZ" dirty="0" err="1"/>
+              <a:t>String</a:t>
+            </a:r>
+            <a:r>
+              <a:rPr lang="cs-CZ" dirty="0"/>
+              <a:t> je to prázdný řetězec apod.</a:t>
+            </a:r>
+          </a:p>
+          <a:p>
+            <a:pPr marL="0" indent="0">
+              <a:buFont typeface="Arial" panose="020B0604020202020204" pitchFamily="34" charset="0"/>
+              <a:buNone/>
+            </a:pPr>
+            <a:endParaRPr lang="cs-CZ" dirty="0"/>
+          </a:p>
+          <a:p>
+            <a:pPr marL="0" indent="0">
+              <a:buFont typeface="Arial" panose="020B0604020202020204" pitchFamily="34" charset="0"/>
+              <a:buNone/>
+            </a:pPr>
+            <a:r>
+              <a:rPr lang="cs-CZ" dirty="0"/>
+              <a:t>Dvojice </a:t>
+            </a:r>
+            <a:r>
+              <a:rPr lang="cs-CZ" dirty="0" err="1"/>
+              <a:t>traitů</a:t>
+            </a:r>
+            <a:r>
+              <a:rPr lang="cs-CZ" dirty="0"/>
+              <a:t> </a:t>
+            </a:r>
+            <a:r>
+              <a:rPr lang="cs-CZ" dirty="0" err="1"/>
+              <a:t>PartialEq</a:t>
+            </a:r>
+            <a:r>
+              <a:rPr lang="cs-CZ" dirty="0"/>
+              <a:t> a </a:t>
+            </a:r>
+            <a:r>
+              <a:rPr lang="cs-CZ" dirty="0" err="1"/>
+              <a:t>Eq</a:t>
+            </a:r>
+            <a:r>
+              <a:rPr lang="cs-CZ" dirty="0"/>
+              <a:t> definuje způsob porovnávání u operátoru rovnosti</a:t>
+            </a:r>
+          </a:p>
+          <a:p>
+            <a:pPr marL="171450" indent="-171450">
+              <a:buFont typeface="Arial" panose="020B0604020202020204" pitchFamily="34" charset="0"/>
+              <a:buChar char="•"/>
+            </a:pPr>
+            <a:r>
+              <a:rPr lang="cs-CZ" dirty="0" err="1"/>
+              <a:t>PartialEq</a:t>
+            </a:r>
+            <a:r>
+              <a:rPr lang="cs-CZ" dirty="0"/>
+              <a:t> vyžaduje symetrickou a tranzitivní relaci</a:t>
+            </a:r>
+          </a:p>
+          <a:p>
+            <a:pPr marL="171450" indent="-171450">
+              <a:buFont typeface="Arial" panose="020B0604020202020204" pitchFamily="34" charset="0"/>
+              <a:buChar char="•"/>
+            </a:pPr>
+            <a:r>
+              <a:rPr lang="cs-CZ" dirty="0" err="1"/>
+              <a:t>Eq</a:t>
+            </a:r>
+            <a:r>
+              <a:rPr lang="cs-CZ" dirty="0"/>
+              <a:t> je </a:t>
+            </a:r>
+            <a:r>
+              <a:rPr lang="cs-CZ" dirty="0" err="1"/>
+              <a:t>subtrait</a:t>
+            </a:r>
+            <a:r>
+              <a:rPr lang="cs-CZ" dirty="0"/>
+              <a:t> (podmnožina) </a:t>
+            </a:r>
+            <a:r>
+              <a:rPr lang="cs-CZ" dirty="0" err="1"/>
+              <a:t>PartialEq</a:t>
+            </a:r>
+            <a:r>
+              <a:rPr lang="cs-CZ" dirty="0"/>
+              <a:t> a vyžaduje navíc reflexivní relaci</a:t>
+            </a:r>
+          </a:p>
+          <a:p>
+            <a:pPr marL="0" indent="0">
+              <a:buFont typeface="Arial" panose="020B0604020202020204" pitchFamily="34" charset="0"/>
+              <a:buNone/>
+            </a:pPr>
+            <a:endParaRPr lang="cs-CZ" dirty="0"/>
+          </a:p>
+          <a:p>
+            <a:pPr marL="0" indent="0">
+              <a:buFont typeface="Arial" panose="020B0604020202020204" pitchFamily="34" charset="0"/>
+              <a:buNone/>
+            </a:pPr>
+            <a:r>
+              <a:rPr lang="cs-CZ" dirty="0"/>
+              <a:t>Dvojice </a:t>
+            </a:r>
+            <a:r>
+              <a:rPr lang="cs-CZ" dirty="0" err="1"/>
+              <a:t>PartialOrd</a:t>
+            </a:r>
+            <a:r>
+              <a:rPr lang="cs-CZ" dirty="0"/>
+              <a:t> a </a:t>
+            </a:r>
+            <a:r>
+              <a:rPr lang="cs-CZ" dirty="0" err="1"/>
+              <a:t>Ord</a:t>
+            </a:r>
+            <a:r>
+              <a:rPr lang="cs-CZ" dirty="0"/>
+              <a:t> definuje způsob porovnávání / seřazování u operátorů nerovnosti</a:t>
+            </a:r>
+          </a:p>
+          <a:p>
+            <a:pPr marL="171450" indent="-171450">
+              <a:buFont typeface="Arial" panose="020B0604020202020204" pitchFamily="34" charset="0"/>
+              <a:buChar char="•"/>
+            </a:pPr>
+            <a:r>
+              <a:rPr lang="cs-CZ" dirty="0"/>
+              <a:t>Porovnání </a:t>
+            </a:r>
+            <a:r>
+              <a:rPr lang="cs-CZ" dirty="0" err="1"/>
+              <a:t>PartialOrd</a:t>
+            </a:r>
+            <a:r>
+              <a:rPr lang="cs-CZ" dirty="0"/>
+              <a:t> může selhat, </a:t>
+            </a:r>
+            <a:r>
+              <a:rPr lang="cs-CZ" dirty="0" err="1"/>
+              <a:t>Ord</a:t>
+            </a:r>
+            <a:r>
+              <a:rPr lang="cs-CZ" dirty="0"/>
+              <a:t> je schopno seřadit celou množinu hodnot</a:t>
+            </a:r>
+          </a:p>
+          <a:p>
+            <a:pPr marL="0" indent="0">
+              <a:buFont typeface="Arial" panose="020B0604020202020204" pitchFamily="34" charset="0"/>
+              <a:buNone/>
+            </a:pPr>
+            <a:endParaRPr lang="cs-CZ" dirty="0"/>
+          </a:p>
+          <a:p>
+            <a:pPr marL="0" indent="0">
+              <a:buFont typeface="Arial" panose="020B0604020202020204" pitchFamily="34" charset="0"/>
+              <a:buNone/>
+            </a:pPr>
+            <a:r>
+              <a:rPr lang="cs-CZ" dirty="0"/>
+              <a:t>Předešlé dva </a:t>
+            </a:r>
+            <a:r>
+              <a:rPr lang="cs-CZ" dirty="0" err="1"/>
+              <a:t>traity</a:t>
+            </a:r>
+            <a:r>
+              <a:rPr lang="cs-CZ" dirty="0"/>
+              <a:t> </a:t>
+            </a:r>
+            <a:r>
+              <a:rPr lang="cs-CZ" dirty="0" err="1"/>
+              <a:t>Partial</a:t>
+            </a:r>
+            <a:r>
+              <a:rPr lang="cs-CZ" dirty="0"/>
+              <a:t>* existují hlavně kvůli číslům s plovoucí desetinnou čárkou, protože hodnota </a:t>
+            </a:r>
+            <a:r>
+              <a:rPr lang="cs-CZ" dirty="0" err="1"/>
+              <a:t>NaN</a:t>
+            </a:r>
+            <a:r>
+              <a:rPr lang="cs-CZ" dirty="0"/>
+              <a:t> (=není číslo)</a:t>
+            </a:r>
+            <a:br>
+              <a:rPr lang="cs-CZ" dirty="0"/>
+            </a:br>
+            <a:r>
+              <a:rPr lang="cs-CZ" dirty="0"/>
+              <a:t>se nerovná sama sobě (ani ničemu jinému) a jakékoli porovnání s ní je nepravdivé</a:t>
+            </a:r>
+          </a:p>
+          <a:p>
+            <a:pPr marL="0" indent="0">
+              <a:buFont typeface="Arial" panose="020B0604020202020204" pitchFamily="34" charset="0"/>
+              <a:buNone/>
+            </a:pPr>
+            <a:endParaRPr lang="cs-CZ" dirty="0"/>
+          </a:p>
+          <a:p>
+            <a:pPr marL="0" indent="0">
+              <a:buFont typeface="Arial" panose="020B0604020202020204" pitchFamily="34" charset="0"/>
+              <a:buNone/>
+            </a:pPr>
+            <a:r>
+              <a:rPr lang="cs-CZ" dirty="0"/>
+              <a:t>Dvojice </a:t>
+            </a:r>
+            <a:r>
+              <a:rPr lang="cs-CZ" dirty="0" err="1"/>
+              <a:t>Debug</a:t>
+            </a:r>
+            <a:r>
+              <a:rPr lang="cs-CZ" dirty="0"/>
+              <a:t> a Display specifikuje způsob, jak formátovat hodnotu na text</a:t>
+            </a:r>
+          </a:p>
+          <a:p>
+            <a:pPr marL="171450" indent="-171450">
+              <a:buFont typeface="Arial" panose="020B0604020202020204" pitchFamily="34" charset="0"/>
+              <a:buChar char="•"/>
+            </a:pPr>
+            <a:r>
+              <a:rPr lang="cs-CZ" dirty="0" err="1"/>
+              <a:t>Debug</a:t>
+            </a:r>
+            <a:r>
+              <a:rPr lang="cs-CZ" dirty="0"/>
+              <a:t> je zamýšleno jako zobrazení pro programátora, nemá být nijak „hezké“</a:t>
+            </a:r>
+          </a:p>
+          <a:p>
+            <a:pPr marL="171450" indent="-171450">
+              <a:buFont typeface="Arial" panose="020B0604020202020204" pitchFamily="34" charset="0"/>
+              <a:buChar char="•"/>
+            </a:pPr>
+            <a:r>
+              <a:rPr lang="cs-CZ" dirty="0"/>
+              <a:t>    Ideálně úplně každý typ by ho měl implementovat, i třeba jen jako výčet hodnot polí ve struktuře</a:t>
+            </a:r>
+          </a:p>
+          <a:p>
+            <a:pPr marL="171450" indent="-171450">
+              <a:buFont typeface="Arial" panose="020B0604020202020204" pitchFamily="34" charset="0"/>
+              <a:buChar char="•"/>
+            </a:pPr>
+            <a:r>
+              <a:rPr lang="cs-CZ" dirty="0"/>
+              <a:t>Display je zamýšleno jako zobrazení pro uživatele, mělo by zobrazovat sémantickou hodnotu</a:t>
+            </a:r>
+          </a:p>
+          <a:p>
+            <a:pPr marL="0" indent="0">
+              <a:buFont typeface="Arial" panose="020B0604020202020204" pitchFamily="34" charset="0"/>
+              <a:buNone/>
+            </a:pPr>
+            <a:endParaRPr lang="cs-CZ" dirty="0"/>
+          </a:p>
+          <a:p>
+            <a:pPr marL="0" indent="0">
+              <a:buFont typeface="Arial" panose="020B0604020202020204" pitchFamily="34" charset="0"/>
+              <a:buNone/>
+            </a:pPr>
+            <a:r>
+              <a:rPr lang="cs-CZ" dirty="0" err="1"/>
+              <a:t>Clone</a:t>
+            </a:r>
+            <a:r>
+              <a:rPr lang="cs-CZ" dirty="0"/>
+              <a:t>, Copy, Default, </a:t>
+            </a:r>
+            <a:r>
+              <a:rPr lang="cs-CZ" dirty="0" err="1"/>
+              <a:t>Debug</a:t>
+            </a:r>
+            <a:r>
+              <a:rPr lang="cs-CZ" dirty="0"/>
+              <a:t> a porovnávání lze automaticky implementovat na naše typy pomocí makra </a:t>
+            </a:r>
+            <a:r>
+              <a:rPr lang="cs-CZ" dirty="0" err="1"/>
+              <a:t>derive</a:t>
+            </a:r>
+            <a:r>
+              <a:rPr lang="cs-CZ" dirty="0"/>
+              <a:t>,</a:t>
+            </a:r>
+            <a:br>
+              <a:rPr lang="cs-CZ" dirty="0"/>
+            </a:br>
+            <a:r>
+              <a:rPr lang="cs-CZ" dirty="0"/>
+              <a:t>ale obvykle pouze pokud je všechny položky ve struktuře / </a:t>
+            </a:r>
+            <a:r>
+              <a:rPr lang="cs-CZ" dirty="0" err="1"/>
+              <a:t>enumu</a:t>
+            </a:r>
+            <a:r>
+              <a:rPr lang="cs-CZ" dirty="0"/>
+              <a:t> rovněž implementují</a:t>
+            </a:r>
+          </a:p>
+        </p:txBody>
+      </p:sp>
+      <p:sp>
+        <p:nvSpPr>
+          <p:cNvPr id="4" name="Slide Number Placeholder 3"/>
+          <p:cNvSpPr>
+            <a:spLocks noGrp="1"/>
+          </p:cNvSpPr>
+          <p:nvPr>
+            <p:ph type="sldNum" sz="quarter" idx="5"/>
+          </p:nvPr>
+        </p:nvSpPr>
+        <p:spPr/>
+        <p:txBody>
+          <a:bodyPr/>
+          <a:lstStyle/>
+          <a:p>
+            <a:fld id="{27274CA6-4D7F-431B-9614-EDAF6E1099E6}" type="slidenum">
+              <a:rPr lang="cs-CZ" smtClean="0"/>
+              <a:t>11</a:t>
+            </a:fld>
+            <a:endParaRPr lang="cs-CZ"/>
+          </a:p>
+        </p:txBody>
+      </p:sp>
+    </p:spTree>
+    <p:extLst>
+      <p:ext uri="{BB962C8B-B14F-4D97-AF65-F5344CB8AC3E}">
+        <p14:creationId xmlns:p14="http://schemas.microsoft.com/office/powerpoint/2010/main" val="3900248440"/>
+      </p:ext>
+    </p:extLst>
+  </p:cSld>
+  <p:clrMapOvr>
+    <a:masterClrMapping/>
+  </p:clrMapOvr>
+</p:notes>
+</file>
+
+<file path=ppt/notesSlides/notesSlide11.xml><?xml version="1.0" encoding="utf-8"?>
+<p:notes xmlns:a="http://schemas.openxmlformats.org/drawingml/2006/main" xmlns:r="http://schemas.openxmlformats.org/officeDocument/2006/relationships" xmlns:p="http://schemas.openxmlformats.org/presentationml/2006/main">
+  <p:cSld>
+    <p:spTree>
+      <p:nvGrpSpPr>
+        <p:cNvPr id="1" name=""/>
+        <p:cNvGrpSpPr/>
+        <p:nvPr/>
+      </p:nvGrpSpPr>
+      <p:grpSpPr>
+        <a:xfrm>
+          <a:off x="0" y="0"/>
+          <a:ext cx="0" cy="0"/>
+          <a:chOff x="0" y="0"/>
+          <a:chExt cx="0" cy="0"/>
+        </a:xfrm>
+      </p:grpSpPr>
+      <p:sp>
+        <p:nvSpPr>
+          <p:cNvPr id="2" name="Slide Image Placeholder 1"/>
+          <p:cNvSpPr>
+            <a:spLocks noGrp="1" noRot="1" noChangeAspect="1"/>
+          </p:cNvSpPr>
+          <p:nvPr>
+            <p:ph type="sldImg"/>
+          </p:nvPr>
+        </p:nvSpPr>
+        <p:spPr/>
+      </p:sp>
+      <p:sp>
+        <p:nvSpPr>
+          <p:cNvPr id="3" name="Notes Placeholder 2"/>
+          <p:cNvSpPr>
+            <a:spLocks noGrp="1"/>
+          </p:cNvSpPr>
+          <p:nvPr>
+            <p:ph type="body" idx="1"/>
+          </p:nvPr>
+        </p:nvSpPr>
+        <p:spPr/>
+        <p:txBody>
+          <a:bodyPr/>
+          <a:lstStyle/>
+          <a:p>
+            <a:r>
+              <a:rPr lang="cs-CZ" dirty="0"/>
+              <a:t>Na začátku běhu programu ty nejsložitější funkce zařídí námi použitý HAL (=vrstva pro abstrakci hardwaru) ve spolupráci s pevně zakódovanou logikou v čipu</a:t>
+            </a:r>
+          </a:p>
+          <a:p>
+            <a:endParaRPr lang="cs-CZ" dirty="0"/>
+          </a:p>
+          <a:p>
+            <a:r>
+              <a:rPr lang="cs-CZ" dirty="0"/>
+              <a:t>Poté, co konečně získáme kontrolu nad čipem (HAL spustí naši hlavní funkci – </a:t>
+            </a:r>
+            <a:r>
+              <a:rPr lang="cs-CZ" dirty="0" err="1"/>
+              <a:t>main</a:t>
+            </a:r>
+            <a:r>
+              <a:rPr lang="cs-CZ" dirty="0"/>
+              <a:t>()), je potřeba:</a:t>
+            </a:r>
+          </a:p>
+          <a:p>
+            <a:pPr marL="171450" indent="-171450">
+              <a:buFont typeface="Arial" panose="020B0604020202020204" pitchFamily="34" charset="0"/>
+              <a:buChar char="•"/>
+            </a:pPr>
+            <a:r>
+              <a:rPr lang="cs-CZ" dirty="0"/>
+              <a:t>Přepnout z výchozího, ale poměrně nepřesného časovače </a:t>
+            </a:r>
+            <a:r>
+              <a:rPr lang="cs-CZ" dirty="0" err="1"/>
+              <a:t>ROSC</a:t>
+            </a:r>
+            <a:r>
+              <a:rPr lang="cs-CZ" dirty="0"/>
+              <a:t> (prstenec hradel NOT) na krystalové hodiny </a:t>
+            </a:r>
+            <a:r>
+              <a:rPr lang="cs-CZ" dirty="0" err="1"/>
+              <a:t>XOSC</a:t>
+            </a:r>
+            <a:r>
+              <a:rPr lang="cs-CZ" dirty="0"/>
+              <a:t> (s externím krystalem)</a:t>
+            </a:r>
+          </a:p>
+          <a:p>
+            <a:pPr marL="171450" indent="-171450">
+              <a:buFont typeface="Arial" panose="020B0604020202020204" pitchFamily="34" charset="0"/>
+              <a:buChar char="•"/>
+            </a:pPr>
+            <a:r>
+              <a:rPr lang="cs-CZ" dirty="0"/>
+              <a:t>Aktivovat a nastavit periferie I2C a </a:t>
+            </a:r>
+            <a:r>
+              <a:rPr lang="cs-CZ" dirty="0" err="1"/>
+              <a:t>UART</a:t>
+            </a:r>
+            <a:endParaRPr lang="cs-CZ" dirty="0"/>
+          </a:p>
+          <a:p>
+            <a:pPr marL="171450" indent="-171450">
+              <a:buFont typeface="Arial" panose="020B0604020202020204" pitchFamily="34" charset="0"/>
+              <a:buChar char="•"/>
+            </a:pPr>
+            <a:r>
+              <a:rPr lang="cs-CZ" dirty="0"/>
+              <a:t>Připojit se k displeji přes sběrnici I2C a inicializovat ho pomocí funkcí poskytovaných ovladačem</a:t>
+            </a:r>
+            <a:br>
+              <a:rPr lang="cs-CZ" dirty="0"/>
+            </a:br>
+            <a:r>
+              <a:rPr lang="cs-CZ" dirty="0"/>
+              <a:t>(snímek obrazovky z kódu ovladače vpravo)</a:t>
+            </a:r>
+          </a:p>
+          <a:p>
+            <a:pPr marL="171450" indent="-171450">
+              <a:buFont typeface="Arial" panose="020B0604020202020204" pitchFamily="34" charset="0"/>
+              <a:buChar char="•"/>
+            </a:pPr>
+            <a:r>
+              <a:rPr lang="cs-CZ" dirty="0"/>
+              <a:t>Vytvořit datové struktury, které náš kód potřebuje, tedy struktury zásobníku a textového pole</a:t>
+            </a:r>
+          </a:p>
+          <a:p>
+            <a:pPr marL="0" indent="0">
+              <a:buFont typeface="Arial" panose="020B0604020202020204" pitchFamily="34" charset="0"/>
+              <a:buNone/>
+            </a:pPr>
+            <a:endParaRPr lang="cs-CZ" dirty="0"/>
+          </a:p>
+          <a:p>
+            <a:pPr marL="0" indent="0">
+              <a:buFont typeface="Arial" panose="020B0604020202020204" pitchFamily="34" charset="0"/>
+              <a:buNone/>
+            </a:pPr>
+            <a:r>
+              <a:rPr lang="cs-CZ" dirty="0"/>
+              <a:t>Nakonec procesor vejde do nekonečné smyčky (ze které se nedostane jinak než restartem)</a:t>
+            </a:r>
+          </a:p>
+          <a:p>
+            <a:pPr marL="171450" indent="-171450">
+              <a:buFont typeface="Arial" panose="020B0604020202020204" pitchFamily="34" charset="0"/>
+              <a:buChar char="•"/>
+            </a:pPr>
+            <a:r>
+              <a:rPr lang="cs-CZ" dirty="0"/>
+              <a:t>Přečte 1 bajt z rozhraní </a:t>
+            </a:r>
+            <a:r>
+              <a:rPr lang="cs-CZ" dirty="0" err="1"/>
+              <a:t>UART</a:t>
+            </a:r>
+            <a:r>
+              <a:rPr lang="cs-CZ" dirty="0"/>
+              <a:t> (čeká, dokud nějaký nedorazí) a převede ho na Unicode znak</a:t>
+            </a:r>
+          </a:p>
+          <a:p>
+            <a:pPr marL="171450" indent="-171450">
+              <a:buFont typeface="Arial" panose="020B0604020202020204" pitchFamily="34" charset="0"/>
+              <a:buChar char="•"/>
+            </a:pPr>
+            <a:r>
+              <a:rPr lang="cs-CZ" dirty="0"/>
+              <a:t>Pomocí velkého výrazu </a:t>
+            </a:r>
+            <a:r>
+              <a:rPr lang="cs-CZ" dirty="0" err="1"/>
+              <a:t>match</a:t>
+            </a:r>
+            <a:r>
+              <a:rPr lang="cs-CZ" dirty="0"/>
+              <a:t> se rozhodne, jak se zachová podle toho, o </a:t>
+            </a:r>
+            <a:r>
+              <a:rPr lang="cs-CZ"/>
+              <a:t>jaký znak jde</a:t>
+            </a:r>
+            <a:endParaRPr lang="cs-CZ" dirty="0"/>
+          </a:p>
+        </p:txBody>
+      </p:sp>
+      <p:sp>
+        <p:nvSpPr>
+          <p:cNvPr id="4" name="Slide Number Placeholder 3"/>
+          <p:cNvSpPr>
+            <a:spLocks noGrp="1"/>
+          </p:cNvSpPr>
+          <p:nvPr>
+            <p:ph type="sldNum" sz="quarter" idx="5"/>
+          </p:nvPr>
+        </p:nvSpPr>
+        <p:spPr/>
+        <p:txBody>
+          <a:bodyPr/>
+          <a:lstStyle/>
+          <a:p>
+            <a:fld id="{27274CA6-4D7F-431B-9614-EDAF6E1099E6}" type="slidenum">
+              <a:rPr lang="cs-CZ" smtClean="0"/>
+              <a:t>12</a:t>
+            </a:fld>
+            <a:endParaRPr lang="cs-CZ"/>
+          </a:p>
+        </p:txBody>
+      </p:sp>
+    </p:spTree>
+    <p:extLst>
+      <p:ext uri="{BB962C8B-B14F-4D97-AF65-F5344CB8AC3E}">
+        <p14:creationId xmlns:p14="http://schemas.microsoft.com/office/powerpoint/2010/main" val="1325202856"/>
       </p:ext>
     </p:extLst>
   </p:cSld>
@@ -1697,14 +2533,14 @@
             </a:pPr>
             <a:r>
               <a:rPr lang="cs-CZ" dirty="0"/>
-              <a:t>Ve výchozím stavu, pokud přiřadíme proměnnou do jiné proměnné, nebo ji předáme jako parametr nějaké funkci,</a:t>
+              <a:t>Ve výchozím stavu, pokud přiřadíme proměnnou do jiné proměnné, nebo ji předáme jako parametr nějaké funkci bez reference,</a:t>
             </a:r>
             <a:br>
               <a:rPr lang="cs-CZ" dirty="0"/>
             </a:br>
             <a:r>
               <a:rPr lang="cs-CZ" dirty="0"/>
-              <a:t>předáme vlastnictví této nové proměnné nebo bloku kódu tvořící kód funkce, tzv. ji přesuneme</a:t>
+              <a:t>předáme vlastnictví této nové proměnné nebo bloku kódu tvořící kód funkce, tzv. ji přesuneme nebo „předáme přes hodnotu“</a:t>
             </a:r>
           </a:p>
           <a:p>
@@ -1813,7 +2649,14 @@
             </a:br>
             <a:r>
               <a:rPr lang="cs-CZ" dirty="0"/>
-              <a:t>    takže pokud předáme funkci jen referenci, tak s hodnotou může funkce pracovat, aniž by proměnná zanikla</a:t>
+              <a:t>    takže pokud předáme funkci jen referenci, tak s hodnotou může funkce pracovat, aniž by proměnná zanikla,</a:t>
+            </a:r>
+            <a:br>
+              <a:rPr lang="cs-CZ" dirty="0"/>
+            </a:br>
+            <a:r>
+              <a:rPr lang="cs-CZ" dirty="0"/>
+              <a:t>    v takovém případě tzv. předáme přes referenci</a:t>
             </a:r>
           </a:p>
           <a:p>
@@ -1925,11 +2768,7 @@
             </a:r>
             <a:r>
               <a:rPr lang="cs-CZ" dirty="0"/>
-              <a:t> nejdříve zavolají Drop samy na sobě, a pak na hodnotách v </a:t>
-            </a:r>
-            <a:r>
-              <a:rPr lang="cs-CZ"/>
-              <a:t>nich uložených</a:t>
+              <a:t> nejdříve zavolají Drop samy na sobě, a pak na hodnotách v nich uložených</a:t>
             </a:r>
           </a:p>
           <a:p>
@@ -2190,6 +3029,109 @@
             <a:r>
               <a:rPr lang="cs-CZ" dirty="0"/>
               <a:t> sémanticky stejné, i když samotné implementace v kódu se mohou lišit</a:t>
+            </a:r>
+          </a:p>
+          <a:p>
+            <a:pPr marL="0" marR="0" lvl="0" indent="0" algn="l" defTabSz="914400" rtl="0" eaLnBrk="1" fontAlgn="auto" latinLnBrk="0" hangingPunct="1">
+              <a:lnSpc>
+                <a:spcPct val="100000"/>
+              </a:lnSpc>
+              <a:spcBef>
+                <a:spcPts val="0"/>
+              </a:spcBef>
+              <a:spcAft>
+                <a:spcPts val="0"/>
+              </a:spcAft>
+              <a:buClrTx/>
+              <a:buSzTx/>
+              <a:buFont typeface="Arial" panose="020B0604020202020204" pitchFamily="34" charset="0"/>
+              <a:buNone/>
+              <a:tabLst/>
+              <a:defRPr/>
+            </a:pPr>
+            <a:endParaRPr lang="cs-CZ" dirty="0"/>
+          </a:p>
+          <a:p>
+            <a:pPr marL="0" marR="0" lvl="0" indent="0" algn="l" defTabSz="914400" rtl="0" eaLnBrk="1" fontAlgn="auto" latinLnBrk="0" hangingPunct="1">
+              <a:lnSpc>
+                <a:spcPct val="100000"/>
+              </a:lnSpc>
+              <a:spcBef>
+                <a:spcPts val="0"/>
+              </a:spcBef>
+              <a:spcAft>
+                <a:spcPts val="0"/>
+              </a:spcAft>
+              <a:buClrTx/>
+              <a:buSzTx/>
+              <a:buFont typeface="Arial" panose="020B0604020202020204" pitchFamily="34" charset="0"/>
+              <a:buNone/>
+              <a:tabLst/>
+              <a:defRPr/>
+            </a:pPr>
+            <a:r>
+              <a:rPr lang="cs-CZ" dirty="0" err="1"/>
+              <a:t>Traity</a:t>
+            </a:r>
+            <a:r>
+              <a:rPr lang="cs-CZ" dirty="0"/>
+              <a:t> mohou volitelně vyžadovat, že mohou být implementovány pouze pokud je implementován i jiný </a:t>
+            </a:r>
+            <a:r>
+              <a:rPr lang="cs-CZ" dirty="0" err="1"/>
+              <a:t>trait</a:t>
+            </a:r>
+            <a:endParaRPr lang="cs-CZ" dirty="0"/>
+          </a:p>
+          <a:p>
+            <a:pPr marL="171450" marR="0" lvl="0" indent="-171450" algn="l" defTabSz="914400" rtl="0" eaLnBrk="1" fontAlgn="auto" latinLnBrk="0" hangingPunct="1">
+              <a:lnSpc>
+                <a:spcPct val="100000"/>
+              </a:lnSpc>
+              <a:spcBef>
+                <a:spcPts val="0"/>
+              </a:spcBef>
+              <a:spcAft>
+                <a:spcPts val="0"/>
+              </a:spcAft>
+              <a:buClrTx/>
+              <a:buSzTx/>
+              <a:buFont typeface="Arial" panose="020B0604020202020204" pitchFamily="34" charset="0"/>
+              <a:buChar char="•"/>
+              <a:tabLst/>
+              <a:defRPr/>
+            </a:pPr>
+            <a:r>
+              <a:rPr lang="cs-CZ" dirty="0" err="1"/>
+              <a:t>Trait</a:t>
+            </a:r>
+            <a:r>
+              <a:rPr lang="cs-CZ" dirty="0"/>
+              <a:t>, který je vyžadován, je nazývaný „</a:t>
+            </a:r>
+            <a:r>
+              <a:rPr lang="cs-CZ" dirty="0" err="1"/>
+              <a:t>supertrait</a:t>
+            </a:r>
+            <a:r>
+              <a:rPr lang="cs-CZ" dirty="0"/>
+              <a:t>“ (jako nadmnožina), vyžadující </a:t>
+            </a:r>
+            <a:r>
+              <a:rPr lang="cs-CZ" dirty="0" err="1"/>
+              <a:t>trait</a:t>
+            </a:r>
+            <a:r>
+              <a:rPr lang="cs-CZ" dirty="0"/>
+              <a:t> je „</a:t>
+            </a:r>
+            <a:r>
+              <a:rPr lang="cs-CZ" dirty="0" err="1"/>
+              <a:t>subtrait</a:t>
+            </a:r>
+            <a:r>
+              <a:rPr lang="cs-CZ" dirty="0"/>
+              <a:t>“ (jako podmnožina)</a:t>
             </a:r>
           </a:p>
           <a:p>
@@ -2835,7 +3777,7 @@
           <a:p>
             <a:fld id="{798D3673-CB33-4FFC-8C38-E9A4E5339B0B}" type="datetimeFigureOut">
               <a:rPr lang="cs-CZ" smtClean="0"/>
-              <a:t>02.04.2026</a:t>
+              <a:t>03.04.2026</a:t>
             </a:fld>
             <a:endParaRPr lang="cs-CZ"/>
           </a:p>
@@ -3033,7 +3975,7 @@
           <a:p>
             <a:fld id="{798D3673-CB33-4FFC-8C38-E9A4E5339B0B}" type="datetimeFigureOut">
               <a:rPr lang="cs-CZ" smtClean="0"/>
-              <a:t>02.04.2026</a:t>
+              <a:t>03.04.2026</a:t>
             </a:fld>
             <a:endParaRPr lang="cs-CZ"/>
           </a:p>
@@ -3241,7 +4183,7 @@
           <a:p>
             <a:fld id="{798D3673-CB33-4FFC-8C38-E9A4E5339B0B}" type="datetimeFigureOut">
               <a:rPr lang="cs-CZ" smtClean="0"/>
-              <a:t>02.04.2026</a:t>
+              <a:t>03.04.2026</a:t>
             </a:fld>
             <a:endParaRPr lang="cs-CZ"/>
           </a:p>
@@ -3439,7 +4381,7 @@
           <a:p>
             <a:fld id="{798D3673-CB33-4FFC-8C38-E9A4E5339B0B}" type="datetimeFigureOut">
               <a:rPr lang="cs-CZ" smtClean="0"/>
-              <a:t>02.04.2026</a:t>
+              <a:t>03.04.2026</a:t>
             </a:fld>
             <a:endParaRPr lang="cs-CZ"/>
           </a:p>
@@ -3714,7 +4656,7 @@
           <a:p>
             <a:fld id="{798D3673-CB33-4FFC-8C38-E9A4E5339B0B}" type="datetimeFigureOut">
               <a:rPr lang="cs-CZ" smtClean="0"/>
-              <a:t>02.04.2026</a:t>
+              <a:t>03.04.2026</a:t>
             </a:fld>
             <a:endParaRPr lang="cs-CZ"/>
           </a:p>
@@ -3979,7 +4921,7 @@
           <a:p>
             <a:fld id="{798D3673-CB33-4FFC-8C38-E9A4E5339B0B}" type="datetimeFigureOut">
               <a:rPr lang="cs-CZ" smtClean="0"/>
-              <a:t>02.04.2026</a:t>
+              <a:t>03.04.2026</a:t>
             </a:fld>
             <a:endParaRPr lang="cs-CZ"/>
           </a:p>
@@ -4391,7 +5333,7 @@
           <a:p>
             <a:fld id="{798D3673-CB33-4FFC-8C38-E9A4E5339B0B}" type="datetimeFigureOut">
               <a:rPr lang="cs-CZ" smtClean="0"/>
-              <a:t>02.04.2026</a:t>
+              <a:t>03.04.2026</a:t>
             </a:fld>
             <a:endParaRPr lang="cs-CZ"/>
           </a:p>
@@ -4532,7 +5474,7 @@
           <a:p>
             <a:fld id="{798D3673-CB33-4FFC-8C38-E9A4E5339B0B}" type="datetimeFigureOut">
               <a:rPr lang="cs-CZ" smtClean="0"/>
-              <a:t>02.04.2026</a:t>
+              <a:t>03.04.2026</a:t>
             </a:fld>
             <a:endParaRPr lang="cs-CZ"/>
           </a:p>
@@ -4645,7 +5587,7 @@
           <a:p>
             <a:fld id="{798D3673-CB33-4FFC-8C38-E9A4E5339B0B}" type="datetimeFigureOut">
               <a:rPr lang="cs-CZ" smtClean="0"/>
-              <a:t>02.04.2026</a:t>
+              <a:t>03.04.2026</a:t>
             </a:fld>
             <a:endParaRPr lang="cs-CZ"/>
           </a:p>
@@ -4956,7 +5898,7 @@
           <a:p>
             <a:fld id="{798D3673-CB33-4FFC-8C38-E9A4E5339B0B}" type="datetimeFigureOut">
               <a:rPr lang="cs-CZ" smtClean="0"/>
-              <a:t>02.04.2026</a:t>
+              <a:t>03.04.2026</a:t>
             </a:fld>
             <a:endParaRPr lang="cs-CZ"/>
           </a:p>
@@ -5244,7 +6186,7 @@
           <a:p>
             <a:fld id="{798D3673-CB33-4FFC-8C38-E9A4E5339B0B}" type="datetimeFigureOut">
               <a:rPr lang="cs-CZ" smtClean="0"/>
-              <a:t>02.04.2026</a:t>
+              <a:t>03.04.2026</a:t>
             </a:fld>
             <a:endParaRPr lang="cs-CZ"/>
           </a:p>
@@ -5485,7 +6427,7 @@
           <a:p>
             <a:fld id="{798D3673-CB33-4FFC-8C38-E9A4E5339B0B}" type="datetimeFigureOut">
               <a:rPr lang="cs-CZ" smtClean="0"/>
-              <a:t>02.04.2026</a:t>
+              <a:t>03.04.2026</a:t>
             </a:fld>
             <a:endParaRPr lang="cs-CZ"/>
           </a:p>
@@ -6594,7 +7536,225 @@
           <a:bodyPr/>
           <a:lstStyle/>
           <a:p>
-            <a:endParaRPr lang="cs-CZ"/>
+            <a:r>
+              <a:rPr lang="cs-CZ" dirty="0"/>
+              <a:t>Speciální, interní </a:t>
+            </a:r>
+            <a:r>
+              <a:rPr lang="cs-CZ" dirty="0" err="1"/>
+              <a:t>traity</a:t>
+            </a:r>
+            <a:endParaRPr lang="cs-CZ" dirty="0"/>
+          </a:p>
+          <a:p>
+            <a:r>
+              <a:rPr lang="cs-CZ" dirty="0" err="1">
+                <a:highlight>
+                  <a:srgbClr val="C0C0C0"/>
+                </a:highlight>
+              </a:rPr>
+              <a:t>Clone</a:t>
+            </a:r>
+            <a:r>
+              <a:rPr lang="cs-CZ" dirty="0"/>
+              <a:t>, </a:t>
+            </a:r>
+            <a:r>
+              <a:rPr lang="cs-CZ" dirty="0">
+                <a:highlight>
+                  <a:srgbClr val="C0C0C0"/>
+                </a:highlight>
+              </a:rPr>
+              <a:t>Copy</a:t>
+            </a:r>
+            <a:r>
+              <a:rPr lang="cs-CZ" dirty="0"/>
+              <a:t> – kopírování hodnot</a:t>
+            </a:r>
+          </a:p>
+          <a:p>
+            <a:r>
+              <a:rPr lang="cs-CZ" dirty="0">
+                <a:highlight>
+                  <a:srgbClr val="C0C0C0"/>
+                </a:highlight>
+              </a:rPr>
+              <a:t>Drop</a:t>
+            </a:r>
+            <a:r>
+              <a:rPr lang="cs-CZ" dirty="0"/>
+              <a:t> – zničení hodnot</a:t>
+            </a:r>
+          </a:p>
+          <a:p>
+            <a:r>
+              <a:rPr lang="cs-CZ" dirty="0">
+                <a:highlight>
+                  <a:srgbClr val="C0C0C0"/>
+                </a:highlight>
+              </a:rPr>
+              <a:t>Default</a:t>
+            </a:r>
+            <a:r>
+              <a:rPr lang="cs-CZ" dirty="0"/>
+              <a:t> – výchozí hodnota</a:t>
+            </a:r>
+          </a:p>
+          <a:p>
+            <a:r>
+              <a:rPr lang="cs-CZ" dirty="0" err="1">
+                <a:highlight>
+                  <a:srgbClr val="C0C0C0"/>
+                </a:highlight>
+              </a:rPr>
+              <a:t>PartialEq</a:t>
+            </a:r>
+            <a:r>
+              <a:rPr lang="cs-CZ" dirty="0"/>
+              <a:t> a </a:t>
+            </a:r>
+            <a:r>
+              <a:rPr lang="cs-CZ" dirty="0" err="1">
+                <a:highlight>
+                  <a:srgbClr val="C0C0C0"/>
+                </a:highlight>
+              </a:rPr>
+              <a:t>Eq</a:t>
+            </a:r>
+            <a:r>
+              <a:rPr lang="cs-CZ" dirty="0"/>
+              <a:t> – operátor rovnosti </a:t>
+            </a:r>
+            <a:r>
+              <a:rPr lang="cs-CZ" dirty="0">
+                <a:highlight>
+                  <a:srgbClr val="C0C0C0"/>
+                </a:highlight>
+              </a:rPr>
+              <a:t>==</a:t>
+            </a:r>
+            <a:r>
+              <a:rPr lang="cs-CZ" dirty="0"/>
+              <a:t> </a:t>
+            </a:r>
+          </a:p>
+          <a:p>
+            <a:r>
+              <a:rPr lang="cs-CZ" dirty="0" err="1">
+                <a:highlight>
+                  <a:srgbClr val="C0C0C0"/>
+                </a:highlight>
+              </a:rPr>
+              <a:t>PartialOrd</a:t>
+            </a:r>
+            <a:r>
+              <a:rPr lang="cs-CZ" dirty="0"/>
+              <a:t> a </a:t>
+            </a:r>
+            <a:r>
+              <a:rPr lang="cs-CZ" dirty="0" err="1">
+                <a:highlight>
+                  <a:srgbClr val="C0C0C0"/>
+                </a:highlight>
+              </a:rPr>
+              <a:t>Ord</a:t>
+            </a:r>
+            <a:r>
+              <a:rPr lang="cs-CZ" dirty="0"/>
+              <a:t> – operátory nerovnosti </a:t>
+            </a:r>
+            <a:r>
+              <a:rPr lang="cs-CZ" dirty="0">
+                <a:highlight>
+                  <a:srgbClr val="C0C0C0"/>
+                </a:highlight>
+              </a:rPr>
+              <a:t>&lt;</a:t>
+            </a:r>
+            <a:r>
+              <a:rPr lang="cs-CZ" dirty="0"/>
+              <a:t>, </a:t>
+            </a:r>
+            <a:r>
+              <a:rPr lang="cs-CZ" dirty="0">
+                <a:highlight>
+                  <a:srgbClr val="C0C0C0"/>
+                </a:highlight>
+              </a:rPr>
+              <a:t>&lt;=</a:t>
+            </a:r>
+            <a:r>
+              <a:rPr lang="cs-CZ" dirty="0"/>
+              <a:t>, </a:t>
+            </a:r>
+            <a:r>
+              <a:rPr lang="cs-CZ" dirty="0">
+                <a:highlight>
+                  <a:srgbClr val="C0C0C0"/>
+                </a:highlight>
+              </a:rPr>
+              <a:t>&gt;</a:t>
+            </a:r>
+            <a:r>
+              <a:rPr lang="cs-CZ" dirty="0"/>
+              <a:t> a </a:t>
+            </a:r>
+            <a:r>
+              <a:rPr lang="cs-CZ" dirty="0">
+                <a:highlight>
+                  <a:srgbClr val="C0C0C0"/>
+                </a:highlight>
+              </a:rPr>
+              <a:t>&gt;=</a:t>
+            </a:r>
+            <a:r>
+              <a:rPr lang="cs-CZ" dirty="0"/>
+              <a:t> </a:t>
+            </a:r>
+          </a:p>
+          <a:p>
+            <a:r>
+              <a:rPr lang="cs-CZ" dirty="0" err="1">
+                <a:highlight>
+                  <a:srgbClr val="C0C0C0"/>
+                </a:highlight>
+              </a:rPr>
+              <a:t>Debug</a:t>
+            </a:r>
+            <a:r>
+              <a:rPr lang="cs-CZ" dirty="0"/>
+              <a:t> a </a:t>
+            </a:r>
+            <a:r>
+              <a:rPr lang="cs-CZ" dirty="0">
+                <a:highlight>
+                  <a:srgbClr val="C0C0C0"/>
+                </a:highlight>
+              </a:rPr>
+              <a:t>Display</a:t>
+            </a:r>
+            <a:r>
+              <a:rPr lang="cs-CZ" dirty="0"/>
+              <a:t> – formátování na text</a:t>
+            </a:r>
+          </a:p>
+          <a:p>
+            <a:r>
+              <a:rPr lang="cs-CZ" dirty="0"/>
+              <a:t>Makro </a:t>
+            </a:r>
+            <a:r>
+              <a:rPr lang="cs-CZ" dirty="0">
+                <a:highlight>
+                  <a:srgbClr val="C0C0C0"/>
+                </a:highlight>
+              </a:rPr>
+              <a:t>#[derive(…)]</a:t>
+            </a:r>
+            <a:r>
+              <a:rPr lang="cs-CZ" dirty="0"/>
+              <a:t> – automatická implementace</a:t>
+            </a:r>
           </a:p>
         </p:txBody>
       </p:sp>
@@ -6651,7 +7811,7 @@
           <a:p>
             <a:r>
               <a:rPr lang="cs-CZ" dirty="0"/>
-              <a:t>Architektura programu</a:t>
+              <a:t>Průběh programu</a:t>
             </a:r>
           </a:p>
         </p:txBody>
@@ -6672,24 +7832,117 @@
             <p:ph idx="1"/>
           </p:nvPr>
         </p:nvSpPr>
-        <p:spPr/>
+        <p:spPr>
+          <a:xfrm>
+            <a:off x="838200" y="1825625"/>
+            <a:ext cx="5257800" cy="4351338"/>
+          </a:xfrm>
+        </p:spPr>
         <p:txBody>
           <a:bodyPr/>
           <a:lstStyle/>
           <a:p>
             <a:r>
               <a:rPr lang="cs-CZ" dirty="0"/>
-              <a:t>Setup, event </a:t>
-            </a:r>
-            <a:r>
-              <a:rPr lang="cs-CZ" dirty="0" err="1"/>
-              <a:t>loop</a:t>
-            </a:r>
+              <a:t>Nejsložitější zařídí HAL a HW</a:t>
+            </a:r>
+          </a:p>
+          <a:p>
+            <a:r>
+              <a:rPr lang="cs-CZ" dirty="0"/>
+              <a:t>Inicializace – hodiny, periferie, datové struktury</a:t>
+            </a:r>
+          </a:p>
+          <a:p>
+            <a:r>
+              <a:rPr lang="cs-CZ" dirty="0"/>
+              <a:t>Nekonečná smyčka</a:t>
+            </a:r>
+          </a:p>
+          <a:p>
             <a:endParaRPr lang="cs-CZ" dirty="0"/>
           </a:p>
-          <a:p>
-            <a:r>
-              <a:rPr lang="cs-CZ" dirty="0" err="1"/>
+        </p:txBody>
+      </p:sp>
+      <p:pic>
+        <p:nvPicPr>
+          <p:cNvPr id="4" name="Picture 3">
+            <a:extLst>
+              <a:ext uri="{FF2B5EF4-FFF2-40B4-BE49-F238E27FC236}">
+                <a16:creationId xmlns:a16="http://schemas.microsoft.com/office/drawing/2014/main" id="{1607DF11-18E6-81EB-899D-30D875558B83}"/>
+              </a:ext>
+            </a:extLst>
+          </p:cNvPr>
+          <p:cNvPicPr>
+            <a:picLocks noChangeAspect="1"/>
+          </p:cNvPicPr>
+          <p:nvPr/>
+        </p:nvPicPr>
+        <p:blipFill>
+          <a:blip r:embed="rId4"/>
+          <a:stretch>
+            <a:fillRect/>
+          </a:stretch>
+        </p:blipFill>
+        <p:spPr>
+          <a:xfrm>
+            <a:off x="6096000" y="0"/>
+            <a:ext cx="6096000" cy="6858000"/>
+          </a:xfrm>
+          <a:prstGeom prst="rect">
+            <a:avLst/>
+          </a:prstGeom>
+        </p:spPr>
+      </p:pic>
+      <p:sp>
+        <p:nvSpPr>
+          <p:cNvPr id="2" name="TextBox 1">
+            <a:extLst>
+              <a:ext uri="{FF2B5EF4-FFF2-40B4-BE49-F238E27FC236}">
+                <a16:creationId xmlns:a16="http://schemas.microsoft.com/office/drawing/2014/main" id="{C4F6BF35-AA84-5EA3-E0FB-30180604E98F}"/>
+              </a:ext>
+            </a:extLst>
+          </p:cNvPr>
+          <p:cNvSpPr txBox="1"/>
+          <p:nvPr/>
+        </p:nvSpPr>
+        <p:spPr>
+          <a:xfrm>
+            <a:off x="8951884" y="5955972"/>
+            <a:ext cx="3028208" cy="646331"/>
+          </a:xfrm>
+          <a:prstGeom prst="rect">
+            <a:avLst/>
+          </a:prstGeom>
+        </p:spPr>
+        <p:style>
+          <a:lnRef idx="2">
+            <a:schemeClr val="accent5"/>
+          </a:lnRef>
+          <a:fillRef idx="1">
+            <a:schemeClr val="lt1"/>
+          </a:fillRef>
+          <a:effectRef idx="0">
+            <a:schemeClr val="accent5"/>
+          </a:effectRef>
+          <a:fontRef idx="minor">
+            <a:schemeClr val="dk1"/>
+          </a:fontRef>
+        </p:style>
+        <p:txBody>
+          <a:bodyPr wrap="square" rtlCol="0">
+            <a:spAutoFit/>
+          </a:bodyPr>
+          <a:lstStyle/>
+          <a:p>
+            <a:r>
+              <a:rPr lang="cs-CZ"/>
+              <a:t>Setup, event loop</a:t>
+            </a:r>
+          </a:p>
+          <a:p>
+            <a:r>
+              <a:rPr lang="cs-CZ"/>
               <a:t>modules</a:t>
             </a:r>
             <a:endParaRPr lang="cs-CZ" dirty="0"/>
@@ -6706,6 +7959,11 @@
   <p:clrMapOvr>
     <a:masterClrMapping/>
   </p:clrMapOvr>
+  <p:extLst>
+    <p:ext uri="{6950BFC3-D8DA-4A85-94F7-54DA5524770B}">
+      <p188:commentRel xmlns:p188="http://schemas.microsoft.com/office/powerpoint/2018/8/main" r:id="rId3"/>
+    </p:ext>
+  </p:extLst>
 </p:sld>
 </file>
 
@@ -8707,15 +9965,15 @@
             </a:r>
             <a:r>
               <a:rPr lang="cs-CZ" sz="5400" dirty="0"/>
-              <a:t> [</a:t>
+              <a:t>	/ˈ</a:t>
             </a:r>
             <a:r>
               <a:rPr lang="cs-CZ" sz="5400" dirty="0" err="1"/>
-              <a:t>ínam</a:t>
+              <a:t>inʌm</a:t>
             </a:r>
             <a:r>
               <a:rPr lang="cs-CZ" sz="5400" dirty="0"/>
-              <a:t>]</a:t>
+              <a:t>/</a:t>
             </a:r>
           </a:p>
         </p:txBody>
@@ -9063,8 +10321,8 @@
           </a:p>
         </p:txBody>
       </p:sp>
-      <mc:AlternateContent xmlns:mc="http://schemas.openxmlformats.org/markup-compatibility/2006" xmlns:a14="http://schemas.microsoft.com/office/drawing/2010/main">
-        <mc:Choice Requires="a14">
+      <mc:AlternateContent xmlns:mc="http://schemas.openxmlformats.org/markup-compatibility/2006">
+        <mc:Choice xmlns:a14="http://schemas.microsoft.com/office/drawing/2010/main" Requires="a14">
           <p:sp>
             <p:nvSpPr>
               <p:cNvPr id="3" name="Content Placeholder 2">
@@ -9095,7 +10353,7 @@
               <a:p>
                 <a:r>
                   <a:rPr lang="cs-CZ" sz="2200" dirty="0"/>
-                  <a:t>C: výčtový typ (fixní sada hodnot s identifikátory)</a:t>
+                  <a:t>Jinde: výčtový typ (fixní sada hodnot s identifikátory)</a:t>
                 </a:r>
               </a:p>
               <a:p>
@@ -9437,7 +10695,7 @@
             </p:txBody>
           </p:sp>
         </mc:Choice>
-        <mc:Fallback xmlns="">
+        <mc:Fallback>
           <p:sp>
             <p:nvSpPr>
               <p:cNvPr id="3" name="Content Placeholder 2">
@@ -9460,7 +10718,7 @@
                 <a:ext cx="7328263" cy="3483864"/>
               </a:xfrm>
               <a:blipFill>
-                <a:blip r:embed="rId3"/>
+                <a:blip r:embed="rId4"/>
                 <a:stretch>
                   <a:fillRect l="-915" t="-2098"/>
                 </a:stretch>
@@ -9496,7 +10754,7 @@
           <p:nvPr/>
         </p:nvPicPr>
         <p:blipFill>
-          <a:blip r:embed="rId4">
+          <a:blip r:embed="rId5">
             <a:extLst>
               <a:ext uri="{28A0092B-C50C-407E-A947-70E740481C1C}">
                 <a14:useLocalDpi xmlns:a14="http://schemas.microsoft.com/office/drawing/2010/main" val="0"/>
@@ -9533,7 +10791,7 @@
           <p:nvPr/>
         </p:nvPicPr>
         <p:blipFill>
-          <a:blip r:embed="rId5">
+          <a:blip r:embed="rId6">
             <a:extLst>
               <a:ext uri="{28A0092B-C50C-407E-A947-70E740481C1C}">
                 <a14:useLocalDpi xmlns:a14="http://schemas.microsoft.com/office/drawing/2010/main" val="0"/>
@@ -9565,6 +10823,11 @@
   <p:clrMapOvr>
     <a:masterClrMapping/>
   </p:clrMapOvr>
+  <p:extLst>
+    <p:ext uri="{6950BFC3-D8DA-4A85-94F7-54DA5524770B}">
+      <p188:commentRel xmlns:p188="http://schemas.microsoft.com/office/powerpoint/2018/8/main" r:id="rId3"/>
+    </p:ext>
+  </p:extLst>
 </p:sld>
 </file>
 
@@ -9631,8 +10894,8 @@
         </p:nvSpPr>
         <p:spPr>
           <a:xfrm>
-            <a:off x="838200" y="1825624"/>
-            <a:ext cx="10515600" cy="5032375"/>
+            <a:off x="838200" y="1825625"/>
+            <a:ext cx="10515600" cy="4527674"/>
           </a:xfrm>
         </p:spPr>
         <p:txBody>
@@ -9644,21 +10907,6 @@
             <a:r>
               <a:rPr lang="cs-CZ" dirty="0"/>
               <a:t>Každá hodnota má jediného vlastníka</a:t>
-            </a:r>
-          </a:p>
-          <a:p>
-            <a:pPr lvl="1"/>
-            <a:r>
-              <a:rPr lang="cs-CZ" dirty="0"/>
-              <a:t>Vlastník: proměnná v bloku kódu / objekt (struktura či </a:t>
-            </a:r>
-            <a:r>
-              <a:rPr lang="cs-CZ" dirty="0" err="1"/>
-              <a:t>enum</a:t>
-            </a:r>
-            <a:r>
-              <a:rPr lang="cs-CZ" dirty="0"/>
-              <a:t>)</a:t>
             </a:r>
           </a:p>
           <a:p>
@@ -9725,6 +10973,12 @@
             <a:r>
               <a:rPr lang="cs-CZ" dirty="0"/>
               <a:t>Při skončení životnosti automaticky zavolán Drop</a:t>
+            </a:r>
+          </a:p>
+          <a:p>
+            <a:r>
+              <a:rPr lang="cs-CZ" dirty="0"/>
+              <a:t>Surové ukazatele přenáší zodpovědnost na programátora</a:t>
             </a:r>
           </a:p>
         </p:txBody>
@@ -10195,6 +11449,25 @@
               <a:rPr lang="cs-CZ" sz="2000" dirty="0"/>
               <a:t>Vlastnosti, metody (funkce na typy)</a:t>
             </a:r>
+          </a:p>
+          <a:p>
+            <a:r>
+              <a:rPr lang="cs-CZ" sz="2400" dirty="0"/>
+              <a:t>Jeden </a:t>
+            </a:r>
+            <a:r>
+              <a:rPr lang="cs-CZ" sz="2400" dirty="0" err="1"/>
+              <a:t>trait</a:t>
+            </a:r>
+            <a:r>
+              <a:rPr lang="cs-CZ" sz="2400" dirty="0"/>
+              <a:t> může vyžadovat jiný </a:t>
+            </a:r>
+            <a:r>
+              <a:rPr lang="cs-CZ" sz="2400" dirty="0" err="1"/>
+              <a:t>trait</a:t>
+            </a:r>
+            <a:endParaRPr lang="cs-CZ" sz="2400" dirty="0"/>
           </a:p>
           <a:p>
             <a:r>

</xml_diff>

<commit_message>
Done Decfix, quitting for today
</commit_message>
<xml_diff>
--- a/Prezentace.pptx
+++ b/Prezentace.pptx
@@ -5,7 +5,7 @@
     <p:sldMasterId id="2147483648" r:id="rId1"/>
   </p:sldMasterIdLst>
   <p:notesMasterIdLst>
-    <p:notesMasterId r:id="rId18"/>
+    <p:notesMasterId r:id="rId19"/>
   </p:notesMasterIdLst>
   <p:sldIdLst>
     <p:sldId id="256" r:id="rId2"/>
@@ -21,9 +21,10 @@
     <p:sldId id="272" r:id="rId12"/>
     <p:sldId id="265" r:id="rId13"/>
     <p:sldId id="266" r:id="rId14"/>
-    <p:sldId id="267" r:id="rId15"/>
-    <p:sldId id="268" r:id="rId16"/>
-    <p:sldId id="269" r:id="rId17"/>
+    <p:sldId id="273" r:id="rId15"/>
+    <p:sldId id="267" r:id="rId16"/>
+    <p:sldId id="268" r:id="rId17"/>
+    <p:sldId id="269" r:id="rId18"/>
   </p:sldIdLst>
   <p:sldSz cx="12192000" cy="6858000"/>
   <p:notesSz cx="6858000" cy="9144000"/>
@@ -197,27 +198,6 @@
 </p188:cmLst>
 </file>
 
-<file path=ppt/comments/modernComment_109_8B2154FC.xml><?xml version="1.0" encoding="utf-8"?>
-<p188:cmLst xmlns:a="http://schemas.openxmlformats.org/drawingml/2006/main" xmlns:r="http://schemas.openxmlformats.org/officeDocument/2006/relationships" xmlns:p188="http://schemas.microsoft.com/office/powerpoint/2018/8/main">
-  <p188:cm id="{4114CA40-1E1C-4583-9708-DB630D347108}" authorId="{6027075E-E1E5-2701-A4E4-E7D417A591B4}" created="2026-04-03T10:23:43.275">
-    <pc:sldMkLst xmlns:pc="http://schemas.microsoft.com/office/powerpoint/2013/main/command">
-      <pc:docMk/>
-      <pc:sldMk cId="2334217468" sldId="265"/>
-    </pc:sldMkLst>
-    <p188:txBody>
-      <a:bodyPr/>
-      <a:lstStyle/>
-      <a:p>
-        <a:r>
-          <a:rPr lang="cs-CZ"/>
-          <a:t>Teoreticky není potřeba ho převádět na Unicode, ale… Pššt!</a:t>
-        </a:r>
-      </a:p>
-    </p188:txBody>
-  </p188:cm>
-</p188:cmLst>
-</file>
-
 <file path=ppt/comments/modernComment_10F_1D3B1A8A.xml><?xml version="1.0" encoding="utf-8"?>
 <p188:cmLst xmlns:a="http://schemas.openxmlformats.org/drawingml/2006/main" xmlns:r="http://schemas.openxmlformats.org/officeDocument/2006/relationships" xmlns:p188="http://schemas.microsoft.com/office/powerpoint/2018/8/main">
   <p188:cm id="{53E681B9-C046-4031-A410-095919527E16}" authorId="{6027075E-E1E5-2701-A4E4-E7D417A591B4}" created="2026-04-03T09:12:43.940">
@@ -237,6 +217,32 @@
         <a:r>
           <a:rPr lang="cs-CZ"/>
           <a:t>Mezinárodní fonetická abeceda, abychom potěšili předsedu češtináře...</a:t>
+        </a:r>
+      </a:p>
+    </p188:txBody>
+  </p188:cm>
+</p188:cmLst>
+</file>
+
+<file path=ppt/comments/modernComment_110_236875D5.xml><?xml version="1.0" encoding="utf-8"?>
+<p188:cmLst xmlns:a="http://schemas.openxmlformats.org/drawingml/2006/main" xmlns:r="http://schemas.openxmlformats.org/officeDocument/2006/relationships" xmlns:p188="http://schemas.microsoft.com/office/powerpoint/2018/8/main">
+  <p188:cm id="{E0E62FC9-A357-4372-91FC-D2BFCF308EE1}" authorId="{6027075E-E1E5-2701-A4E4-E7D417A591B4}" created="2026-04-03T17:41:46.065">
+    <ac:txMkLst xmlns:ac="http://schemas.microsoft.com/office/drawing/2013/main/command">
+      <pc:docMk xmlns:pc="http://schemas.microsoft.com/office/powerpoint/2013/main/command"/>
+      <pc:sldMk xmlns:pc="http://schemas.microsoft.com/office/powerpoint/2013/main/command" cId="594048469" sldId="272"/>
+      <ac:spMk id="6" creationId="{25717209-8749-396C-9CE4-92D63F73388D}"/>
+      <ac:txMk cp="105" len="94">
+        <ac:context len="284" hash="3670548495"/>
+      </ac:txMk>
+    </ac:txMkLst>
+    <p188:pos x="8341426" y="1736972"/>
+    <p188:txBody>
+      <a:bodyPr/>
+      <a:lstStyle/>
+      <a:p>
+        <a:r>
+          <a:rPr lang="cs-CZ"/>
+          <a:t>Možná vyloučit pro délku?</a:t>
         </a:r>
       </a:p>
     </p188:txBody>
@@ -1423,13 +1429,130 @@
             </a:r>
             <a:r>
               <a:rPr lang="cs-CZ" dirty="0"/>
-              <a:t> se rozhodne, jak se zachová podle toho, o </a:t>
-            </a:r>
-            <a:r>
-              <a:rPr lang="cs-CZ"/>
-              <a:t>jaký znak jde</a:t>
-            </a:r>
+              <a:t> se rozhodne, jak se zachová podle toho, o jaký znak jde</a:t>
+            </a:r>
+            <a:br>
+              <a:rPr lang="cs-CZ" dirty="0"/>
+            </a:br>
+            <a:r>
+              <a:rPr lang="cs-CZ" dirty="0"/>
+              <a:t>(přidání znaku do textového pole / odstranění znaku / negace vstupu / matematická operace / ovládání kalkulačky)</a:t>
+            </a:r>
+          </a:p>
+          <a:p>
+            <a:pPr marL="0" indent="0">
+              <a:buFont typeface="Arial" panose="020B0604020202020204" pitchFamily="34" charset="0"/>
+              <a:buNone/>
+            </a:pPr>
             <a:endParaRPr lang="cs-CZ" dirty="0"/>
+          </a:p>
+          <a:p>
+            <a:pPr marL="0" indent="0">
+              <a:buFont typeface="Arial" panose="020B0604020202020204" pitchFamily="34" charset="0"/>
+              <a:buNone/>
+            </a:pPr>
+            <a:r>
+              <a:rPr lang="cs-CZ" dirty="0"/>
+              <a:t>Celý kód se nenachází pouze v jednom souboru, ale pro vyšší čitelnost i lepší členění rozdělen do více modulů, každý v zvláštním souboru</a:t>
+            </a:r>
+          </a:p>
+          <a:p>
+            <a:pPr marL="171450" indent="-171450">
+              <a:buFont typeface="Arial" panose="020B0604020202020204" pitchFamily="34" charset="0"/>
+              <a:buChar char="•"/>
+            </a:pPr>
+            <a:r>
+              <a:rPr lang="cs-CZ" dirty="0"/>
+              <a:t>Modul </a:t>
+            </a:r>
+            <a:r>
+              <a:rPr lang="cs-CZ" dirty="0" err="1"/>
+              <a:t>stack</a:t>
+            </a:r>
+            <a:r>
+              <a:rPr lang="cs-CZ" dirty="0"/>
+              <a:t> je zodpovědný za definici samotné datové struktury zásobníku, na kterou ukládáme čísla, se kterými provádíme operace, a kterou zobrazujeme na displej</a:t>
+            </a:r>
+          </a:p>
+          <a:p>
+            <a:pPr marL="171450" indent="-171450">
+              <a:buFont typeface="Arial" panose="020B0604020202020204" pitchFamily="34" charset="0"/>
+              <a:buChar char="•"/>
+            </a:pPr>
+            <a:r>
+              <a:rPr lang="cs-CZ" dirty="0"/>
+              <a:t>Modul </a:t>
+            </a:r>
+            <a:r>
+              <a:rPr lang="cs-CZ" dirty="0" err="1"/>
+              <a:t>textbox</a:t>
+            </a:r>
+            <a:r>
+              <a:rPr lang="cs-CZ" dirty="0"/>
+              <a:t> definuje pomocnou strukturu, která provádí operace na textovém poli a vykresluje jej na displej</a:t>
+            </a:r>
+          </a:p>
+          <a:p>
+            <a:pPr marL="171450" indent="-171450">
+              <a:buFont typeface="Arial" panose="020B0604020202020204" pitchFamily="34" charset="0"/>
+              <a:buChar char="•"/>
+            </a:pPr>
+            <a:r>
+              <a:rPr lang="cs-CZ" dirty="0"/>
+              <a:t>Modul </a:t>
+            </a:r>
+            <a:r>
+              <a:rPr lang="cs-CZ" dirty="0" err="1"/>
+              <a:t>decfix</a:t>
+            </a:r>
+            <a:r>
+              <a:rPr lang="cs-CZ" dirty="0"/>
+              <a:t> obsahuje kód pro náš (dále popsaný) datový typ čísla s fixní desetinnou čárkou</a:t>
+            </a:r>
+          </a:p>
+          <a:p>
+            <a:pPr marL="171450" indent="-171450">
+              <a:buFont typeface="Arial" panose="020B0604020202020204" pitchFamily="34" charset="0"/>
+              <a:buChar char="•"/>
+            </a:pPr>
+            <a:r>
+              <a:rPr lang="cs-CZ" dirty="0"/>
+              <a:t>Modul </a:t>
+            </a:r>
+            <a:r>
+              <a:rPr lang="cs-CZ" dirty="0" err="1"/>
+              <a:t>custom_error</a:t>
+            </a:r>
+            <a:r>
+              <a:rPr lang="cs-CZ" dirty="0"/>
+              <a:t> popisuje </a:t>
+            </a:r>
+            <a:r>
+              <a:rPr lang="cs-CZ" dirty="0" err="1"/>
+              <a:t>enum</a:t>
+            </a:r>
+            <a:r>
+              <a:rPr lang="cs-CZ" dirty="0"/>
+              <a:t>, který v celé aplikaci používáme pro práci s chybami, obsahující všechny možné typy chyb</a:t>
+            </a:r>
+          </a:p>
+          <a:p>
+            <a:pPr marL="171450" indent="-171450">
+              <a:buFont typeface="Arial" panose="020B0604020202020204" pitchFamily="34" charset="0"/>
+              <a:buChar char="•"/>
+            </a:pPr>
+            <a:r>
+              <a:rPr lang="cs-CZ" dirty="0"/>
+              <a:t>Nakonec modul </a:t>
+            </a:r>
+            <a:r>
+              <a:rPr lang="cs-CZ" dirty="0" err="1"/>
+              <a:t>command_mode</a:t>
+            </a:r>
+            <a:r>
+              <a:rPr lang="cs-CZ" dirty="0"/>
+              <a:t> se skládá pouze z jedné funkce, skrze kterou implementujeme příkazový mód</a:t>
+            </a:r>
           </a:p>
         </p:txBody>
       </p:sp>
@@ -1460,6 +1583,297 @@
     <p:extLst>
       <p:ext uri="{BB962C8B-B14F-4D97-AF65-F5344CB8AC3E}">
         <p14:creationId xmlns:p14="http://schemas.microsoft.com/office/powerpoint/2010/main" val="1325202856"/>
+      </p:ext>
+    </p:extLst>
+  </p:cSld>
+  <p:clrMapOvr>
+    <a:masterClrMapping/>
+  </p:clrMapOvr>
+</p:notes>
+</file>
+
+<file path=ppt/notesSlides/notesSlide12.xml><?xml version="1.0" encoding="utf-8"?>
+<p:notes xmlns:a="http://schemas.openxmlformats.org/drawingml/2006/main" xmlns:r="http://schemas.openxmlformats.org/officeDocument/2006/relationships" xmlns:p="http://schemas.openxmlformats.org/presentationml/2006/main">
+  <p:cSld>
+    <p:spTree>
+      <p:nvGrpSpPr>
+        <p:cNvPr id="1" name=""/>
+        <p:cNvGrpSpPr/>
+        <p:nvPr/>
+      </p:nvGrpSpPr>
+      <p:grpSpPr>
+        <a:xfrm>
+          <a:off x="0" y="0"/>
+          <a:ext cx="0" cy="0"/>
+          <a:chOff x="0" y="0"/>
+          <a:chExt cx="0" cy="0"/>
+        </a:xfrm>
+      </p:grpSpPr>
+      <p:sp>
+        <p:nvSpPr>
+          <p:cNvPr id="2" name="Slide Image Placeholder 1"/>
+          <p:cNvSpPr>
+            <a:spLocks noGrp="1" noRot="1" noChangeAspect="1"/>
+          </p:cNvSpPr>
+          <p:nvPr>
+            <p:ph type="sldImg"/>
+          </p:nvPr>
+        </p:nvSpPr>
+        <p:spPr/>
+      </p:sp>
+      <p:sp>
+        <p:nvSpPr>
+          <p:cNvPr id="3" name="Notes Placeholder 2"/>
+          <p:cNvSpPr>
+            <a:spLocks noGrp="1"/>
+          </p:cNvSpPr>
+          <p:nvPr>
+            <p:ph type="body" idx="1"/>
+          </p:nvPr>
+        </p:nvSpPr>
+        <p:spPr/>
+        <p:txBody>
+          <a:bodyPr/>
+          <a:lstStyle/>
+          <a:p>
+            <a:r>
+              <a:rPr lang="cs-CZ" dirty="0"/>
+              <a:t>V průběhu tvorby kalkulačky nastal těžký problém: buď zůstat u celočíselných operací a mít rozbité dělení,</a:t>
+            </a:r>
+            <a:br>
+              <a:rPr lang="cs-CZ" dirty="0"/>
+            </a:br>
+            <a:r>
+              <a:rPr lang="cs-CZ" dirty="0"/>
+              <a:t>nebo používat čísla s plovoucí desetinnou čárkou a mít nepřesné všechny operace</a:t>
+            </a:r>
+          </a:p>
+          <a:p>
+            <a:pPr marL="171450" indent="-171450">
+              <a:buFont typeface="Arial" panose="020B0604020202020204" pitchFamily="34" charset="0"/>
+              <a:buChar char="•"/>
+            </a:pPr>
+            <a:r>
+              <a:rPr lang="cs-CZ" dirty="0"/>
+              <a:t>Čísla s plovoucí desetinnou čárkou jsou také binární, takže se snaží napasovat své hodnoty do binárních desetinných čísel,</a:t>
+            </a:r>
+            <a:br>
+              <a:rPr lang="cs-CZ" dirty="0"/>
+            </a:br>
+            <a:r>
+              <a:rPr lang="cs-CZ" dirty="0"/>
+              <a:t>což ale v mnoha případech vede k nepřesnému a neintuitivnímu zaokrouhlování</a:t>
+            </a:r>
+          </a:p>
+          <a:p>
+            <a:pPr marL="171450" indent="-171450">
+              <a:buFont typeface="Arial" panose="020B0604020202020204" pitchFamily="34" charset="0"/>
+              <a:buChar char="•"/>
+            </a:pPr>
+            <a:r>
+              <a:rPr lang="cs-CZ" dirty="0"/>
+              <a:t>Nenašel jsem žádnou vhodnou knihovnu, která by to implementovala za mě, takže jsem se rozhodl si to napsat sám</a:t>
+            </a:r>
+          </a:p>
+          <a:p>
+            <a:pPr marL="0" indent="0">
+              <a:buFont typeface="Arial" panose="020B0604020202020204" pitchFamily="34" charset="0"/>
+              <a:buNone/>
+            </a:pPr>
+            <a:endParaRPr lang="cs-CZ" dirty="0"/>
+          </a:p>
+          <a:p>
+            <a:pPr marL="0" indent="0">
+              <a:buFont typeface="Arial" panose="020B0604020202020204" pitchFamily="34" charset="0"/>
+              <a:buNone/>
+            </a:pPr>
+            <a:r>
+              <a:rPr lang="cs-CZ" dirty="0"/>
+              <a:t>Struktura se skládá z dvou čísel: </a:t>
+            </a:r>
+            <a:r>
+              <a:rPr lang="cs-CZ" dirty="0" err="1"/>
+              <a:t>value</a:t>
+            </a:r>
+            <a:r>
+              <a:rPr lang="cs-CZ" dirty="0"/>
+              <a:t> (hodnota) a exponent. Sémantická hodnota je číslo </a:t>
+            </a:r>
+            <a:r>
+              <a:rPr lang="cs-CZ" dirty="0" err="1"/>
+              <a:t>value</a:t>
+            </a:r>
+            <a:r>
+              <a:rPr lang="cs-CZ" dirty="0"/>
+              <a:t> vynásobené</a:t>
+            </a:r>
+            <a:br>
+              <a:rPr lang="cs-CZ" dirty="0"/>
+            </a:br>
+            <a:r>
+              <a:rPr lang="cs-CZ" dirty="0"/>
+              <a:t>desítkou umocněnou na číslo exponent = číslo </a:t>
+            </a:r>
+            <a:r>
+              <a:rPr lang="cs-CZ" dirty="0" err="1"/>
+              <a:t>value</a:t>
+            </a:r>
+            <a:r>
+              <a:rPr lang="cs-CZ" dirty="0"/>
+              <a:t> s desetinnou čárkou posunutou o „exponent“ míst doprava (doleva, pokud záporné)</a:t>
+            </a:r>
+          </a:p>
+          <a:p>
+            <a:pPr marL="171450" indent="-171450">
+              <a:buFont typeface="Arial" panose="020B0604020202020204" pitchFamily="34" charset="0"/>
+              <a:buChar char="•"/>
+            </a:pPr>
+            <a:r>
+              <a:rPr lang="cs-CZ" dirty="0"/>
+              <a:t>Výchozí exponent je mínus devět, což odpovídá přesnosti na devět desetinných míst</a:t>
+            </a:r>
+          </a:p>
+          <a:p>
+            <a:pPr marL="171450" indent="-171450">
+              <a:buFont typeface="Arial" panose="020B0604020202020204" pitchFamily="34" charset="0"/>
+              <a:buChar char="•"/>
+            </a:pPr>
+            <a:r>
+              <a:rPr lang="cs-CZ" dirty="0"/>
+              <a:t>Celkový rozsah reprezentovatelných hodnot je přibližně ±9,2 miliard – dostatek pro běžné počty</a:t>
+            </a:r>
+          </a:p>
+          <a:p>
+            <a:pPr marL="0" indent="0">
+              <a:buFont typeface="Arial" panose="020B0604020202020204" pitchFamily="34" charset="0"/>
+              <a:buNone/>
+            </a:pPr>
+            <a:endParaRPr lang="cs-CZ" dirty="0"/>
+          </a:p>
+          <a:p>
+            <a:pPr marL="0" indent="0">
+              <a:buFont typeface="Arial" panose="020B0604020202020204" pitchFamily="34" charset="0"/>
+              <a:buNone/>
+            </a:pPr>
+            <a:r>
+              <a:rPr lang="cs-CZ" dirty="0"/>
+              <a:t>Sčítání a odčítání čísel v takovémto formátu je prosté, stačí sčítat jen hodnoty </a:t>
+            </a:r>
+            <a:r>
+              <a:rPr lang="cs-CZ" dirty="0" err="1"/>
+              <a:t>value</a:t>
+            </a:r>
+            <a:r>
+              <a:rPr lang="cs-CZ" dirty="0"/>
+              <a:t>,</a:t>
+            </a:r>
+          </a:p>
+          <a:p>
+            <a:pPr marL="0" indent="0">
+              <a:buFont typeface="Arial" panose="020B0604020202020204" pitchFamily="34" charset="0"/>
+              <a:buNone/>
+            </a:pPr>
+            <a:r>
+              <a:rPr lang="cs-CZ" dirty="0"/>
+              <a:t>ale násobení a dělení by sčítaly / odčítaly exponenty, takže je potřeba čísla škálovat tak, aby výsledek zachoval exponent</a:t>
+            </a:r>
+          </a:p>
+          <a:p>
+            <a:pPr marL="0" indent="0">
+              <a:buFont typeface="Arial" panose="020B0604020202020204" pitchFamily="34" charset="0"/>
+              <a:buNone/>
+            </a:pPr>
+            <a:endParaRPr lang="cs-CZ" dirty="0"/>
+          </a:p>
+          <a:p>
+            <a:pPr marL="0" indent="0">
+              <a:buFont typeface="Arial" panose="020B0604020202020204" pitchFamily="34" charset="0"/>
+              <a:buNone/>
+            </a:pPr>
+            <a:r>
+              <a:rPr lang="cs-CZ" dirty="0"/>
+              <a:t>Čísla vytvářena pomocí zpracování textu na číslo funkcí </a:t>
+            </a:r>
+            <a:r>
+              <a:rPr lang="cs-CZ" dirty="0" err="1"/>
+              <a:t>parse_str</a:t>
+            </a:r>
+            <a:r>
+              <a:rPr lang="cs-CZ" dirty="0"/>
+              <a:t>(), která jej rozdělí podle desetinné čárky a zpracuje</a:t>
+            </a:r>
+          </a:p>
+          <a:p>
+            <a:pPr marL="171450" indent="-171450">
+              <a:buFont typeface="Arial" panose="020B0604020202020204" pitchFamily="34" charset="0"/>
+              <a:buChar char="•"/>
+            </a:pPr>
+            <a:r>
+              <a:rPr lang="cs-CZ" dirty="0"/>
+              <a:t>Pokud není desetinná část přesně 9 číslic dlouhá, buď ji zkrátí, nebo doplní nulami (oboje zprava), obě části sečte</a:t>
+            </a:r>
+          </a:p>
+          <a:p>
+            <a:pPr marL="0" indent="0">
+              <a:buFont typeface="Arial" panose="020B0604020202020204" pitchFamily="34" charset="0"/>
+              <a:buNone/>
+            </a:pPr>
+            <a:endParaRPr lang="cs-CZ" dirty="0"/>
+          </a:p>
+          <a:p>
+            <a:pPr marL="0" indent="0">
+              <a:buFont typeface="Arial" panose="020B0604020202020204" pitchFamily="34" charset="0"/>
+              <a:buNone/>
+            </a:pPr>
+            <a:r>
+              <a:rPr lang="cs-CZ" dirty="0"/>
+              <a:t>Pro zobrazení na displej implementuje </a:t>
+            </a:r>
+            <a:r>
+              <a:rPr lang="cs-CZ" dirty="0" err="1"/>
+              <a:t>trait</a:t>
+            </a:r>
+            <a:r>
+              <a:rPr lang="cs-CZ" dirty="0"/>
+              <a:t> Display, který naopak formátuje číslo na text,</a:t>
+            </a:r>
+            <a:br>
+              <a:rPr lang="cs-CZ" dirty="0"/>
+            </a:br>
+            <a:r>
+              <a:rPr lang="cs-CZ" dirty="0"/>
+              <a:t>rozdělí textový řetězec podle místa desetinné čárky, a vloží ji, pokud není desetinná část nulová.</a:t>
+            </a:r>
+          </a:p>
+        </p:txBody>
+      </p:sp>
+      <p:sp>
+        <p:nvSpPr>
+          <p:cNvPr id="4" name="Slide Number Placeholder 3"/>
+          <p:cNvSpPr>
+            <a:spLocks noGrp="1"/>
+          </p:cNvSpPr>
+          <p:nvPr>
+            <p:ph type="sldNum" sz="quarter" idx="5"/>
+          </p:nvPr>
+        </p:nvSpPr>
+        <p:spPr/>
+        <p:txBody>
+          <a:bodyPr/>
+          <a:lstStyle/>
+          <a:p>
+            <a:fld id="{27274CA6-4D7F-431B-9614-EDAF6E1099E6}" type="slidenum">
+              <a:rPr lang="cs-CZ" smtClean="0"/>
+              <a:t>13</a:t>
+            </a:fld>
+            <a:endParaRPr lang="cs-CZ"/>
+          </a:p>
+        </p:txBody>
+      </p:sp>
+    </p:spTree>
+    <p:extLst>
+      <p:ext uri="{BB962C8B-B14F-4D97-AF65-F5344CB8AC3E}">
+        <p14:creationId xmlns:p14="http://schemas.microsoft.com/office/powerpoint/2010/main" val="2537979919"/>
       </p:ext>
     </p:extLst>
   </p:cSld>
@@ -7435,6 +7849,7 @@
                 <a:highlight>
                   <a:srgbClr val="C0C0C0"/>
                 </a:highlight>
+                <a:latin typeface="Consolas" panose="020B0609020204030204" pitchFamily="49" charset="0"/>
               </a:rPr>
               <a:t>embedded</a:t>
             </a:r>
@@ -7443,6 +7858,7 @@
                 <a:highlight>
                   <a:srgbClr val="C0C0C0"/>
                 </a:highlight>
+                <a:latin typeface="Consolas" panose="020B0609020204030204" pitchFamily="49" charset="0"/>
               </a:rPr>
               <a:t>-hal</a:t>
             </a:r>
@@ -7552,6 +7968,7 @@
                 <a:highlight>
                   <a:srgbClr val="C0C0C0"/>
                 </a:highlight>
+                <a:latin typeface="Consolas" panose="020B0609020204030204" pitchFamily="49" charset="0"/>
               </a:rPr>
               <a:t>Clone</a:t>
             </a:r>
@@ -7564,6 +7981,7 @@
                 <a:highlight>
                   <a:srgbClr val="C0C0C0"/>
                 </a:highlight>
+                <a:latin typeface="Consolas" panose="020B0609020204030204" pitchFamily="49" charset="0"/>
               </a:rPr>
               <a:t>Copy</a:t>
             </a:r>
@@ -7578,6 +7996,7 @@
                 <a:highlight>
                   <a:srgbClr val="C0C0C0"/>
                 </a:highlight>
+                <a:latin typeface="Consolas" panose="020B0609020204030204" pitchFamily="49" charset="0"/>
               </a:rPr>
               <a:t>Drop</a:t>
             </a:r>
@@ -7592,6 +8011,7 @@
                 <a:highlight>
                   <a:srgbClr val="C0C0C0"/>
                 </a:highlight>
+                <a:latin typeface="Consolas" panose="020B0609020204030204" pitchFamily="49" charset="0"/>
               </a:rPr>
               <a:t>Default</a:t>
             </a:r>
@@ -7606,6 +8026,7 @@
                 <a:highlight>
                   <a:srgbClr val="C0C0C0"/>
                 </a:highlight>
+                <a:latin typeface="Consolas" panose="020B0609020204030204" pitchFamily="49" charset="0"/>
               </a:rPr>
               <a:t>PartialEq</a:t>
             </a:r>
@@ -7618,6 +8039,7 @@
                 <a:highlight>
                   <a:srgbClr val="C0C0C0"/>
                 </a:highlight>
+                <a:latin typeface="Consolas" panose="020B0609020204030204" pitchFamily="49" charset="0"/>
               </a:rPr>
               <a:t>Eq</a:t>
             </a:r>
@@ -7630,6 +8052,7 @@
                 <a:highlight>
                   <a:srgbClr val="C0C0C0"/>
                 </a:highlight>
+                <a:latin typeface="Consolas" panose="020B0609020204030204" pitchFamily="49" charset="0"/>
               </a:rPr>
               <a:t>==</a:t>
             </a:r>
@@ -7644,6 +8067,7 @@
                 <a:highlight>
                   <a:srgbClr val="C0C0C0"/>
                 </a:highlight>
+                <a:latin typeface="Consolas" panose="020B0609020204030204" pitchFamily="49" charset="0"/>
               </a:rPr>
               <a:t>PartialOrd</a:t>
             </a:r>
@@ -7656,6 +8080,7 @@
                 <a:highlight>
                   <a:srgbClr val="C0C0C0"/>
                 </a:highlight>
+                <a:latin typeface="Consolas" panose="020B0609020204030204" pitchFamily="49" charset="0"/>
               </a:rPr>
               <a:t>Ord</a:t>
             </a:r>
@@ -7668,6 +8093,7 @@
                 <a:highlight>
                   <a:srgbClr val="C0C0C0"/>
                 </a:highlight>
+                <a:latin typeface="Consolas" panose="020B0609020204030204" pitchFamily="49" charset="0"/>
               </a:rPr>
               <a:t>&lt;</a:t>
             </a:r>
@@ -7680,6 +8106,7 @@
                 <a:highlight>
                   <a:srgbClr val="C0C0C0"/>
                 </a:highlight>
+                <a:latin typeface="Consolas" panose="020B0609020204030204" pitchFamily="49" charset="0"/>
               </a:rPr>
               <a:t>&lt;=</a:t>
             </a:r>
@@ -7692,6 +8119,7 @@
                 <a:highlight>
                   <a:srgbClr val="C0C0C0"/>
                 </a:highlight>
+                <a:latin typeface="Consolas" panose="020B0609020204030204" pitchFamily="49" charset="0"/>
               </a:rPr>
               <a:t>&gt;</a:t>
             </a:r>
@@ -7704,6 +8132,7 @@
                 <a:highlight>
                   <a:srgbClr val="C0C0C0"/>
                 </a:highlight>
+                <a:latin typeface="Consolas" panose="020B0609020204030204" pitchFamily="49" charset="0"/>
               </a:rPr>
               <a:t>&gt;=</a:t>
             </a:r>
@@ -7718,6 +8147,7 @@
                 <a:highlight>
                   <a:srgbClr val="C0C0C0"/>
                 </a:highlight>
+                <a:latin typeface="Consolas" panose="020B0609020204030204" pitchFamily="49" charset="0"/>
               </a:rPr>
               <a:t>Debug</a:t>
             </a:r>
@@ -7730,6 +8160,7 @@
                 <a:highlight>
                   <a:srgbClr val="C0C0C0"/>
                 </a:highlight>
+                <a:latin typeface="Consolas" panose="020B0609020204030204" pitchFamily="49" charset="0"/>
               </a:rPr>
               <a:t>Display</a:t>
             </a:r>
@@ -7748,6 +8179,7 @@
                 <a:highlight>
                   <a:srgbClr val="C0C0C0"/>
                 </a:highlight>
+                <a:latin typeface="Consolas" panose="020B0609020204030204" pitchFamily="49" charset="0"/>
               </a:rPr>
               <a:t>#[derive(…)]</a:t>
             </a:r>
@@ -7768,6 +8200,11 @@
   <p:clrMapOvr>
     <a:masterClrMapping/>
   </p:clrMapOvr>
+  <p:extLst>
+    <p:ext uri="{6950BFC3-D8DA-4A85-94F7-54DA5524770B}">
+      <p188:commentRel xmlns:p188="http://schemas.microsoft.com/office/powerpoint/2018/8/main" r:id="rId3"/>
+    </p:ext>
+  </p:extLst>
 </p:sld>
 </file>
 
@@ -7860,6 +8297,71 @@
             </a:r>
           </a:p>
           <a:p>
+            <a:pPr lvl="1"/>
+            <a:r>
+              <a:rPr lang="cs-CZ" dirty="0"/>
+              <a:t>Enter, </a:t>
+            </a:r>
+            <a:r>
+              <a:rPr lang="cs-CZ" dirty="0" err="1"/>
+              <a:t>Backspace</a:t>
+            </a:r>
+            <a:r>
+              <a:rPr lang="cs-CZ" dirty="0"/>
+              <a:t>, tečka, N, 0-9, +-*/, Ctrl-R, Ctrl-T</a:t>
+            </a:r>
+          </a:p>
+          <a:p>
+            <a:r>
+              <a:rPr lang="cs-CZ" dirty="0"/>
+              <a:t>Aplikační kód rozdělen do modulů</a:t>
+            </a:r>
+          </a:p>
+          <a:p>
+            <a:pPr lvl="1"/>
+            <a:r>
+              <a:rPr lang="cs-CZ" dirty="0" err="1"/>
+              <a:t>stack</a:t>
+            </a:r>
+            <a:r>
+              <a:rPr lang="cs-CZ" dirty="0"/>
+              <a:t>, </a:t>
+            </a:r>
+            <a:r>
+              <a:rPr lang="cs-CZ" dirty="0" err="1"/>
+              <a:t>textbox</a:t>
+            </a:r>
+            <a:r>
+              <a:rPr lang="cs-CZ" dirty="0"/>
+              <a:t>, </a:t>
+            </a:r>
+            <a:r>
+              <a:rPr lang="cs-CZ" dirty="0" err="1"/>
+              <a:t>decfix</a:t>
+            </a:r>
+            <a:r>
+              <a:rPr lang="cs-CZ" dirty="0"/>
+              <a:t>, </a:t>
+            </a:r>
+            <a:r>
+              <a:rPr lang="cs-CZ" dirty="0" err="1"/>
+              <a:t>custom_error</a:t>
+            </a:r>
+            <a:r>
+              <a:rPr lang="cs-CZ" dirty="0"/>
+              <a:t>, </a:t>
+            </a:r>
+            <a:r>
+              <a:rPr lang="cs-CZ" dirty="0" err="1"/>
+              <a:t>command_mode</a:t>
+            </a:r>
+            <a:endParaRPr lang="cs-CZ" dirty="0"/>
+          </a:p>
+          <a:p>
+            <a:pPr lvl="1"/>
+            <a:endParaRPr lang="cs-CZ" dirty="0"/>
+          </a:p>
+          <a:p>
             <a:endParaRPr lang="cs-CZ" dirty="0"/>
           </a:p>
         </p:txBody>
@@ -7879,7 +8381,7 @@
           <p:nvPr/>
         </p:nvPicPr>
         <p:blipFill>
-          <a:blip r:embed="rId4"/>
+          <a:blip r:embed="rId3"/>
           <a:stretch>
             <a:fillRect/>
           </a:stretch>
@@ -7894,61 +8396,6 @@
           </a:prstGeom>
         </p:spPr>
       </p:pic>
-      <p:sp>
-        <p:nvSpPr>
-          <p:cNvPr id="2" name="TextBox 1">
-            <a:extLst>
-              <a:ext uri="{FF2B5EF4-FFF2-40B4-BE49-F238E27FC236}">
-                <a16:creationId xmlns:a16="http://schemas.microsoft.com/office/drawing/2014/main" id="{C4F6BF35-AA84-5EA3-E0FB-30180604E98F}"/>
-              </a:ext>
-            </a:extLst>
-          </p:cNvPr>
-          <p:cNvSpPr txBox="1"/>
-          <p:nvPr/>
-        </p:nvSpPr>
-        <p:spPr>
-          <a:xfrm>
-            <a:off x="8951884" y="5955972"/>
-            <a:ext cx="3028208" cy="646331"/>
-          </a:xfrm>
-          <a:prstGeom prst="rect">
-            <a:avLst/>
-          </a:prstGeom>
-        </p:spPr>
-        <p:style>
-          <a:lnRef idx="2">
-            <a:schemeClr val="accent5"/>
-          </a:lnRef>
-          <a:fillRef idx="1">
-            <a:schemeClr val="lt1"/>
-          </a:fillRef>
-          <a:effectRef idx="0">
-            <a:schemeClr val="accent5"/>
-          </a:effectRef>
-          <a:fontRef idx="minor">
-            <a:schemeClr val="dk1"/>
-          </a:fontRef>
-        </p:style>
-        <p:txBody>
-          <a:bodyPr wrap="square" rtlCol="0">
-            <a:spAutoFit/>
-          </a:bodyPr>
-          <a:lstStyle/>
-          <a:p>
-            <a:r>
-              <a:rPr lang="cs-CZ"/>
-              <a:t>Setup, event loop</a:t>
-            </a:r>
-          </a:p>
-          <a:p>
-            <a:r>
-              <a:rPr lang="cs-CZ"/>
-              <a:t>modules</a:t>
-            </a:r>
-            <a:endParaRPr lang="cs-CZ" dirty="0"/>
-          </a:p>
-        </p:txBody>
-      </p:sp>
     </p:spTree>
     <p:extLst>
       <p:ext uri="{BB962C8B-B14F-4D97-AF65-F5344CB8AC3E}">
@@ -7959,11 +8406,6 @@
   <p:clrMapOvr>
     <a:masterClrMapping/>
   </p:clrMapOvr>
-  <p:extLst>
-    <p:ext uri="{6950BFC3-D8DA-4A85-94F7-54DA5524770B}">
-      <p188:commentRel xmlns:p188="http://schemas.microsoft.com/office/powerpoint/2018/8/main" r:id="rId3"/>
-    </p:ext>
-  </p:extLst>
 </p:sld>
 </file>
 
@@ -8012,31 +8454,207 @@
           </a:p>
         </p:txBody>
       </p:sp>
-      <p:sp>
-        <p:nvSpPr>
-          <p:cNvPr id="3" name="Content Placeholder 2">
-            <a:extLst>
-              <a:ext uri="{FF2B5EF4-FFF2-40B4-BE49-F238E27FC236}">
-                <a16:creationId xmlns:a16="http://schemas.microsoft.com/office/drawing/2014/main" id="{2615C0BB-C97C-4C65-9E4F-8751068C46AC}"/>
-              </a:ext>
-            </a:extLst>
-          </p:cNvPr>
-          <p:cNvSpPr>
-            <a:spLocks noGrp="1"/>
-          </p:cNvSpPr>
-          <p:nvPr>
-            <p:ph idx="1"/>
-          </p:nvPr>
-        </p:nvSpPr>
-        <p:spPr/>
-        <p:txBody>
-          <a:bodyPr/>
-          <a:lstStyle/>
-          <a:p>
-            <a:endParaRPr lang="cs-CZ"/>
-          </a:p>
-        </p:txBody>
-      </p:sp>
+      <mc:AlternateContent xmlns:mc="http://schemas.openxmlformats.org/markup-compatibility/2006">
+        <mc:Choice xmlns:a14="http://schemas.microsoft.com/office/drawing/2010/main" Requires="a14">
+          <p:sp>
+            <p:nvSpPr>
+              <p:cNvPr id="3" name="Content Placeholder 2">
+                <a:extLst>
+                  <a:ext uri="{FF2B5EF4-FFF2-40B4-BE49-F238E27FC236}">
+                    <a16:creationId xmlns:a16="http://schemas.microsoft.com/office/drawing/2014/main" id="{2615C0BB-C97C-4C65-9E4F-8751068C46AC}"/>
+                  </a:ext>
+                </a:extLst>
+              </p:cNvPr>
+              <p:cNvSpPr>
+                <a:spLocks noGrp="1"/>
+              </p:cNvSpPr>
+              <p:nvPr>
+                <p:ph idx="1"/>
+              </p:nvPr>
+            </p:nvSpPr>
+            <p:spPr/>
+            <p:txBody>
+              <a:bodyPr/>
+              <a:lstStyle/>
+              <a:p>
+                <a:r>
+                  <a:rPr lang="cs-CZ" dirty="0"/>
+                  <a:t>Binární plovoucí desetinná čárka není přesná</a:t>
+                </a:r>
+              </a:p>
+              <a:p>
+                <a:pPr lvl="1"/>
+                <a14:m>
+                  <m:oMath xmlns:m="http://schemas.openxmlformats.org/officeDocument/2006/math">
+                    <m:r>
+                      <a:rPr lang="cs-CZ" i="1" dirty="0" smtClean="0">
+                        <a:latin typeface="Cambria Math" panose="02040503050406030204" pitchFamily="18" charset="0"/>
+                      </a:rPr>
+                      <m:t>0.1+0.2=0.30000000000000004</m:t>
+                    </m:r>
+                  </m:oMath>
+                </a14:m>
+                <a:endParaRPr lang="cs-CZ" dirty="0"/>
+              </a:p>
+              <a:p>
+                <a:r>
+                  <a:rPr lang="cs-CZ" dirty="0"/>
+                  <a:t>„Už vím! Prostě si to udělám sám! Jak těžké to může být?“</a:t>
+                </a:r>
+              </a:p>
+              <a:p>
+                <a14:m>
+                  <m:oMath xmlns:m="http://schemas.openxmlformats.org/officeDocument/2006/math">
+                    <m:r>
+                      <a:rPr lang="cs-CZ" b="0" i="1" smtClean="0">
+                        <a:latin typeface="Cambria Math" panose="02040503050406030204" pitchFamily="18" charset="0"/>
+                      </a:rPr>
+                      <m:t>𝑚𝑒𝑎𝑛𝑖𝑛𝑔</m:t>
+                    </m:r>
+                    <m:r>
+                      <a:rPr lang="cs-CZ" b="0" i="1" smtClean="0">
+                        <a:latin typeface="Cambria Math" panose="02040503050406030204" pitchFamily="18" charset="0"/>
+                      </a:rPr>
+                      <m:t>=(</m:t>
+                    </m:r>
+                    <m:r>
+                      <a:rPr lang="cs-CZ" b="0" i="1" smtClean="0">
+                        <a:latin typeface="Cambria Math" panose="02040503050406030204" pitchFamily="18" charset="0"/>
+                      </a:rPr>
+                      <m:t>𝑣𝑎𝑙𝑢𝑒</m:t>
+                    </m:r>
+                    <m:r>
+                      <a:rPr lang="cs-CZ" b="0" i="1" smtClean="0">
+                        <a:latin typeface="Cambria Math" panose="02040503050406030204" pitchFamily="18" charset="0"/>
+                      </a:rPr>
+                      <m:t>)×10^(</m:t>
+                    </m:r>
+                    <m:r>
+                      <a:rPr lang="cs-CZ" b="0" i="1" smtClean="0">
+                        <a:latin typeface="Cambria Math" panose="02040503050406030204" pitchFamily="18" charset="0"/>
+                        <a:ea typeface="Cambria Math" panose="02040503050406030204" pitchFamily="18" charset="0"/>
+                      </a:rPr>
+                      <m:t>𝑒𝑥𝑝𝑜𝑛𝑒𝑛𝑡</m:t>
+                    </m:r>
+                    <m:r>
+                      <a:rPr lang="cs-CZ" b="0" i="1" smtClean="0">
+                        <a:latin typeface="Cambria Math" panose="02040503050406030204" pitchFamily="18" charset="0"/>
+                        <a:ea typeface="Cambria Math" panose="02040503050406030204" pitchFamily="18" charset="0"/>
+                      </a:rPr>
+                      <m:t>)</m:t>
+                    </m:r>
+                  </m:oMath>
+                </a14:m>
+                <a:endParaRPr lang="cs-CZ" dirty="0"/>
+              </a:p>
+              <a:p>
+                <a:r>
+                  <a:rPr lang="cs-CZ" dirty="0"/>
+                  <a:t>Násobení a dělení vyžaduje škálování</a:t>
+                </a:r>
+              </a:p>
+              <a:p>
+                <a:r>
+                  <a:rPr lang="cs-CZ" dirty="0"/>
+                  <a:t>Text → číslo: </a:t>
+                </a:r>
+                <a:r>
+                  <a:rPr lang="cs-CZ" dirty="0" err="1">
+                    <a:highlight>
+                      <a:srgbClr val="C0C0C0"/>
+                    </a:highlight>
+                    <a:latin typeface="Consolas" panose="020B0609020204030204" pitchFamily="49" charset="0"/>
+                  </a:rPr>
+                  <a:t>parse_str</a:t>
+                </a:r>
+                <a:r>
+                  <a:rPr lang="cs-CZ" dirty="0">
+                    <a:highlight>
+                      <a:srgbClr val="C0C0C0"/>
+                    </a:highlight>
+                    <a:latin typeface="Consolas" panose="020B0609020204030204" pitchFamily="49" charset="0"/>
+                  </a:rPr>
+                  <a:t>()</a:t>
+                </a:r>
+                <a:r>
+                  <a:rPr lang="cs-CZ" dirty="0"/>
+                  <a:t> </a:t>
+                </a:r>
+              </a:p>
+              <a:p>
+                <a:r>
+                  <a:rPr lang="cs-CZ" dirty="0"/>
+                  <a:t>Číslo → text: </a:t>
+                </a:r>
+                <a:r>
+                  <a:rPr lang="cs-CZ" dirty="0" err="1">
+                    <a:highlight>
+                      <a:srgbClr val="C0C0C0"/>
+                    </a:highlight>
+                    <a:latin typeface="Consolas" panose="020B0609020204030204" pitchFamily="49" charset="0"/>
+                  </a:rPr>
+                  <a:t>impl</a:t>
+                </a:r>
+                <a:r>
+                  <a:rPr lang="cs-CZ" dirty="0">
+                    <a:highlight>
+                      <a:srgbClr val="C0C0C0"/>
+                    </a:highlight>
+                    <a:latin typeface="Consolas" panose="020B0609020204030204" pitchFamily="49" charset="0"/>
+                  </a:rPr>
+                  <a:t> Display</a:t>
+                </a:r>
+                <a:r>
+                  <a:rPr lang="cs-CZ" dirty="0"/>
+                  <a:t> </a:t>
+                </a:r>
+              </a:p>
+              <a:p>
+                <a:endParaRPr lang="cs-CZ" dirty="0"/>
+              </a:p>
+            </p:txBody>
+          </p:sp>
+        </mc:Choice>
+        <mc:Fallback>
+          <p:sp>
+            <p:nvSpPr>
+              <p:cNvPr id="3" name="Content Placeholder 2">
+                <a:extLst>
+                  <a:ext uri="{FF2B5EF4-FFF2-40B4-BE49-F238E27FC236}">
+                    <a16:creationId xmlns:a16="http://schemas.microsoft.com/office/drawing/2014/main" id="{2615C0BB-C97C-4C65-9E4F-8751068C46AC}"/>
+                  </a:ext>
+                </a:extLst>
+              </p:cNvPr>
+              <p:cNvSpPr>
+                <a:spLocks noGrp="1" noRot="1" noChangeAspect="1" noMove="1" noResize="1" noEditPoints="1" noAdjustHandles="1" noChangeArrowheads="1" noChangeShapeType="1" noTextEdit="1"/>
+              </p:cNvSpPr>
+              <p:nvPr>
+                <p:ph idx="1"/>
+              </p:nvPr>
+            </p:nvSpPr>
+            <p:spPr>
+              <a:blipFill>
+                <a:blip r:embed="rId3"/>
+                <a:stretch>
+                  <a:fillRect l="-1043" t="-2381"/>
+                </a:stretch>
+              </a:blipFill>
+            </p:spPr>
+            <p:txBody>
+              <a:bodyPr/>
+              <a:lstStyle/>
+              <a:p>
+                <a:r>
+                  <a:rPr lang="cs-CZ">
+                    <a:noFill/>
+                  </a:rPr>
+                  <a:t> </a:t>
+                </a:r>
+              </a:p>
+            </p:txBody>
+          </p:sp>
+        </mc:Fallback>
+      </mc:AlternateContent>
     </p:spTree>
     <p:extLst>
       <p:ext uri="{BB962C8B-B14F-4D97-AF65-F5344CB8AC3E}">
@@ -8072,6 +8690,93 @@
           <p:cNvPr id="2" name="Title 1">
             <a:extLst>
               <a:ext uri="{FF2B5EF4-FFF2-40B4-BE49-F238E27FC236}">
+                <a16:creationId xmlns:a16="http://schemas.microsoft.com/office/drawing/2014/main" id="{E56F6631-18AD-EAD5-E1FE-131DFF68E20C}"/>
+              </a:ext>
+            </a:extLst>
+          </p:cNvPr>
+          <p:cNvSpPr>
+            <a:spLocks noGrp="1"/>
+          </p:cNvSpPr>
+          <p:nvPr>
+            <p:ph type="title"/>
+          </p:nvPr>
+        </p:nvSpPr>
+        <p:spPr/>
+        <p:txBody>
+          <a:bodyPr/>
+          <a:lstStyle/>
+          <a:p>
+            <a:r>
+              <a:rPr lang="cs-CZ" dirty="0" err="1"/>
+              <a:t>Command</a:t>
+            </a:r>
+            <a:r>
+              <a:rPr lang="cs-CZ" dirty="0"/>
+              <a:t> mode</a:t>
+            </a:r>
+          </a:p>
+        </p:txBody>
+      </p:sp>
+      <p:sp>
+        <p:nvSpPr>
+          <p:cNvPr id="3" name="Content Placeholder 2">
+            <a:extLst>
+              <a:ext uri="{FF2B5EF4-FFF2-40B4-BE49-F238E27FC236}">
+                <a16:creationId xmlns:a16="http://schemas.microsoft.com/office/drawing/2014/main" id="{10691F17-FCAC-ABC4-0C75-E29C1B20E52C}"/>
+              </a:ext>
+            </a:extLst>
+          </p:cNvPr>
+          <p:cNvSpPr>
+            <a:spLocks noGrp="1"/>
+          </p:cNvSpPr>
+          <p:nvPr>
+            <p:ph idx="1"/>
+          </p:nvPr>
+        </p:nvSpPr>
+        <p:spPr/>
+        <p:txBody>
+          <a:bodyPr/>
+          <a:lstStyle/>
+          <a:p>
+            <a:endParaRPr lang="cs-CZ"/>
+          </a:p>
+        </p:txBody>
+      </p:sp>
+    </p:spTree>
+    <p:extLst>
+      <p:ext uri="{BB962C8B-B14F-4D97-AF65-F5344CB8AC3E}">
+        <p14:creationId xmlns:p14="http://schemas.microsoft.com/office/powerpoint/2010/main" val="4065437153"/>
+      </p:ext>
+    </p:extLst>
+  </p:cSld>
+  <p:clrMapOvr>
+    <a:masterClrMapping/>
+  </p:clrMapOvr>
+</p:sld>
+</file>
+
+<file path=ppt/slides/slide15.xml><?xml version="1.0" encoding="utf-8"?>
+<p:sld xmlns:a="http://schemas.openxmlformats.org/drawingml/2006/main" xmlns:r="http://schemas.openxmlformats.org/officeDocument/2006/relationships" xmlns:p="http://schemas.openxmlformats.org/presentationml/2006/main" show="0">
+  <p:cSld>
+    <p:spTree>
+      <p:nvGrpSpPr>
+        <p:cNvPr id="1" name=""/>
+        <p:cNvGrpSpPr/>
+        <p:nvPr/>
+      </p:nvGrpSpPr>
+      <p:grpSpPr>
+        <a:xfrm>
+          <a:off x="0" y="0"/>
+          <a:ext cx="0" cy="0"/>
+          <a:chOff x="0" y="0"/>
+          <a:chExt cx="0" cy="0"/>
+        </a:xfrm>
+      </p:grpSpPr>
+      <p:sp>
+        <p:nvSpPr>
+          <p:cNvPr id="2" name="Title 1">
+            <a:extLst>
+              <a:ext uri="{FF2B5EF4-FFF2-40B4-BE49-F238E27FC236}">
                 <a16:creationId xmlns:a16="http://schemas.microsoft.com/office/drawing/2014/main" id="{8075CEB5-567A-56FC-A79D-8EBBE314CA35}"/>
               </a:ext>
             </a:extLst>
@@ -8133,7 +8838,7 @@
 </p:sld>
 </file>
 
-<file path=ppt/slides/slide15.xml><?xml version="1.0" encoding="utf-8"?>
+<file path=ppt/slides/slide16.xml><?xml version="1.0" encoding="utf-8"?>
 <p:sld xmlns:a="http://schemas.openxmlformats.org/drawingml/2006/main" xmlns:r="http://schemas.openxmlformats.org/officeDocument/2006/relationships" xmlns:p="http://schemas.openxmlformats.org/presentationml/2006/main">
   <p:cSld>
     <p:spTree>
@@ -8216,7 +8921,7 @@
 </p:sld>
 </file>
 
-<file path=ppt/slides/slide16.xml><?xml version="1.0" encoding="utf-8"?>
+<file path=ppt/slides/slide17.xml><?xml version="1.0" encoding="utf-8"?>
 <p:sld xmlns:a="http://schemas.openxmlformats.org/drawingml/2006/main" xmlns:r="http://schemas.openxmlformats.org/officeDocument/2006/relationships" xmlns:p="http://schemas.openxmlformats.org/presentationml/2006/main">
   <p:cSld>
     <p:spTree>
@@ -8431,8 +9136,8 @@
           </a:p>
         </p:txBody>
       </p:sp>
-      <mc:AlternateContent xmlns:mc="http://schemas.openxmlformats.org/markup-compatibility/2006" xmlns:a14="http://schemas.microsoft.com/office/drawing/2010/main">
-        <mc:Choice Requires="a14">
+      <mc:AlternateContent xmlns:mc="http://schemas.openxmlformats.org/markup-compatibility/2006">
+        <mc:Choice xmlns:a14="http://schemas.microsoft.com/office/drawing/2010/main" Requires="a14">
           <p:sp>
             <p:nvSpPr>
               <p:cNvPr id="3" name="Zástupný obsah 2">
@@ -8449,7 +9154,12 @@
                 <p:ph idx="1"/>
               </p:nvPr>
             </p:nvSpPr>
-            <p:spPr/>
+            <p:spPr>
+              <a:xfrm>
+                <a:off x="838199" y="1825625"/>
+                <a:ext cx="11239005" cy="4351338"/>
+              </a:xfrm>
+            </p:spPr>
             <p:txBody>
               <a:bodyPr/>
               <a:lstStyle/>
@@ -8487,6 +9197,12 @@
                 <a:r>
                   <a:rPr lang="cs-CZ" dirty="0"/>
                   <a:t> </a:t>
+                </a:r>
+              </a:p>
+              <a:p>
+                <a:r>
+                  <a:rPr lang="cs-CZ" dirty="0"/>
+                  <a:t>Obvykle implementováno skrze zásobník (poslední dovnitř, první ven)</a:t>
                 </a:r>
               </a:p>
               <a:p>
@@ -8663,10 +9379,11 @@
                           </m:e>
                         </m:d>
                         <m:r>
-                          <a:rPr lang="cs-CZ" b="0" i="1" smtClean="0">
+                          <a:rPr lang="cs-CZ" i="1">
                             <a:latin typeface="Cambria Math" panose="02040503050406030204" pitchFamily="18" charset="0"/>
+                            <a:ea typeface="Cambria Math" panose="02040503050406030204" pitchFamily="18" charset="0"/>
                           </a:rPr>
-                          <m:t>+</m:t>
+                          <m:t>÷</m:t>
                         </m:r>
                         <m:d>
                           <m:dPr>
@@ -8697,9 +9414,15 @@
                     <m:r>
                       <a:rPr lang="cs-CZ" i="1">
                         <a:latin typeface="Cambria Math" panose="02040503050406030204" pitchFamily="18" charset="0"/>
+                      </a:rPr>
+                      <m:t>+</m:t>
+                    </m:r>
+                    <m:r>
+                      <a:rPr lang="cs-CZ" i="1">
+                        <a:latin typeface="Cambria Math" panose="02040503050406030204" pitchFamily="18" charset="0"/>
                         <a:ea typeface="Cambria Math" panose="02040503050406030204" pitchFamily="18" charset="0"/>
                       </a:rPr>
-                      <m:t>÷5</m:t>
+                      <m:t>5</m:t>
                     </m:r>
                   </m:oMath>
                 </a14:m>
@@ -8714,7 +9437,35 @@
                         <a:latin typeface="Cambria Math" panose="02040503050406030204" pitchFamily="18" charset="0"/>
                         <a:ea typeface="Cambria Math" panose="02040503050406030204" pitchFamily="18" charset="0"/>
                       </a:rPr>
-                      <m:t>⇒2 3+5 4×+ 5÷</m:t>
+                      <m:t>⇒2 3+5 4×</m:t>
+                    </m:r>
+                    <m:r>
+                      <a:rPr lang="cs-CZ" b="0" i="1" smtClean="0">
+                        <a:latin typeface="Cambria Math" panose="02040503050406030204" pitchFamily="18" charset="0"/>
+                        <a:ea typeface="Cambria Math" panose="02040503050406030204" pitchFamily="18" charset="0"/>
+                      </a:rPr>
+                      <m:t> </m:t>
+                    </m:r>
+                    <m:r>
+                      <a:rPr lang="cs-CZ" i="1">
+                        <a:latin typeface="Cambria Math" panose="02040503050406030204" pitchFamily="18" charset="0"/>
+                        <a:ea typeface="Cambria Math" panose="02040503050406030204" pitchFamily="18" charset="0"/>
+                      </a:rPr>
+                      <m:t>÷</m:t>
+                    </m:r>
+                    <m:r>
+                      <a:rPr lang="cs-CZ" i="1">
+                        <a:latin typeface="Cambria Math" panose="02040503050406030204" pitchFamily="18" charset="0"/>
+                        <a:ea typeface="Cambria Math" panose="02040503050406030204" pitchFamily="18" charset="0"/>
+                      </a:rPr>
+                      <m:t>5</m:t>
+                    </m:r>
+                    <m:r>
+                      <a:rPr lang="cs-CZ" i="1">
+                        <a:latin typeface="Cambria Math" panose="02040503050406030204" pitchFamily="18" charset="0"/>
+                        <a:ea typeface="Cambria Math" panose="02040503050406030204" pitchFamily="18" charset="0"/>
+                      </a:rPr>
+                      <m:t>+</m:t>
                     </m:r>
                   </m:oMath>
                 </a14:m>
@@ -8729,7 +9480,7 @@
             </p:txBody>
           </p:sp>
         </mc:Choice>
-        <mc:Fallback xmlns="">
+        <mc:Fallback>
           <p:sp>
             <p:nvSpPr>
               <p:cNvPr id="3" name="Zástupný obsah 2">
@@ -8747,10 +9498,14 @@
               </p:nvPr>
             </p:nvSpPr>
             <p:spPr>
+              <a:xfrm>
+                <a:off x="838199" y="1825625"/>
+                <a:ext cx="11239005" cy="4351338"/>
+              </a:xfrm>
               <a:blipFill>
                 <a:blip r:embed="rId3"/>
                 <a:stretch>
-                  <a:fillRect l="-1043" t="-2381"/>
+                  <a:fillRect l="-922" t="-2381"/>
                 </a:stretch>
               </a:blipFill>
             </p:spPr>
@@ -10321,8 +11076,8 @@
           </a:p>
         </p:txBody>
       </p:sp>
-      <mc:AlternateContent xmlns:mc="http://schemas.openxmlformats.org/markup-compatibility/2006">
-        <mc:Choice xmlns:a14="http://schemas.microsoft.com/office/drawing/2010/main" Requires="a14">
+      <mc:AlternateContent xmlns:mc="http://schemas.openxmlformats.org/markup-compatibility/2006" xmlns:a14="http://schemas.microsoft.com/office/drawing/2010/main">
+        <mc:Choice Requires="a14">
           <p:sp>
             <p:nvSpPr>
               <p:cNvPr id="3" name="Content Placeholder 2">
@@ -10695,7 +11450,7 @@
             </p:txBody>
           </p:sp>
         </mc:Choice>
-        <mc:Fallback>
+        <mc:Fallback xmlns="">
           <p:sp>
             <p:nvSpPr>
               <p:cNvPr id="3" name="Content Placeholder 2">

</xml_diff>

<commit_message>
Fix sources; finish command mode
</commit_message>
<xml_diff>
--- a/Prezentace.pptx
+++ b/Prezentace.pptx
@@ -332,7 +332,7 @@
           <a:p>
             <a:fld id="{015F5405-DF1B-4076-864B-7962BED0FCA9}" type="datetimeFigureOut">
               <a:rPr lang="cs-CZ" smtClean="0"/>
-              <a:t>03.04.2026</a:t>
+              <a:t>07.04.2026</a:t>
             </a:fld>
             <a:endParaRPr lang="cs-CZ"/>
           </a:p>
@@ -1883,6 +1883,257 @@
 </p:notes>
 </file>
 
+<file path=ppt/notesSlides/notesSlide13.xml><?xml version="1.0" encoding="utf-8"?>
+<p:notes xmlns:a="http://schemas.openxmlformats.org/drawingml/2006/main" xmlns:r="http://schemas.openxmlformats.org/officeDocument/2006/relationships" xmlns:p="http://schemas.openxmlformats.org/presentationml/2006/main">
+  <p:cSld>
+    <p:spTree>
+      <p:nvGrpSpPr>
+        <p:cNvPr id="1" name=""/>
+        <p:cNvGrpSpPr/>
+        <p:nvPr/>
+      </p:nvGrpSpPr>
+      <p:grpSpPr>
+        <a:xfrm>
+          <a:off x="0" y="0"/>
+          <a:ext cx="0" cy="0"/>
+          <a:chOff x="0" y="0"/>
+          <a:chExt cx="0" cy="0"/>
+        </a:xfrm>
+      </p:grpSpPr>
+      <p:sp>
+        <p:nvSpPr>
+          <p:cNvPr id="2" name="Zástupný symbol pro obrázek snímku 1"/>
+          <p:cNvSpPr>
+            <a:spLocks noGrp="1" noRot="1" noChangeAspect="1"/>
+          </p:cNvSpPr>
+          <p:nvPr>
+            <p:ph type="sldImg"/>
+          </p:nvPr>
+        </p:nvSpPr>
+        <p:spPr/>
+      </p:sp>
+      <p:sp>
+        <p:nvSpPr>
+          <p:cNvPr id="3" name="Zástupný symbol pro poznámky 2"/>
+          <p:cNvSpPr>
+            <a:spLocks noGrp="1"/>
+          </p:cNvSpPr>
+          <p:nvPr>
+            <p:ph type="body" idx="1"/>
+          </p:nvPr>
+        </p:nvSpPr>
+        <p:spPr/>
+        <p:txBody>
+          <a:bodyPr/>
+          <a:lstStyle/>
+          <a:p>
+            <a:r>
+              <a:rPr lang="cs-CZ" dirty="0"/>
+              <a:t>Příkazový mód kalkulačky, interně nazván </a:t>
+            </a:r>
+            <a:r>
+              <a:rPr lang="cs-CZ" dirty="0" err="1"/>
+              <a:t>command</a:t>
+            </a:r>
+            <a:r>
+              <a:rPr lang="cs-CZ" dirty="0"/>
+              <a:t> mode (neboť kód i jeho komentáře jsem psal v angličtině),</a:t>
+            </a:r>
+            <a:br>
+              <a:rPr lang="cs-CZ" dirty="0"/>
+            </a:br>
+            <a:r>
+              <a:rPr lang="cs-CZ" dirty="0"/>
+              <a:t>slouží k ovládání kalkulačky mimo provádění matematických operací nebo zadávání čísel. Uživatel do něj přepne klávesou </a:t>
+            </a:r>
+            <a:r>
+              <a:rPr lang="cs-CZ" dirty="0" err="1"/>
+              <a:t>Ctrl+T</a:t>
+            </a:r>
+            <a:r>
+              <a:rPr lang="cs-CZ" dirty="0"/>
+              <a:t>.</a:t>
+            </a:r>
+          </a:p>
+          <a:p>
+            <a:pPr marL="171450" indent="-171450">
+              <a:buFont typeface="Arial" panose="020B0604020202020204" pitchFamily="34" charset="0"/>
+              <a:buChar char="•"/>
+            </a:pPr>
+            <a:r>
+              <a:rPr lang="cs-CZ" dirty="0"/>
+              <a:t>Textové pole začne přijímat alfanumerické znaky (písmena a čísla), aby do něj uživatel zadal textový příkaz</a:t>
+            </a:r>
+          </a:p>
+          <a:p>
+            <a:endParaRPr lang="cs-CZ" dirty="0"/>
+          </a:p>
+          <a:p>
+            <a:r>
+              <a:rPr lang="cs-CZ" dirty="0"/>
+              <a:t>Některé příkazy jsou používány pro jednodušší ladění (reset, </a:t>
+            </a:r>
+            <a:r>
+              <a:rPr lang="cs-CZ" dirty="0" err="1"/>
+              <a:t>breakpoint</a:t>
+            </a:r>
+            <a:r>
+              <a:rPr lang="cs-CZ" dirty="0"/>
+              <a:t> / </a:t>
+            </a:r>
+            <a:r>
+              <a:rPr lang="cs-CZ" dirty="0" err="1"/>
+              <a:t>breakpoint</a:t>
+            </a:r>
+            <a:r>
+              <a:rPr lang="cs-CZ" dirty="0"/>
+              <a:t> alt, </a:t>
+            </a:r>
+            <a:r>
+              <a:rPr lang="cs-CZ" dirty="0" err="1"/>
+              <a:t>boot</a:t>
+            </a:r>
+            <a:r>
+              <a:rPr lang="cs-CZ" dirty="0"/>
+              <a:t> </a:t>
+            </a:r>
+            <a:r>
+              <a:rPr lang="cs-CZ" dirty="0" err="1"/>
+              <a:t>usb</a:t>
+            </a:r>
+            <a:r>
+              <a:rPr lang="cs-CZ" dirty="0"/>
+              <a:t>, </a:t>
+            </a:r>
+            <a:r>
+              <a:rPr lang="cs-CZ" dirty="0" err="1"/>
+              <a:t>redraw</a:t>
+            </a:r>
+            <a:r>
+              <a:rPr lang="cs-CZ" dirty="0"/>
+              <a:t>)</a:t>
+            </a:r>
+          </a:p>
+          <a:p>
+            <a:endParaRPr lang="cs-CZ" dirty="0"/>
+          </a:p>
+          <a:p>
+            <a:r>
+              <a:rPr lang="cs-CZ" dirty="0"/>
+              <a:t>Příkaz </a:t>
+            </a:r>
+            <a:r>
+              <a:rPr lang="cs-CZ" dirty="0" err="1"/>
+              <a:t>brightness</a:t>
+            </a:r>
+            <a:r>
+              <a:rPr lang="cs-CZ" dirty="0"/>
+              <a:t> {1-5} nastaví jas displeje na jeden z pěti úrovní</a:t>
+            </a:r>
+          </a:p>
+          <a:p>
+            <a:endParaRPr lang="cs-CZ" dirty="0"/>
+          </a:p>
+          <a:p>
+            <a:r>
+              <a:rPr lang="cs-CZ" dirty="0"/>
+              <a:t>Další příkazy ovládají zásobník, na kterém jsou čísla</a:t>
+            </a:r>
+          </a:p>
+          <a:p>
+            <a:pPr marL="171450" indent="-171450">
+              <a:buFont typeface="Arial" panose="020B0604020202020204" pitchFamily="34" charset="0"/>
+              <a:buChar char="•"/>
+            </a:pPr>
+            <a:r>
+              <a:rPr lang="cs-CZ" dirty="0" err="1"/>
+              <a:t>clear</a:t>
+            </a:r>
+            <a:r>
+              <a:rPr lang="cs-CZ" dirty="0"/>
+              <a:t> vymaže zásobník</a:t>
+            </a:r>
+          </a:p>
+          <a:p>
+            <a:pPr marL="171450" indent="-171450">
+              <a:buFont typeface="Arial" panose="020B0604020202020204" pitchFamily="34" charset="0"/>
+              <a:buChar char="•"/>
+            </a:pPr>
+            <a:r>
+              <a:rPr lang="cs-CZ" dirty="0" err="1"/>
+              <a:t>duplicate</a:t>
+            </a:r>
+            <a:r>
+              <a:rPr lang="cs-CZ" dirty="0"/>
+              <a:t> </a:t>
+            </a:r>
+            <a:r>
+              <a:rPr lang="cs-CZ" dirty="0" err="1"/>
+              <a:t>zduplikuje</a:t>
+            </a:r>
+            <a:r>
+              <a:rPr lang="cs-CZ" dirty="0"/>
+              <a:t> posední číslo</a:t>
+            </a:r>
+          </a:p>
+          <a:p>
+            <a:pPr marL="171450" indent="-171450">
+              <a:buFont typeface="Arial" panose="020B0604020202020204" pitchFamily="34" charset="0"/>
+              <a:buChar char="•"/>
+            </a:pPr>
+            <a:r>
+              <a:rPr lang="cs-CZ" dirty="0"/>
+              <a:t>drop upustí vrchních N čísel, pokud není číslo zadáno, tak jedno vrchní</a:t>
+            </a:r>
+          </a:p>
+          <a:p>
+            <a:pPr marL="171450" indent="-171450">
+              <a:buFont typeface="Arial" panose="020B0604020202020204" pitchFamily="34" charset="0"/>
+              <a:buChar char="•"/>
+            </a:pPr>
+            <a:r>
+              <a:rPr lang="cs-CZ" dirty="0"/>
+              <a:t>swap prohodí vrchní dvě položky</a:t>
+            </a:r>
+          </a:p>
+        </p:txBody>
+      </p:sp>
+      <p:sp>
+        <p:nvSpPr>
+          <p:cNvPr id="4" name="Zástupný symbol pro číslo snímku 3"/>
+          <p:cNvSpPr>
+            <a:spLocks noGrp="1"/>
+          </p:cNvSpPr>
+          <p:nvPr>
+            <p:ph type="sldNum" sz="quarter" idx="5"/>
+          </p:nvPr>
+        </p:nvSpPr>
+        <p:spPr/>
+        <p:txBody>
+          <a:bodyPr/>
+          <a:lstStyle/>
+          <a:p>
+            <a:fld id="{27274CA6-4D7F-431B-9614-EDAF6E1099E6}" type="slidenum">
+              <a:rPr lang="cs-CZ" smtClean="0"/>
+              <a:t>14</a:t>
+            </a:fld>
+            <a:endParaRPr lang="cs-CZ"/>
+          </a:p>
+        </p:txBody>
+      </p:sp>
+    </p:spTree>
+    <p:extLst>
+      <p:ext uri="{BB962C8B-B14F-4D97-AF65-F5344CB8AC3E}">
+        <p14:creationId xmlns:p14="http://schemas.microsoft.com/office/powerpoint/2010/main" val="4233737635"/>
+      </p:ext>
+    </p:extLst>
+  </p:cSld>
+  <p:clrMapOvr>
+    <a:masterClrMapping/>
+  </p:clrMapOvr>
+</p:notes>
+</file>
+
 <file path=ppt/notesSlides/notesSlide2.xml><?xml version="1.0" encoding="utf-8"?>
 <p:notes xmlns:a="http://schemas.openxmlformats.org/drawingml/2006/main" xmlns:r="http://schemas.openxmlformats.org/officeDocument/2006/relationships" xmlns:p="http://schemas.openxmlformats.org/presentationml/2006/main">
   <p:cSld>
@@ -4191,7 +4442,7 @@
           <a:p>
             <a:fld id="{798D3673-CB33-4FFC-8C38-E9A4E5339B0B}" type="datetimeFigureOut">
               <a:rPr lang="cs-CZ" smtClean="0"/>
-              <a:t>03.04.2026</a:t>
+              <a:t>07.04.2026</a:t>
             </a:fld>
             <a:endParaRPr lang="cs-CZ"/>
           </a:p>
@@ -4389,7 +4640,7 @@
           <a:p>
             <a:fld id="{798D3673-CB33-4FFC-8C38-E9A4E5339B0B}" type="datetimeFigureOut">
               <a:rPr lang="cs-CZ" smtClean="0"/>
-              <a:t>03.04.2026</a:t>
+              <a:t>07.04.2026</a:t>
             </a:fld>
             <a:endParaRPr lang="cs-CZ"/>
           </a:p>
@@ -4597,7 +4848,7 @@
           <a:p>
             <a:fld id="{798D3673-CB33-4FFC-8C38-E9A4E5339B0B}" type="datetimeFigureOut">
               <a:rPr lang="cs-CZ" smtClean="0"/>
-              <a:t>03.04.2026</a:t>
+              <a:t>07.04.2026</a:t>
             </a:fld>
             <a:endParaRPr lang="cs-CZ"/>
           </a:p>
@@ -4795,7 +5046,7 @@
           <a:p>
             <a:fld id="{798D3673-CB33-4FFC-8C38-E9A4E5339B0B}" type="datetimeFigureOut">
               <a:rPr lang="cs-CZ" smtClean="0"/>
-              <a:t>03.04.2026</a:t>
+              <a:t>07.04.2026</a:t>
             </a:fld>
             <a:endParaRPr lang="cs-CZ"/>
           </a:p>
@@ -5070,7 +5321,7 @@
           <a:p>
             <a:fld id="{798D3673-CB33-4FFC-8C38-E9A4E5339B0B}" type="datetimeFigureOut">
               <a:rPr lang="cs-CZ" smtClean="0"/>
-              <a:t>03.04.2026</a:t>
+              <a:t>07.04.2026</a:t>
             </a:fld>
             <a:endParaRPr lang="cs-CZ"/>
           </a:p>
@@ -5335,7 +5586,7 @@
           <a:p>
             <a:fld id="{798D3673-CB33-4FFC-8C38-E9A4E5339B0B}" type="datetimeFigureOut">
               <a:rPr lang="cs-CZ" smtClean="0"/>
-              <a:t>03.04.2026</a:t>
+              <a:t>07.04.2026</a:t>
             </a:fld>
             <a:endParaRPr lang="cs-CZ"/>
           </a:p>
@@ -5747,7 +5998,7 @@
           <a:p>
             <a:fld id="{798D3673-CB33-4FFC-8C38-E9A4E5339B0B}" type="datetimeFigureOut">
               <a:rPr lang="cs-CZ" smtClean="0"/>
-              <a:t>03.04.2026</a:t>
+              <a:t>07.04.2026</a:t>
             </a:fld>
             <a:endParaRPr lang="cs-CZ"/>
           </a:p>
@@ -5888,7 +6139,7 @@
           <a:p>
             <a:fld id="{798D3673-CB33-4FFC-8C38-E9A4E5339B0B}" type="datetimeFigureOut">
               <a:rPr lang="cs-CZ" smtClean="0"/>
-              <a:t>03.04.2026</a:t>
+              <a:t>07.04.2026</a:t>
             </a:fld>
             <a:endParaRPr lang="cs-CZ"/>
           </a:p>
@@ -6001,7 +6252,7 @@
           <a:p>
             <a:fld id="{798D3673-CB33-4FFC-8C38-E9A4E5339B0B}" type="datetimeFigureOut">
               <a:rPr lang="cs-CZ" smtClean="0"/>
-              <a:t>03.04.2026</a:t>
+              <a:t>07.04.2026</a:t>
             </a:fld>
             <a:endParaRPr lang="cs-CZ"/>
           </a:p>
@@ -6312,7 +6563,7 @@
           <a:p>
             <a:fld id="{798D3673-CB33-4FFC-8C38-E9A4E5339B0B}" type="datetimeFigureOut">
               <a:rPr lang="cs-CZ" smtClean="0"/>
-              <a:t>03.04.2026</a:t>
+              <a:t>07.04.2026</a:t>
             </a:fld>
             <a:endParaRPr lang="cs-CZ"/>
           </a:p>
@@ -6600,7 +6851,7 @@
           <a:p>
             <a:fld id="{798D3673-CB33-4FFC-8C38-E9A4E5339B0B}" type="datetimeFigureOut">
               <a:rPr lang="cs-CZ" smtClean="0"/>
-              <a:t>03.04.2026</a:t>
+              <a:t>07.04.2026</a:t>
             </a:fld>
             <a:endParaRPr lang="cs-CZ"/>
           </a:p>
@@ -6841,7 +7092,7 @@
           <a:p>
             <a:fld id="{798D3673-CB33-4FFC-8C38-E9A4E5339B0B}" type="datetimeFigureOut">
               <a:rPr lang="cs-CZ" smtClean="0"/>
-              <a:t>03.04.2026</a:t>
+              <a:t>07.04.2026</a:t>
             </a:fld>
             <a:endParaRPr lang="cs-CZ"/>
           </a:p>
@@ -7505,68 +7756,68 @@
           <a:custGeom>
             <a:avLst/>
             <a:gdLst>
-              <a:gd name="csX0" fmla="*/ 0 w 3255095"/>
-              <a:gd name="csY0" fmla="*/ 0 h 18288"/>
-              <a:gd name="csX1" fmla="*/ 618468 w 3255095"/>
-              <a:gd name="csY1" fmla="*/ 0 h 18288"/>
-              <a:gd name="csX2" fmla="*/ 1269487 w 3255095"/>
-              <a:gd name="csY2" fmla="*/ 0 h 18288"/>
-              <a:gd name="csX3" fmla="*/ 1953057 w 3255095"/>
-              <a:gd name="csY3" fmla="*/ 0 h 18288"/>
-              <a:gd name="csX4" fmla="*/ 2636627 w 3255095"/>
-              <a:gd name="csY4" fmla="*/ 0 h 18288"/>
-              <a:gd name="csX5" fmla="*/ 3255095 w 3255095"/>
-              <a:gd name="csY5" fmla="*/ 0 h 18288"/>
-              <a:gd name="csX6" fmla="*/ 3255095 w 3255095"/>
-              <a:gd name="csY6" fmla="*/ 18288 h 18288"/>
-              <a:gd name="csX7" fmla="*/ 2538974 w 3255095"/>
-              <a:gd name="csY7" fmla="*/ 18288 h 18288"/>
-              <a:gd name="csX8" fmla="*/ 1822853 w 3255095"/>
-              <a:gd name="csY8" fmla="*/ 18288 h 18288"/>
-              <a:gd name="csX9" fmla="*/ 1171834 w 3255095"/>
-              <a:gd name="csY9" fmla="*/ 18288 h 18288"/>
-              <a:gd name="csX10" fmla="*/ 0 w 3255095"/>
-              <a:gd name="csY10" fmla="*/ 18288 h 18288"/>
-              <a:gd name="csX11" fmla="*/ 0 w 3255095"/>
-              <a:gd name="csY11" fmla="*/ 0 h 18288"/>
+              <a:gd name="connsiteX0" fmla="*/ 0 w 3255095"/>
+              <a:gd name="connsiteY0" fmla="*/ 0 h 18288"/>
+              <a:gd name="connsiteX1" fmla="*/ 618468 w 3255095"/>
+              <a:gd name="connsiteY1" fmla="*/ 0 h 18288"/>
+              <a:gd name="connsiteX2" fmla="*/ 1269487 w 3255095"/>
+              <a:gd name="connsiteY2" fmla="*/ 0 h 18288"/>
+              <a:gd name="connsiteX3" fmla="*/ 1953057 w 3255095"/>
+              <a:gd name="connsiteY3" fmla="*/ 0 h 18288"/>
+              <a:gd name="connsiteX4" fmla="*/ 2636627 w 3255095"/>
+              <a:gd name="connsiteY4" fmla="*/ 0 h 18288"/>
+              <a:gd name="connsiteX5" fmla="*/ 3255095 w 3255095"/>
+              <a:gd name="connsiteY5" fmla="*/ 0 h 18288"/>
+              <a:gd name="connsiteX6" fmla="*/ 3255095 w 3255095"/>
+              <a:gd name="connsiteY6" fmla="*/ 18288 h 18288"/>
+              <a:gd name="connsiteX7" fmla="*/ 2538974 w 3255095"/>
+              <a:gd name="connsiteY7" fmla="*/ 18288 h 18288"/>
+              <a:gd name="connsiteX8" fmla="*/ 1822853 w 3255095"/>
+              <a:gd name="connsiteY8" fmla="*/ 18288 h 18288"/>
+              <a:gd name="connsiteX9" fmla="*/ 1171834 w 3255095"/>
+              <a:gd name="connsiteY9" fmla="*/ 18288 h 18288"/>
+              <a:gd name="connsiteX10" fmla="*/ 0 w 3255095"/>
+              <a:gd name="connsiteY10" fmla="*/ 18288 h 18288"/>
+              <a:gd name="connsiteX11" fmla="*/ 0 w 3255095"/>
+              <a:gd name="connsiteY11" fmla="*/ 0 h 18288"/>
             </a:gdLst>
             <a:ahLst/>
             <a:cxnLst>
               <a:cxn ang="0">
-                <a:pos x="csX0" y="csY0"/>
+                <a:pos x="connsiteX0" y="connsiteY0"/>
               </a:cxn>
               <a:cxn ang="0">
-                <a:pos x="csX1" y="csY1"/>
+                <a:pos x="connsiteX1" y="connsiteY1"/>
               </a:cxn>
               <a:cxn ang="0">
-                <a:pos x="csX2" y="csY2"/>
+                <a:pos x="connsiteX2" y="connsiteY2"/>
               </a:cxn>
               <a:cxn ang="0">
-                <a:pos x="csX3" y="csY3"/>
+                <a:pos x="connsiteX3" y="connsiteY3"/>
               </a:cxn>
               <a:cxn ang="0">
-                <a:pos x="csX4" y="csY4"/>
+                <a:pos x="connsiteX4" y="connsiteY4"/>
               </a:cxn>
               <a:cxn ang="0">
-                <a:pos x="csX5" y="csY5"/>
+                <a:pos x="connsiteX5" y="connsiteY5"/>
               </a:cxn>
               <a:cxn ang="0">
-                <a:pos x="csX6" y="csY6"/>
+                <a:pos x="connsiteX6" y="connsiteY6"/>
               </a:cxn>
               <a:cxn ang="0">
-                <a:pos x="csX7" y="csY7"/>
+                <a:pos x="connsiteX7" y="connsiteY7"/>
               </a:cxn>
               <a:cxn ang="0">
-                <a:pos x="csX8" y="csY8"/>
+                <a:pos x="connsiteX8" y="connsiteY8"/>
               </a:cxn>
               <a:cxn ang="0">
-                <a:pos x="csX9" y="csY9"/>
+                <a:pos x="connsiteX9" y="connsiteY9"/>
               </a:cxn>
               <a:cxn ang="0">
-                <a:pos x="csX10" y="csY10"/>
+                <a:pos x="connsiteX10" y="connsiteY10"/>
               </a:cxn>
               <a:cxn ang="0">
-                <a:pos x="csX11" y="csY11"/>
+                <a:pos x="connsiteX11" y="connsiteY11"/>
               </a:cxn>
             </a:cxnLst>
             <a:rect l="l" t="t" r="r" b="b"/>
@@ -7762,10 +8013,10 @@
           <p:nvPr/>
         </p:nvPicPr>
         <p:blipFill>
-          <a:blip>
+          <a:blip r:embed="rId3">
             <a:extLst>
               <a:ext uri="{96DAC541-7B7A-43D3-8B79-37D633B846F1}">
-                <asvg:svgBlip xmlns:asvg="http://schemas.microsoft.com/office/drawing/2016/SVG/main" r:embed="rId3"/>
+                <asvg:svgBlip xmlns:asvg="http://schemas.microsoft.com/office/drawing/2016/SVG/main" r:embed="rId4"/>
               </a:ext>
             </a:extLst>
           </a:blip>
@@ -8454,8 +8705,8 @@
           </a:p>
         </p:txBody>
       </p:sp>
-      <mc:AlternateContent xmlns:mc="http://schemas.openxmlformats.org/markup-compatibility/2006">
-        <mc:Choice xmlns:a14="http://schemas.microsoft.com/office/drawing/2010/main" Requires="a14">
+      <mc:AlternateContent xmlns:mc="http://schemas.openxmlformats.org/markup-compatibility/2006" xmlns:a14="http://schemas.microsoft.com/office/drawing/2010/main">
+        <mc:Choice Requires="a14">
           <p:sp>
             <p:nvSpPr>
               <p:cNvPr id="3" name="Content Placeholder 2">
@@ -8615,7 +8866,7 @@
             </p:txBody>
           </p:sp>
         </mc:Choice>
-        <mc:Fallback>
+        <mc:Fallback xmlns="">
           <p:sp>
             <p:nvSpPr>
               <p:cNvPr id="3" name="Content Placeholder 2">
@@ -8738,7 +8989,46 @@
           <a:bodyPr/>
           <a:lstStyle/>
           <a:p>
-            <a:endParaRPr lang="cs-CZ"/>
+            <a:r>
+              <a:rPr lang="cs-CZ" dirty="0"/>
+              <a:t>= příkazový mód</a:t>
+            </a:r>
+          </a:p>
+          <a:p>
+            <a:r>
+              <a:rPr lang="cs-CZ" dirty="0"/>
+              <a:t>Ovládání mimo matematické operace</a:t>
+            </a:r>
+          </a:p>
+          <a:p>
+            <a:r>
+              <a:rPr lang="cs-CZ" dirty="0"/>
+              <a:t>Textové pole pro (textové) příkazy namísto čísel</a:t>
+            </a:r>
+          </a:p>
+          <a:p>
+            <a:pPr marL="0" indent="0">
+              <a:buNone/>
+            </a:pPr>
+            <a:endParaRPr lang="cs-CZ" dirty="0"/>
+          </a:p>
+          <a:p>
+            <a:r>
+              <a:rPr lang="cs-CZ" dirty="0"/>
+              <a:t>Ladicí příkazy</a:t>
+            </a:r>
+          </a:p>
+          <a:p>
+            <a:r>
+              <a:rPr lang="cs-CZ" dirty="0"/>
+              <a:t>Jas displeje</a:t>
+            </a:r>
+          </a:p>
+          <a:p>
+            <a:r>
+              <a:rPr lang="cs-CZ" dirty="0"/>
+              <a:t>Zásobník</a:t>
+            </a:r>
           </a:p>
         </p:txBody>
       </p:sp>
@@ -9136,8 +9426,8 @@
           </a:p>
         </p:txBody>
       </p:sp>
-      <mc:AlternateContent xmlns:mc="http://schemas.openxmlformats.org/markup-compatibility/2006">
-        <mc:Choice xmlns:a14="http://schemas.microsoft.com/office/drawing/2010/main" Requires="a14">
+      <mc:AlternateContent xmlns:mc="http://schemas.openxmlformats.org/markup-compatibility/2006" xmlns:a14="http://schemas.microsoft.com/office/drawing/2010/main">
+        <mc:Choice Requires="a14">
           <p:sp>
             <p:nvSpPr>
               <p:cNvPr id="3" name="Zástupný obsah 2">
@@ -9451,21 +9741,7 @@
                         <a:latin typeface="Cambria Math" panose="02040503050406030204" pitchFamily="18" charset="0"/>
                         <a:ea typeface="Cambria Math" panose="02040503050406030204" pitchFamily="18" charset="0"/>
                       </a:rPr>
-                      <m:t>÷</m:t>
-                    </m:r>
-                    <m:r>
-                      <a:rPr lang="cs-CZ" i="1">
-                        <a:latin typeface="Cambria Math" panose="02040503050406030204" pitchFamily="18" charset="0"/>
-                        <a:ea typeface="Cambria Math" panose="02040503050406030204" pitchFamily="18" charset="0"/>
-                      </a:rPr>
-                      <m:t>5</m:t>
-                    </m:r>
-                    <m:r>
-                      <a:rPr lang="cs-CZ" i="1">
-                        <a:latin typeface="Cambria Math" panose="02040503050406030204" pitchFamily="18" charset="0"/>
-                        <a:ea typeface="Cambria Math" panose="02040503050406030204" pitchFamily="18" charset="0"/>
-                      </a:rPr>
-                      <m:t>+</m:t>
+                      <m:t>÷5+</m:t>
                     </m:r>
                   </m:oMath>
                 </a14:m>
@@ -9480,7 +9756,7 @@
             </p:txBody>
           </p:sp>
         </mc:Choice>
-        <mc:Fallback>
+        <mc:Fallback xmlns="">
           <p:sp>
             <p:nvSpPr>
               <p:cNvPr id="3" name="Zástupný obsah 2">
@@ -9763,10 +10039,10 @@
           <p:nvPr/>
         </p:nvPicPr>
         <p:blipFill>
-          <a:blip>
+          <a:blip r:embed="rId7">
             <a:extLst>
               <a:ext uri="{96DAC541-7B7A-43D3-8B79-37D633B846F1}">
-                <asvg:svgBlip xmlns:asvg="http://schemas.microsoft.com/office/drawing/2016/SVG/main" r:embed="rId7"/>
+                <asvg:svgBlip xmlns:asvg="http://schemas.microsoft.com/office/drawing/2016/SVG/main" r:embed="rId8"/>
               </a:ext>
             </a:extLst>
           </a:blip>
@@ -10557,10 +10833,10 @@
           <p:nvPr/>
         </p:nvPicPr>
         <p:blipFill>
-          <a:blip>
+          <a:blip r:embed="rId4">
             <a:extLst>
               <a:ext uri="{96DAC541-7B7A-43D3-8B79-37D633B846F1}">
-                <asvg:svgBlip xmlns:asvg="http://schemas.microsoft.com/office/drawing/2016/SVG/main" r:embed="rId4"/>
+                <asvg:svgBlip xmlns:asvg="http://schemas.microsoft.com/office/drawing/2016/SVG/main" r:embed="rId5"/>
               </a:ext>
             </a:extLst>
           </a:blip>
@@ -10764,93 +11040,93 @@
           <a:custGeom>
             <a:avLst/>
             <a:gdLst>
-              <a:gd name="csX0" fmla="*/ 0 w 4243589"/>
-              <a:gd name="csY0" fmla="*/ 0 h 18288"/>
-              <a:gd name="csX1" fmla="*/ 478919 w 4243589"/>
-              <a:gd name="csY1" fmla="*/ 0 h 18288"/>
-              <a:gd name="csX2" fmla="*/ 957839 w 4243589"/>
-              <a:gd name="csY2" fmla="*/ 0 h 18288"/>
-              <a:gd name="csX3" fmla="*/ 1521630 w 4243589"/>
-              <a:gd name="csY3" fmla="*/ 0 h 18288"/>
-              <a:gd name="csX4" fmla="*/ 2212729 w 4243589"/>
-              <a:gd name="csY4" fmla="*/ 0 h 18288"/>
-              <a:gd name="csX5" fmla="*/ 2734084 w 4243589"/>
-              <a:gd name="csY5" fmla="*/ 0 h 18288"/>
-              <a:gd name="csX6" fmla="*/ 3255439 w 4243589"/>
-              <a:gd name="csY6" fmla="*/ 0 h 18288"/>
-              <a:gd name="csX7" fmla="*/ 4243589 w 4243589"/>
-              <a:gd name="csY7" fmla="*/ 0 h 18288"/>
-              <a:gd name="csX8" fmla="*/ 4243589 w 4243589"/>
-              <a:gd name="csY8" fmla="*/ 18288 h 18288"/>
-              <a:gd name="csX9" fmla="*/ 3594926 w 4243589"/>
-              <a:gd name="csY9" fmla="*/ 18288 h 18288"/>
-              <a:gd name="csX10" fmla="*/ 3073571 w 4243589"/>
-              <a:gd name="csY10" fmla="*/ 18288 h 18288"/>
-              <a:gd name="csX11" fmla="*/ 2552216 w 4243589"/>
-              <a:gd name="csY11" fmla="*/ 18288 h 18288"/>
-              <a:gd name="csX12" fmla="*/ 1903553 w 4243589"/>
-              <a:gd name="csY12" fmla="*/ 18288 h 18288"/>
-              <a:gd name="csX13" fmla="*/ 1212454 w 4243589"/>
-              <a:gd name="csY13" fmla="*/ 18288 h 18288"/>
-              <a:gd name="csX14" fmla="*/ 733535 w 4243589"/>
-              <a:gd name="csY14" fmla="*/ 18288 h 18288"/>
-              <a:gd name="csX15" fmla="*/ 0 w 4243589"/>
-              <a:gd name="csY15" fmla="*/ 18288 h 18288"/>
-              <a:gd name="csX16" fmla="*/ 0 w 4243589"/>
-              <a:gd name="csY16" fmla="*/ 0 h 18288"/>
+              <a:gd name="connsiteX0" fmla="*/ 0 w 4243589"/>
+              <a:gd name="connsiteY0" fmla="*/ 0 h 18288"/>
+              <a:gd name="connsiteX1" fmla="*/ 478919 w 4243589"/>
+              <a:gd name="connsiteY1" fmla="*/ 0 h 18288"/>
+              <a:gd name="connsiteX2" fmla="*/ 957839 w 4243589"/>
+              <a:gd name="connsiteY2" fmla="*/ 0 h 18288"/>
+              <a:gd name="connsiteX3" fmla="*/ 1521630 w 4243589"/>
+              <a:gd name="connsiteY3" fmla="*/ 0 h 18288"/>
+              <a:gd name="connsiteX4" fmla="*/ 2212729 w 4243589"/>
+              <a:gd name="connsiteY4" fmla="*/ 0 h 18288"/>
+              <a:gd name="connsiteX5" fmla="*/ 2734084 w 4243589"/>
+              <a:gd name="connsiteY5" fmla="*/ 0 h 18288"/>
+              <a:gd name="connsiteX6" fmla="*/ 3255439 w 4243589"/>
+              <a:gd name="connsiteY6" fmla="*/ 0 h 18288"/>
+              <a:gd name="connsiteX7" fmla="*/ 4243589 w 4243589"/>
+              <a:gd name="connsiteY7" fmla="*/ 0 h 18288"/>
+              <a:gd name="connsiteX8" fmla="*/ 4243589 w 4243589"/>
+              <a:gd name="connsiteY8" fmla="*/ 18288 h 18288"/>
+              <a:gd name="connsiteX9" fmla="*/ 3594926 w 4243589"/>
+              <a:gd name="connsiteY9" fmla="*/ 18288 h 18288"/>
+              <a:gd name="connsiteX10" fmla="*/ 3073571 w 4243589"/>
+              <a:gd name="connsiteY10" fmla="*/ 18288 h 18288"/>
+              <a:gd name="connsiteX11" fmla="*/ 2552216 w 4243589"/>
+              <a:gd name="connsiteY11" fmla="*/ 18288 h 18288"/>
+              <a:gd name="connsiteX12" fmla="*/ 1903553 w 4243589"/>
+              <a:gd name="connsiteY12" fmla="*/ 18288 h 18288"/>
+              <a:gd name="connsiteX13" fmla="*/ 1212454 w 4243589"/>
+              <a:gd name="connsiteY13" fmla="*/ 18288 h 18288"/>
+              <a:gd name="connsiteX14" fmla="*/ 733535 w 4243589"/>
+              <a:gd name="connsiteY14" fmla="*/ 18288 h 18288"/>
+              <a:gd name="connsiteX15" fmla="*/ 0 w 4243589"/>
+              <a:gd name="connsiteY15" fmla="*/ 18288 h 18288"/>
+              <a:gd name="connsiteX16" fmla="*/ 0 w 4243589"/>
+              <a:gd name="connsiteY16" fmla="*/ 0 h 18288"/>
             </a:gdLst>
             <a:ahLst/>
             <a:cxnLst>
               <a:cxn ang="0">
-                <a:pos x="csX0" y="csY0"/>
+                <a:pos x="connsiteX0" y="connsiteY0"/>
               </a:cxn>
               <a:cxn ang="0">
-                <a:pos x="csX1" y="csY1"/>
+                <a:pos x="connsiteX1" y="connsiteY1"/>
               </a:cxn>
               <a:cxn ang="0">
-                <a:pos x="csX2" y="csY2"/>
+                <a:pos x="connsiteX2" y="connsiteY2"/>
               </a:cxn>
               <a:cxn ang="0">
-                <a:pos x="csX3" y="csY3"/>
+                <a:pos x="connsiteX3" y="connsiteY3"/>
               </a:cxn>
               <a:cxn ang="0">
-                <a:pos x="csX4" y="csY4"/>
+                <a:pos x="connsiteX4" y="connsiteY4"/>
               </a:cxn>
               <a:cxn ang="0">
-                <a:pos x="csX5" y="csY5"/>
+                <a:pos x="connsiteX5" y="connsiteY5"/>
               </a:cxn>
               <a:cxn ang="0">
-                <a:pos x="csX6" y="csY6"/>
+                <a:pos x="connsiteX6" y="connsiteY6"/>
               </a:cxn>
               <a:cxn ang="0">
-                <a:pos x="csX7" y="csY7"/>
+                <a:pos x="connsiteX7" y="connsiteY7"/>
               </a:cxn>
               <a:cxn ang="0">
-                <a:pos x="csX8" y="csY8"/>
+                <a:pos x="connsiteX8" y="connsiteY8"/>
               </a:cxn>
               <a:cxn ang="0">
-                <a:pos x="csX9" y="csY9"/>
+                <a:pos x="connsiteX9" y="connsiteY9"/>
               </a:cxn>
               <a:cxn ang="0">
-                <a:pos x="csX10" y="csY10"/>
+                <a:pos x="connsiteX10" y="connsiteY10"/>
               </a:cxn>
               <a:cxn ang="0">
-                <a:pos x="csX11" y="csY11"/>
+                <a:pos x="connsiteX11" y="connsiteY11"/>
               </a:cxn>
               <a:cxn ang="0">
-                <a:pos x="csX12" y="csY12"/>
+                <a:pos x="connsiteX12" y="connsiteY12"/>
               </a:cxn>
               <a:cxn ang="0">
-                <a:pos x="csX13" y="csY13"/>
+                <a:pos x="connsiteX13" y="connsiteY13"/>
               </a:cxn>
               <a:cxn ang="0">
-                <a:pos x="csX14" y="csY14"/>
+                <a:pos x="connsiteX14" y="connsiteY14"/>
               </a:cxn>
               <a:cxn ang="0">
-                <a:pos x="csX15" y="csY15"/>
+                <a:pos x="connsiteX15" y="connsiteY15"/>
               </a:cxn>
               <a:cxn ang="0">
-                <a:pos x="csX16" y="csY16"/>
+                <a:pos x="connsiteX16" y="connsiteY16"/>
               </a:cxn>
             </a:cxnLst>
             <a:rect l="l" t="t" r="r" b="b"/>
@@ -11917,68 +12193,68 @@
           <a:custGeom>
             <a:avLst/>
             <a:gdLst>
-              <a:gd name="csX0" fmla="*/ 0 w 3255095"/>
-              <a:gd name="csY0" fmla="*/ 0 h 18288"/>
-              <a:gd name="csX1" fmla="*/ 618468 w 3255095"/>
-              <a:gd name="csY1" fmla="*/ 0 h 18288"/>
-              <a:gd name="csX2" fmla="*/ 1269487 w 3255095"/>
-              <a:gd name="csY2" fmla="*/ 0 h 18288"/>
-              <a:gd name="csX3" fmla="*/ 1953057 w 3255095"/>
-              <a:gd name="csY3" fmla="*/ 0 h 18288"/>
-              <a:gd name="csX4" fmla="*/ 2636627 w 3255095"/>
-              <a:gd name="csY4" fmla="*/ 0 h 18288"/>
-              <a:gd name="csX5" fmla="*/ 3255095 w 3255095"/>
-              <a:gd name="csY5" fmla="*/ 0 h 18288"/>
-              <a:gd name="csX6" fmla="*/ 3255095 w 3255095"/>
-              <a:gd name="csY6" fmla="*/ 18288 h 18288"/>
-              <a:gd name="csX7" fmla="*/ 2538974 w 3255095"/>
-              <a:gd name="csY7" fmla="*/ 18288 h 18288"/>
-              <a:gd name="csX8" fmla="*/ 1822853 w 3255095"/>
-              <a:gd name="csY8" fmla="*/ 18288 h 18288"/>
-              <a:gd name="csX9" fmla="*/ 1171834 w 3255095"/>
-              <a:gd name="csY9" fmla="*/ 18288 h 18288"/>
-              <a:gd name="csX10" fmla="*/ 0 w 3255095"/>
-              <a:gd name="csY10" fmla="*/ 18288 h 18288"/>
-              <a:gd name="csX11" fmla="*/ 0 w 3255095"/>
-              <a:gd name="csY11" fmla="*/ 0 h 18288"/>
+              <a:gd name="connsiteX0" fmla="*/ 0 w 3255095"/>
+              <a:gd name="connsiteY0" fmla="*/ 0 h 18288"/>
+              <a:gd name="connsiteX1" fmla="*/ 618468 w 3255095"/>
+              <a:gd name="connsiteY1" fmla="*/ 0 h 18288"/>
+              <a:gd name="connsiteX2" fmla="*/ 1269487 w 3255095"/>
+              <a:gd name="connsiteY2" fmla="*/ 0 h 18288"/>
+              <a:gd name="connsiteX3" fmla="*/ 1953057 w 3255095"/>
+              <a:gd name="connsiteY3" fmla="*/ 0 h 18288"/>
+              <a:gd name="connsiteX4" fmla="*/ 2636627 w 3255095"/>
+              <a:gd name="connsiteY4" fmla="*/ 0 h 18288"/>
+              <a:gd name="connsiteX5" fmla="*/ 3255095 w 3255095"/>
+              <a:gd name="connsiteY5" fmla="*/ 0 h 18288"/>
+              <a:gd name="connsiteX6" fmla="*/ 3255095 w 3255095"/>
+              <a:gd name="connsiteY6" fmla="*/ 18288 h 18288"/>
+              <a:gd name="connsiteX7" fmla="*/ 2538974 w 3255095"/>
+              <a:gd name="connsiteY7" fmla="*/ 18288 h 18288"/>
+              <a:gd name="connsiteX8" fmla="*/ 1822853 w 3255095"/>
+              <a:gd name="connsiteY8" fmla="*/ 18288 h 18288"/>
+              <a:gd name="connsiteX9" fmla="*/ 1171834 w 3255095"/>
+              <a:gd name="connsiteY9" fmla="*/ 18288 h 18288"/>
+              <a:gd name="connsiteX10" fmla="*/ 0 w 3255095"/>
+              <a:gd name="connsiteY10" fmla="*/ 18288 h 18288"/>
+              <a:gd name="connsiteX11" fmla="*/ 0 w 3255095"/>
+              <a:gd name="connsiteY11" fmla="*/ 0 h 18288"/>
             </a:gdLst>
             <a:ahLst/>
             <a:cxnLst>
               <a:cxn ang="0">
-                <a:pos x="csX0" y="csY0"/>
+                <a:pos x="connsiteX0" y="connsiteY0"/>
               </a:cxn>
               <a:cxn ang="0">
-                <a:pos x="csX1" y="csY1"/>
+                <a:pos x="connsiteX1" y="connsiteY1"/>
               </a:cxn>
               <a:cxn ang="0">
-                <a:pos x="csX2" y="csY2"/>
+                <a:pos x="connsiteX2" y="connsiteY2"/>
               </a:cxn>
               <a:cxn ang="0">
-                <a:pos x="csX3" y="csY3"/>
+                <a:pos x="connsiteX3" y="connsiteY3"/>
               </a:cxn>
               <a:cxn ang="0">
-                <a:pos x="csX4" y="csY4"/>
+                <a:pos x="connsiteX4" y="connsiteY4"/>
               </a:cxn>
               <a:cxn ang="0">
-                <a:pos x="csX5" y="csY5"/>
+                <a:pos x="connsiteX5" y="connsiteY5"/>
               </a:cxn>
               <a:cxn ang="0">
-                <a:pos x="csX6" y="csY6"/>
+                <a:pos x="connsiteX6" y="connsiteY6"/>
               </a:cxn>
               <a:cxn ang="0">
-                <a:pos x="csX7" y="csY7"/>
+                <a:pos x="connsiteX7" y="connsiteY7"/>
               </a:cxn>
               <a:cxn ang="0">
-                <a:pos x="csX8" y="csY8"/>
+                <a:pos x="connsiteX8" y="connsiteY8"/>
               </a:cxn>
               <a:cxn ang="0">
-                <a:pos x="csX9" y="csY9"/>
+                <a:pos x="connsiteX9" y="connsiteY9"/>
               </a:cxn>
               <a:cxn ang="0">
-                <a:pos x="csX10" y="csY10"/>
+                <a:pos x="connsiteX10" y="connsiteY10"/>
               </a:cxn>
               <a:cxn ang="0">
-                <a:pos x="csX11" y="csY11"/>
+                <a:pos x="connsiteX11" y="connsiteY11"/>
               </a:cxn>
             </a:cxnLst>
             <a:rect l="l" t="t" r="r" b="b"/>

</xml_diff>